<commit_message>
Improve deck: embed charts into the empty zones (slides 4, 6, 8)
- src/make_deck_figures.py: 4 figures in the deck's green/salmon palette
  (transparent bg, no titles since slides supply headers)
- slide 4: internal_code leak chart (train +0.46 vs test -0.02) fills the empty left half
- slide 6: risk inverted-U curve + 60-template opinion tiers (was ~85% empty)
- slide 8: feature-importance bars inside the 'What drives the model' box
- original deck preserved in git history (commit 2debf6f)
</commit_message>
<xml_diff>
--- a/presentation/Consulting_Finance_ML_Slides.pptx
+++ b/presentation/Consulting_Finance_ML_Slides.pptx
@@ -6861,6 +6861,30 @@
           </a:p>
         </p:txBody>
       </p:sp>
+      <p:pic>
+        <p:nvPicPr>
+          <p:cNvPr id="22" name="Picture 21" descr="deck_leak.png"/>
+          <p:cNvPicPr>
+            <a:picLocks noChangeAspect="1"/>
+          </p:cNvPicPr>
+          <p:nvPr/>
+        </p:nvPicPr>
+        <p:blipFill>
+          <a:blip r:embed="rId3"/>
+          <a:stretch>
+            <a:fillRect/>
+          </a:stretch>
+        </p:blipFill>
+        <p:spPr>
+          <a:xfrm>
+            <a:off x="1188720" y="3200400"/>
+            <a:ext cx="7589520" cy="4843590"/>
+          </a:xfrm>
+          <a:prstGeom prst="rect">
+            <a:avLst/>
+          </a:prstGeom>
+        </p:spPr>
+      </p:pic>
     </p:spTree>
   </p:cSld>
   <p:clrMapOvr>
@@ -8285,6 +8309,54 @@
           </a:p>
         </p:txBody>
       </p:sp>
+      <p:pic>
+        <p:nvPicPr>
+          <p:cNvPr id="11" name="Picture 10" descr="deck_risk.png"/>
+          <p:cNvPicPr>
+            <a:picLocks noChangeAspect="1"/>
+          </p:cNvPicPr>
+          <p:nvPr/>
+        </p:nvPicPr>
+        <p:blipFill>
+          <a:blip r:embed="rId3"/>
+          <a:stretch>
+            <a:fillRect/>
+          </a:stretch>
+        </p:blipFill>
+        <p:spPr>
+          <a:xfrm>
+            <a:off x="950976" y="3703320"/>
+            <a:ext cx="8165592" cy="4727448"/>
+          </a:xfrm>
+          <a:prstGeom prst="rect">
+            <a:avLst/>
+          </a:prstGeom>
+        </p:spPr>
+      </p:pic>
+      <p:pic>
+        <p:nvPicPr>
+          <p:cNvPr id="12" name="Picture 11" descr="deck_opinion.png"/>
+          <p:cNvPicPr>
+            <a:picLocks noChangeAspect="1"/>
+          </p:cNvPicPr>
+          <p:nvPr/>
+        </p:nvPicPr>
+        <p:blipFill>
+          <a:blip r:embed="rId4"/>
+          <a:stretch>
+            <a:fillRect/>
+          </a:stretch>
+        </p:blipFill>
+        <p:spPr>
+          <a:xfrm>
+            <a:off x="9409176" y="3703320"/>
+            <a:ext cx="8165592" cy="4727448"/>
+          </a:xfrm>
+          <a:prstGeom prst="rect">
+            <a:avLst/>
+          </a:prstGeom>
+        </p:spPr>
+      </p:pic>
     </p:spTree>
   </p:cSld>
   <p:clrMapOvr>
@@ -10423,6 +10495,30 @@
           </a:p>
         </p:txBody>
       </p:sp>
+      <p:pic>
+        <p:nvPicPr>
+          <p:cNvPr id="41" name="Picture 40" descr="deck_importance.png"/>
+          <p:cNvPicPr>
+            <a:picLocks noChangeAspect="1"/>
+          </p:cNvPicPr>
+          <p:nvPr/>
+        </p:nvPicPr>
+        <p:blipFill>
+          <a:blip r:embed="rId3"/>
+          <a:stretch>
+            <a:fillRect/>
+          </a:stretch>
+        </p:blipFill>
+        <p:spPr>
+          <a:xfrm>
+            <a:off x="10515600" y="6967728"/>
+            <a:ext cx="6583680" cy="2139696"/>
+          </a:xfrm>
+          <a:prstGeom prst="rect">
+            <a:avLst/>
+          </a:prstGeom>
+        </p:spPr>
+      </p:pic>
     </p:spTree>
   </p:cSld>
   <p:clrMapOvr>

</xml_diff>

<commit_message>
Add score-progression hero strip to slide 9 (OOF vs public LB, v1-v10)
Visualizes the slide's claim that validation tracked above the live score the whole
way: green OOF line consistently above salmon public-LB line, leader ref at 0.8565.
Fills the empty band between title and table.
</commit_message>
<xml_diff>
--- a/presentation/Consulting_Finance_ML_Slides.pptx
+++ b/presentation/Consulting_Finance_ML_Slides.pptx
@@ -12729,6 +12729,30 @@
           </a:p>
         </p:txBody>
       </p:sp>
+      <p:pic>
+        <p:nvPicPr>
+          <p:cNvPr id="62" name="Picture 61" descr="deck_progression.png"/>
+          <p:cNvPicPr>
+            <a:picLocks noChangeAspect="1"/>
+          </p:cNvPicPr>
+          <p:nvPr/>
+        </p:nvPicPr>
+        <p:blipFill>
+          <a:blip r:embed="rId3"/>
+          <a:stretch>
+            <a:fillRect/>
+          </a:stretch>
+        </p:blipFill>
+        <p:spPr>
+          <a:xfrm>
+            <a:off x="1188720" y="2103120"/>
+            <a:ext cx="15361920" cy="1632204"/>
+          </a:xfrm>
+          <a:prstGeom prst="rect">
+            <a:avLst/>
+          </a:prstGeom>
+        </p:spPr>
+      </p:pic>
     </p:spTree>
   </p:cSld>
   <p:clrMapOvr>

</xml_diff>

<commit_message>
Add 'Key code' slide (12) with the 3 signature snippets
- opinion-probe leak detection, legacy-mess fixes, OOF + smooth threshold
- code (Courier New, comments muted) left, plain-English explanation right
- matches deck template; Questions slide renumbered to 13
</commit_message>
<xml_diff>
--- a/presentation/Consulting_Finance_ML_Slides.pptx
+++ b/presentation/Consulting_Finance_ML_Slides.pptx
@@ -16,6 +16,7 @@
     <p:sldId id="264" r:id="rId10"/>
     <p:sldId id="265" r:id="rId11"/>
     <p:sldId id="266" r:id="rId12"/>
+    <p:sldId id="268" r:id="rId19"/>
     <p:sldId id="267" r:id="rId13"/>
   </p:sldIdLst>
   <p:notesMasterIdLst>
@@ -3745,6 +3746,720 @@
 </file>
 
 <file path=ppt/slides/slide12.xml><?xml version="1.0" encoding="utf-8"?>
+<p:sld xmlns:a="http://schemas.openxmlformats.org/drawingml/2006/main" xmlns:p="http://schemas.openxmlformats.org/presentationml/2006/main" xmlns:r="http://schemas.openxmlformats.org/officeDocument/2006/relationships">
+  <p:cSld>
+    <p:spTree>
+      <p:nvGrpSpPr>
+        <p:cNvPr id="1" name=""/>
+        <p:cNvGrpSpPr/>
+        <p:nvPr/>
+      </p:nvGrpSpPr>
+      <p:grpSpPr/>
+      <p:sp>
+        <p:nvSpPr>
+          <p:cNvPr id="2" name="Shape 0"/>
+          <p:cNvSpPr/>
+          <p:nvPr/>
+        </p:nvSpPr>
+        <p:spPr>
+          <a:xfrm>
+            <a:off x="952500" y="1912218"/>
+            <a:ext cx="16383000" cy="19050"/>
+          </a:xfrm>
+          <a:prstGeom prst="rect">
+            <a:avLst/>
+          </a:prstGeom>
+          <a:solidFill>
+            <a:srgbClr val="1A7A57"/>
+          </a:solidFill>
+          <a:ln/>
+        </p:spPr>
+        <p:txBody>
+          <a:bodyPr/>
+          <a:p>
+            <a:pPr algn="l"/>
+          </a:p>
+        </p:txBody>
+      </p:sp>
+      <p:sp>
+        <p:nvSpPr>
+          <p:cNvPr id="3" name="Text 1"/>
+          <p:cNvSpPr/>
+          <p:nvPr/>
+        </p:nvSpPr>
+        <p:spPr>
+          <a:xfrm>
+            <a:off x="952500" y="742950"/>
+            <a:ext cx="18021300" cy="295275"/>
+          </a:xfrm>
+          <a:prstGeom prst="rect">
+            <a:avLst/>
+          </a:prstGeom>
+          <a:noFill/>
+          <a:ln/>
+        </p:spPr>
+        <p:txBody>
+          <a:bodyPr wrap="square" lIns="25400" tIns="25400" rIns="25400" bIns="25400" rtlCol="0" anchor="t">
+            <a:normAutofit/>
+          </a:bodyPr>
+          <a:lstStyle/>
+          <a:p>
+            <a:pPr algn="l" indent="0" marL="0">
+              <a:buNone/>
+            </a:pPr>
+            <a:r>
+              <a:rPr lang="en-US" sz="1800" spc="225" kern="0" dirty="0">
+                <a:solidFill>
+                  <a:srgbClr val="007A33"/>
+                </a:solidFill>
+                <a:latin typeface="Courier New" pitchFamily="34" charset="0"/>
+                <a:ea typeface="Courier New" pitchFamily="34" charset="-122"/>
+                <a:cs typeface="Courier New" pitchFamily="34" charset="-120"/>
+              </a:rPr>
+              <a:t>12 · KEY CODE</a:t>
+            </a:r>
+            <a:endParaRPr lang="en-US" sz="1800" dirty="0"/>
+          </a:p>
+        </p:txBody>
+      </p:sp>
+      <p:sp>
+        <p:nvSpPr>
+          <p:cNvPr id="4" name="Text 2"/>
+          <p:cNvSpPr/>
+          <p:nvPr/>
+        </p:nvSpPr>
+        <p:spPr>
+          <a:xfrm>
+            <a:off x="952500" y="1152525"/>
+            <a:ext cx="18021300" cy="550143"/>
+          </a:xfrm>
+          <a:prstGeom prst="rect">
+            <a:avLst/>
+          </a:prstGeom>
+          <a:noFill/>
+          <a:ln/>
+        </p:spPr>
+        <p:txBody>
+          <a:bodyPr wrap="square" lIns="25400" tIns="25400" rIns="25400" bIns="25400" rtlCol="0" anchor="t">
+            <a:normAutofit/>
+          </a:bodyPr>
+          <a:lstStyle/>
+          <a:p>
+            <a:pPr algn="l" indent="0" marL="0">
+              <a:lnSpc>
+                <a:spcPct val="112000"/>
+              </a:lnSpc>
+              <a:buNone/>
+            </a:pPr>
+            <a:r>
+              <a:rPr lang="en-US" sz="3600" b="1" spc="-37" kern="0" dirty="0">
+                <a:solidFill>
+                  <a:srgbClr val="063D22"/>
+                </a:solidFill>
+                <a:latin typeface="Arial" pitchFamily="34" charset="0"/>
+                <a:ea typeface="Arial" pitchFamily="34" charset="-122"/>
+                <a:cs typeface="Arial" pitchFamily="34" charset="-120"/>
+              </a:rPr>
+              <a:t>The code behind the method</a:t>
+            </a:r>
+            <a:endParaRPr lang="en-US" sz="3600" dirty="0"/>
+          </a:p>
+        </p:txBody>
+      </p:sp>
+      <p:sp>
+        <p:nvSpPr>
+          <p:cNvPr id="20" name="Shape 18"/>
+          <p:cNvSpPr/>
+          <p:nvPr/>
+        </p:nvSpPr>
+        <p:spPr>
+          <a:xfrm>
+            <a:off x="952500" y="9239250"/>
+            <a:ext cx="16383000" cy="9525"/>
+          </a:xfrm>
+          <a:prstGeom prst="rect">
+            <a:avLst/>
+          </a:prstGeom>
+          <a:solidFill>
+            <a:srgbClr val="D2E6DD"/>
+          </a:solidFill>
+          <a:ln/>
+        </p:spPr>
+        <p:txBody>
+          <a:bodyPr/>
+          <a:p>
+            <a:pPr algn="l"/>
+          </a:p>
+        </p:txBody>
+      </p:sp>
+      <p:sp>
+        <p:nvSpPr>
+          <p:cNvPr id="21" name="Text 19"/>
+          <p:cNvSpPr/>
+          <p:nvPr/>
+        </p:nvSpPr>
+        <p:spPr>
+          <a:xfrm>
+            <a:off x="952500" y="9458325"/>
+            <a:ext cx="16874490" cy="295275"/>
+          </a:xfrm>
+          <a:prstGeom prst="rect">
+            <a:avLst/>
+          </a:prstGeom>
+          <a:noFill/>
+          <a:ln/>
+        </p:spPr>
+        <p:txBody>
+          <a:bodyPr wrap="square" lIns="25400" tIns="25400" rIns="25400" bIns="25400" rtlCol="0" anchor="t">
+            <a:normAutofit/>
+          </a:bodyPr>
+          <a:lstStyle/>
+          <a:p>
+            <a:pPr algn="l" indent="0" marL="0">
+              <a:buNone/>
+            </a:pPr>
+            <a:r>
+              <a:rPr lang="en-US" sz="1800" dirty="0">
+                <a:solidFill>
+                  <a:srgbClr val="5C7268"/>
+                </a:solidFill>
+                <a:latin typeface="Courier New" pitchFamily="34" charset="0"/>
+                <a:ea typeface="Courier New" pitchFamily="34" charset="-122"/>
+                <a:cs typeface="Courier New" pitchFamily="34" charset="-120"/>
+              </a:rPr>
+              <a:t>Source: src/prep.py · src/model_v10.py · full notebook in repo</a:t>
+            </a:r>
+            <a:endParaRPr lang="en-US" sz="1800" dirty="0"/>
+          </a:p>
+        </p:txBody>
+      </p:sp>
+      <p:sp>
+        <p:nvSpPr>
+          <p:cNvPr id="22" name="TextBox 21"/>
+          <p:cNvSpPr txBox="1"/>
+          <p:nvPr/>
+        </p:nvSpPr>
+        <p:spPr>
+          <a:xfrm>
+            <a:off x="950976" y="2395728"/>
+            <a:ext cx="10058400" cy="365760"/>
+          </a:xfrm>
+          <a:prstGeom prst="rect">
+            <a:avLst/>
+          </a:prstGeom>
+          <a:noFill/>
+        </p:spPr>
+        <p:txBody>
+          <a:bodyPr wrap="none">
+            <a:spAutoFit/>
+          </a:bodyPr>
+          <a:lstStyle/>
+          <a:p>
+            <a:r>
+              <a:rPr sz="2100" b="1">
+                <a:solidFill>
+                  <a:srgbClr val="063D22"/>
+                </a:solidFill>
+                <a:latin typeface="Arial"/>
+              </a:rPr>
+              <a:t>Catching the planted leak</a:t>
+            </a:r>
+          </a:p>
+        </p:txBody>
+      </p:sp>
+      <p:sp>
+        <p:nvSpPr>
+          <p:cNvPr id="23" name="Rounded Rectangle 22"/>
+          <p:cNvSpPr/>
+          <p:nvPr/>
+        </p:nvSpPr>
+        <p:spPr>
+          <a:xfrm>
+            <a:off x="950976" y="2807208"/>
+            <a:ext cx="9692640" cy="1344168"/>
+          </a:xfrm>
+          <a:prstGeom prst="roundRect">
+            <a:avLst/>
+          </a:prstGeom>
+          <a:solidFill>
+            <a:srgbClr val="EAF3EF"/>
+          </a:solidFill>
+          <a:ln>
+            <a:noFill/>
+          </a:ln>
+          <a:effectLst/>
+        </p:spPr>
+        <p:style>
+          <a:lnRef idx="1">
+            <a:schemeClr val="accent1"/>
+          </a:lnRef>
+          <a:fillRef idx="3">
+            <a:schemeClr val="accent1"/>
+          </a:fillRef>
+          <a:effectRef idx="2">
+            <a:schemeClr val="accent1"/>
+          </a:effectRef>
+          <a:fontRef idx="minor">
+            <a:schemeClr val="lt1"/>
+          </a:fontRef>
+        </p:style>
+        <p:txBody>
+          <a:bodyPr rtlCol="0" anchor="ctr" wrap="square" lIns="228600" rIns="137160" tIns="137160" bIns="109728"/>
+          <a:lstStyle/>
+          <a:p>
+            <a:pPr algn="l">
+              <a:spcAft>
+                <a:spcPts val="400"/>
+              </a:spcAft>
+            </a:pPr>
+            <a:r>
+              <a:rPr sz="1500">
+                <a:solidFill>
+                  <a:srgbClr val="14533B"/>
+                </a:solidFill>
+                <a:latin typeface="Courier New"/>
+              </a:rPr>
+              <a:t>tr_op = train.analyst_opinion.map(approval_rate)</a:t>
+            </a:r>
+          </a:p>
+          <a:p>
+            <a:pPr algn="l">
+              <a:spcAft>
+                <a:spcPts val="400"/>
+              </a:spcAft>
+            </a:pPr>
+            <a:r>
+              <a:rPr sz="1500">
+                <a:solidFill>
+                  <a:srgbClr val="14533B"/>
+                </a:solidFill>
+                <a:latin typeface="Courier New"/>
+              </a:rPr>
+              <a:t>train.internal_code.corr(tr_op)</a:t>
+            </a:r>
+            <a:r>
+              <a:rPr sz="1500">
+                <a:solidFill>
+                  <a:srgbClr val="8A9A93"/>
+                </a:solidFill>
+                <a:latin typeface="Courier New"/>
+              </a:rPr>
+              <a:t>   # +0.46  real signal</a:t>
+            </a:r>
+          </a:p>
+          <a:p>
+            <a:pPr algn="l">
+              <a:spcAft>
+                <a:spcPts val="400"/>
+              </a:spcAft>
+            </a:pPr>
+            <a:r>
+              <a:rPr sz="1500">
+                <a:solidFill>
+                  <a:srgbClr val="14533B"/>
+                </a:solidFill>
+                <a:latin typeface="Courier New"/>
+              </a:rPr>
+              <a:t>test.internal_code.corr(te_op)</a:t>
+            </a:r>
+            <a:r>
+              <a:rPr sz="1500">
+                <a:solidFill>
+                  <a:srgbClr val="8A9A93"/>
+                </a:solidFill>
+                <a:latin typeface="Courier New"/>
+              </a:rPr>
+              <a:t>    # -0.02  noise -&gt; DROP</a:t>
+            </a:r>
+          </a:p>
+        </p:txBody>
+      </p:sp>
+      <p:sp>
+        <p:nvSpPr>
+          <p:cNvPr id="24" name="TextBox 23"/>
+          <p:cNvSpPr txBox="1"/>
+          <p:nvPr/>
+        </p:nvSpPr>
+        <p:spPr>
+          <a:xfrm>
+            <a:off x="11338560" y="2852928"/>
+            <a:ext cx="6400800" cy="1371600"/>
+          </a:xfrm>
+          <a:prstGeom prst="rect">
+            <a:avLst/>
+          </a:prstGeom>
+          <a:noFill/>
+        </p:spPr>
+        <p:txBody>
+          <a:bodyPr wrap="square">
+            <a:spAutoFit/>
+          </a:bodyPr>
+          <a:lstStyle/>
+          <a:p>
+            <a:r>
+              <a:rPr sz="1700">
+                <a:solidFill>
+                  <a:srgbClr val="5C7268"/>
+                </a:solidFill>
+                <a:latin typeface="Arial"/>
+              </a:rPr>
+              <a:t>The column that predicts in training is random noise in test — proof it was scrambled on purpose.</a:t>
+            </a:r>
+          </a:p>
+        </p:txBody>
+      </p:sp>
+      <p:sp>
+        <p:nvSpPr>
+          <p:cNvPr id="25" name="TextBox 24"/>
+          <p:cNvSpPr txBox="1"/>
+          <p:nvPr/>
+        </p:nvSpPr>
+        <p:spPr>
+          <a:xfrm>
+            <a:off x="950976" y="4681728"/>
+            <a:ext cx="10058400" cy="365760"/>
+          </a:xfrm>
+          <a:prstGeom prst="rect">
+            <a:avLst/>
+          </a:prstGeom>
+          <a:noFill/>
+        </p:spPr>
+        <p:txBody>
+          <a:bodyPr wrap="none">
+            <a:spAutoFit/>
+          </a:bodyPr>
+          <a:lstStyle/>
+          <a:p>
+            <a:r>
+              <a:rPr sz="2100" b="1">
+                <a:solidFill>
+                  <a:srgbClr val="063D22"/>
+                </a:solidFill>
+                <a:latin typeface="Arial"/>
+              </a:rPr>
+              <a:t>Fixing the legacy mess</a:t>
+            </a:r>
+          </a:p>
+        </p:txBody>
+      </p:sp>
+      <p:sp>
+        <p:nvSpPr>
+          <p:cNvPr id="26" name="Rounded Rectangle 25"/>
+          <p:cNvSpPr/>
+          <p:nvPr/>
+        </p:nvSpPr>
+        <p:spPr>
+          <a:xfrm>
+            <a:off x="950976" y="5093208"/>
+            <a:ext cx="9692640" cy="1344168"/>
+          </a:xfrm>
+          <a:prstGeom prst="roundRect">
+            <a:avLst/>
+          </a:prstGeom>
+          <a:solidFill>
+            <a:srgbClr val="EAF3EF"/>
+          </a:solidFill>
+          <a:ln>
+            <a:noFill/>
+          </a:ln>
+          <a:effectLst/>
+        </p:spPr>
+        <p:style>
+          <a:lnRef idx="1">
+            <a:schemeClr val="accent1"/>
+          </a:lnRef>
+          <a:fillRef idx="3">
+            <a:schemeClr val="accent1"/>
+          </a:fillRef>
+          <a:effectRef idx="2">
+            <a:schemeClr val="accent1"/>
+          </a:effectRef>
+          <a:fontRef idx="minor">
+            <a:schemeClr val="lt1"/>
+          </a:fontRef>
+        </p:style>
+        <p:txBody>
+          <a:bodyPr rtlCol="0" anchor="ctr" wrap="square" lIns="228600" rIns="137160" tIns="137160" bIns="109728"/>
+          <a:lstStyle/>
+          <a:p>
+            <a:pPr algn="l">
+              <a:spcAft>
+                <a:spcPts val="400"/>
+              </a:spcAft>
+            </a:pPr>
+            <a:r>
+              <a:rPr sz="1500">
+                <a:solidFill>
+                  <a:srgbClr val="14533B"/>
+                </a:solidFill>
+                <a:latin typeface="Courier New"/>
+              </a:rPr>
+              <a:t>ann_income = np.where(inc &lt; 700, inc*1000, inc)</a:t>
+            </a:r>
+            <a:r>
+              <a:rPr sz="1500">
+                <a:solidFill>
+                  <a:srgbClr val="8A9A93"/>
+                </a:solidFill>
+                <a:latin typeface="Courier New"/>
+              </a:rPr>
+              <a:t>  # units</a:t>
+            </a:r>
+          </a:p>
+          <a:p>
+            <a:pPr algn="l">
+              <a:spcAft>
+                <a:spcPts val="400"/>
+              </a:spcAft>
+            </a:pPr>
+            <a:r>
+              <a:rPr sz="1500">
+                <a:solidFill>
+                  <a:srgbClr val="14533B"/>
+                </a:solidFill>
+                <a:latin typeface="Courier New"/>
+              </a:rPr>
+              <a:t>risk12 = risk_1.fillna(risk_2)</a:t>
+            </a:r>
+            <a:r>
+              <a:rPr sz="1500">
+                <a:solidFill>
+                  <a:srgbClr val="8A9A93"/>
+                </a:solidFill>
+                <a:latin typeface="Courier New"/>
+              </a:rPr>
+              <a:t>                  # r1 == r2</a:t>
+            </a:r>
+          </a:p>
+          <a:p>
+            <a:pPr algn="l">
+              <a:spcAft>
+                <a:spcPts val="400"/>
+              </a:spcAft>
+            </a:pPr>
+            <a:r>
+              <a:rPr sz="1500">
+                <a:solidFill>
+                  <a:srgbClr val="14533B"/>
+                </a:solidFill>
+                <a:latin typeface="Courier New"/>
+              </a:rPr>
+              <a:t>risk_dev = (risk - 55).abs()</a:t>
+            </a:r>
+            <a:r>
+              <a:rPr sz="1500">
+                <a:solidFill>
+                  <a:srgbClr val="8A9A93"/>
+                </a:solidFill>
+                <a:latin typeface="Courier New"/>
+              </a:rPr>
+              <a:t>                    # inverted-U</a:t>
+            </a:r>
+          </a:p>
+        </p:txBody>
+      </p:sp>
+      <p:sp>
+        <p:nvSpPr>
+          <p:cNvPr id="27" name="TextBox 26"/>
+          <p:cNvSpPr txBox="1"/>
+          <p:nvPr/>
+        </p:nvSpPr>
+        <p:spPr>
+          <a:xfrm>
+            <a:off x="11338560" y="5138928"/>
+            <a:ext cx="6400800" cy="1371600"/>
+          </a:xfrm>
+          <a:prstGeom prst="rect">
+            <a:avLst/>
+          </a:prstGeom>
+          <a:noFill/>
+        </p:spPr>
+        <p:txBody>
+          <a:bodyPr wrap="square">
+            <a:spAutoFit/>
+          </a:bodyPr>
+          <a:lstStyle/>
+          <a:p>
+            <a:r>
+              <a:rPr sz="1700">
+                <a:solidFill>
+                  <a:srgbClr val="5C7268"/>
+                </a:solidFill>
+                <a:latin typeface="Arial"/>
+              </a:rPr>
+              <a:t>Three of the highest-value fixes: unit rescaling, one duplicate column, and the risk-shape feature.</a:t>
+            </a:r>
+          </a:p>
+        </p:txBody>
+      </p:sp>
+      <p:sp>
+        <p:nvSpPr>
+          <p:cNvPr id="28" name="TextBox 27"/>
+          <p:cNvSpPr txBox="1"/>
+          <p:nvPr/>
+        </p:nvSpPr>
+        <p:spPr>
+          <a:xfrm>
+            <a:off x="950976" y="6967728"/>
+            <a:ext cx="10058400" cy="365760"/>
+          </a:xfrm>
+          <a:prstGeom prst="rect">
+            <a:avLst/>
+          </a:prstGeom>
+          <a:noFill/>
+        </p:spPr>
+        <p:txBody>
+          <a:bodyPr wrap="none">
+            <a:spAutoFit/>
+          </a:bodyPr>
+          <a:lstStyle/>
+          <a:p>
+            <a:r>
+              <a:rPr sz="2100" b="1">
+                <a:solidFill>
+                  <a:srgbClr val="063D22"/>
+                </a:solidFill>
+                <a:latin typeface="Arial"/>
+              </a:rPr>
+              <a:t>Honest validation + robust cutoff</a:t>
+            </a:r>
+          </a:p>
+        </p:txBody>
+      </p:sp>
+      <p:sp>
+        <p:nvSpPr>
+          <p:cNvPr id="29" name="Rounded Rectangle 28"/>
+          <p:cNvSpPr/>
+          <p:nvPr/>
+        </p:nvSpPr>
+        <p:spPr>
+          <a:xfrm>
+            <a:off x="950976" y="7379208"/>
+            <a:ext cx="9692640" cy="1033272"/>
+          </a:xfrm>
+          <a:prstGeom prst="roundRect">
+            <a:avLst/>
+          </a:prstGeom>
+          <a:solidFill>
+            <a:srgbClr val="EAF3EF"/>
+          </a:solidFill>
+          <a:ln>
+            <a:noFill/>
+          </a:ln>
+          <a:effectLst/>
+        </p:spPr>
+        <p:style>
+          <a:lnRef idx="1">
+            <a:schemeClr val="accent1"/>
+          </a:lnRef>
+          <a:fillRef idx="3">
+            <a:schemeClr val="accent1"/>
+          </a:fillRef>
+          <a:effectRef idx="2">
+            <a:schemeClr val="accent1"/>
+          </a:effectRef>
+          <a:fontRef idx="minor">
+            <a:schemeClr val="lt1"/>
+          </a:fontRef>
+        </p:style>
+        <p:txBody>
+          <a:bodyPr rtlCol="0" anchor="ctr" wrap="square" lIns="228600" rIns="137160" tIns="137160" bIns="109728"/>
+          <a:lstStyle/>
+          <a:p>
+            <a:pPr algn="l">
+              <a:spcAft>
+                <a:spcPts val="400"/>
+              </a:spcAft>
+            </a:pPr>
+            <a:r>
+              <a:rPr sz="1500">
+                <a:solidFill>
+                  <a:srgbClr val="14533B"/>
+                </a:solidFill>
+                <a:latin typeface="Courier New"/>
+              </a:rPr>
+              <a:t>oof[val] = model.predict_proba(X.iloc[val])[:,1]</a:t>
+            </a:r>
+            <a:r>
+              <a:rPr sz="1500">
+                <a:solidFill>
+                  <a:srgbClr val="8A9A93"/>
+                </a:solidFill>
+                <a:latin typeface="Courier New"/>
+              </a:rPr>
+              <a:t>  # 5-fold OOF</a:t>
+            </a:r>
+          </a:p>
+          <a:p>
+            <a:pPr algn="l">
+              <a:spcAft>
+                <a:spcPts val="400"/>
+              </a:spcAft>
+            </a:pPr>
+            <a:r>
+              <a:rPr sz="1500">
+                <a:solidFill>
+                  <a:srgbClr val="14533B"/>
+                </a:solidFill>
+                <a:latin typeface="Courier New"/>
+              </a:rPr>
+              <a:t>t = thresholds[acc.argsort()[-6:]].mean()</a:t>
+            </a:r>
+            <a:r>
+              <a:rPr sz="1500">
+                <a:solidFill>
+                  <a:srgbClr val="8A9A93"/>
+                </a:solidFill>
+                <a:latin typeface="Courier New"/>
+              </a:rPr>
+              <a:t>         # smooth cutoff</a:t>
+            </a:r>
+          </a:p>
+        </p:txBody>
+      </p:sp>
+      <p:sp>
+        <p:nvSpPr>
+          <p:cNvPr id="30" name="TextBox 29"/>
+          <p:cNvSpPr txBox="1"/>
+          <p:nvPr/>
+        </p:nvSpPr>
+        <p:spPr>
+          <a:xfrm>
+            <a:off x="11338560" y="7424928"/>
+            <a:ext cx="6400800" cy="1371600"/>
+          </a:xfrm>
+          <a:prstGeom prst="rect">
+            <a:avLst/>
+          </a:prstGeom>
+          <a:noFill/>
+        </p:spPr>
+        <p:txBody>
+          <a:bodyPr wrap="square">
+            <a:spAutoFit/>
+          </a:bodyPr>
+          <a:lstStyle/>
+          <a:p>
+            <a:r>
+              <a:rPr sz="1700">
+                <a:solidFill>
+                  <a:srgbClr val="5C7268"/>
+                </a:solidFill>
+                <a:latin typeface="Arial"/>
+              </a:rPr>
+              <a:t>Every row scored out-of-fold; the decision cutoff is averaged over the top-1% to avoid overfitting noise.</a:t>
+            </a:r>
+          </a:p>
+        </p:txBody>
+      </p:sp>
+    </p:spTree>
+  </p:cSld>
+  <p:clrMapOvr>
+    <a:masterClrMapping/>
+  </p:clrMapOvr>
+</p:sld>
+</file>
+
+<file path=ppt/slides/slide13.xml><?xml version="1.0" encoding="utf-8"?>
 <p:sld xmlns:a="http://schemas.openxmlformats.org/drawingml/2006/main" xmlns:r="http://schemas.openxmlformats.org/officeDocument/2006/relationships" xmlns:p="http://schemas.openxmlformats.org/presentationml/2006/main">
   <p:cSld name="Slide 12">
     <p:bg>
@@ -3803,7 +4518,7 @@
                 <a:ea typeface="Courier New" pitchFamily="34" charset="-122"/>
                 <a:cs typeface="Courier New" pitchFamily="34" charset="-120"/>
               </a:rPr>
-              <a:t>12 · QUESTIONS</a:t>
+              <a:t>13 · QUESTIONS</a:t>
             </a:r>
             <a:endParaRPr lang="en-US" sz="1800" dirty="0"/>
           </a:p>
@@ -3913,6 +4628,10 @@
           </a:solidFill>
           <a:ln/>
         </p:spPr>
+        <p:txBody>
+          <a:bodyPr/>
+          <a:p/>
+        </p:txBody>
       </p:sp>
       <p:sp>
         <p:nvSpPr>
@@ -4018,6 +4737,10 @@
           </a:solidFill>
           <a:ln/>
         </p:spPr>
+        <p:txBody>
+          <a:bodyPr/>
+          <a:p/>
+        </p:txBody>
       </p:sp>
       <p:sp>
         <p:nvSpPr>
@@ -4123,6 +4846,10 @@
           </a:solidFill>
           <a:ln/>
         </p:spPr>
+        <p:txBody>
+          <a:bodyPr/>
+          <a:p/>
+        </p:txBody>
       </p:sp>
       <p:sp>
         <p:nvSpPr>
@@ -4230,6 +4957,10 @@
           </a:solidFill>
           <a:ln/>
         </p:spPr>
+        <p:txBody>
+          <a:bodyPr/>
+          <a:p/>
+        </p:txBody>
       </p:sp>
       <p:sp>
         <p:nvSpPr>

</xml_diff>

<commit_message>
Remove first-place claim from deck (cover, slide 9, Questions)
We are not first place — replaced the ranking claim with truthful framing:
caught the planted trap + used no protected attributes. Kept the real public
accuracy (0.8565) on slide 9 without the ranking assertion.
</commit_message>
<xml_diff>
--- a/presentation/Consulting_Finance_ML_Slides.pptx
+++ b/presentation/Consulting_Finance_ML_Slides.pptx
@@ -1983,50 +1983,6 @@
       </p:sp>
       <p:sp>
         <p:nvSpPr>
-          <p:cNvPr id="5" name="Text 3"/>
-          <p:cNvSpPr/>
-          <p:nvPr/>
-        </p:nvSpPr>
-        <p:spPr>
-          <a:xfrm>
-            <a:off x="990600" y="6279877"/>
-            <a:ext cx="872654" cy="781050"/>
-          </a:xfrm>
-          <a:prstGeom prst="rect">
-            <a:avLst/>
-          </a:prstGeom>
-          <a:noFill/>
-          <a:ln/>
-        </p:spPr>
-        <p:txBody>
-          <a:bodyPr wrap="square" lIns="25400" tIns="25400" rIns="25400" bIns="25400" rtlCol="0" anchor="t">
-            <a:normAutofit/>
-          </a:bodyPr>
-          <a:lstStyle/>
-          <a:p>
-            <a:pPr algn="l" indent="0" marL="0">
-              <a:lnSpc>
-                <a:spcPct val="100000"/>
-              </a:lnSpc>
-              <a:buNone/>
-            </a:pPr>
-            <a:r>
-              <a:rPr lang="en-US" sz="5850" b="1" dirty="0">
-                <a:solidFill>
-                  <a:srgbClr val="FFFFFF"/>
-                </a:solidFill>
-                <a:latin typeface="Georgia" pitchFamily="34" charset="0"/>
-                <a:ea typeface="Georgia" pitchFamily="34" charset="-122"/>
-                <a:cs typeface="Georgia" pitchFamily="34" charset="-120"/>
-              </a:rPr>
-              <a:t>#1</a:t>
-            </a:r>
-            <a:endParaRPr lang="en-US" sz="5850" dirty="0"/>
-          </a:p>
-        </p:txBody>
-      </p:sp>
-      <p:sp>
-        <p:nvSpPr>
           <p:cNvPr id="6" name="Text 4"/>
           <p:cNvSpPr/>
           <p:nvPr/>
@@ -2063,7 +2019,7 @@
                 <a:ea typeface="Arial" pitchFamily="34" charset="-122"/>
                 <a:cs typeface="Arial" pitchFamily="34" charset="-120"/>
               </a:rPr>
-              <a:t>Tied for first place — reached without the planted data trap and without using race or religion.</a:t>
+              <a:t>Built clean — we caught the planted data trap and used no race or religion data.</a:t>
             </a:r>
             <a:endParaRPr lang="en-US" sz="2100" dirty="0"/>
           </a:p>
@@ -4668,7 +4624,7 @@
                 <a:ea typeface="Arial" pitchFamily="34" charset="-122"/>
                 <a:cs typeface="Arial" pitchFamily="34" charset="-120"/>
               </a:rPr>
-              <a:t>Tied for #1</a:t>
+              <a:t>Built clean</a:t>
             </a:r>
             <a:endParaRPr lang="en-US" sz="1950" dirty="0"/>
           </a:p>
@@ -4712,7 +4668,7 @@
                 <a:ea typeface="Arial" pitchFamily="34" charset="-122"/>
                 <a:cs typeface="Arial" pitchFamily="34" charset="-120"/>
               </a:rPr>
-              <a:t>without the planted trap or any protected data.</a:t>
+              <a:t>no planted trap, no protected data.</a:t>
             </a:r>
             <a:endParaRPr lang="en-US" sz="1875" dirty="0"/>
           </a:p>
@@ -11301,6 +11257,10 @@
           </a:solidFill>
           <a:ln/>
         </p:spPr>
+        <p:txBody>
+          <a:bodyPr/>
+          <a:p/>
+        </p:txBody>
       </p:sp>
       <p:sp>
         <p:nvSpPr>
@@ -11381,7 +11341,7 @@
                 <a:ea typeface="Arial" pitchFamily="34" charset="-122"/>
                 <a:cs typeface="Arial" pitchFamily="34" charset="-120"/>
               </a:rPr>
-              <a:t>We tied for first — and our own validation predicted it</a:t>
+              <a:t>Our own validation predicted the result in advance</a:t>
             </a:r>
             <a:endParaRPr lang="en-US" sz="3600" dirty="0"/>
           </a:p>
@@ -11447,6 +11407,10 @@
           </a:solidFill>
           <a:ln/>
         </p:spPr>
+        <p:txBody>
+          <a:bodyPr/>
+          <a:p/>
+        </p:txBody>
       </p:sp>
       <p:sp>
         <p:nvSpPr>
@@ -11508,6 +11472,10 @@
           </a:solidFill>
           <a:ln/>
         </p:spPr>
+        <p:txBody>
+          <a:bodyPr/>
+          <a:p/>
+        </p:txBody>
       </p:sp>
       <p:sp>
         <p:nvSpPr>
@@ -11569,6 +11537,10 @@
           </a:solidFill>
           <a:ln/>
         </p:spPr>
+        <p:txBody>
+          <a:bodyPr/>
+          <a:p/>
+        </p:txBody>
       </p:sp>
       <p:sp>
         <p:nvSpPr>
@@ -11630,6 +11602,10 @@
           </a:solidFill>
           <a:ln/>
         </p:spPr>
+        <p:txBody>
+          <a:bodyPr/>
+          <a:p/>
+        </p:txBody>
       </p:sp>
       <p:sp>
         <p:nvSpPr>
@@ -11691,6 +11667,10 @@
           </a:solidFill>
           <a:ln/>
         </p:spPr>
+        <p:txBody>
+          <a:bodyPr/>
+          <a:p/>
+        </p:txBody>
       </p:sp>
       <p:sp>
         <p:nvSpPr>
@@ -11752,6 +11732,10 @@
           </a:solidFill>
           <a:ln/>
         </p:spPr>
+        <p:txBody>
+          <a:bodyPr/>
+          <a:p/>
+        </p:txBody>
       </p:sp>
       <p:sp>
         <p:nvSpPr>
@@ -11813,6 +11797,10 @@
           </a:solidFill>
           <a:ln/>
         </p:spPr>
+        <p:txBody>
+          <a:bodyPr/>
+          <a:p/>
+        </p:txBody>
       </p:sp>
       <p:sp>
         <p:nvSpPr>
@@ -11874,6 +11862,10 @@
           </a:solidFill>
           <a:ln/>
         </p:spPr>
+        <p:txBody>
+          <a:bodyPr/>
+          <a:p/>
+        </p:txBody>
       </p:sp>
       <p:sp>
         <p:nvSpPr>
@@ -11935,6 +11927,10 @@
           </a:solidFill>
           <a:ln/>
         </p:spPr>
+        <p:txBody>
+          <a:bodyPr/>
+          <a:p/>
+        </p:txBody>
       </p:sp>
       <p:sp>
         <p:nvSpPr>
@@ -11996,6 +11992,10 @@
           </a:solidFill>
           <a:ln/>
         </p:spPr>
+        <p:txBody>
+          <a:bodyPr/>
+          <a:p/>
+        </p:txBody>
       </p:sp>
       <p:sp>
         <p:nvSpPr>
@@ -12057,6 +12057,10 @@
           </a:solidFill>
           <a:ln/>
         </p:spPr>
+        <p:txBody>
+          <a:bodyPr/>
+          <a:p/>
+        </p:txBody>
       </p:sp>
       <p:sp>
         <p:nvSpPr>
@@ -12077,6 +12081,10 @@
           </a:solidFill>
           <a:ln/>
         </p:spPr>
+        <p:txBody>
+          <a:bodyPr/>
+          <a:p/>
+        </p:txBody>
       </p:sp>
       <p:sp>
         <p:nvSpPr>
@@ -12138,6 +12146,10 @@
           </a:solidFill>
           <a:ln/>
         </p:spPr>
+        <p:txBody>
+          <a:bodyPr/>
+          <a:p/>
+        </p:txBody>
       </p:sp>
       <p:sp>
         <p:nvSpPr>
@@ -12199,6 +12211,10 @@
           </a:solidFill>
           <a:ln/>
         </p:spPr>
+        <p:txBody>
+          <a:bodyPr/>
+          <a:p/>
+        </p:txBody>
       </p:sp>
       <p:sp>
         <p:nvSpPr>
@@ -12260,6 +12276,10 @@
           </a:solidFill>
           <a:ln/>
         </p:spPr>
+        <p:txBody>
+          <a:bodyPr/>
+          <a:p/>
+        </p:txBody>
       </p:sp>
       <p:sp>
         <p:nvSpPr>
@@ -12321,6 +12341,10 @@
           </a:solidFill>
           <a:ln/>
         </p:spPr>
+        <p:txBody>
+          <a:bodyPr/>
+          <a:p/>
+        </p:txBody>
       </p:sp>
       <p:sp>
         <p:nvSpPr>
@@ -12382,6 +12406,10 @@
           </a:solidFill>
           <a:ln/>
         </p:spPr>
+        <p:txBody>
+          <a:bodyPr/>
+          <a:p/>
+        </p:txBody>
       </p:sp>
       <p:sp>
         <p:nvSpPr>
@@ -13237,7 +13265,7 @@
                 <a:ea typeface="Arial" pitchFamily="34" charset="-122"/>
                 <a:cs typeface="Arial" pitchFamily="34" charset="-120"/>
               </a:rPr>
-              <a:t>Tied for #1 on the public leaderboard — no leak, no protected attributes.</a:t>
+              <a:t>0.8565 public accuracy — no leak, no protected attributes.</a:t>
             </a:r>
             <a:endParaRPr lang="en-US" sz="2250" dirty="0"/>
           </a:p>

</xml_diff>

<commit_message>
Add 'Features we engineered' slide (09) pairing with the importance chart
Explains the engineered-feature names shown on slide 8: risk_mean/max, risk_dev,
amt_to_income, total/log income, credit_z, missingness flags, year/month.
Styled table in deck palette; subsequent slides renumbered to 10-14.
</commit_message>
<xml_diff>
--- a/presentation/Consulting_Finance_ML_Slides.pptx
+++ b/presentation/Consulting_Finance_ML_Slides.pptx
@@ -16,6 +16,7 @@
     <p:sldId id="261" r:id="rId7"/>
     <p:sldId id="262" r:id="rId8"/>
     <p:sldId id="263" r:id="rId9"/>
+    <p:sldId id="269" r:id="rId20"/>
     <p:sldId id="264" r:id="rId10"/>
     <p:sldId id="265" r:id="rId11"/>
     <p:sldId id="266" r:id="rId12"/>
@@ -2006,7 +2007,7 @@
                 <a:ea typeface="Courier New" pitchFamily="34" charset="-122"/>
                 <a:cs typeface="Courier New" pitchFamily="34" charset="-120"/>
               </a:rPr>
-              <a:t>10 · WHAT WE LEARNED</a:t>
+              <a:t>11 · WHAT WE LEARNED</a:t>
             </a:r>
             <a:endParaRPr lang="en-US" sz="1800" dirty="0"/>
           </a:p>
@@ -2816,7 +2817,7 @@
                 <a:ea typeface="Courier New" pitchFamily="34" charset="-122"/>
                 <a:cs typeface="Courier New" pitchFamily="34" charset="-120"/>
               </a:rPr>
-              <a:t>11 · WHAT COMES NEXT</a:t>
+              <a:t>12 · WHAT COMES NEXT</a:t>
             </a:r>
             <a:endParaRPr lang="en-US" sz="1800" dirty="0"/>
           </a:p>
@@ -3642,7 +3643,7 @@
                 <a:ea typeface="Courier New" pitchFamily="34" charset="-122"/>
                 <a:cs typeface="Courier New" pitchFamily="34" charset="-120"/>
               </a:rPr>
-              <a:t>12 · KEY CODE</a:t>
+              <a:t>13 · KEY CODE</a:t>
             </a:r>
             <a:endParaRPr lang="en-US" sz="1800" dirty="0"/>
           </a:p>
@@ -4347,7 +4348,7 @@
                 <a:ea typeface="Courier New" pitchFamily="34" charset="-122"/>
                 <a:cs typeface="Courier New" pitchFamily="34" charset="-120"/>
               </a:rPr>
-              <a:t>13 · QUESTIONS</a:t>
+              <a:t>14 · QUESTIONS</a:t>
             </a:r>
             <a:endParaRPr lang="en-US" sz="1800" dirty="0"/>
           </a:p>
@@ -4885,6 +4886,799 @@
           </a:p>
         </p:txBody>
       </p:sp>
+    </p:spTree>
+  </p:cSld>
+  <p:clrMapOvr>
+    <a:masterClrMapping/>
+  </p:clrMapOvr>
+</p:sld>
+</file>
+
+<file path=ppt/slides/slide14.xml><?xml version="1.0" encoding="utf-8"?>
+<p:sld xmlns:a="http://schemas.openxmlformats.org/drawingml/2006/main" xmlns:p="http://schemas.openxmlformats.org/presentationml/2006/main" xmlns:r="http://schemas.openxmlformats.org/officeDocument/2006/relationships">
+  <p:cSld>
+    <p:spTree>
+      <p:nvGrpSpPr>
+        <p:cNvPr id="1" name=""/>
+        <p:cNvGrpSpPr/>
+        <p:nvPr/>
+      </p:nvGrpSpPr>
+      <p:grpSpPr/>
+      <p:sp>
+        <p:nvSpPr>
+          <p:cNvPr id="2" name="Shape 0"/>
+          <p:cNvSpPr/>
+          <p:nvPr/>
+        </p:nvSpPr>
+        <p:spPr>
+          <a:xfrm>
+            <a:off x="952500" y="1912218"/>
+            <a:ext cx="16383000" cy="19050"/>
+          </a:xfrm>
+          <a:prstGeom prst="rect">
+            <a:avLst/>
+          </a:prstGeom>
+          <a:solidFill>
+            <a:srgbClr val="1A7A57"/>
+          </a:solidFill>
+          <a:ln/>
+        </p:spPr>
+        <p:txBody>
+          <a:bodyPr/>
+          <a:lstStyle/>
+          <a:p>
+            <a:endParaRPr lang="en-GB"/>
+          </a:p>
+        </p:txBody>
+      </p:sp>
+      <p:sp>
+        <p:nvSpPr>
+          <p:cNvPr id="3" name="Text 1"/>
+          <p:cNvSpPr/>
+          <p:nvPr/>
+        </p:nvSpPr>
+        <p:spPr>
+          <a:xfrm>
+            <a:off x="952500" y="742950"/>
+            <a:ext cx="18021300" cy="295275"/>
+          </a:xfrm>
+          <a:prstGeom prst="rect">
+            <a:avLst/>
+          </a:prstGeom>
+          <a:noFill/>
+          <a:ln/>
+        </p:spPr>
+        <p:txBody>
+          <a:bodyPr wrap="square" lIns="25400" tIns="25400" rIns="25400" bIns="25400" rtlCol="0" anchor="t">
+            <a:normAutofit fontScale="92500" lnSpcReduction="10000"/>
+          </a:bodyPr>
+          <a:lstStyle/>
+          <a:p>
+            <a:pPr marL="0" indent="0" algn="l">
+              <a:buNone/>
+            </a:pPr>
+            <a:r>
+              <a:rPr lang="en-US" sz="1800" kern="0" spc="225" dirty="0">
+                <a:solidFill>
+                  <a:srgbClr val="007A33"/>
+                </a:solidFill>
+                <a:latin typeface="Courier New" pitchFamily="34" charset="0"/>
+                <a:ea typeface="Courier New" pitchFamily="34" charset="-122"/>
+                <a:cs typeface="Courier New" pitchFamily="34" charset="-120"/>
+              </a:rPr>
+              <a:t>09 · FEATURES WE BUILT</a:t>
+            </a:r>
+            <a:endParaRPr lang="en-US" sz="1800" dirty="0"/>
+          </a:p>
+        </p:txBody>
+      </p:sp>
+      <p:sp>
+        <p:nvSpPr>
+          <p:cNvPr id="4" name="Text 2"/>
+          <p:cNvSpPr/>
+          <p:nvPr/>
+        </p:nvSpPr>
+        <p:spPr>
+          <a:xfrm>
+            <a:off x="952500" y="1152525"/>
+            <a:ext cx="18021300" cy="550143"/>
+          </a:xfrm>
+          <a:prstGeom prst="rect">
+            <a:avLst/>
+          </a:prstGeom>
+          <a:noFill/>
+          <a:ln/>
+        </p:spPr>
+        <p:txBody>
+          <a:bodyPr wrap="square" lIns="25400" tIns="25400" rIns="25400" bIns="25400" rtlCol="0" anchor="t">
+            <a:normAutofit fontScale="92500" lnSpcReduction="10000"/>
+          </a:bodyPr>
+          <a:lstStyle/>
+          <a:p>
+            <a:pPr marL="0" indent="0" algn="l">
+              <a:lnSpc>
+                <a:spcPct val="112000"/>
+              </a:lnSpc>
+              <a:buNone/>
+            </a:pPr>
+            <a:r>
+              <a:rPr lang="en-US" sz="3600" b="1" kern="0" spc="-37" dirty="0">
+                <a:solidFill>
+                  <a:srgbClr val="063D22"/>
+                </a:solidFill>
+                <a:latin typeface="Arial" pitchFamily="34" charset="0"/>
+                <a:ea typeface="Arial" pitchFamily="34" charset="-122"/>
+                <a:cs typeface="Arial" pitchFamily="34" charset="-120"/>
+              </a:rPr>
+              <a:t>The features we engineered</a:t>
+            </a:r>
+            <a:endParaRPr lang="en-US" sz="3600" dirty="0"/>
+          </a:p>
+        </p:txBody>
+      </p:sp>
+      <p:sp>
+        <p:nvSpPr>
+          <p:cNvPr id="20" name="Shape 18"/>
+          <p:cNvSpPr/>
+          <p:nvPr/>
+        </p:nvSpPr>
+        <p:spPr>
+          <a:xfrm>
+            <a:off x="952500" y="9239250"/>
+            <a:ext cx="16383000" cy="9525"/>
+          </a:xfrm>
+          <a:prstGeom prst="rect">
+            <a:avLst/>
+          </a:prstGeom>
+          <a:solidFill>
+            <a:srgbClr val="D2E6DD"/>
+          </a:solidFill>
+          <a:ln/>
+        </p:spPr>
+        <p:txBody>
+          <a:bodyPr/>
+          <a:lstStyle/>
+          <a:p>
+            <a:endParaRPr lang="en-GB"/>
+          </a:p>
+        </p:txBody>
+      </p:sp>
+      <p:sp>
+        <p:nvSpPr>
+          <p:cNvPr id="21" name="Text 19"/>
+          <p:cNvSpPr/>
+          <p:nvPr/>
+        </p:nvSpPr>
+        <p:spPr>
+          <a:xfrm>
+            <a:off x="952500" y="9458325"/>
+            <a:ext cx="16874490" cy="295275"/>
+          </a:xfrm>
+          <a:prstGeom prst="rect">
+            <a:avLst/>
+          </a:prstGeom>
+          <a:noFill/>
+          <a:ln/>
+        </p:spPr>
+        <p:txBody>
+          <a:bodyPr wrap="square" lIns="25400" tIns="25400" rIns="25400" bIns="25400" rtlCol="0" anchor="t">
+            <a:normAutofit fontScale="92500" lnSpcReduction="10000"/>
+          </a:bodyPr>
+          <a:lstStyle/>
+          <a:p>
+            <a:pPr marL="0" indent="0" algn="l">
+              <a:buNone/>
+            </a:pPr>
+            <a:r>
+              <a:rPr lang="en-US" sz="1800" dirty="0">
+                <a:solidFill>
+                  <a:srgbClr val="5C7268"/>
+                </a:solidFill>
+                <a:latin typeface="Courier New" pitchFamily="34" charset="0"/>
+                <a:ea typeface="Courier New" pitchFamily="34" charset="-122"/>
+                <a:cs typeface="Courier New" pitchFamily="34" charset="-120"/>
+              </a:rPr>
+              <a:t>Source: src/prep.py · engineered features ranked on slide 8</a:t>
+            </a:r>
+            <a:endParaRPr lang="en-US" sz="1800" dirty="0"/>
+          </a:p>
+        </p:txBody>
+      </p:sp>
+      <p:graphicFrame>
+        <p:nvGraphicFramePr>
+          <p:cNvPr id="22" name="Table 21"/>
+          <p:cNvGraphicFramePr>
+            <a:graphicFrameLocks noGrp="1"/>
+          </p:cNvGraphicFramePr>
+          <p:nvPr/>
+        </p:nvGraphicFramePr>
+        <p:xfrm>
+          <a:off x="950976" y="2468880"/>
+          <a:ext cx="16367760" cy="6035040"/>
+        </p:xfrm>
+        <a:graphic>
+          <a:graphicData uri="http://schemas.openxmlformats.org/drawingml/2006/table">
+            <a:tbl>
+              <a:tblPr>
+                <a:tableStyleId>{5C22544A-7EE6-4342-B048-85BDC9FD1C3A}</a:tableStyleId>
+              </a:tblPr>
+              <a:tblGrid>
+                <a:gridCol w="3931920"/>
+                <a:gridCol w="5943600"/>
+                <a:gridCol w="6492240"/>
+              </a:tblGrid>
+              <a:tr h="754380">
+                <a:tc>
+                  <a:txBody>
+                    <a:bodyPr wrap="square"/>
+                    <a:lstStyle/>
+                    <a:p>
+                      <a:pPr algn="l"/>
+                      <a:r>
+                        <a:rPr sz="1700" b="1">
+                          <a:solidFill>
+                            <a:srgbClr val="FFFFFF"/>
+                          </a:solidFill>
+                          <a:latin typeface="Arial"/>
+                        </a:rPr>
+                        <a:t>Feature</a:t>
+                      </a:r>
+                    </a:p>
+                  </a:txBody>
+                  <a:tcPr anchor="ctr" marL="164592" marT="54864" marB="54864">
+                    <a:solidFill>
+                      <a:srgbClr val="063D22"/>
+                    </a:solidFill>
+                  </a:tcPr>
+                </a:tc>
+                <a:tc>
+                  <a:txBody>
+                    <a:bodyPr wrap="square"/>
+                    <a:lstStyle/>
+                    <a:p>
+                      <a:pPr algn="l"/>
+                      <a:r>
+                        <a:rPr sz="1700" b="1">
+                          <a:solidFill>
+                            <a:srgbClr val="FFFFFF"/>
+                          </a:solidFill>
+                          <a:latin typeface="Arial"/>
+                        </a:rPr>
+                        <a:t>How we built it</a:t>
+                      </a:r>
+                    </a:p>
+                  </a:txBody>
+                  <a:tcPr anchor="ctr" marL="164592" marT="54864" marB="54864">
+                    <a:solidFill>
+                      <a:srgbClr val="063D22"/>
+                    </a:solidFill>
+                  </a:tcPr>
+                </a:tc>
+                <a:tc>
+                  <a:txBody>
+                    <a:bodyPr wrap="square"/>
+                    <a:lstStyle/>
+                    <a:p>
+                      <a:pPr algn="l"/>
+                      <a:r>
+                        <a:rPr sz="1700" b="1">
+                          <a:solidFill>
+                            <a:srgbClr val="FFFFFF"/>
+                          </a:solidFill>
+                          <a:latin typeface="Arial"/>
+                        </a:rPr>
+                        <a:t>Why it helps</a:t>
+                      </a:r>
+                    </a:p>
+                  </a:txBody>
+                  <a:tcPr anchor="ctr" marL="164592" marT="54864" marB="54864">
+                    <a:solidFill>
+                      <a:srgbClr val="063D22"/>
+                    </a:solidFill>
+                  </a:tcPr>
+                </a:tc>
+              </a:tr>
+              <a:tr h="754380">
+                <a:tc>
+                  <a:txBody>
+                    <a:bodyPr wrap="square"/>
+                    <a:lstStyle/>
+                    <a:p>
+                      <a:pPr algn="l"/>
+                      <a:r>
+                        <a:rPr sz="1500">
+                          <a:solidFill>
+                            <a:srgbClr val="14533B"/>
+                          </a:solidFill>
+                          <a:latin typeface="Courier New"/>
+                        </a:rPr>
+                        <a:t>risk_mean · risk_max</a:t>
+                      </a:r>
+                    </a:p>
+                  </a:txBody>
+                  <a:tcPr anchor="ctr" marL="164592" marT="54864" marB="54864">
+                    <a:solidFill>
+                      <a:srgbClr val="EAF3EF"/>
+                    </a:solidFill>
+                  </a:tcPr>
+                </a:tc>
+                <a:tc>
+                  <a:txBody>
+                    <a:bodyPr wrap="square"/>
+                    <a:lstStyle/>
+                    <a:p>
+                      <a:pPr algn="l"/>
+                      <a:r>
+                        <a:rPr sz="1500">
+                          <a:solidFill>
+                            <a:srgbClr val="14533B"/>
+                          </a:solidFill>
+                          <a:latin typeface="Courier New"/>
+                        </a:rPr>
+                        <a:t>mean &amp; max of the two risk indicators</a:t>
+                      </a:r>
+                    </a:p>
+                  </a:txBody>
+                  <a:tcPr anchor="ctr" marL="164592" marT="54864" marB="54864">
+                    <a:solidFill>
+                      <a:srgbClr val="EAF3EF"/>
+                    </a:solidFill>
+                  </a:tcPr>
+                </a:tc>
+                <a:tc>
+                  <a:txBody>
+                    <a:bodyPr wrap="square"/>
+                    <a:lstStyle/>
+                    <a:p>
+                      <a:pPr algn="l"/>
+                      <a:r>
+                        <a:rPr sz="1500">
+                          <a:solidFill>
+                            <a:srgbClr val="5C7268"/>
+                          </a:solidFill>
+                          <a:latin typeface="Arial"/>
+                        </a:rPr>
+                        <a:t>Combine both risk sources</a:t>
+                      </a:r>
+                    </a:p>
+                  </a:txBody>
+                  <a:tcPr anchor="ctr" marL="164592" marT="54864" marB="54864">
+                    <a:solidFill>
+                      <a:srgbClr val="EAF3EF"/>
+                    </a:solidFill>
+                  </a:tcPr>
+                </a:tc>
+              </a:tr>
+              <a:tr h="754380">
+                <a:tc>
+                  <a:txBody>
+                    <a:bodyPr wrap="square"/>
+                    <a:lstStyle/>
+                    <a:p>
+                      <a:pPr algn="l"/>
+                      <a:r>
+                        <a:rPr sz="1500">
+                          <a:solidFill>
+                            <a:srgbClr val="14533B"/>
+                          </a:solidFill>
+                          <a:latin typeface="Courier New"/>
+                        </a:rPr>
+                        <a:t>risk_dev</a:t>
+                      </a:r>
+                    </a:p>
+                  </a:txBody>
+                  <a:tcPr anchor="ctr" marL="164592" marT="54864" marB="54864">
+                    <a:solidFill>
+                      <a:srgbClr val="FFFFFF"/>
+                    </a:solidFill>
+                  </a:tcPr>
+                </a:tc>
+                <a:tc>
+                  <a:txBody>
+                    <a:bodyPr wrap="square"/>
+                    <a:lstStyle/>
+                    <a:p>
+                      <a:pPr algn="l"/>
+                      <a:r>
+                        <a:rPr sz="1500">
+                          <a:solidFill>
+                            <a:srgbClr val="14533B"/>
+                          </a:solidFill>
+                          <a:latin typeface="Courier New"/>
+                        </a:rPr>
+                        <a:t>distance from the middle:  |risk - 55|</a:t>
+                      </a:r>
+                    </a:p>
+                  </a:txBody>
+                  <a:tcPr anchor="ctr" marL="164592" marT="54864" marB="54864">
+                    <a:solidFill>
+                      <a:srgbClr val="FFFFFF"/>
+                    </a:solidFill>
+                  </a:tcPr>
+                </a:tc>
+                <a:tc>
+                  <a:txBody>
+                    <a:bodyPr wrap="square"/>
+                    <a:lstStyle/>
+                    <a:p>
+                      <a:pPr algn="l"/>
+                      <a:r>
+                        <a:rPr sz="1500">
+                          <a:solidFill>
+                            <a:srgbClr val="5C7268"/>
+                          </a:solidFill>
+                          <a:latin typeface="Arial"/>
+                        </a:rPr>
+                        <a:t>Turns the risk hump into usable signal</a:t>
+                      </a:r>
+                    </a:p>
+                  </a:txBody>
+                  <a:tcPr anchor="ctr" marL="164592" marT="54864" marB="54864">
+                    <a:solidFill>
+                      <a:srgbClr val="FFFFFF"/>
+                    </a:solidFill>
+                  </a:tcPr>
+                </a:tc>
+              </a:tr>
+              <a:tr h="754380">
+                <a:tc>
+                  <a:txBody>
+                    <a:bodyPr wrap="square"/>
+                    <a:lstStyle/>
+                    <a:p>
+                      <a:pPr algn="l"/>
+                      <a:r>
+                        <a:rPr sz="1500">
+                          <a:solidFill>
+                            <a:srgbClr val="14533B"/>
+                          </a:solidFill>
+                          <a:latin typeface="Courier New"/>
+                        </a:rPr>
+                        <a:t>amt_to_income</a:t>
+                      </a:r>
+                    </a:p>
+                  </a:txBody>
+                  <a:tcPr anchor="ctr" marL="164592" marT="54864" marB="54864">
+                    <a:solidFill>
+                      <a:srgbClr val="EAF3EF"/>
+                    </a:solidFill>
+                  </a:tcPr>
+                </a:tc>
+                <a:tc>
+                  <a:txBody>
+                    <a:bodyPr wrap="square"/>
+                    <a:lstStyle/>
+                    <a:p>
+                      <a:pPr algn="l"/>
+                      <a:r>
+                        <a:rPr sz="1500">
+                          <a:solidFill>
+                            <a:srgbClr val="14533B"/>
+                          </a:solidFill>
+                          <a:latin typeface="Courier New"/>
+                        </a:rPr>
+                        <a:t>amount / (total_income + 1)</a:t>
+                      </a:r>
+                    </a:p>
+                  </a:txBody>
+                  <a:tcPr anchor="ctr" marL="164592" marT="54864" marB="54864">
+                    <a:solidFill>
+                      <a:srgbClr val="EAF3EF"/>
+                    </a:solidFill>
+                  </a:tcPr>
+                </a:tc>
+                <a:tc>
+                  <a:txBody>
+                    <a:bodyPr wrap="square"/>
+                    <a:lstStyle/>
+                    <a:p>
+                      <a:pPr algn="l"/>
+                      <a:r>
+                        <a:rPr sz="1500">
+                          <a:solidFill>
+                            <a:srgbClr val="5C7268"/>
+                          </a:solidFill>
+                          <a:latin typeface="Arial"/>
+                        </a:rPr>
+                        <a:t>Affordability ratio — a credit standard</a:t>
+                      </a:r>
+                    </a:p>
+                  </a:txBody>
+                  <a:tcPr anchor="ctr" marL="164592" marT="54864" marB="54864">
+                    <a:solidFill>
+                      <a:srgbClr val="EAF3EF"/>
+                    </a:solidFill>
+                  </a:tcPr>
+                </a:tc>
+              </a:tr>
+              <a:tr h="754380">
+                <a:tc>
+                  <a:txBody>
+                    <a:bodyPr wrap="square"/>
+                    <a:lstStyle/>
+                    <a:p>
+                      <a:pPr algn="l"/>
+                      <a:r>
+                        <a:rPr sz="1500">
+                          <a:solidFill>
+                            <a:srgbClr val="14533B"/>
+                          </a:solidFill>
+                          <a:latin typeface="Courier New"/>
+                        </a:rPr>
+                        <a:t>total_income · log_income</a:t>
+                      </a:r>
+                    </a:p>
+                  </a:txBody>
+                  <a:tcPr anchor="ctr" marL="164592" marT="54864" marB="54864">
+                    <a:solidFill>
+                      <a:srgbClr val="FFFFFF"/>
+                    </a:solidFill>
+                  </a:tcPr>
+                </a:tc>
+                <a:tc>
+                  <a:txBody>
+                    <a:bodyPr wrap="square"/>
+                    <a:lstStyle/>
+                    <a:p>
+                      <a:pPr algn="l"/>
+                      <a:r>
+                        <a:rPr sz="1500">
+                          <a:solidFill>
+                            <a:srgbClr val="14533B"/>
+                          </a:solidFill>
+                          <a:latin typeface="Courier New"/>
+                        </a:rPr>
+                        <a:t>ann_income + other_income (log-scaled)</a:t>
+                      </a:r>
+                    </a:p>
+                  </a:txBody>
+                  <a:tcPr anchor="ctr" marL="164592" marT="54864" marB="54864">
+                    <a:solidFill>
+                      <a:srgbClr val="FFFFFF"/>
+                    </a:solidFill>
+                  </a:tcPr>
+                </a:tc>
+                <a:tc>
+                  <a:txBody>
+                    <a:bodyPr wrap="square"/>
+                    <a:lstStyle/>
+                    <a:p>
+                      <a:pPr algn="l"/>
+                      <a:r>
+                        <a:rPr sz="1500">
+                          <a:solidFill>
+                            <a:srgbClr val="5C7268"/>
+                          </a:solidFill>
+                          <a:latin typeface="Arial"/>
+                        </a:rPr>
+                        <a:t>Real disposable income</a:t>
+                      </a:r>
+                    </a:p>
+                  </a:txBody>
+                  <a:tcPr anchor="ctr" marL="164592" marT="54864" marB="54864">
+                    <a:solidFill>
+                      <a:srgbClr val="FFFFFF"/>
+                    </a:solidFill>
+                  </a:tcPr>
+                </a:tc>
+              </a:tr>
+              <a:tr h="754380">
+                <a:tc>
+                  <a:txBody>
+                    <a:bodyPr wrap="square"/>
+                    <a:lstStyle/>
+                    <a:p>
+                      <a:pPr algn="l"/>
+                      <a:r>
+                        <a:rPr sz="1500">
+                          <a:solidFill>
+                            <a:srgbClr val="14533B"/>
+                          </a:solidFill>
+                          <a:latin typeface="Courier New"/>
+                        </a:rPr>
+                        <a:t>credit_z</a:t>
+                      </a:r>
+                    </a:p>
+                  </a:txBody>
+                  <a:tcPr anchor="ctr" marL="164592" marT="54864" marB="54864">
+                    <a:solidFill>
+                      <a:srgbClr val="EAF3EF"/>
+                    </a:solidFill>
+                  </a:tcPr>
+                </a:tc>
+                <a:tc>
+                  <a:txBody>
+                    <a:bodyPr wrap="square"/>
+                    <a:lstStyle/>
+                    <a:p>
+                      <a:pPr algn="l"/>
+                      <a:r>
+                        <a:rPr sz="1500">
+                          <a:solidFill>
+                            <a:srgbClr val="14533B"/>
+                          </a:solidFill>
+                          <a:latin typeface="Courier New"/>
+                        </a:rPr>
+                        <a:t>3 bureau scores z-scored &amp; merged</a:t>
+                      </a:r>
+                    </a:p>
+                  </a:txBody>
+                  <a:tcPr anchor="ctr" marL="164592" marT="54864" marB="54864">
+                    <a:solidFill>
+                      <a:srgbClr val="EAF3EF"/>
+                    </a:solidFill>
+                  </a:tcPr>
+                </a:tc>
+                <a:tc>
+                  <a:txBody>
+                    <a:bodyPr wrap="square"/>
+                    <a:lstStyle/>
+                    <a:p>
+                      <a:pPr algn="l"/>
+                      <a:r>
+                        <a:rPr sz="1500">
+                          <a:solidFill>
+                            <a:srgbClr val="5C7268"/>
+                          </a:solidFill>
+                          <a:latin typeface="Arial"/>
+                        </a:rPr>
+                        <a:t>One comparable score from 3 scales</a:t>
+                      </a:r>
+                    </a:p>
+                  </a:txBody>
+                  <a:tcPr anchor="ctr" marL="164592" marT="54864" marB="54864">
+                    <a:solidFill>
+                      <a:srgbClr val="EAF3EF"/>
+                    </a:solidFill>
+                  </a:tcPr>
+                </a:tc>
+              </a:tr>
+              <a:tr h="754380">
+                <a:tc>
+                  <a:txBody>
+                    <a:bodyPr wrap="square"/>
+                    <a:lstStyle/>
+                    <a:p>
+                      <a:pPr algn="l"/>
+                      <a:r>
+                        <a:rPr sz="1500">
+                          <a:solidFill>
+                            <a:srgbClr val="14533B"/>
+                          </a:solidFill>
+                          <a:latin typeface="Courier New"/>
+                        </a:rPr>
+                        <a:t>has_score · *_missing</a:t>
+                      </a:r>
+                    </a:p>
+                  </a:txBody>
+                  <a:tcPr anchor="ctr" marL="164592" marT="54864" marB="54864">
+                    <a:solidFill>
+                      <a:srgbClr val="FFFFFF"/>
+                    </a:solidFill>
+                  </a:tcPr>
+                </a:tc>
+                <a:tc>
+                  <a:txBody>
+                    <a:bodyPr wrap="square"/>
+                    <a:lstStyle/>
+                    <a:p>
+                      <a:pPr algn="l"/>
+                      <a:r>
+                        <a:rPr sz="1500">
+                          <a:solidFill>
+                            <a:srgbClr val="14533B"/>
+                          </a:solidFill>
+                          <a:latin typeface="Courier New"/>
+                        </a:rPr>
+                        <a:t>binary 0/1 flags</a:t>
+                      </a:r>
+                    </a:p>
+                  </a:txBody>
+                  <a:tcPr anchor="ctr" marL="164592" marT="54864" marB="54864">
+                    <a:solidFill>
+                      <a:srgbClr val="FFFFFF"/>
+                    </a:solidFill>
+                  </a:tcPr>
+                </a:tc>
+                <a:tc>
+                  <a:txBody>
+                    <a:bodyPr wrap="square"/>
+                    <a:lstStyle/>
+                    <a:p>
+                      <a:pPr algn="l"/>
+                      <a:r>
+                        <a:rPr sz="1500">
+                          <a:solidFill>
+                            <a:srgbClr val="5C7268"/>
+                          </a:solidFill>
+                          <a:latin typeface="Arial"/>
+                        </a:rPr>
+                        <a:t>“Value absent” is itself a signal</a:t>
+                      </a:r>
+                    </a:p>
+                  </a:txBody>
+                  <a:tcPr anchor="ctr" marL="164592" marT="54864" marB="54864">
+                    <a:solidFill>
+                      <a:srgbClr val="FFFFFF"/>
+                    </a:solidFill>
+                  </a:tcPr>
+                </a:tc>
+              </a:tr>
+              <a:tr h="754380">
+                <a:tc>
+                  <a:txBody>
+                    <a:bodyPr wrap="square"/>
+                    <a:lstStyle/>
+                    <a:p>
+                      <a:pPr algn="l"/>
+                      <a:r>
+                        <a:rPr sz="1500">
+                          <a:solidFill>
+                            <a:srgbClr val="14533B"/>
+                          </a:solidFill>
+                          <a:latin typeface="Courier New"/>
+                        </a:rPr>
+                        <a:t>year · month</a:t>
+                      </a:r>
+                    </a:p>
+                  </a:txBody>
+                  <a:tcPr anchor="ctr" marL="164592" marT="54864" marB="54864">
+                    <a:solidFill>
+                      <a:srgbClr val="EAF3EF"/>
+                    </a:solidFill>
+                  </a:tcPr>
+                </a:tc>
+                <a:tc>
+                  <a:txBody>
+                    <a:bodyPr wrap="square"/>
+                    <a:lstStyle/>
+                    <a:p>
+                      <a:pPr algn="l"/>
+                      <a:r>
+                        <a:rPr sz="1500">
+                          <a:solidFill>
+                            <a:srgbClr val="14533B"/>
+                          </a:solidFill>
+                          <a:latin typeface="Courier New"/>
+                        </a:rPr>
+                        <a:t>parsed from the date</a:t>
+                      </a:r>
+                    </a:p>
+                  </a:txBody>
+                  <a:tcPr anchor="ctr" marL="164592" marT="54864" marB="54864">
+                    <a:solidFill>
+                      <a:srgbClr val="EAF3EF"/>
+                    </a:solidFill>
+                  </a:tcPr>
+                </a:tc>
+                <a:tc>
+                  <a:txBody>
+                    <a:bodyPr wrap="square"/>
+                    <a:lstStyle/>
+                    <a:p>
+                      <a:pPr algn="l"/>
+                      <a:r>
+                        <a:rPr sz="1500">
+                          <a:solidFill>
+                            <a:srgbClr val="5C7268"/>
+                          </a:solidFill>
+                          <a:latin typeface="Arial"/>
+                        </a:rPr>
+                        <a:t>Captures the downward 2026 approval trend</a:t>
+                      </a:r>
+                    </a:p>
+                  </a:txBody>
+                  <a:tcPr anchor="ctr" marL="164592" marT="54864" marB="54864">
+                    <a:solidFill>
+                      <a:srgbClr val="EAF3EF"/>
+                    </a:solidFill>
+                  </a:tcPr>
+                </a:tc>
+              </a:tr>
+            </a:tbl>
+          </a:graphicData>
+        </a:graphic>
+      </p:graphicFrame>
     </p:spTree>
   </p:cSld>
   <p:clrMapOvr>
@@ -11641,7 +12435,7 @@
                 <a:ea typeface="Courier New" pitchFamily="34" charset="-122"/>
                 <a:cs typeface="Courier New" pitchFamily="34" charset="-120"/>
               </a:rPr>
-              <a:t>09 · RESULTS</a:t>
+              <a:t>10 · RESULTS</a:t>
             </a:r>
             <a:endParaRPr lang="en-US" sz="1800" dirty="0"/>
           </a:p>

</xml_diff>

<commit_message>
Slide 8: add 'Final model' callout (ensemble LGBM+XGB+CatBoost -> 0.859)
Fixes the ambiguity that the bar chart's LightGBM 0.836 looked like the final model.
Bars now clearly = model selection; callout = the shipped ensemble.
</commit_message>
<xml_diff>
--- a/presentation/Consulting_Finance_ML_Slides.pptx
+++ b/presentation/Consulting_Finance_ML_Slides.pptx
@@ -13915,6 +13915,95 @@
           </a:prstGeom>
         </p:spPr>
       </p:pic>
+      <p:sp>
+        <p:nvSpPr>
+          <p:cNvPr id="42" name="Rounded Rectangle 41"/>
+          <p:cNvSpPr/>
+          <p:nvPr/>
+        </p:nvSpPr>
+        <p:spPr>
+          <a:xfrm>
+            <a:off x="950976" y="6967728"/>
+            <a:ext cx="8595360" cy="1207008"/>
+          </a:xfrm>
+          <a:prstGeom prst="roundRect">
+            <a:avLst/>
+          </a:prstGeom>
+          <a:solidFill>
+            <a:srgbClr val="063D22"/>
+          </a:solidFill>
+          <a:ln>
+            <a:noFill/>
+          </a:ln>
+          <a:effectLst/>
+        </p:spPr>
+        <p:style>
+          <a:lnRef idx="1">
+            <a:schemeClr val="accent1"/>
+          </a:lnRef>
+          <a:fillRef idx="3">
+            <a:schemeClr val="accent1"/>
+          </a:fillRef>
+          <a:effectRef idx="2">
+            <a:schemeClr val="accent1"/>
+          </a:effectRef>
+          <a:fontRef idx="minor">
+            <a:schemeClr val="lt1"/>
+          </a:fontRef>
+        </p:style>
+        <p:txBody>
+          <a:bodyPr rtlCol="0" anchor="ctr" wrap="square" lIns="274320" tIns="146304" rIns="182880" bIns="109728"/>
+          <a:lstStyle/>
+          <a:p>
+            <a:pPr algn="l">
+              <a:spcAft>
+                <a:spcPts val="300"/>
+              </a:spcAft>
+            </a:pPr>
+            <a:r>
+              <a:rPr sz="1300" b="0">
+                <a:solidFill>
+                  <a:srgbClr val="8FD0BB"/>
+                </a:solidFill>
+                <a:latin typeface="Courier New"/>
+              </a:rPr>
+              <a:t>FINAL MODEL</a:t>
+            </a:r>
+          </a:p>
+          <a:p>
+            <a:pPr algn="l">
+              <a:spcAft>
+                <a:spcPts val="300"/>
+              </a:spcAft>
+            </a:pPr>
+            <a:r>
+              <a:rPr sz="1700" b="1">
+                <a:solidFill>
+                  <a:srgbClr val="FFFFFF"/>
+                </a:solidFill>
+                <a:latin typeface="Arial"/>
+              </a:rPr>
+              <a:t>Ensemble — LightGBM + XGBoost + CatBoost</a:t>
+            </a:r>
+          </a:p>
+          <a:p>
+            <a:pPr algn="l">
+              <a:spcAft>
+                <a:spcPts val="300"/>
+              </a:spcAft>
+            </a:pPr>
+            <a:r>
+              <a:rPr sz="1400" b="0">
+                <a:solidFill>
+                  <a:srgbClr val="BCDDCE"/>
+                </a:solidFill>
+                <a:latin typeface="Arial"/>
+              </a:rPr>
+              <a:t>+ pseudo-labeling &amp; smooth threshold  →  0.859 accuracy</a:t>
+            </a:r>
+          </a:p>
+        </p:txBody>
+      </p:sp>
     </p:spTree>
   </p:cSld>
   <p:clrMapOvr>

</xml_diff>

<commit_message>
Rebuild slide 8 as model-architecture diagram
Replaced the model bake-off bars + adversarial-validation box (per feedback, not
useful for the audience) with a clear pipeline: clean X (20 feats) -> 9 LGBM + 3 XGB
+ 4 CatBoost -> mean blend (16->1) -> smooth cutoff, plus the pseudo-labeling pass.
Kept the feature-importance chart (the part worth showing).
</commit_message>
<xml_diff>
--- a/presentation/Consulting_Finance_ML_Slides.pptx
+++ b/presentation/Consulting_Finance_ML_Slides.pptx
@@ -12516,7 +12516,7 @@
                 <a:ea typeface="Arial" pitchFamily="34" charset="-122"/>
                 <a:cs typeface="Arial" pitchFamily="34" charset="-120"/>
               </a:rPr>
-              <a:t>We judged every model on next-month accuracy, not the leaderboard</a:t>
+              <a:t>How our model turns features into a decision</a:t>
             </a:r>
             <a:endParaRPr lang="en-US" sz="3600" dirty="0"/>
           </a:p>
@@ -12524,14 +12524,41 @@
       </p:sp>
       <p:sp>
         <p:nvSpPr>
-          <p:cNvPr id="5" name="Text 3"/>
-          <p:cNvSpPr/>
-          <p:nvPr/>
-        </p:nvSpPr>
-        <p:spPr>
-          <a:xfrm>
-            <a:off x="952500" y="2350368"/>
-            <a:ext cx="9620228" cy="295275"/>
+          <p:cNvPr id="39" name="Shape 37"/>
+          <p:cNvSpPr/>
+          <p:nvPr/>
+        </p:nvSpPr>
+        <p:spPr>
+          <a:xfrm>
+            <a:off x="952500" y="9239250"/>
+            <a:ext cx="16383000" cy="9525"/>
+          </a:xfrm>
+          <a:prstGeom prst="rect">
+            <a:avLst/>
+          </a:prstGeom>
+          <a:solidFill>
+            <a:srgbClr val="D2E6DD"/>
+          </a:solidFill>
+          <a:ln/>
+        </p:spPr>
+        <p:txBody>
+          <a:bodyPr/>
+          <a:lstStyle/>
+          <a:p>
+            <a:endParaRPr lang="en-GB"/>
+          </a:p>
+        </p:txBody>
+      </p:sp>
+      <p:sp>
+        <p:nvSpPr>
+          <p:cNvPr id="40" name="Text 38"/>
+          <p:cNvSpPr/>
+          <p:nvPr/>
+        </p:nvSpPr>
+        <p:spPr>
+          <a:xfrm>
+            <a:off x="952500" y="9458325"/>
+            <a:ext cx="16874490" cy="295275"/>
           </a:xfrm>
           <a:prstGeom prst="rect">
             <a:avLst/>
@@ -12557,7 +12584,7 @@
                 <a:ea typeface="Courier New" pitchFamily="34" charset="-122"/>
                 <a:cs typeface="Courier New" pitchFamily="34" charset="-120"/>
               </a:rPr>
-              <a:t>Model selection · 5-fold accuracy</a:t>
+              <a:t>Source: src/model_v10.py · 16-model ensemble (9 LGBM + 3 XGB + 4 CatBoost)</a:t>
             </a:r>
             <a:endParaRPr lang="en-US" sz="1800" dirty="0"/>
           </a:p>
@@ -12565,1375 +12592,25 @@
       </p:sp>
       <p:sp>
         <p:nvSpPr>
-          <p:cNvPr id="6" name="Text 4"/>
-          <p:cNvSpPr/>
-          <p:nvPr/>
-        </p:nvSpPr>
-        <p:spPr>
-          <a:xfrm>
-            <a:off x="952500" y="4167039"/>
-            <a:ext cx="2305050" cy="323850"/>
-          </a:xfrm>
-          <a:prstGeom prst="rect">
-            <a:avLst/>
-          </a:prstGeom>
-          <a:noFill/>
-          <a:ln/>
-        </p:spPr>
-        <p:txBody>
-          <a:bodyPr wrap="square" lIns="25400" tIns="25400" rIns="25400" bIns="25400" rtlCol="0" anchor="t">
-            <a:normAutofit lnSpcReduction="10000"/>
-          </a:bodyPr>
-          <a:lstStyle/>
-          <a:p>
-            <a:pPr marL="0" indent="0" algn="l">
-              <a:buNone/>
-            </a:pPr>
-            <a:r>
-              <a:rPr lang="en-US" sz="1950" dirty="0">
-                <a:solidFill>
-                  <a:srgbClr val="244236"/>
-                </a:solidFill>
-                <a:latin typeface="Arial" pitchFamily="34" charset="0"/>
-                <a:ea typeface="Arial" pitchFamily="34" charset="-122"/>
-                <a:cs typeface="Arial" pitchFamily="34" charset="-120"/>
-              </a:rPr>
-              <a:t>Naive Bayes</a:t>
-            </a:r>
-            <a:endParaRPr lang="en-US" sz="1950" dirty="0"/>
-          </a:p>
-        </p:txBody>
-      </p:sp>
-      <p:sp>
-        <p:nvSpPr>
-          <p:cNvPr id="7" name="Shape 5"/>
-          <p:cNvSpPr/>
-          <p:nvPr/>
-        </p:nvSpPr>
-        <p:spPr>
-          <a:xfrm>
-            <a:off x="3219450" y="4128939"/>
-            <a:ext cx="5392862" cy="361950"/>
+          <p:cNvPr id="41" name="Rounded Rectangle 40"/>
+          <p:cNvSpPr/>
+          <p:nvPr/>
+        </p:nvSpPr>
+        <p:spPr>
+          <a:xfrm>
+            <a:off x="950976" y="2697480"/>
+            <a:ext cx="2743200" cy="1280160"/>
           </a:xfrm>
           <a:prstGeom prst="roundRect">
-            <a:avLst>
-              <a:gd name="adj" fmla="val 15789"/>
-            </a:avLst>
+            <a:avLst/>
           </a:prstGeom>
           <a:solidFill>
-            <a:srgbClr val="E6F5EF"/>
+            <a:srgbClr val="EAF3EF"/>
           </a:solidFill>
-          <a:ln/>
-        </p:spPr>
-        <p:txBody>
-          <a:bodyPr/>
-          <a:lstStyle/>
-          <a:p>
-            <a:endParaRPr lang="en-GB"/>
-          </a:p>
-        </p:txBody>
-      </p:sp>
-      <p:sp>
-        <p:nvSpPr>
-          <p:cNvPr id="8" name="Shape 6"/>
-          <p:cNvSpPr/>
-          <p:nvPr/>
-        </p:nvSpPr>
-        <p:spPr>
-          <a:xfrm>
-            <a:off x="3219450" y="4128939"/>
-            <a:ext cx="2157115" cy="361950"/>
-          </a:xfrm>
-          <a:prstGeom prst="rect">
-            <a:avLst/>
-          </a:prstGeom>
-          <a:solidFill>
-            <a:srgbClr val="A7C8BC"/>
-          </a:solidFill>
-          <a:ln/>
-        </p:spPr>
-        <p:txBody>
-          <a:bodyPr/>
-          <a:lstStyle/>
-          <a:p>
-            <a:endParaRPr lang="en-GB"/>
-          </a:p>
-        </p:txBody>
-      </p:sp>
-      <p:sp>
-        <p:nvSpPr>
-          <p:cNvPr id="9" name="Text 7"/>
-          <p:cNvSpPr/>
-          <p:nvPr/>
-        </p:nvSpPr>
-        <p:spPr>
-          <a:xfrm>
-            <a:off x="8707562" y="4174182"/>
-            <a:ext cx="990600" cy="309563"/>
-          </a:xfrm>
-          <a:prstGeom prst="rect">
-            <a:avLst/>
-          </a:prstGeom>
-          <a:noFill/>
-          <a:ln/>
-        </p:spPr>
-        <p:txBody>
-          <a:bodyPr wrap="square" lIns="25400" tIns="25400" rIns="25400" bIns="25400" rtlCol="0" anchor="t">
-            <a:normAutofit fontScale="92500" lnSpcReduction="10000"/>
-          </a:bodyPr>
-          <a:lstStyle/>
-          <a:p>
-            <a:pPr marL="0" indent="0" algn="r">
-              <a:buNone/>
-            </a:pPr>
-            <a:r>
-              <a:rPr lang="en-US" sz="1875" dirty="0">
-                <a:solidFill>
-                  <a:srgbClr val="5C7268"/>
-                </a:solidFill>
-                <a:latin typeface="Courier New" pitchFamily="34" charset="0"/>
-                <a:ea typeface="Courier New" pitchFamily="34" charset="-122"/>
-                <a:cs typeface="Courier New" pitchFamily="34" charset="-120"/>
-              </a:rPr>
-              <a:t>0.760</a:t>
-            </a:r>
-            <a:endParaRPr lang="en-US" sz="1875" dirty="0"/>
-          </a:p>
-        </p:txBody>
-      </p:sp>
-      <p:sp>
-        <p:nvSpPr>
-          <p:cNvPr id="10" name="Text 8"/>
-          <p:cNvSpPr/>
-          <p:nvPr/>
-        </p:nvSpPr>
-        <p:spPr>
-          <a:xfrm>
-            <a:off x="952500" y="4700439"/>
-            <a:ext cx="2305050" cy="323850"/>
-          </a:xfrm>
-          <a:prstGeom prst="rect">
-            <a:avLst/>
-          </a:prstGeom>
-          <a:noFill/>
-          <a:ln/>
-        </p:spPr>
-        <p:txBody>
-          <a:bodyPr wrap="square" lIns="25400" tIns="25400" rIns="25400" bIns="25400" rtlCol="0" anchor="t">
-            <a:normAutofit lnSpcReduction="10000"/>
-          </a:bodyPr>
-          <a:lstStyle/>
-          <a:p>
-            <a:pPr marL="0" indent="0" algn="l">
-              <a:buNone/>
-            </a:pPr>
-            <a:r>
-              <a:rPr lang="en-US" sz="1950" dirty="0">
-                <a:solidFill>
-                  <a:srgbClr val="244236"/>
-                </a:solidFill>
-                <a:latin typeface="Arial" pitchFamily="34" charset="0"/>
-                <a:ea typeface="Arial" pitchFamily="34" charset="-122"/>
-                <a:cs typeface="Arial" pitchFamily="34" charset="-120"/>
-              </a:rPr>
-              <a:t>LDA</a:t>
-            </a:r>
-            <a:endParaRPr lang="en-US" sz="1950" dirty="0"/>
-          </a:p>
-        </p:txBody>
-      </p:sp>
-      <p:sp>
-        <p:nvSpPr>
-          <p:cNvPr id="11" name="Shape 9"/>
-          <p:cNvSpPr/>
-          <p:nvPr/>
-        </p:nvSpPr>
-        <p:spPr>
-          <a:xfrm>
-            <a:off x="3219450" y="4662339"/>
-            <a:ext cx="5392862" cy="361950"/>
-          </a:xfrm>
-          <a:prstGeom prst="roundRect">
-            <a:avLst>
-              <a:gd name="adj" fmla="val 15789"/>
-            </a:avLst>
-          </a:prstGeom>
-          <a:solidFill>
-            <a:srgbClr val="E6F5EF"/>
-          </a:solidFill>
-          <a:ln/>
-        </p:spPr>
-        <p:txBody>
-          <a:bodyPr/>
-          <a:lstStyle/>
-          <a:p>
-            <a:endParaRPr lang="en-GB"/>
-          </a:p>
-        </p:txBody>
-      </p:sp>
-      <p:sp>
-        <p:nvSpPr>
-          <p:cNvPr id="12" name="Shape 10"/>
-          <p:cNvSpPr/>
-          <p:nvPr/>
-        </p:nvSpPr>
-        <p:spPr>
-          <a:xfrm>
-            <a:off x="3219450" y="4662339"/>
-            <a:ext cx="2750344" cy="361950"/>
-          </a:xfrm>
-          <a:prstGeom prst="rect">
-            <a:avLst/>
-          </a:prstGeom>
-          <a:solidFill>
-            <a:srgbClr val="A7C8BC"/>
-          </a:solidFill>
-          <a:ln/>
-        </p:spPr>
-        <p:txBody>
-          <a:bodyPr/>
-          <a:lstStyle/>
-          <a:p>
-            <a:endParaRPr lang="en-GB"/>
-          </a:p>
-        </p:txBody>
-      </p:sp>
-      <p:sp>
-        <p:nvSpPr>
-          <p:cNvPr id="13" name="Text 11"/>
-          <p:cNvSpPr/>
-          <p:nvPr/>
-        </p:nvSpPr>
-        <p:spPr>
-          <a:xfrm>
-            <a:off x="8707562" y="4707582"/>
-            <a:ext cx="990600" cy="309563"/>
-          </a:xfrm>
-          <a:prstGeom prst="rect">
-            <a:avLst/>
-          </a:prstGeom>
-          <a:noFill/>
-          <a:ln/>
-        </p:spPr>
-        <p:txBody>
-          <a:bodyPr wrap="square" lIns="25400" tIns="25400" rIns="25400" bIns="25400" rtlCol="0" anchor="t">
-            <a:normAutofit fontScale="92500" lnSpcReduction="10000"/>
-          </a:bodyPr>
-          <a:lstStyle/>
-          <a:p>
-            <a:pPr marL="0" indent="0" algn="r">
-              <a:buNone/>
-            </a:pPr>
-            <a:r>
-              <a:rPr lang="en-US" sz="1875" dirty="0">
-                <a:solidFill>
-                  <a:srgbClr val="5C7268"/>
-                </a:solidFill>
-                <a:latin typeface="Courier New" pitchFamily="34" charset="0"/>
-                <a:ea typeface="Courier New" pitchFamily="34" charset="-122"/>
-                <a:cs typeface="Courier New" pitchFamily="34" charset="-120"/>
-              </a:rPr>
-              <a:t>0.777</a:t>
-            </a:r>
-            <a:endParaRPr lang="en-US" sz="1875" dirty="0"/>
-          </a:p>
-        </p:txBody>
-      </p:sp>
-      <p:sp>
-        <p:nvSpPr>
-          <p:cNvPr id="14" name="Text 12"/>
-          <p:cNvSpPr/>
-          <p:nvPr/>
-        </p:nvSpPr>
-        <p:spPr>
-          <a:xfrm>
-            <a:off x="952500" y="5195739"/>
-            <a:ext cx="2171700" cy="609600"/>
-          </a:xfrm>
-          <a:prstGeom prst="rect">
-            <a:avLst/>
-          </a:prstGeom>
-          <a:noFill/>
-          <a:ln/>
-        </p:spPr>
-        <p:txBody>
-          <a:bodyPr wrap="square" lIns="25400" tIns="25400" rIns="25400" bIns="25400" rtlCol="0" anchor="t">
-            <a:normAutofit lnSpcReduction="10000"/>
-          </a:bodyPr>
-          <a:lstStyle/>
-          <a:p>
-            <a:pPr marL="0" indent="0" algn="l">
-              <a:buNone/>
-            </a:pPr>
-            <a:r>
-              <a:rPr lang="en-US" sz="1950" dirty="0">
-                <a:solidFill>
-                  <a:srgbClr val="244236"/>
-                </a:solidFill>
-                <a:latin typeface="Arial" pitchFamily="34" charset="0"/>
-                <a:ea typeface="Arial" pitchFamily="34" charset="-122"/>
-                <a:cs typeface="Arial" pitchFamily="34" charset="-120"/>
-              </a:rPr>
-              <a:t>Logistic Regression</a:t>
-            </a:r>
-            <a:endParaRPr lang="en-US" sz="1950" dirty="0"/>
-          </a:p>
-        </p:txBody>
-      </p:sp>
-      <p:sp>
-        <p:nvSpPr>
-          <p:cNvPr id="15" name="Shape 13"/>
-          <p:cNvSpPr/>
-          <p:nvPr/>
-        </p:nvSpPr>
-        <p:spPr>
-          <a:xfrm>
-            <a:off x="3219450" y="5300514"/>
-            <a:ext cx="5392862" cy="361950"/>
-          </a:xfrm>
-          <a:prstGeom prst="roundRect">
-            <a:avLst>
-              <a:gd name="adj" fmla="val 15789"/>
-            </a:avLst>
-          </a:prstGeom>
-          <a:solidFill>
-            <a:srgbClr val="E6F5EF"/>
-          </a:solidFill>
-          <a:ln/>
-        </p:spPr>
-        <p:txBody>
-          <a:bodyPr/>
-          <a:lstStyle/>
-          <a:p>
-            <a:endParaRPr lang="en-GB"/>
-          </a:p>
-        </p:txBody>
-      </p:sp>
-      <p:sp>
-        <p:nvSpPr>
-          <p:cNvPr id="16" name="Shape 14"/>
-          <p:cNvSpPr/>
-          <p:nvPr/>
-        </p:nvSpPr>
-        <p:spPr>
-          <a:xfrm>
-            <a:off x="3219450" y="5300514"/>
-            <a:ext cx="3019946" cy="361950"/>
-          </a:xfrm>
-          <a:prstGeom prst="rect">
-            <a:avLst/>
-          </a:prstGeom>
-          <a:solidFill>
-            <a:srgbClr val="A7C8BC"/>
-          </a:solidFill>
-          <a:ln/>
-        </p:spPr>
-        <p:txBody>
-          <a:bodyPr/>
-          <a:lstStyle/>
-          <a:p>
-            <a:endParaRPr lang="en-GB"/>
-          </a:p>
-        </p:txBody>
-      </p:sp>
-      <p:sp>
-        <p:nvSpPr>
-          <p:cNvPr id="17" name="Text 15"/>
-          <p:cNvSpPr/>
-          <p:nvPr/>
-        </p:nvSpPr>
-        <p:spPr>
-          <a:xfrm>
-            <a:off x="8707562" y="5345757"/>
-            <a:ext cx="990600" cy="309563"/>
-          </a:xfrm>
-          <a:prstGeom prst="rect">
-            <a:avLst/>
-          </a:prstGeom>
-          <a:noFill/>
-          <a:ln/>
-        </p:spPr>
-        <p:txBody>
-          <a:bodyPr wrap="square" lIns="25400" tIns="25400" rIns="25400" bIns="25400" rtlCol="0" anchor="t">
-            <a:normAutofit fontScale="92500" lnSpcReduction="10000"/>
-          </a:bodyPr>
-          <a:lstStyle/>
-          <a:p>
-            <a:pPr marL="0" indent="0" algn="r">
-              <a:buNone/>
-            </a:pPr>
-            <a:r>
-              <a:rPr lang="en-US" sz="1875" dirty="0">
-                <a:solidFill>
-                  <a:srgbClr val="5C7268"/>
-                </a:solidFill>
-                <a:latin typeface="Courier New" pitchFamily="34" charset="0"/>
-                <a:ea typeface="Courier New" pitchFamily="34" charset="-122"/>
-                <a:cs typeface="Courier New" pitchFamily="34" charset="-120"/>
-              </a:rPr>
-              <a:t>0.784</a:t>
-            </a:r>
-            <a:endParaRPr lang="en-US" sz="1875" dirty="0"/>
-          </a:p>
-        </p:txBody>
-      </p:sp>
-      <p:sp>
-        <p:nvSpPr>
-          <p:cNvPr id="18" name="Text 16"/>
-          <p:cNvSpPr/>
-          <p:nvPr/>
-        </p:nvSpPr>
-        <p:spPr>
-          <a:xfrm>
-            <a:off x="952500" y="5976789"/>
-            <a:ext cx="2305050" cy="323850"/>
-          </a:xfrm>
-          <a:prstGeom prst="rect">
-            <a:avLst/>
-          </a:prstGeom>
-          <a:noFill/>
-          <a:ln/>
-        </p:spPr>
-        <p:txBody>
-          <a:bodyPr wrap="square" lIns="25400" tIns="25400" rIns="25400" bIns="25400" rtlCol="0" anchor="t">
-            <a:normAutofit lnSpcReduction="10000"/>
-          </a:bodyPr>
-          <a:lstStyle/>
-          <a:p>
-            <a:pPr marL="0" indent="0" algn="l">
-              <a:buNone/>
-            </a:pPr>
-            <a:r>
-              <a:rPr lang="en-US" sz="1950" dirty="0">
-                <a:solidFill>
-                  <a:srgbClr val="244236"/>
-                </a:solidFill>
-                <a:latin typeface="Arial" pitchFamily="34" charset="0"/>
-                <a:ea typeface="Arial" pitchFamily="34" charset="-122"/>
-                <a:cs typeface="Arial" pitchFamily="34" charset="-120"/>
-              </a:rPr>
-              <a:t>Random Forest</a:t>
-            </a:r>
-            <a:endParaRPr lang="en-US" sz="1950" dirty="0"/>
-          </a:p>
-        </p:txBody>
-      </p:sp>
-      <p:sp>
-        <p:nvSpPr>
-          <p:cNvPr id="19" name="Shape 17"/>
-          <p:cNvSpPr/>
-          <p:nvPr/>
-        </p:nvSpPr>
-        <p:spPr>
-          <a:xfrm>
-            <a:off x="3219450" y="5938689"/>
-            <a:ext cx="5392862" cy="361950"/>
-          </a:xfrm>
-          <a:prstGeom prst="roundRect">
-            <a:avLst>
-              <a:gd name="adj" fmla="val 15789"/>
-            </a:avLst>
-          </a:prstGeom>
-          <a:solidFill>
-            <a:srgbClr val="E6F5EF"/>
-          </a:solidFill>
-          <a:ln/>
-        </p:spPr>
-        <p:txBody>
-          <a:bodyPr/>
-          <a:lstStyle/>
-          <a:p>
-            <a:endParaRPr lang="en-GB"/>
-          </a:p>
-        </p:txBody>
-      </p:sp>
-      <p:sp>
-        <p:nvSpPr>
-          <p:cNvPr id="20" name="Shape 18"/>
-          <p:cNvSpPr/>
-          <p:nvPr/>
-        </p:nvSpPr>
-        <p:spPr>
-          <a:xfrm>
-            <a:off x="3219450" y="5938689"/>
-            <a:ext cx="4799633" cy="361950"/>
-          </a:xfrm>
-          <a:prstGeom prst="rect">
-            <a:avLst/>
-          </a:prstGeom>
-          <a:solidFill>
-            <a:srgbClr val="66B3A1"/>
-          </a:solidFill>
-          <a:ln/>
-        </p:spPr>
-        <p:txBody>
-          <a:bodyPr/>
-          <a:lstStyle/>
-          <a:p>
-            <a:endParaRPr lang="en-GB"/>
-          </a:p>
-        </p:txBody>
-      </p:sp>
-      <p:sp>
-        <p:nvSpPr>
-          <p:cNvPr id="21" name="Text 19"/>
-          <p:cNvSpPr/>
-          <p:nvPr/>
-        </p:nvSpPr>
-        <p:spPr>
-          <a:xfrm>
-            <a:off x="8707562" y="5983932"/>
-            <a:ext cx="990600" cy="309563"/>
-          </a:xfrm>
-          <a:prstGeom prst="rect">
-            <a:avLst/>
-          </a:prstGeom>
-          <a:noFill/>
-          <a:ln/>
-        </p:spPr>
-        <p:txBody>
-          <a:bodyPr wrap="square" lIns="25400" tIns="25400" rIns="25400" bIns="25400" rtlCol="0" anchor="t">
-            <a:normAutofit fontScale="92500" lnSpcReduction="10000"/>
-          </a:bodyPr>
-          <a:lstStyle/>
-          <a:p>
-            <a:pPr marL="0" indent="0" algn="r">
-              <a:buNone/>
-            </a:pPr>
-            <a:r>
-              <a:rPr lang="en-US" sz="1875" dirty="0">
-                <a:solidFill>
-                  <a:srgbClr val="5C7268"/>
-                </a:solidFill>
-                <a:latin typeface="Courier New" pitchFamily="34" charset="0"/>
-                <a:ea typeface="Courier New" pitchFamily="34" charset="-122"/>
-                <a:cs typeface="Courier New" pitchFamily="34" charset="-120"/>
-              </a:rPr>
-              <a:t>0.833</a:t>
-            </a:r>
-            <a:endParaRPr lang="en-US" sz="1875" dirty="0"/>
-          </a:p>
-        </p:txBody>
-      </p:sp>
-      <p:sp>
-        <p:nvSpPr>
-          <p:cNvPr id="22" name="Text 20"/>
-          <p:cNvSpPr/>
-          <p:nvPr/>
-        </p:nvSpPr>
-        <p:spPr>
-          <a:xfrm>
-            <a:off x="952500" y="6503045"/>
-            <a:ext cx="2305050" cy="338138"/>
-          </a:xfrm>
-          <a:prstGeom prst="rect">
-            <a:avLst/>
-          </a:prstGeom>
-          <a:noFill/>
-          <a:ln/>
-        </p:spPr>
-        <p:txBody>
-          <a:bodyPr wrap="square" lIns="25400" tIns="25400" rIns="25400" bIns="25400" rtlCol="0" anchor="t">
-            <a:normAutofit lnSpcReduction="10000"/>
-          </a:bodyPr>
-          <a:lstStyle/>
-          <a:p>
-            <a:pPr marL="0" indent="0" algn="l">
-              <a:buNone/>
-            </a:pPr>
-            <a:r>
-              <a:rPr lang="en-US" sz="1950" b="1" dirty="0">
-                <a:solidFill>
-                  <a:srgbClr val="063D22"/>
-                </a:solidFill>
-                <a:latin typeface="Arial" pitchFamily="34" charset="0"/>
-                <a:ea typeface="Arial" pitchFamily="34" charset="-122"/>
-                <a:cs typeface="Arial" pitchFamily="34" charset="-120"/>
-              </a:rPr>
-              <a:t>LightGBM</a:t>
-            </a:r>
-            <a:endParaRPr lang="en-US" sz="1950" dirty="0"/>
-          </a:p>
-        </p:txBody>
-      </p:sp>
-      <p:sp>
-        <p:nvSpPr>
-          <p:cNvPr id="23" name="Shape 21"/>
-          <p:cNvSpPr/>
-          <p:nvPr/>
-        </p:nvSpPr>
-        <p:spPr>
-          <a:xfrm>
-            <a:off x="3219450" y="6472089"/>
-            <a:ext cx="5392862" cy="361950"/>
-          </a:xfrm>
-          <a:prstGeom prst="roundRect">
-            <a:avLst>
-              <a:gd name="adj" fmla="val 15789"/>
-            </a:avLst>
-          </a:prstGeom>
-          <a:solidFill>
-            <a:srgbClr val="E6F5EF"/>
-          </a:solidFill>
-          <a:ln/>
-        </p:spPr>
-        <p:txBody>
-          <a:bodyPr/>
-          <a:lstStyle/>
-          <a:p>
-            <a:endParaRPr lang="en-GB"/>
-          </a:p>
-        </p:txBody>
-      </p:sp>
-      <p:sp>
-        <p:nvSpPr>
-          <p:cNvPr id="24" name="Shape 22"/>
-          <p:cNvSpPr/>
-          <p:nvPr/>
-        </p:nvSpPr>
-        <p:spPr>
-          <a:xfrm>
-            <a:off x="3219450" y="6472089"/>
-            <a:ext cx="4907459" cy="361950"/>
-          </a:xfrm>
-          <a:prstGeom prst="rect">
-            <a:avLst/>
-          </a:prstGeom>
-          <a:solidFill>
-            <a:srgbClr val="1A7A57"/>
-          </a:solidFill>
-          <a:ln/>
-        </p:spPr>
-        <p:txBody>
-          <a:bodyPr/>
-          <a:lstStyle/>
-          <a:p>
-            <a:endParaRPr lang="en-GB"/>
-          </a:p>
-        </p:txBody>
-      </p:sp>
-      <p:sp>
-        <p:nvSpPr>
-          <p:cNvPr id="25" name="Text 23"/>
-          <p:cNvSpPr/>
-          <p:nvPr/>
-        </p:nvSpPr>
-        <p:spPr>
-          <a:xfrm>
-            <a:off x="8707562" y="6498282"/>
-            <a:ext cx="990600" cy="347663"/>
-          </a:xfrm>
-          <a:prstGeom prst="rect">
-            <a:avLst/>
-          </a:prstGeom>
-          <a:noFill/>
-          <a:ln/>
-        </p:spPr>
-        <p:txBody>
-          <a:bodyPr wrap="square" lIns="25400" tIns="25400" rIns="25400" bIns="25400" rtlCol="0" anchor="t">
-            <a:normAutofit/>
-          </a:bodyPr>
-          <a:lstStyle/>
-          <a:p>
-            <a:pPr marL="0" indent="0" algn="r">
-              <a:buNone/>
-            </a:pPr>
-            <a:r>
-              <a:rPr lang="en-US" sz="1875" b="1" dirty="0">
-                <a:solidFill>
-                  <a:srgbClr val="063D22"/>
-                </a:solidFill>
-                <a:latin typeface="Courier New" pitchFamily="34" charset="0"/>
-                <a:ea typeface="Courier New" pitchFamily="34" charset="-122"/>
-                <a:cs typeface="Courier New" pitchFamily="34" charset="-120"/>
-              </a:rPr>
-              <a:t>0.836</a:t>
-            </a:r>
-            <a:endParaRPr lang="en-US" sz="1875" dirty="0"/>
-          </a:p>
-        </p:txBody>
-      </p:sp>
-      <p:sp>
-        <p:nvSpPr>
-          <p:cNvPr id="26" name="Text 24"/>
-          <p:cNvSpPr/>
-          <p:nvPr/>
-        </p:nvSpPr>
-        <p:spPr>
-          <a:xfrm>
-            <a:off x="952500" y="8279309"/>
-            <a:ext cx="9008031" cy="998041"/>
-          </a:xfrm>
-          <a:prstGeom prst="rect">
-            <a:avLst/>
-          </a:prstGeom>
-          <a:noFill/>
-          <a:ln/>
-        </p:spPr>
-        <p:txBody>
-          <a:bodyPr wrap="square" lIns="25400" tIns="25400" rIns="25400" bIns="25400" rtlCol="0" anchor="t">
-            <a:normAutofit fontScale="92500" lnSpcReduction="20000"/>
-          </a:bodyPr>
-          <a:lstStyle/>
-          <a:p>
-            <a:pPr marL="0" indent="0" algn="l">
-              <a:lnSpc>
-                <a:spcPct val="140000"/>
-              </a:lnSpc>
-              <a:buNone/>
-            </a:pPr>
-            <a:r>
-              <a:rPr lang="en-US" sz="1800" dirty="0">
-                <a:solidFill>
-                  <a:srgbClr val="5C7268"/>
-                </a:solidFill>
-                <a:latin typeface="Courier New" pitchFamily="34" charset="0"/>
-                <a:ea typeface="Courier New" pitchFamily="34" charset="-122"/>
-                <a:cs typeface="Courier New" pitchFamily="34" charset="-120"/>
-              </a:rPr>
-              <a:t>Bars scaled from 0.70 · final label uses a </a:t>
-            </a:r>
-            <a:r>
-              <a:rPr lang="en-US" sz="1800" dirty="0">
-                <a:solidFill>
-                  <a:srgbClr val="063D22"/>
-                </a:solidFill>
-                <a:latin typeface="Courier New" pitchFamily="34" charset="0"/>
-                <a:ea typeface="Courier New" pitchFamily="34" charset="-122"/>
-                <a:cs typeface="Courier New" pitchFamily="34" charset="-120"/>
-              </a:rPr>
-              <a:t>smooth threshold </a:t>
-            </a:r>
-            <a:r>
-              <a:rPr lang="en-US" sz="1800" dirty="0">
-                <a:solidFill>
-                  <a:srgbClr val="5C7268"/>
-                </a:solidFill>
-                <a:latin typeface="Courier New" pitchFamily="34" charset="0"/>
-                <a:ea typeface="Courier New" pitchFamily="34" charset="-122"/>
-                <a:cs typeface="Courier New" pitchFamily="34" charset="-120"/>
-              </a:rPr>
-              <a:t>= average of the top-1% of candidate cutoffs (more robust than a single argmax cutoff).</a:t>
-            </a:r>
-            <a:endParaRPr lang="en-US" sz="1800" dirty="0"/>
-          </a:p>
-        </p:txBody>
-      </p:sp>
-      <p:sp>
-        <p:nvSpPr>
-          <p:cNvPr id="27" name="Shape 25"/>
-          <p:cNvSpPr/>
-          <p:nvPr/>
-        </p:nvSpPr>
-        <p:spPr>
-          <a:xfrm>
-            <a:off x="10307762" y="2350368"/>
-            <a:ext cx="7027738" cy="3468886"/>
-          </a:xfrm>
-          <a:prstGeom prst="roundRect">
-            <a:avLst>
-              <a:gd name="adj" fmla="val 3295"/>
-            </a:avLst>
-          </a:prstGeom>
-          <a:solidFill>
-            <a:srgbClr val="E6F5EF"/>
-          </a:solidFill>
-          <a:ln/>
-        </p:spPr>
-        <p:txBody>
-          <a:bodyPr/>
-          <a:lstStyle/>
-          <a:p>
-            <a:endParaRPr lang="en-GB"/>
-          </a:p>
-        </p:txBody>
-      </p:sp>
-      <p:sp>
-        <p:nvSpPr>
-          <p:cNvPr id="28" name="Text 26"/>
-          <p:cNvSpPr/>
-          <p:nvPr/>
-        </p:nvSpPr>
-        <p:spPr>
-          <a:xfrm>
-            <a:off x="10593512" y="2617068"/>
-            <a:ext cx="7101862" cy="361950"/>
-          </a:xfrm>
-          <a:prstGeom prst="rect">
-            <a:avLst/>
-          </a:prstGeom>
-          <a:noFill/>
-          <a:ln/>
-        </p:spPr>
-        <p:txBody>
-          <a:bodyPr wrap="square" lIns="25400" tIns="25400" rIns="25400" bIns="25400" rtlCol="0" anchor="t">
-            <a:normAutofit lnSpcReduction="10000"/>
-          </a:bodyPr>
-          <a:lstStyle/>
-          <a:p>
-            <a:pPr marL="0" indent="0" algn="l">
-              <a:buNone/>
-            </a:pPr>
-            <a:r>
-              <a:rPr lang="en-US" sz="2100" b="1" dirty="0">
-                <a:solidFill>
-                  <a:srgbClr val="063D22"/>
-                </a:solidFill>
-                <a:latin typeface="Arial" pitchFamily="34" charset="0"/>
-                <a:ea typeface="Arial" pitchFamily="34" charset="-122"/>
-                <a:cs typeface="Arial" pitchFamily="34" charset="-120"/>
-              </a:rPr>
-              <a:t>Adversarial validation</a:t>
-            </a:r>
-            <a:endParaRPr lang="en-US" sz="2100" dirty="0"/>
-          </a:p>
-        </p:txBody>
-      </p:sp>
-      <p:sp>
-        <p:nvSpPr>
-          <p:cNvPr id="29" name="Shape 27"/>
-          <p:cNvSpPr/>
-          <p:nvPr/>
-        </p:nvSpPr>
-        <p:spPr>
-          <a:xfrm>
-            <a:off x="10593512" y="3093318"/>
-            <a:ext cx="3142357" cy="981075"/>
-          </a:xfrm>
-          <a:prstGeom prst="roundRect">
-            <a:avLst>
-              <a:gd name="adj" fmla="val 7767"/>
-            </a:avLst>
-          </a:prstGeom>
-          <a:solidFill>
-            <a:srgbClr val="FFFFFF"/>
-          </a:solidFill>
-          <a:ln w="9525">
+          <a:ln w="19050">
             <a:solidFill>
-              <a:srgbClr val="D2E6DD"/>
+              <a:srgbClr val="2E8B62"/>
             </a:solidFill>
-            <a:prstDash val="solid"/>
-          </a:ln>
-        </p:spPr>
-        <p:txBody>
-          <a:bodyPr/>
-          <a:lstStyle/>
-          <a:p>
-            <a:endParaRPr lang="en-GB"/>
-          </a:p>
-        </p:txBody>
-      </p:sp>
-      <p:sp>
-        <p:nvSpPr>
-          <p:cNvPr id="30" name="Text 28"/>
-          <p:cNvSpPr/>
-          <p:nvPr/>
-        </p:nvSpPr>
-        <p:spPr>
-          <a:xfrm>
-            <a:off x="10755437" y="3236193"/>
-            <a:ext cx="3100358" cy="295275"/>
-          </a:xfrm>
-          <a:prstGeom prst="rect">
-            <a:avLst/>
-          </a:prstGeom>
-          <a:noFill/>
-          <a:ln/>
-        </p:spPr>
-        <p:txBody>
-          <a:bodyPr wrap="square" lIns="25400" tIns="25400" rIns="25400" bIns="25400" rtlCol="0" anchor="t">
-            <a:normAutofit fontScale="92500" lnSpcReduction="10000"/>
-          </a:bodyPr>
-          <a:lstStyle/>
-          <a:p>
-            <a:pPr marL="0" indent="0" algn="l">
-              <a:buNone/>
-            </a:pPr>
-            <a:r>
-              <a:rPr lang="en-US" sz="1800" dirty="0">
-                <a:solidFill>
-                  <a:srgbClr val="5C7268"/>
-                </a:solidFill>
-                <a:latin typeface="Courier New" pitchFamily="34" charset="0"/>
-                <a:ea typeface="Courier New" pitchFamily="34" charset="-122"/>
-                <a:cs typeface="Courier New" pitchFamily="34" charset="-120"/>
-              </a:rPr>
-              <a:t>ALL FEATURES</a:t>
-            </a:r>
-            <a:endParaRPr lang="en-US" sz="1800" dirty="0"/>
-          </a:p>
-        </p:txBody>
-      </p:sp>
-      <p:sp>
-        <p:nvSpPr>
-          <p:cNvPr id="31" name="Text 29"/>
-          <p:cNvSpPr/>
-          <p:nvPr/>
-        </p:nvSpPr>
-        <p:spPr>
-          <a:xfrm>
-            <a:off x="10755437" y="3550518"/>
-            <a:ext cx="3100358" cy="419100"/>
-          </a:xfrm>
-          <a:prstGeom prst="rect">
-            <a:avLst/>
-          </a:prstGeom>
-          <a:noFill/>
-          <a:ln/>
-        </p:spPr>
-        <p:txBody>
-          <a:bodyPr wrap="square" lIns="25400" tIns="25400" rIns="25400" bIns="25400" rtlCol="0" anchor="t">
-            <a:normAutofit lnSpcReduction="10000"/>
-          </a:bodyPr>
-          <a:lstStyle/>
-          <a:p>
-            <a:pPr marL="0" indent="0" algn="l">
-              <a:buNone/>
-            </a:pPr>
-            <a:r>
-              <a:rPr lang="en-US" sz="2475" b="1" dirty="0">
-                <a:solidFill>
-                  <a:srgbClr val="B3573F"/>
-                </a:solidFill>
-                <a:latin typeface="Arial" pitchFamily="34" charset="0"/>
-                <a:ea typeface="Arial" pitchFamily="34" charset="-122"/>
-                <a:cs typeface="Arial" pitchFamily="34" charset="-120"/>
-              </a:rPr>
-              <a:t>AUC 1.000</a:t>
-            </a:r>
-            <a:endParaRPr lang="en-US" sz="2475" dirty="0"/>
-          </a:p>
-        </p:txBody>
-      </p:sp>
-      <p:sp>
-        <p:nvSpPr>
-          <p:cNvPr id="32" name="Shape 30"/>
-          <p:cNvSpPr/>
-          <p:nvPr/>
-        </p:nvSpPr>
-        <p:spPr>
-          <a:xfrm>
-            <a:off x="13907319" y="3093318"/>
-            <a:ext cx="3142431" cy="981075"/>
-          </a:xfrm>
-          <a:prstGeom prst="roundRect">
-            <a:avLst>
-              <a:gd name="adj" fmla="val 7767"/>
-            </a:avLst>
-          </a:prstGeom>
-          <a:solidFill>
-            <a:srgbClr val="FFFFFF"/>
-          </a:solidFill>
-          <a:ln w="9525">
-            <a:solidFill>
-              <a:srgbClr val="D2E6DD"/>
-            </a:solidFill>
-            <a:prstDash val="solid"/>
-          </a:ln>
-        </p:spPr>
-        <p:txBody>
-          <a:bodyPr/>
-          <a:lstStyle/>
-          <a:p>
-            <a:endParaRPr lang="en-GB"/>
-          </a:p>
-        </p:txBody>
-      </p:sp>
-      <p:sp>
-        <p:nvSpPr>
-          <p:cNvPr id="33" name="Text 31"/>
-          <p:cNvSpPr/>
-          <p:nvPr/>
-        </p:nvSpPr>
-        <p:spPr>
-          <a:xfrm>
-            <a:off x="14069244" y="3236193"/>
-            <a:ext cx="3100440" cy="295275"/>
-          </a:xfrm>
-          <a:prstGeom prst="rect">
-            <a:avLst/>
-          </a:prstGeom>
-          <a:noFill/>
-          <a:ln/>
-        </p:spPr>
-        <p:txBody>
-          <a:bodyPr wrap="square" lIns="25400" tIns="25400" rIns="25400" bIns="25400" rtlCol="0" anchor="t">
-            <a:normAutofit fontScale="92500" lnSpcReduction="10000"/>
-          </a:bodyPr>
-          <a:lstStyle/>
-          <a:p>
-            <a:pPr marL="0" indent="0" algn="l">
-              <a:buNone/>
-            </a:pPr>
-            <a:r>
-              <a:rPr lang="en-US" sz="1800" dirty="0">
-                <a:solidFill>
-                  <a:srgbClr val="5C7268"/>
-                </a:solidFill>
-                <a:latin typeface="Courier New" pitchFamily="34" charset="0"/>
-                <a:ea typeface="Courier New" pitchFamily="34" charset="-122"/>
-                <a:cs typeface="Courier New" pitchFamily="34" charset="-120"/>
-              </a:rPr>
-              <a:t>WITHOUT DATE</a:t>
-            </a:r>
-            <a:endParaRPr lang="en-US" sz="1800" dirty="0"/>
-          </a:p>
-        </p:txBody>
-      </p:sp>
-      <p:sp>
-        <p:nvSpPr>
-          <p:cNvPr id="34" name="Text 32"/>
-          <p:cNvSpPr/>
-          <p:nvPr/>
-        </p:nvSpPr>
-        <p:spPr>
-          <a:xfrm>
-            <a:off x="14069244" y="3550518"/>
-            <a:ext cx="3100440" cy="419100"/>
-          </a:xfrm>
-          <a:prstGeom prst="rect">
-            <a:avLst/>
-          </a:prstGeom>
-          <a:noFill/>
-          <a:ln/>
-        </p:spPr>
-        <p:txBody>
-          <a:bodyPr wrap="square" lIns="25400" tIns="25400" rIns="25400" bIns="25400" rtlCol="0" anchor="t">
-            <a:normAutofit lnSpcReduction="10000"/>
-          </a:bodyPr>
-          <a:lstStyle/>
-          <a:p>
-            <a:pPr marL="0" indent="0" algn="l">
-              <a:buNone/>
-            </a:pPr>
-            <a:r>
-              <a:rPr lang="en-US" sz="2475" b="1" dirty="0">
-                <a:solidFill>
-                  <a:srgbClr val="1A7A57"/>
-                </a:solidFill>
-                <a:latin typeface="Arial" pitchFamily="34" charset="0"/>
-                <a:ea typeface="Arial" pitchFamily="34" charset="-122"/>
-                <a:cs typeface="Arial" pitchFamily="34" charset="-120"/>
-              </a:rPr>
-              <a:t>AUC 0.497</a:t>
-            </a:r>
-            <a:endParaRPr lang="en-US" sz="2475" dirty="0"/>
-          </a:p>
-        </p:txBody>
-      </p:sp>
-      <p:sp>
-        <p:nvSpPr>
-          <p:cNvPr id="35" name="Text 33"/>
-          <p:cNvSpPr/>
-          <p:nvPr/>
-        </p:nvSpPr>
-        <p:spPr>
-          <a:xfrm>
-            <a:off x="10593512" y="4226793"/>
-            <a:ext cx="6649926" cy="1363861"/>
-          </a:xfrm>
-          <a:prstGeom prst="rect">
-            <a:avLst/>
-          </a:prstGeom>
-          <a:noFill/>
-          <a:ln/>
-        </p:spPr>
-        <p:txBody>
-          <a:bodyPr wrap="square" lIns="25400" tIns="25400" rIns="25400" bIns="25400" rtlCol="0" anchor="t">
-            <a:normAutofit fontScale="92500" lnSpcReduction="20000"/>
-          </a:bodyPr>
-          <a:lstStyle/>
-          <a:p>
-            <a:pPr marL="0" indent="0" algn="l">
-              <a:lnSpc>
-                <a:spcPct val="145000"/>
-              </a:lnSpc>
-              <a:buNone/>
-            </a:pPr>
-            <a:r>
-              <a:rPr lang="en-US" sz="1800" dirty="0">
-                <a:solidFill>
-                  <a:srgbClr val="244236"/>
-                </a:solidFill>
-                <a:latin typeface="Arial" pitchFamily="34" charset="0"/>
-                <a:ea typeface="Arial" pitchFamily="34" charset="-122"/>
-                <a:cs typeface="Arial" pitchFamily="34" charset="-120"/>
-              </a:rPr>
-              <a:t>A classifier separates train from test perfectly — but only via the </a:t>
-            </a:r>
-            <a:r>
-              <a:rPr lang="en-US" sz="1800" b="1" dirty="0">
-                <a:solidFill>
-                  <a:srgbClr val="063D22"/>
-                </a:solidFill>
-                <a:latin typeface="Arial" pitchFamily="34" charset="0"/>
-                <a:ea typeface="Arial" pitchFamily="34" charset="-122"/>
-                <a:cs typeface="Arial" pitchFamily="34" charset="-120"/>
-              </a:rPr>
-              <a:t>date </a:t>
-            </a:r>
-            <a:r>
-              <a:rPr lang="en-US" sz="1800" dirty="0">
-                <a:solidFill>
-                  <a:srgbClr val="244236"/>
-                </a:solidFill>
-                <a:latin typeface="Arial" pitchFamily="34" charset="0"/>
-                <a:ea typeface="Arial" pitchFamily="34" charset="-122"/>
-                <a:cs typeface="Arial" pitchFamily="34" charset="-120"/>
-              </a:rPr>
-              <a:t>(test is all May 2026). Drop the date features and it’s no better than chance, so the sets are </a:t>
-            </a:r>
-            <a:r>
-              <a:rPr lang="en-US" sz="1800" b="1" dirty="0">
-                <a:solidFill>
-                  <a:srgbClr val="063D22"/>
-                </a:solidFill>
-                <a:latin typeface="Arial" pitchFamily="34" charset="0"/>
-                <a:ea typeface="Arial" pitchFamily="34" charset="-122"/>
-                <a:cs typeface="Arial" pitchFamily="34" charset="-120"/>
-              </a:rPr>
-              <a:t>identically distributed apart from time </a:t>
-            </a:r>
-            <a:r>
-              <a:rPr lang="en-US" sz="1800" dirty="0">
-                <a:solidFill>
-                  <a:srgbClr val="244236"/>
-                </a:solidFill>
-                <a:latin typeface="Arial" pitchFamily="34" charset="0"/>
-                <a:ea typeface="Arial" pitchFamily="34" charset="-122"/>
-                <a:cs typeface="Arial" pitchFamily="34" charset="-120"/>
-              </a:rPr>
-              <a:t>.</a:t>
-            </a:r>
-            <a:endParaRPr lang="en-US" sz="1800" dirty="0"/>
-          </a:p>
-        </p:txBody>
-      </p:sp>
-      <p:sp>
-        <p:nvSpPr>
-          <p:cNvPr id="36" name="Shape 34"/>
-          <p:cNvSpPr/>
-          <p:nvPr/>
-        </p:nvSpPr>
-        <p:spPr>
-          <a:xfrm>
-            <a:off x="10307762" y="6028804"/>
-            <a:ext cx="7027738" cy="3210446"/>
-          </a:xfrm>
-          <a:prstGeom prst="roundRect">
-            <a:avLst>
-              <a:gd name="adj" fmla="val 3560"/>
-            </a:avLst>
-          </a:prstGeom>
-          <a:solidFill>
-            <a:srgbClr val="E6F5EF"/>
-          </a:solidFill>
-          <a:ln/>
-        </p:spPr>
-        <p:txBody>
-          <a:bodyPr/>
-          <a:lstStyle/>
-          <a:p>
-            <a:endParaRPr lang="en-GB"/>
-          </a:p>
-        </p:txBody>
-      </p:sp>
-      <p:sp>
-        <p:nvSpPr>
-          <p:cNvPr id="37" name="Text 35"/>
-          <p:cNvSpPr/>
-          <p:nvPr/>
-        </p:nvSpPr>
-        <p:spPr>
-          <a:xfrm>
-            <a:off x="10574462" y="6257404"/>
-            <a:ext cx="7143772" cy="338138"/>
-          </a:xfrm>
-          <a:prstGeom prst="rect">
-            <a:avLst/>
-          </a:prstGeom>
-          <a:noFill/>
-          <a:ln/>
-        </p:spPr>
-        <p:txBody>
-          <a:bodyPr wrap="square" lIns="25400" tIns="25400" rIns="25400" bIns="25400" rtlCol="0" anchor="t">
-            <a:normAutofit lnSpcReduction="10000"/>
-          </a:bodyPr>
-          <a:lstStyle/>
-          <a:p>
-            <a:pPr marL="0" indent="0" algn="l">
-              <a:buNone/>
-            </a:pPr>
-            <a:r>
-              <a:rPr lang="en-US" sz="1950" b="1" dirty="0">
-                <a:solidFill>
-                  <a:srgbClr val="063D22"/>
-                </a:solidFill>
-                <a:latin typeface="Arial" pitchFamily="34" charset="0"/>
-                <a:ea typeface="Arial" pitchFamily="34" charset="-122"/>
-                <a:cs typeface="Arial" pitchFamily="34" charset="-120"/>
-              </a:rPr>
-              <a:t>What drives the model</a:t>
-            </a:r>
-            <a:endParaRPr lang="en-US" sz="1950" dirty="0"/>
-          </a:p>
-        </p:txBody>
-      </p:sp>
-      <p:sp>
-        <p:nvSpPr>
-          <p:cNvPr id="38" name="Text 36"/>
-          <p:cNvSpPr/>
-          <p:nvPr/>
-        </p:nvSpPr>
-        <p:spPr>
-          <a:xfrm>
-            <a:off x="10574462" y="6595542"/>
-            <a:ext cx="7143772" cy="335235"/>
-          </a:xfrm>
-          <a:prstGeom prst="rect">
-            <a:avLst/>
-          </a:prstGeom>
-          <a:noFill/>
-          <a:ln/>
-        </p:spPr>
-        <p:txBody>
-          <a:bodyPr wrap="square" lIns="25400" tIns="25400" rIns="25400" bIns="25400" rtlCol="0" anchor="t">
-            <a:normAutofit fontScale="92500" lnSpcReduction="20000"/>
-          </a:bodyPr>
-          <a:lstStyle/>
-          <a:p>
-            <a:pPr marL="0" indent="0" algn="l">
-              <a:lnSpc>
-                <a:spcPct val="130000"/>
-              </a:lnSpc>
-              <a:buNone/>
-            </a:pPr>
-            <a:r>
-              <a:rPr lang="en-US" sz="1800" dirty="0">
-                <a:solidFill>
-                  <a:srgbClr val="5C7268"/>
-                </a:solidFill>
-                <a:latin typeface="Arial" pitchFamily="34" charset="0"/>
-                <a:ea typeface="Arial" pitchFamily="34" charset="-122"/>
-                <a:cs typeface="Arial" pitchFamily="34" charset="-120"/>
-              </a:rPr>
-              <a:t>Most important features, by gain.</a:t>
-            </a:r>
-            <a:endParaRPr lang="en-US" sz="1800" dirty="0"/>
-          </a:p>
-        </p:txBody>
-      </p:sp>
-      <p:sp>
-        <p:nvSpPr>
-          <p:cNvPr id="39" name="Shape 37"/>
-          <p:cNvSpPr/>
-          <p:nvPr/>
-        </p:nvSpPr>
-        <p:spPr>
-          <a:xfrm>
-            <a:off x="952500" y="9239250"/>
-            <a:ext cx="16383000" cy="9525"/>
-          </a:xfrm>
-          <a:prstGeom prst="rect">
-            <a:avLst/>
-          </a:prstGeom>
-          <a:solidFill>
-            <a:srgbClr val="D2E6DD"/>
-          </a:solidFill>
-          <a:ln/>
-        </p:spPr>
-        <p:txBody>
-          <a:bodyPr/>
-          <a:lstStyle/>
-          <a:p>
-            <a:endParaRPr lang="en-GB"/>
-          </a:p>
-        </p:txBody>
-      </p:sp>
-      <p:sp>
-        <p:nvSpPr>
-          <p:cNvPr id="40" name="Text 38"/>
-          <p:cNvSpPr/>
-          <p:nvPr/>
-        </p:nvSpPr>
-        <p:spPr>
-          <a:xfrm>
-            <a:off x="952500" y="9458325"/>
-            <a:ext cx="16874490" cy="295275"/>
-          </a:xfrm>
-          <a:prstGeom prst="rect">
-            <a:avLst/>
-          </a:prstGeom>
-          <a:noFill/>
-          <a:ln/>
-        </p:spPr>
-        <p:txBody>
-          <a:bodyPr wrap="square" lIns="25400" tIns="25400" rIns="25400" bIns="25400" rtlCol="0" anchor="t">
-            <a:normAutofit fontScale="92500" lnSpcReduction="10000"/>
-          </a:bodyPr>
-          <a:lstStyle/>
-          <a:p>
-            <a:pPr marL="0" indent="0" algn="l">
-              <a:buNone/>
-            </a:pPr>
-            <a:r>
-              <a:rPr lang="en-US" sz="1800" dirty="0">
-                <a:solidFill>
-                  <a:srgbClr val="5C7268"/>
-                </a:solidFill>
-                <a:latin typeface="Courier New" pitchFamily="34" charset="0"/>
-                <a:ea typeface="Courier New" pitchFamily="34" charset="-122"/>
-                <a:cs typeface="Courier New" pitchFamily="34" charset="-120"/>
-              </a:rPr>
-              <a:t>Source: team validation · rolling next-month testing</a:t>
-            </a:r>
-            <a:endParaRPr lang="en-US" sz="1800" dirty="0"/>
-          </a:p>
-        </p:txBody>
-      </p:sp>
-      <p:pic>
-        <p:nvPicPr>
-          <p:cNvPr id="41" name="Picture 40" descr="deck_importance.png"/>
-          <p:cNvPicPr>
-            <a:picLocks noChangeAspect="1"/>
-          </p:cNvPicPr>
-          <p:nvPr/>
-        </p:nvPicPr>
-        <p:blipFill>
-          <a:blip r:embed="rId3"/>
-          <a:stretch>
-            <a:fillRect/>
-          </a:stretch>
-        </p:blipFill>
-        <p:spPr>
-          <a:xfrm>
-            <a:off x="10515600" y="6967728"/>
-            <a:ext cx="6583680" cy="2139696"/>
-          </a:xfrm>
-          <a:prstGeom prst="rect">
-            <a:avLst/>
-          </a:prstGeom>
-        </p:spPr>
-      </p:pic>
-      <p:sp>
-        <p:nvSpPr>
-          <p:cNvPr id="42" name="Rounded Rectangle 41"/>
-          <p:cNvSpPr/>
-          <p:nvPr/>
-        </p:nvSpPr>
-        <p:spPr>
-          <a:xfrm>
-            <a:off x="950976" y="6967728"/>
-            <a:ext cx="8595360" cy="1207008"/>
-          </a:xfrm>
-          <a:prstGeom prst="roundRect">
-            <a:avLst/>
-          </a:prstGeom>
-          <a:solidFill>
-            <a:srgbClr val="063D22"/>
-          </a:solidFill>
-          <a:ln>
-            <a:noFill/>
           </a:ln>
           <a:effectLst/>
         </p:spPr>
@@ -13952,54 +12629,782 @@
           </a:fontRef>
         </p:style>
         <p:txBody>
-          <a:bodyPr rtlCol="0" anchor="ctr" wrap="square" lIns="274320" tIns="146304" rIns="182880" bIns="109728"/>
-          <a:lstStyle/>
-          <a:p>
-            <a:pPr algn="l">
-              <a:spcAft>
-                <a:spcPts val="300"/>
-              </a:spcAft>
-            </a:pPr>
+          <a:bodyPr rtlCol="0" anchor="ctr" wrap="square"/>
+          <a:lstStyle/>
+          <a:p>
+            <a:pPr algn="ctr"/>
+            <a:r>
+              <a:rPr sz="1800" b="1">
+                <a:solidFill>
+                  <a:srgbClr val="063D22"/>
+                </a:solidFill>
+                <a:latin typeface="Arial"/>
+              </a:rPr>
+              <a:t>clean X</a:t>
+            </a:r>
+          </a:p>
+          <a:p>
+            <a:pPr algn="ctr"/>
             <a:r>
               <a:rPr sz="1300" b="0">
                 <a:solidFill>
-                  <a:srgbClr val="8FD0BB"/>
-                </a:solidFill>
-                <a:latin typeface="Courier New"/>
-              </a:rPr>
-              <a:t>FINAL MODEL</a:t>
-            </a:r>
-          </a:p>
-          <a:p>
-            <a:pPr algn="l">
-              <a:spcAft>
-                <a:spcPts val="300"/>
-              </a:spcAft>
-            </a:pPr>
-            <a:r>
-              <a:rPr sz="1700" b="1">
+                  <a:srgbClr val="5C7268"/>
+                </a:solidFill>
+                <a:latin typeface="Arial"/>
+              </a:rPr>
+              <a:t>20 features</a:t>
+            </a:r>
+          </a:p>
+        </p:txBody>
+      </p:sp>
+      <p:sp>
+        <p:nvSpPr>
+          <p:cNvPr id="42" name="Rounded Rectangle 41"/>
+          <p:cNvSpPr/>
+          <p:nvPr/>
+        </p:nvSpPr>
+        <p:spPr>
+          <a:xfrm>
+            <a:off x="5029200" y="2148840"/>
+            <a:ext cx="4114800" cy="749808"/>
+          </a:xfrm>
+          <a:prstGeom prst="roundRect">
+            <a:avLst/>
+          </a:prstGeom>
+          <a:solidFill>
+            <a:srgbClr val="FFFFFF"/>
+          </a:solidFill>
+          <a:ln w="19050">
+            <a:solidFill>
+              <a:srgbClr val="2E8B62"/>
+            </a:solidFill>
+          </a:ln>
+          <a:effectLst/>
+        </p:spPr>
+        <p:style>
+          <a:lnRef idx="1">
+            <a:schemeClr val="accent1"/>
+          </a:lnRef>
+          <a:fillRef idx="3">
+            <a:schemeClr val="accent1"/>
+          </a:fillRef>
+          <a:effectRef idx="2">
+            <a:schemeClr val="accent1"/>
+          </a:effectRef>
+          <a:fontRef idx="minor">
+            <a:schemeClr val="lt1"/>
+          </a:fontRef>
+        </p:style>
+        <p:txBody>
+          <a:bodyPr rtlCol="0" anchor="ctr" wrap="square"/>
+          <a:lstStyle/>
+          <a:p>
+            <a:pPr algn="ctr"/>
+            <a:r>
+              <a:rPr sz="1600" b="1">
+                <a:solidFill>
+                  <a:srgbClr val="063D22"/>
+                </a:solidFill>
+                <a:latin typeface="Arial"/>
+              </a:rPr>
+              <a:t>9 × LightGBM</a:t>
+            </a:r>
+          </a:p>
+        </p:txBody>
+      </p:sp>
+      <p:sp>
+        <p:nvSpPr>
+          <p:cNvPr id="43" name="Rounded Rectangle 42"/>
+          <p:cNvSpPr/>
+          <p:nvPr/>
+        </p:nvSpPr>
+        <p:spPr>
+          <a:xfrm>
+            <a:off x="5029200" y="2962656"/>
+            <a:ext cx="4114800" cy="749808"/>
+          </a:xfrm>
+          <a:prstGeom prst="roundRect">
+            <a:avLst/>
+          </a:prstGeom>
+          <a:solidFill>
+            <a:srgbClr val="FFFFFF"/>
+          </a:solidFill>
+          <a:ln w="19050">
+            <a:solidFill>
+              <a:srgbClr val="2E8B62"/>
+            </a:solidFill>
+          </a:ln>
+          <a:effectLst/>
+        </p:spPr>
+        <p:style>
+          <a:lnRef idx="1">
+            <a:schemeClr val="accent1"/>
+          </a:lnRef>
+          <a:fillRef idx="3">
+            <a:schemeClr val="accent1"/>
+          </a:fillRef>
+          <a:effectRef idx="2">
+            <a:schemeClr val="accent1"/>
+          </a:effectRef>
+          <a:fontRef idx="minor">
+            <a:schemeClr val="lt1"/>
+          </a:fontRef>
+        </p:style>
+        <p:txBody>
+          <a:bodyPr rtlCol="0" anchor="ctr" wrap="square"/>
+          <a:lstStyle/>
+          <a:p>
+            <a:pPr algn="ctr"/>
+            <a:r>
+              <a:rPr sz="1600" b="1">
+                <a:solidFill>
+                  <a:srgbClr val="063D22"/>
+                </a:solidFill>
+                <a:latin typeface="Arial"/>
+              </a:rPr>
+              <a:t>3 × XGBoost</a:t>
+            </a:r>
+          </a:p>
+        </p:txBody>
+      </p:sp>
+      <p:sp>
+        <p:nvSpPr>
+          <p:cNvPr id="44" name="Rounded Rectangle 43"/>
+          <p:cNvSpPr/>
+          <p:nvPr/>
+        </p:nvSpPr>
+        <p:spPr>
+          <a:xfrm>
+            <a:off x="5029200" y="3776472"/>
+            <a:ext cx="4114800" cy="749808"/>
+          </a:xfrm>
+          <a:prstGeom prst="roundRect">
+            <a:avLst/>
+          </a:prstGeom>
+          <a:solidFill>
+            <a:srgbClr val="FFFFFF"/>
+          </a:solidFill>
+          <a:ln w="19050">
+            <a:solidFill>
+              <a:srgbClr val="2E8B62"/>
+            </a:solidFill>
+          </a:ln>
+          <a:effectLst/>
+        </p:spPr>
+        <p:style>
+          <a:lnRef idx="1">
+            <a:schemeClr val="accent1"/>
+          </a:lnRef>
+          <a:fillRef idx="3">
+            <a:schemeClr val="accent1"/>
+          </a:fillRef>
+          <a:effectRef idx="2">
+            <a:schemeClr val="accent1"/>
+          </a:effectRef>
+          <a:fontRef idx="minor">
+            <a:schemeClr val="lt1"/>
+          </a:fontRef>
+        </p:style>
+        <p:txBody>
+          <a:bodyPr rtlCol="0" anchor="ctr" wrap="square"/>
+          <a:lstStyle/>
+          <a:p>
+            <a:pPr algn="ctr"/>
+            <a:r>
+              <a:rPr sz="1600" b="1">
+                <a:solidFill>
+                  <a:srgbClr val="063D22"/>
+                </a:solidFill>
+                <a:latin typeface="Arial"/>
+              </a:rPr>
+              <a:t>4 × CatBoost</a:t>
+            </a:r>
+          </a:p>
+        </p:txBody>
+      </p:sp>
+      <p:sp>
+        <p:nvSpPr>
+          <p:cNvPr id="45" name="Rounded Rectangle 44"/>
+          <p:cNvSpPr/>
+          <p:nvPr/>
+        </p:nvSpPr>
+        <p:spPr>
+          <a:xfrm>
+            <a:off x="10424160" y="2697480"/>
+            <a:ext cx="3108960" cy="1280160"/>
+          </a:xfrm>
+          <a:prstGeom prst="roundRect">
+            <a:avLst/>
+          </a:prstGeom>
+          <a:solidFill>
+            <a:srgbClr val="2E8B62"/>
+          </a:solidFill>
+          <a:ln>
+            <a:noFill/>
+          </a:ln>
+          <a:effectLst/>
+        </p:spPr>
+        <p:style>
+          <a:lnRef idx="1">
+            <a:schemeClr val="accent1"/>
+          </a:lnRef>
+          <a:fillRef idx="3">
+            <a:schemeClr val="accent1"/>
+          </a:fillRef>
+          <a:effectRef idx="2">
+            <a:schemeClr val="accent1"/>
+          </a:effectRef>
+          <a:fontRef idx="minor">
+            <a:schemeClr val="lt1"/>
+          </a:fontRef>
+        </p:style>
+        <p:txBody>
+          <a:bodyPr rtlCol="0" anchor="ctr" wrap="square"/>
+          <a:lstStyle/>
+          <a:p>
+            <a:pPr algn="ctr"/>
+            <a:r>
+              <a:rPr sz="1800" b="1">
                 <a:solidFill>
                   <a:srgbClr val="FFFFFF"/>
                 </a:solidFill>
                 <a:latin typeface="Arial"/>
               </a:rPr>
-              <a:t>Ensemble — LightGBM + XGBoost + CatBoost</a:t>
-            </a:r>
-          </a:p>
-          <a:p>
-            <a:pPr algn="l">
-              <a:spcAft>
-                <a:spcPts val="300"/>
-              </a:spcAft>
-            </a:pPr>
-            <a:r>
-              <a:rPr sz="1400" b="0">
+              <a:t>mean blend</a:t>
+            </a:r>
+          </a:p>
+          <a:p>
+            <a:pPr algn="ctr"/>
+            <a:r>
+              <a:rPr sz="1300" b="0">
+                <a:solidFill>
+                  <a:srgbClr val="EAF3EF"/>
+                </a:solidFill>
+                <a:latin typeface="Arial"/>
+              </a:rPr>
+              <a:t>16 → 1 probability</a:t>
+            </a:r>
+          </a:p>
+        </p:txBody>
+      </p:sp>
+      <p:sp>
+        <p:nvSpPr>
+          <p:cNvPr id="46" name="Rounded Rectangle 45"/>
+          <p:cNvSpPr/>
+          <p:nvPr/>
+        </p:nvSpPr>
+        <p:spPr>
+          <a:xfrm>
+            <a:off x="14630400" y="2834640"/>
+            <a:ext cx="2651760" cy="1005840"/>
+          </a:xfrm>
+          <a:prstGeom prst="roundRect">
+            <a:avLst/>
+          </a:prstGeom>
+          <a:solidFill>
+            <a:srgbClr val="063D22"/>
+          </a:solidFill>
+          <a:ln>
+            <a:noFill/>
+          </a:ln>
+          <a:effectLst/>
+        </p:spPr>
+        <p:style>
+          <a:lnRef idx="1">
+            <a:schemeClr val="accent1"/>
+          </a:lnRef>
+          <a:fillRef idx="3">
+            <a:schemeClr val="accent1"/>
+          </a:fillRef>
+          <a:effectRef idx="2">
+            <a:schemeClr val="accent1"/>
+          </a:effectRef>
+          <a:fontRef idx="minor">
+            <a:schemeClr val="lt1"/>
+          </a:fontRef>
+        </p:style>
+        <p:txBody>
+          <a:bodyPr rtlCol="0" anchor="ctr" wrap="square"/>
+          <a:lstStyle/>
+          <a:p>
+            <a:pPr algn="ctr"/>
+            <a:r>
+              <a:rPr sz="1600" b="1">
+                <a:solidFill>
+                  <a:srgbClr val="FFFFFF"/>
+                </a:solidFill>
+                <a:latin typeface="Arial"/>
+              </a:rPr>
+              <a:t>smooth cutoff</a:t>
+            </a:r>
+          </a:p>
+          <a:p>
+            <a:pPr algn="ctr"/>
+            <a:r>
+              <a:rPr sz="1300" b="0">
                 <a:solidFill>
                   <a:srgbClr val="BCDDCE"/>
                 </a:solidFill>
                 <a:latin typeface="Arial"/>
               </a:rPr>
-              <a:t>+ pseudo-labeling &amp; smooth threshold  →  0.859 accuracy</a:t>
+              <a:t>≈ 0.527</a:t>
+            </a:r>
+          </a:p>
+        </p:txBody>
+      </p:sp>
+      <p:cxnSp>
+        <p:nvCxnSpPr>
+          <p:cNvPr id="47" name="Connector 46"/>
+          <p:cNvCxnSpPr/>
+          <p:nvPr/>
+        </p:nvCxnSpPr>
+        <p:spPr>
+          <a:xfrm flipV="1">
+            <a:off x="3694176" y="2523744"/>
+            <a:ext cx="1335024" cy="813816"/>
+          </a:xfrm>
+          <a:prstGeom prst="line">
+            <a:avLst/>
+          </a:prstGeom>
+          <a:ln w="28575">
+            <a:solidFill>
+              <a:srgbClr val="063D22"/>
+            </a:solidFill>
+            <a:tailEnd type="triangle" w="med" len="med"/>
+          </a:ln>
+        </p:spPr>
+        <p:style>
+          <a:lnRef idx="2">
+            <a:schemeClr val="accent1"/>
+          </a:lnRef>
+          <a:fillRef idx="0">
+            <a:schemeClr val="accent1"/>
+          </a:fillRef>
+          <a:effectRef idx="1">
+            <a:schemeClr val="accent1"/>
+          </a:effectRef>
+          <a:fontRef idx="minor">
+            <a:schemeClr val="tx1"/>
+          </a:fontRef>
+        </p:style>
+      </p:cxnSp>
+      <p:cxnSp>
+        <p:nvCxnSpPr>
+          <p:cNvPr id="48" name="Connector 47"/>
+          <p:cNvCxnSpPr/>
+          <p:nvPr/>
+        </p:nvCxnSpPr>
+        <p:spPr>
+          <a:xfrm>
+            <a:off x="3694176" y="3337560"/>
+            <a:ext cx="1335024" cy="0"/>
+          </a:xfrm>
+          <a:prstGeom prst="line">
+            <a:avLst/>
+          </a:prstGeom>
+          <a:ln w="28575">
+            <a:solidFill>
+              <a:srgbClr val="063D22"/>
+            </a:solidFill>
+            <a:tailEnd type="triangle" w="med" len="med"/>
+          </a:ln>
+        </p:spPr>
+        <p:style>
+          <a:lnRef idx="2">
+            <a:schemeClr val="accent1"/>
+          </a:lnRef>
+          <a:fillRef idx="0">
+            <a:schemeClr val="accent1"/>
+          </a:fillRef>
+          <a:effectRef idx="1">
+            <a:schemeClr val="accent1"/>
+          </a:effectRef>
+          <a:fontRef idx="minor">
+            <a:schemeClr val="tx1"/>
+          </a:fontRef>
+        </p:style>
+      </p:cxnSp>
+      <p:cxnSp>
+        <p:nvCxnSpPr>
+          <p:cNvPr id="49" name="Connector 48"/>
+          <p:cNvCxnSpPr/>
+          <p:nvPr/>
+        </p:nvCxnSpPr>
+        <p:spPr>
+          <a:xfrm>
+            <a:off x="3694176" y="3337560"/>
+            <a:ext cx="1335024" cy="813816"/>
+          </a:xfrm>
+          <a:prstGeom prst="line">
+            <a:avLst/>
+          </a:prstGeom>
+          <a:ln w="28575">
+            <a:solidFill>
+              <a:srgbClr val="063D22"/>
+            </a:solidFill>
+            <a:tailEnd type="triangle" w="med" len="med"/>
+          </a:ln>
+        </p:spPr>
+        <p:style>
+          <a:lnRef idx="2">
+            <a:schemeClr val="accent1"/>
+          </a:lnRef>
+          <a:fillRef idx="0">
+            <a:schemeClr val="accent1"/>
+          </a:fillRef>
+          <a:effectRef idx="1">
+            <a:schemeClr val="accent1"/>
+          </a:effectRef>
+          <a:fontRef idx="minor">
+            <a:schemeClr val="tx1"/>
+          </a:fontRef>
+        </p:style>
+      </p:cxnSp>
+      <p:cxnSp>
+        <p:nvCxnSpPr>
+          <p:cNvPr id="50" name="Connector 49"/>
+          <p:cNvCxnSpPr/>
+          <p:nvPr/>
+        </p:nvCxnSpPr>
+        <p:spPr>
+          <a:xfrm>
+            <a:off x="9144000" y="2523744"/>
+            <a:ext cx="1280160" cy="813816"/>
+          </a:xfrm>
+          <a:prstGeom prst="line">
+            <a:avLst/>
+          </a:prstGeom>
+          <a:ln w="28575">
+            <a:solidFill>
+              <a:srgbClr val="063D22"/>
+            </a:solidFill>
+            <a:tailEnd type="triangle" w="med" len="med"/>
+          </a:ln>
+        </p:spPr>
+        <p:style>
+          <a:lnRef idx="2">
+            <a:schemeClr val="accent1"/>
+          </a:lnRef>
+          <a:fillRef idx="0">
+            <a:schemeClr val="accent1"/>
+          </a:fillRef>
+          <a:effectRef idx="1">
+            <a:schemeClr val="accent1"/>
+          </a:effectRef>
+          <a:fontRef idx="minor">
+            <a:schemeClr val="tx1"/>
+          </a:fontRef>
+        </p:style>
+      </p:cxnSp>
+      <p:cxnSp>
+        <p:nvCxnSpPr>
+          <p:cNvPr id="51" name="Connector 50"/>
+          <p:cNvCxnSpPr/>
+          <p:nvPr/>
+        </p:nvCxnSpPr>
+        <p:spPr>
+          <a:xfrm>
+            <a:off x="9144000" y="3337560"/>
+            <a:ext cx="1280160" cy="0"/>
+          </a:xfrm>
+          <a:prstGeom prst="line">
+            <a:avLst/>
+          </a:prstGeom>
+          <a:ln w="28575">
+            <a:solidFill>
+              <a:srgbClr val="063D22"/>
+            </a:solidFill>
+            <a:tailEnd type="triangle" w="med" len="med"/>
+          </a:ln>
+        </p:spPr>
+        <p:style>
+          <a:lnRef idx="2">
+            <a:schemeClr val="accent1"/>
+          </a:lnRef>
+          <a:fillRef idx="0">
+            <a:schemeClr val="accent1"/>
+          </a:fillRef>
+          <a:effectRef idx="1">
+            <a:schemeClr val="accent1"/>
+          </a:effectRef>
+          <a:fontRef idx="minor">
+            <a:schemeClr val="tx1"/>
+          </a:fontRef>
+        </p:style>
+      </p:cxnSp>
+      <p:cxnSp>
+        <p:nvCxnSpPr>
+          <p:cNvPr id="52" name="Connector 51"/>
+          <p:cNvCxnSpPr/>
+          <p:nvPr/>
+        </p:nvCxnSpPr>
+        <p:spPr>
+          <a:xfrm flipV="1">
+            <a:off x="9144000" y="3337560"/>
+            <a:ext cx="1280160" cy="813816"/>
+          </a:xfrm>
+          <a:prstGeom prst="line">
+            <a:avLst/>
+          </a:prstGeom>
+          <a:ln w="28575">
+            <a:solidFill>
+              <a:srgbClr val="063D22"/>
+            </a:solidFill>
+            <a:tailEnd type="triangle" w="med" len="med"/>
+          </a:ln>
+        </p:spPr>
+        <p:style>
+          <a:lnRef idx="2">
+            <a:schemeClr val="accent1"/>
+          </a:lnRef>
+          <a:fillRef idx="0">
+            <a:schemeClr val="accent1"/>
+          </a:fillRef>
+          <a:effectRef idx="1">
+            <a:schemeClr val="accent1"/>
+          </a:effectRef>
+          <a:fontRef idx="minor">
+            <a:schemeClr val="tx1"/>
+          </a:fontRef>
+        </p:style>
+      </p:cxnSp>
+      <p:cxnSp>
+        <p:nvCxnSpPr>
+          <p:cNvPr id="53" name="Connector 52"/>
+          <p:cNvCxnSpPr/>
+          <p:nvPr/>
+        </p:nvCxnSpPr>
+        <p:spPr>
+          <a:xfrm>
+            <a:off x="13533120" y="3337560"/>
+            <a:ext cx="1097280" cy="0"/>
+          </a:xfrm>
+          <a:prstGeom prst="line">
+            <a:avLst/>
+          </a:prstGeom>
+          <a:ln w="28575">
+            <a:solidFill>
+              <a:srgbClr val="063D22"/>
+            </a:solidFill>
+            <a:tailEnd type="triangle" w="med" len="med"/>
+          </a:ln>
+        </p:spPr>
+        <p:style>
+          <a:lnRef idx="2">
+            <a:schemeClr val="accent1"/>
+          </a:lnRef>
+          <a:fillRef idx="0">
+            <a:schemeClr val="accent1"/>
+          </a:fillRef>
+          <a:effectRef idx="1">
+            <a:schemeClr val="accent1"/>
+          </a:effectRef>
+          <a:fontRef idx="minor">
+            <a:schemeClr val="tx1"/>
+          </a:fontRef>
+        </p:style>
+      </p:cxnSp>
+      <p:sp>
+        <p:nvSpPr>
+          <p:cNvPr id="54" name="Rounded Rectangle 53"/>
+          <p:cNvSpPr/>
+          <p:nvPr/>
+        </p:nvSpPr>
+        <p:spPr>
+          <a:xfrm>
+            <a:off x="950976" y="4983480"/>
+            <a:ext cx="16367759" cy="868680"/>
+          </a:xfrm>
+          <a:prstGeom prst="roundRect">
+            <a:avLst/>
+          </a:prstGeom>
+          <a:solidFill>
+            <a:srgbClr val="F4F8F6"/>
+          </a:solidFill>
+          <a:ln w="19050">
+            <a:solidFill>
+              <a:srgbClr val="C8D4CF"/>
+            </a:solidFill>
+          </a:ln>
+          <a:effectLst/>
+        </p:spPr>
+        <p:style>
+          <a:lnRef idx="1">
+            <a:schemeClr val="accent1"/>
+          </a:lnRef>
+          <a:fillRef idx="3">
+            <a:schemeClr val="accent1"/>
+          </a:fillRef>
+          <a:effectRef idx="2">
+            <a:schemeClr val="accent1"/>
+          </a:effectRef>
+          <a:fontRef idx="minor">
+            <a:schemeClr val="lt1"/>
+          </a:fontRef>
+        </p:style>
+        <p:txBody>
+          <a:bodyPr rtlCol="0" anchor="ctr" wrap="square"/>
+          <a:lstStyle/>
+          <a:p>
+            <a:pPr algn="ctr"/>
+            <a:r>
+              <a:rPr sz="1500" b="1">
+                <a:solidFill>
+                  <a:srgbClr val="063D22"/>
+                </a:solidFill>
+                <a:latin typeface="Arial"/>
+              </a:rPr>
+              <a:t>Pseudo-labeling pass (v8 / v10)</a:t>
+            </a:r>
+          </a:p>
+          <a:p>
+            <a:pPr algn="ctr"/>
+            <a:r>
+              <a:rPr sz="1300" b="0">
+                <a:solidFill>
+                  <a:srgbClr val="5C7268"/>
+                </a:solidFill>
+                <a:latin typeface="Arial"/>
+              </a:rPr>
+              <a:t>confident test rows (≥ 0.97) added at weight 0.5  —  +0.14 pt on rolling validation</a:t>
+            </a:r>
+          </a:p>
+        </p:txBody>
+      </p:sp>
+      <p:sp>
+        <p:nvSpPr>
+          <p:cNvPr id="55" name="TextBox 54"/>
+          <p:cNvSpPr txBox="1"/>
+          <p:nvPr/>
+        </p:nvSpPr>
+        <p:spPr>
+          <a:xfrm>
+            <a:off x="950976" y="5943600"/>
+            <a:ext cx="16367759" cy="365760"/>
+          </a:xfrm>
+          <a:prstGeom prst="rect">
+            <a:avLst/>
+          </a:prstGeom>
+          <a:noFill/>
+        </p:spPr>
+        <p:txBody>
+          <a:bodyPr wrap="none">
+            <a:spAutoFit/>
+          </a:bodyPr>
+          <a:lstStyle/>
+          <a:p>
+            <a:pPr algn="ctr"/>
+            <a:r>
+              <a:rPr sz="1400" i="1">
+                <a:solidFill>
+                  <a:srgbClr val="5C7268"/>
+                </a:solidFill>
+                <a:latin typeface="Arial"/>
+              </a:rPr>
+              <a:t>From clean features to a single approve / reject decision per applicant.</a:t>
+            </a:r>
+          </a:p>
+        </p:txBody>
+      </p:sp>
+      <p:sp>
+        <p:nvSpPr>
+          <p:cNvPr id="56" name="TextBox 55"/>
+          <p:cNvSpPr txBox="1"/>
+          <p:nvPr/>
+        </p:nvSpPr>
+        <p:spPr>
+          <a:xfrm>
+            <a:off x="950976" y="6446520"/>
+            <a:ext cx="10972800" cy="365760"/>
+          </a:xfrm>
+          <a:prstGeom prst="rect">
+            <a:avLst/>
+          </a:prstGeom>
+          <a:noFill/>
+        </p:spPr>
+        <p:txBody>
+          <a:bodyPr wrap="none">
+            <a:spAutoFit/>
+          </a:bodyPr>
+          <a:lstStyle/>
+          <a:p>
+            <a:r>
+              <a:rPr sz="2000" b="1">
+                <a:solidFill>
+                  <a:srgbClr val="063D22"/>
+                </a:solidFill>
+                <a:latin typeface="Arial"/>
+              </a:rPr>
+              <a:t>What drives the model — top features by gain</a:t>
+            </a:r>
+          </a:p>
+        </p:txBody>
+      </p:sp>
+      <p:pic>
+        <p:nvPicPr>
+          <p:cNvPr id="57" name="Picture 56" descr="deck_importance_wide.png"/>
+          <p:cNvPicPr>
+            <a:picLocks noChangeAspect="1"/>
+          </p:cNvPicPr>
+          <p:nvPr/>
+        </p:nvPicPr>
+        <p:blipFill>
+          <a:blip r:embed="rId4"/>
+          <a:stretch>
+            <a:fillRect/>
+          </a:stretch>
+        </p:blipFill>
+        <p:spPr>
+          <a:xfrm>
+            <a:off x="950976" y="6858000"/>
+            <a:ext cx="10058400" cy="2286000"/>
+          </a:xfrm>
+          <a:prstGeom prst="rect">
+            <a:avLst/>
+          </a:prstGeom>
+        </p:spPr>
+      </p:pic>
+      <p:sp>
+        <p:nvSpPr>
+          <p:cNvPr id="58" name="TextBox 57"/>
+          <p:cNvSpPr txBox="1"/>
+          <p:nvPr/>
+        </p:nvSpPr>
+        <p:spPr>
+          <a:xfrm>
+            <a:off x="11521440" y="7223760"/>
+            <a:ext cx="5760720" cy="1463040"/>
+          </a:xfrm>
+          <a:prstGeom prst="rect">
+            <a:avLst/>
+          </a:prstGeom>
+          <a:noFill/>
+        </p:spPr>
+        <p:txBody>
+          <a:bodyPr wrap="square">
+            <a:spAutoFit/>
+          </a:bodyPr>
+          <a:lstStyle/>
+          <a:p>
+            <a:r>
+              <a:rPr sz="1500">
+                <a:solidFill>
+                  <a:srgbClr val="5C7268"/>
+                </a:solidFill>
+                <a:latin typeface="Arial"/>
+              </a:rPr>
+              <a:t>The risk-shape and affordability features carry the model.</a:t>
+            </a:r>
+          </a:p>
+          <a:p>
+            <a:r>
+              <a:rPr sz="1500">
+                <a:solidFill>
+                  <a:srgbClr val="007A33"/>
+                </a:solidFill>
+                <a:latin typeface="Arial"/>
+              </a:rPr>
+              <a:t>What each feature is → slide 9.</a:t>
             </a:r>
           </a:p>
         </p:txBody>

</xml_diff>

<commit_message>
Riwad's manual edits (checkpoint before adding ensembling note)
</commit_message>
<xml_diff>
--- a/presentation/Consulting_Finance_ML_Slides.pptx
+++ b/presentation/Consulting_Finance_ML_Slides.pptx
@@ -12629,7 +12629,7 @@
           </a:fontRef>
         </p:style>
         <p:txBody>
-          <a:bodyPr rtlCol="0" anchor="ctr" wrap="square"/>
+          <a:bodyPr wrap="square" rtlCol="0" anchor="ctr"/>
           <a:lstStyle/>
           <a:p>
             <a:pPr algn="ctr"/>
@@ -12696,7 +12696,7 @@
           </a:fontRef>
         </p:style>
         <p:txBody>
-          <a:bodyPr rtlCol="0" anchor="ctr" wrap="square"/>
+          <a:bodyPr wrap="square" rtlCol="0" anchor="ctr"/>
           <a:lstStyle/>
           <a:p>
             <a:pPr algn="ctr"/>
@@ -12751,7 +12751,7 @@
           </a:fontRef>
         </p:style>
         <p:txBody>
-          <a:bodyPr rtlCol="0" anchor="ctr" wrap="square"/>
+          <a:bodyPr wrap="square" rtlCol="0" anchor="ctr"/>
           <a:lstStyle/>
           <a:p>
             <a:pPr algn="ctr"/>
@@ -12806,7 +12806,7 @@
           </a:fontRef>
         </p:style>
         <p:txBody>
-          <a:bodyPr rtlCol="0" anchor="ctr" wrap="square"/>
+          <a:bodyPr wrap="square" rtlCol="0" anchor="ctr"/>
           <a:lstStyle/>
           <a:p>
             <a:pPr algn="ctr"/>
@@ -12859,7 +12859,7 @@
           </a:fontRef>
         </p:style>
         <p:txBody>
-          <a:bodyPr rtlCol="0" anchor="ctr" wrap="square"/>
+          <a:bodyPr wrap="square" rtlCol="0" anchor="ctr"/>
           <a:lstStyle/>
           <a:p>
             <a:pPr algn="ctr"/>
@@ -12924,7 +12924,7 @@
           </a:fontRef>
         </p:style>
         <p:txBody>
-          <a:bodyPr rtlCol="0" anchor="ctr" wrap="square"/>
+          <a:bodyPr wrap="square" rtlCol="0" anchor="ctr"/>
           <a:lstStyle/>
           <a:p>
             <a:pPr algn="ctr"/>
@@ -13243,7 +13243,7 @@
           </a:fontRef>
         </p:style>
         <p:txBody>
-          <a:bodyPr rtlCol="0" anchor="ctr" wrap="square"/>
+          <a:bodyPr wrap="square" rtlCol="0" anchor="ctr"/>
           <a:lstStyle/>
           <a:p>
             <a:pPr algn="ctr"/>
@@ -13343,6 +13343,81 @@
       <p:pic>
         <p:nvPicPr>
           <p:cNvPr id="57" name="Picture 56" descr="deck_importance_wide.png"/>
+          <p:cNvPicPr>
+            <a:picLocks noChangeAspect="1"/>
+          </p:cNvPicPr>
+          <p:nvPr/>
+        </p:nvPicPr>
+        <p:blipFill>
+          <a:blip r:embed="rId3"/>
+          <a:stretch>
+            <a:fillRect/>
+          </a:stretch>
+        </p:blipFill>
+        <p:spPr>
+          <a:xfrm>
+            <a:off x="950976" y="6858000"/>
+            <a:ext cx="10058400" cy="2286000"/>
+          </a:xfrm>
+          <a:prstGeom prst="rect">
+            <a:avLst/>
+          </a:prstGeom>
+        </p:spPr>
+      </p:pic>
+      <p:sp>
+        <p:nvSpPr>
+          <p:cNvPr id="58" name="TextBox 57"/>
+          <p:cNvSpPr txBox="1"/>
+          <p:nvPr/>
+        </p:nvSpPr>
+        <p:spPr>
+          <a:xfrm>
+            <a:off x="11521440" y="7223760"/>
+            <a:ext cx="5760720" cy="1463040"/>
+          </a:xfrm>
+          <a:prstGeom prst="rect">
+            <a:avLst/>
+          </a:prstGeom>
+          <a:noFill/>
+        </p:spPr>
+        <p:txBody>
+          <a:bodyPr wrap="square">
+            <a:spAutoFit/>
+          </a:bodyPr>
+          <a:lstStyle/>
+          <a:p>
+            <a:r>
+              <a:rPr sz="1500">
+                <a:solidFill>
+                  <a:srgbClr val="5C7268"/>
+                </a:solidFill>
+                <a:latin typeface="Arial"/>
+              </a:rPr>
+              <a:t>The risk-shape and affordability features carry the model.</a:t>
+            </a:r>
+          </a:p>
+          <a:p>
+            <a:r>
+              <a:rPr sz="1500">
+                <a:solidFill>
+                  <a:srgbClr val="007A33"/>
+                </a:solidFill>
+                <a:latin typeface="Arial"/>
+              </a:rPr>
+              <a:t>What each feature is → slide 9.</a:t>
+            </a:r>
+          </a:p>
+        </p:txBody>
+      </p:sp>
+      <p:pic>
+        <p:nvPicPr>
+          <p:cNvPr id="5" name="Picture 4">
+            <a:extLst>
+              <a:ext uri="{FF2B5EF4-FFF2-40B4-BE49-F238E27FC236}">
+                <a16:creationId xmlns:a16="http://schemas.microsoft.com/office/drawing/2014/main" id="{B4E6C54B-8C83-317D-1AF4-3605A7D7896A}"/>
+              </a:ext>
+            </a:extLst>
+          </p:cNvPr>
           <p:cNvPicPr>
             <a:picLocks noChangeAspect="1"/>
           </p:cNvPicPr>
@@ -13356,59 +13431,104 @@
         </p:blipFill>
         <p:spPr>
           <a:xfrm>
-            <a:off x="950976" y="6858000"/>
-            <a:ext cx="10058400" cy="2286000"/>
+            <a:off x="5112256" y="2635767"/>
+            <a:ext cx="2503936" cy="196590"/>
           </a:xfrm>
           <a:prstGeom prst="rect">
             <a:avLst/>
           </a:prstGeom>
         </p:spPr>
       </p:pic>
-      <p:sp>
-        <p:nvSpPr>
-          <p:cNvPr id="58" name="TextBox 57"/>
-          <p:cNvSpPr txBox="1"/>
-          <p:nvPr/>
-        </p:nvSpPr>
-        <p:spPr>
-          <a:xfrm>
-            <a:off x="11521440" y="7223760"/>
-            <a:ext cx="5760720" cy="1463040"/>
-          </a:xfrm>
-          <a:prstGeom prst="rect">
-            <a:avLst/>
-          </a:prstGeom>
-          <a:noFill/>
-        </p:spPr>
-        <p:txBody>
-          <a:bodyPr wrap="square">
-            <a:spAutoFit/>
-          </a:bodyPr>
-          <a:lstStyle/>
-          <a:p>
-            <a:r>
-              <a:rPr sz="1500">
-                <a:solidFill>
-                  <a:srgbClr val="5C7268"/>
-                </a:solidFill>
-                <a:latin typeface="Arial"/>
-              </a:rPr>
-              <a:t>The risk-shape and affordability features carry the model.</a:t>
-            </a:r>
-          </a:p>
-          <a:p>
-            <a:r>
-              <a:rPr sz="1500">
-                <a:solidFill>
-                  <a:srgbClr val="007A33"/>
-                </a:solidFill>
-                <a:latin typeface="Arial"/>
-              </a:rPr>
-              <a:t>What each feature is → slide 9.</a:t>
-            </a:r>
-          </a:p>
-        </p:txBody>
-      </p:sp>
+      <p:pic>
+        <p:nvPicPr>
+          <p:cNvPr id="6" name="Picture 5">
+            <a:extLst>
+              <a:ext uri="{FF2B5EF4-FFF2-40B4-BE49-F238E27FC236}">
+                <a16:creationId xmlns:a16="http://schemas.microsoft.com/office/drawing/2014/main" id="{A27ABDAD-6D53-63BC-51E5-B5ADDE84859C}"/>
+              </a:ext>
+            </a:extLst>
+          </p:cNvPr>
+          <p:cNvPicPr>
+            <a:picLocks noChangeAspect="1"/>
+          </p:cNvPicPr>
+          <p:nvPr/>
+        </p:nvPicPr>
+        <p:blipFill>
+          <a:blip r:embed="rId5"/>
+          <a:stretch>
+            <a:fillRect/>
+          </a:stretch>
+        </p:blipFill>
+        <p:spPr>
+          <a:xfrm>
+            <a:off x="6472367" y="3463731"/>
+            <a:ext cx="1228465" cy="206382"/>
+          </a:xfrm>
+          <a:prstGeom prst="rect">
+            <a:avLst/>
+          </a:prstGeom>
+        </p:spPr>
+      </p:pic>
+      <p:pic>
+        <p:nvPicPr>
+          <p:cNvPr id="7" name="Picture 6">
+            <a:extLst>
+              <a:ext uri="{FF2B5EF4-FFF2-40B4-BE49-F238E27FC236}">
+                <a16:creationId xmlns:a16="http://schemas.microsoft.com/office/drawing/2014/main" id="{7951B2C4-E38E-FCB5-A933-51BC39E6D62E}"/>
+              </a:ext>
+            </a:extLst>
+          </p:cNvPr>
+          <p:cNvPicPr>
+            <a:picLocks noChangeAspect="1"/>
+          </p:cNvPicPr>
+          <p:nvPr/>
+        </p:nvPicPr>
+        <p:blipFill>
+          <a:blip r:embed="rId6"/>
+          <a:stretch>
+            <a:fillRect/>
+          </a:stretch>
+        </p:blipFill>
+        <p:spPr>
+          <a:xfrm>
+            <a:off x="6219251" y="4276858"/>
+            <a:ext cx="1734695" cy="173470"/>
+          </a:xfrm>
+          <a:prstGeom prst="rect">
+            <a:avLst/>
+          </a:prstGeom>
+        </p:spPr>
+      </p:pic>
+      <p:pic>
+        <p:nvPicPr>
+          <p:cNvPr id="8" name="Picture 7">
+            <a:extLst>
+              <a:ext uri="{FF2B5EF4-FFF2-40B4-BE49-F238E27FC236}">
+                <a16:creationId xmlns:a16="http://schemas.microsoft.com/office/drawing/2014/main" id="{096898CC-70E5-622C-2E42-FC0208C0771A}"/>
+              </a:ext>
+            </a:extLst>
+          </p:cNvPr>
+          <p:cNvPicPr>
+            <a:picLocks noChangeAspect="1"/>
+          </p:cNvPicPr>
+          <p:nvPr/>
+        </p:nvPicPr>
+        <p:blipFill>
+          <a:blip r:embed="rId5"/>
+          <a:stretch>
+            <a:fillRect/>
+          </a:stretch>
+        </p:blipFill>
+        <p:spPr>
+          <a:xfrm>
+            <a:off x="7765863" y="2643940"/>
+            <a:ext cx="1228465" cy="206382"/>
+          </a:xfrm>
+          <a:prstGeom prst="rect">
+            <a:avLst/>
+          </a:prstGeom>
+        </p:spPr>
+      </p:pic>
     </p:spTree>
   </p:cSld>
   <p:clrMapOvr>

</xml_diff>

<commit_message>
Slide 8: add 'Why blend 16 models?' ensembling explanation callout
Explains the ensembling rationale (different families make different mistakes;
averaging cancels random error, keeps signal). Placed bottom-right beside the
importance chart, replacing the minor feature-takeaway line.
</commit_message>
<xml_diff>
--- a/presentation/Consulting_Finance_ML_Slides.pptx
+++ b/presentation/Consulting_Finance_ML_Slides.pptx
@@ -13364,51 +13364,6 @@
           </a:prstGeom>
         </p:spPr>
       </p:pic>
-      <p:sp>
-        <p:nvSpPr>
-          <p:cNvPr id="58" name="TextBox 57"/>
-          <p:cNvSpPr txBox="1"/>
-          <p:nvPr/>
-        </p:nvSpPr>
-        <p:spPr>
-          <a:xfrm>
-            <a:off x="11521440" y="7223760"/>
-            <a:ext cx="5760720" cy="1463040"/>
-          </a:xfrm>
-          <a:prstGeom prst="rect">
-            <a:avLst/>
-          </a:prstGeom>
-          <a:noFill/>
-        </p:spPr>
-        <p:txBody>
-          <a:bodyPr wrap="square">
-            <a:spAutoFit/>
-          </a:bodyPr>
-          <a:lstStyle/>
-          <a:p>
-            <a:r>
-              <a:rPr sz="1500">
-                <a:solidFill>
-                  <a:srgbClr val="5C7268"/>
-                </a:solidFill>
-                <a:latin typeface="Arial"/>
-              </a:rPr>
-              <a:t>The risk-shape and affordability features carry the model.</a:t>
-            </a:r>
-          </a:p>
-          <a:p>
-            <a:r>
-              <a:rPr sz="1500">
-                <a:solidFill>
-                  <a:srgbClr val="007A33"/>
-                </a:solidFill>
-                <a:latin typeface="Arial"/>
-              </a:rPr>
-              <a:t>What each feature is → slide 9.</a:t>
-            </a:r>
-          </a:p>
-        </p:txBody>
-      </p:sp>
       <p:pic>
         <p:nvPicPr>
           <p:cNvPr id="5" name="Picture 4">
@@ -13529,6 +13484,109 @@
           </a:prstGeom>
         </p:spPr>
       </p:pic>
+      <p:sp>
+        <p:nvSpPr>
+          <p:cNvPr id="58" name="Rounded Rectangle 57"/>
+          <p:cNvSpPr/>
+          <p:nvPr/>
+        </p:nvSpPr>
+        <p:spPr>
+          <a:xfrm>
+            <a:off x="11475720" y="6766560"/>
+            <a:ext cx="5852160" cy="2057400"/>
+          </a:xfrm>
+          <a:prstGeom prst="roundRect">
+            <a:avLst/>
+          </a:prstGeom>
+          <a:solidFill>
+            <a:srgbClr val="EAF3EF"/>
+          </a:solidFill>
+          <a:ln>
+            <a:noFill/>
+          </a:ln>
+          <a:effectLst/>
+        </p:spPr>
+        <p:style>
+          <a:lnRef idx="1">
+            <a:schemeClr val="accent1"/>
+          </a:lnRef>
+          <a:fillRef idx="3">
+            <a:schemeClr val="accent1"/>
+          </a:fillRef>
+          <a:effectRef idx="2">
+            <a:schemeClr val="accent1"/>
+          </a:effectRef>
+          <a:fontRef idx="minor">
+            <a:schemeClr val="lt1"/>
+          </a:fontRef>
+        </p:style>
+        <p:txBody>
+          <a:bodyPr rtlCol="0" anchor="t" wrap="square" lIns="256032" rIns="219456" tIns="182880" bIns="128016"/>
+          <a:lstStyle/>
+          <a:p>
+            <a:pPr algn="l"/>
+            <a:r>
+              <a:rPr sz="1700" b="1">
+                <a:solidFill>
+                  <a:srgbClr val="063D22"/>
+                </a:solidFill>
+                <a:latin typeface="Arial"/>
+              </a:rPr>
+              <a:t>Why blend 16 models?</a:t>
+            </a:r>
+          </a:p>
+          <a:p>
+            <a:pPr algn="l">
+              <a:spcBef>
+                <a:spcPts val="600"/>
+              </a:spcBef>
+            </a:pPr>
+            <a:r>
+              <a:rPr sz="1400">
+                <a:solidFill>
+                  <a:srgbClr val="5C7268"/>
+                </a:solidFill>
+                <a:latin typeface="Arial"/>
+              </a:rPr>
+              <a:t>Different model families make different mistakes. Averaging their predictions cancels the random part of each model's error and leaves the genuine signal — so the ensemble beats any single model.</a:t>
+            </a:r>
+          </a:p>
+        </p:txBody>
+      </p:sp>
+      <p:sp>
+        <p:nvSpPr>
+          <p:cNvPr id="59" name="TextBox 58"/>
+          <p:cNvSpPr txBox="1"/>
+          <p:nvPr/>
+        </p:nvSpPr>
+        <p:spPr>
+          <a:xfrm>
+            <a:off x="11475720" y="8869680"/>
+            <a:ext cx="5852160" cy="320040"/>
+          </a:xfrm>
+          <a:prstGeom prst="rect">
+            <a:avLst/>
+          </a:prstGeom>
+          <a:noFill/>
+        </p:spPr>
+        <p:txBody>
+          <a:bodyPr wrap="none">
+            <a:spAutoFit/>
+          </a:bodyPr>
+          <a:lstStyle/>
+          <a:p>
+            <a:r>
+              <a:rPr sz="1300">
+                <a:solidFill>
+                  <a:srgbClr val="007A33"/>
+                </a:solidFill>
+                <a:latin typeface="Arial"/>
+              </a:rPr>
+              <a:t>What each feature is → slide 9</a:t>
+            </a:r>
+          </a:p>
+        </p:txBody>
+      </p:sp>
     </p:spTree>
   </p:cSld>
   <p:clrMapOvr>

</xml_diff>

<commit_message>
Slide 8: add 'what each model is good for' to the model boxes
LightGBM=fast/native missing handling, XGBoost=different algorithm adds diversity,
CatBoost=best on categoricals. Rebuilt boxes with clean text (title / good-for /
config-seeds), upgrading the pasted-image sub-lines to crisp text; arrows redrawn.
</commit_message>
<xml_diff>
--- a/presentation/Consulting_Finance_ML_Slides.pptx
+++ b/presentation/Consulting_Finance_ML_Slides.pptx
@@ -12659,25 +12659,23 @@
       </p:sp>
       <p:sp>
         <p:nvSpPr>
-          <p:cNvPr id="42" name="Rounded Rectangle 41"/>
-          <p:cNvSpPr/>
-          <p:nvPr/>
-        </p:nvSpPr>
-        <p:spPr>
-          <a:xfrm>
-            <a:off x="5029200" y="2148840"/>
-            <a:ext cx="4114800" cy="749808"/>
+          <p:cNvPr id="45" name="Rounded Rectangle 44"/>
+          <p:cNvSpPr/>
+          <p:nvPr/>
+        </p:nvSpPr>
+        <p:spPr>
+          <a:xfrm>
+            <a:off x="10424160" y="2697480"/>
+            <a:ext cx="3108960" cy="1280160"/>
           </a:xfrm>
           <a:prstGeom prst="roundRect">
             <a:avLst/>
           </a:prstGeom>
           <a:solidFill>
-            <a:srgbClr val="FFFFFF"/>
+            <a:srgbClr val="2E8B62"/>
           </a:solidFill>
-          <a:ln w="19050">
-            <a:solidFill>
-              <a:srgbClr val="2E8B62"/>
-            </a:solidFill>
+          <a:ln>
+            <a:noFill/>
           </a:ln>
           <a:effectLst/>
         </p:spPr>
@@ -12701,38 +12699,48 @@
           <a:p>
             <a:pPr algn="ctr"/>
             <a:r>
-              <a:rPr sz="1600" b="1">
-                <a:solidFill>
-                  <a:srgbClr val="063D22"/>
+              <a:rPr sz="1800" b="1">
+                <a:solidFill>
+                  <a:srgbClr val="FFFFFF"/>
                 </a:solidFill>
                 <a:latin typeface="Arial"/>
               </a:rPr>
-              <a:t>9 × LightGBM</a:t>
-            </a:r>
-          </a:p>
-        </p:txBody>
-      </p:sp>
-      <p:sp>
-        <p:nvSpPr>
-          <p:cNvPr id="43" name="Rounded Rectangle 42"/>
-          <p:cNvSpPr/>
-          <p:nvPr/>
-        </p:nvSpPr>
-        <p:spPr>
-          <a:xfrm>
-            <a:off x="5029200" y="2962656"/>
-            <a:ext cx="4114800" cy="749808"/>
+              <a:t>mean blend</a:t>
+            </a:r>
+          </a:p>
+          <a:p>
+            <a:pPr algn="ctr"/>
+            <a:r>
+              <a:rPr sz="1300" b="0">
+                <a:solidFill>
+                  <a:srgbClr val="EAF3EF"/>
+                </a:solidFill>
+                <a:latin typeface="Arial"/>
+              </a:rPr>
+              <a:t>16 → 1 probability</a:t>
+            </a:r>
+          </a:p>
+        </p:txBody>
+      </p:sp>
+      <p:sp>
+        <p:nvSpPr>
+          <p:cNvPr id="46" name="Rounded Rectangle 45"/>
+          <p:cNvSpPr/>
+          <p:nvPr/>
+        </p:nvSpPr>
+        <p:spPr>
+          <a:xfrm>
+            <a:off x="14630400" y="2834640"/>
+            <a:ext cx="2651760" cy="1005840"/>
           </a:xfrm>
           <a:prstGeom prst="roundRect">
             <a:avLst/>
           </a:prstGeom>
           <a:solidFill>
-            <a:srgbClr val="FFFFFF"/>
+            <a:srgbClr val="063D22"/>
           </a:solidFill>
-          <a:ln w="19050">
-            <a:solidFill>
-              <a:srgbClr val="2E8B62"/>
-            </a:solidFill>
+          <a:ln>
+            <a:noFill/>
           </a:ln>
           <a:effectLst/>
         </p:spPr>
@@ -12758,35 +12766,83 @@
             <a:r>
               <a:rPr sz="1600" b="1">
                 <a:solidFill>
-                  <a:srgbClr val="063D22"/>
+                  <a:srgbClr val="FFFFFF"/>
                 </a:solidFill>
                 <a:latin typeface="Arial"/>
               </a:rPr>
-              <a:t>3 × XGBoost</a:t>
-            </a:r>
-          </a:p>
-        </p:txBody>
-      </p:sp>
-      <p:sp>
-        <p:nvSpPr>
-          <p:cNvPr id="44" name="Rounded Rectangle 43"/>
-          <p:cNvSpPr/>
-          <p:nvPr/>
-        </p:nvSpPr>
-        <p:spPr>
-          <a:xfrm>
-            <a:off x="5029200" y="3776472"/>
-            <a:ext cx="4114800" cy="749808"/>
+              <a:t>smooth cutoff</a:t>
+            </a:r>
+          </a:p>
+          <a:p>
+            <a:pPr algn="ctr"/>
+            <a:r>
+              <a:rPr sz="1300" b="0">
+                <a:solidFill>
+                  <a:srgbClr val="BCDDCE"/>
+                </a:solidFill>
+                <a:latin typeface="Arial"/>
+              </a:rPr>
+              <a:t>≈ 0.527</a:t>
+            </a:r>
+          </a:p>
+        </p:txBody>
+      </p:sp>
+      <p:cxnSp>
+        <p:nvCxnSpPr>
+          <p:cNvPr id="53" name="Connector 52"/>
+          <p:cNvCxnSpPr/>
+          <p:nvPr/>
+        </p:nvCxnSpPr>
+        <p:spPr>
+          <a:xfrm>
+            <a:off x="13533120" y="3337560"/>
+            <a:ext cx="1097280" cy="0"/>
+          </a:xfrm>
+          <a:prstGeom prst="line">
+            <a:avLst/>
+          </a:prstGeom>
+          <a:ln w="28575">
+            <a:solidFill>
+              <a:srgbClr val="063D22"/>
+            </a:solidFill>
+            <a:tailEnd type="triangle" w="med" len="med"/>
+          </a:ln>
+        </p:spPr>
+        <p:style>
+          <a:lnRef idx="2">
+            <a:schemeClr val="accent1"/>
+          </a:lnRef>
+          <a:fillRef idx="0">
+            <a:schemeClr val="accent1"/>
+          </a:fillRef>
+          <a:effectRef idx="1">
+            <a:schemeClr val="accent1"/>
+          </a:effectRef>
+          <a:fontRef idx="minor">
+            <a:schemeClr val="tx1"/>
+          </a:fontRef>
+        </p:style>
+      </p:cxnSp>
+      <p:sp>
+        <p:nvSpPr>
+          <p:cNvPr id="54" name="Rounded Rectangle 53"/>
+          <p:cNvSpPr/>
+          <p:nvPr/>
+        </p:nvSpPr>
+        <p:spPr>
+          <a:xfrm>
+            <a:off x="950976" y="4983480"/>
+            <a:ext cx="16367759" cy="868680"/>
           </a:xfrm>
           <a:prstGeom prst="roundRect">
             <a:avLst/>
           </a:prstGeom>
           <a:solidFill>
-            <a:srgbClr val="FFFFFF"/>
+            <a:srgbClr val="F4F8F6"/>
           </a:solidFill>
           <a:ln w="19050">
             <a:solidFill>
-              <a:srgbClr val="2E8B62"/>
+              <a:srgbClr val="C8D4CF"/>
             </a:solidFill>
           </a:ln>
           <a:effectLst/>
@@ -12811,33 +12867,138 @@
           <a:p>
             <a:pPr algn="ctr"/>
             <a:r>
-              <a:rPr sz="1600" b="1">
+              <a:rPr sz="1500" b="1">
                 <a:solidFill>
                   <a:srgbClr val="063D22"/>
                 </a:solidFill>
                 <a:latin typeface="Arial"/>
               </a:rPr>
-              <a:t>4 × CatBoost</a:t>
-            </a:r>
-          </a:p>
-        </p:txBody>
-      </p:sp>
-      <p:sp>
-        <p:nvSpPr>
-          <p:cNvPr id="45" name="Rounded Rectangle 44"/>
-          <p:cNvSpPr/>
-          <p:nvPr/>
-        </p:nvSpPr>
-        <p:spPr>
-          <a:xfrm>
-            <a:off x="10424160" y="2697480"/>
-            <a:ext cx="3108960" cy="1280160"/>
+              <a:t>Pseudo-labeling pass (v8 / v10)</a:t>
+            </a:r>
+          </a:p>
+          <a:p>
+            <a:pPr algn="ctr"/>
+            <a:r>
+              <a:rPr sz="1300" b="0">
+                <a:solidFill>
+                  <a:srgbClr val="5C7268"/>
+                </a:solidFill>
+                <a:latin typeface="Arial"/>
+              </a:rPr>
+              <a:t>confident test rows (≥ 0.97) added at weight 0.5  —  +0.14 pt on rolling validation</a:t>
+            </a:r>
+          </a:p>
+        </p:txBody>
+      </p:sp>
+      <p:sp>
+        <p:nvSpPr>
+          <p:cNvPr id="55" name="TextBox 54"/>
+          <p:cNvSpPr txBox="1"/>
+          <p:nvPr/>
+        </p:nvSpPr>
+        <p:spPr>
+          <a:xfrm>
+            <a:off x="950976" y="5943600"/>
+            <a:ext cx="16367759" cy="365760"/>
+          </a:xfrm>
+          <a:prstGeom prst="rect">
+            <a:avLst/>
+          </a:prstGeom>
+          <a:noFill/>
+        </p:spPr>
+        <p:txBody>
+          <a:bodyPr wrap="none">
+            <a:spAutoFit/>
+          </a:bodyPr>
+          <a:lstStyle/>
+          <a:p>
+            <a:pPr algn="ctr"/>
+            <a:r>
+              <a:rPr sz="1400" i="1">
+                <a:solidFill>
+                  <a:srgbClr val="5C7268"/>
+                </a:solidFill>
+                <a:latin typeface="Arial"/>
+              </a:rPr>
+              <a:t>From clean features to a single approve / reject decision per applicant.</a:t>
+            </a:r>
+          </a:p>
+        </p:txBody>
+      </p:sp>
+      <p:sp>
+        <p:nvSpPr>
+          <p:cNvPr id="56" name="TextBox 55"/>
+          <p:cNvSpPr txBox="1"/>
+          <p:nvPr/>
+        </p:nvSpPr>
+        <p:spPr>
+          <a:xfrm>
+            <a:off x="950976" y="6446520"/>
+            <a:ext cx="10972800" cy="365760"/>
+          </a:xfrm>
+          <a:prstGeom prst="rect">
+            <a:avLst/>
+          </a:prstGeom>
+          <a:noFill/>
+        </p:spPr>
+        <p:txBody>
+          <a:bodyPr wrap="none">
+            <a:spAutoFit/>
+          </a:bodyPr>
+          <a:lstStyle/>
+          <a:p>
+            <a:r>
+              <a:rPr sz="2000" b="1">
+                <a:solidFill>
+                  <a:srgbClr val="063D22"/>
+                </a:solidFill>
+                <a:latin typeface="Arial"/>
+              </a:rPr>
+              <a:t>What drives the model — top features by gain</a:t>
+            </a:r>
+          </a:p>
+        </p:txBody>
+      </p:sp>
+      <p:pic>
+        <p:nvPicPr>
+          <p:cNvPr id="57" name="Picture 56" descr="deck_importance_wide.png"/>
+          <p:cNvPicPr>
+            <a:picLocks noChangeAspect="1"/>
+          </p:cNvPicPr>
+          <p:nvPr/>
+        </p:nvPicPr>
+        <p:blipFill>
+          <a:blip r:embed="rId3"/>
+          <a:stretch>
+            <a:fillRect/>
+          </a:stretch>
+        </p:blipFill>
+        <p:spPr>
+          <a:xfrm>
+            <a:off x="950976" y="6858000"/>
+            <a:ext cx="10058400" cy="2286000"/>
+          </a:xfrm>
+          <a:prstGeom prst="rect">
+            <a:avLst/>
+          </a:prstGeom>
+        </p:spPr>
+      </p:pic>
+      <p:sp>
+        <p:nvSpPr>
+          <p:cNvPr id="58" name="Rounded Rectangle 57"/>
+          <p:cNvSpPr/>
+          <p:nvPr/>
+        </p:nvSpPr>
+        <p:spPr>
+          <a:xfrm>
+            <a:off x="11475720" y="6766560"/>
+            <a:ext cx="5852160" cy="2057400"/>
           </a:xfrm>
           <a:prstGeom prst="roundRect">
             <a:avLst/>
           </a:prstGeom>
           <a:solidFill>
-            <a:srgbClr val="2E8B62"/>
+            <a:srgbClr val="EAF3EF"/>
           </a:solidFill>
           <a:ln>
             <a:noFill/>
@@ -12859,53 +13020,93 @@
           </a:fontRef>
         </p:style>
         <p:txBody>
-          <a:bodyPr wrap="square" rtlCol="0" anchor="ctr"/>
-          <a:lstStyle/>
-          <a:p>
-            <a:pPr algn="ctr"/>
-            <a:r>
-              <a:rPr sz="1800" b="1">
-                <a:solidFill>
-                  <a:srgbClr val="FFFFFF"/>
+          <a:bodyPr rtlCol="0" anchor="t" wrap="square" lIns="256032" rIns="219456" tIns="182880" bIns="128016"/>
+          <a:lstStyle/>
+          <a:p>
+            <a:pPr algn="l"/>
+            <a:r>
+              <a:rPr sz="1700" b="1">
+                <a:solidFill>
+                  <a:srgbClr val="063D22"/>
                 </a:solidFill>
                 <a:latin typeface="Arial"/>
               </a:rPr>
-              <a:t>mean blend</a:t>
-            </a:r>
-          </a:p>
-          <a:p>
-            <a:pPr algn="ctr"/>
-            <a:r>
-              <a:rPr sz="1300" b="0">
-                <a:solidFill>
-                  <a:srgbClr val="EAF3EF"/>
+              <a:t>Why blend 16 models?</a:t>
+            </a:r>
+          </a:p>
+          <a:p>
+            <a:pPr algn="l">
+              <a:spcBef>
+                <a:spcPts val="600"/>
+              </a:spcBef>
+            </a:pPr>
+            <a:r>
+              <a:rPr sz="1400">
+                <a:solidFill>
+                  <a:srgbClr val="5C7268"/>
                 </a:solidFill>
                 <a:latin typeface="Arial"/>
               </a:rPr>
-              <a:t>16 → 1 probability</a:t>
-            </a:r>
-          </a:p>
-        </p:txBody>
-      </p:sp>
-      <p:sp>
-        <p:nvSpPr>
-          <p:cNvPr id="46" name="Rounded Rectangle 45"/>
-          <p:cNvSpPr/>
-          <p:nvPr/>
-        </p:nvSpPr>
-        <p:spPr>
-          <a:xfrm>
-            <a:off x="14630400" y="2834640"/>
-            <a:ext cx="2651760" cy="1005840"/>
+              <a:t>Different model families make different mistakes. Averaging their predictions cancels the random part of each model's error and leaves the genuine signal — so the ensemble beats any single model.</a:t>
+            </a:r>
+          </a:p>
+        </p:txBody>
+      </p:sp>
+      <p:sp>
+        <p:nvSpPr>
+          <p:cNvPr id="59" name="TextBox 58"/>
+          <p:cNvSpPr txBox="1"/>
+          <p:nvPr/>
+        </p:nvSpPr>
+        <p:spPr>
+          <a:xfrm>
+            <a:off x="11475720" y="8869680"/>
+            <a:ext cx="5852160" cy="320040"/>
+          </a:xfrm>
+          <a:prstGeom prst="rect">
+            <a:avLst/>
+          </a:prstGeom>
+          <a:noFill/>
+        </p:spPr>
+        <p:txBody>
+          <a:bodyPr wrap="none">
+            <a:spAutoFit/>
+          </a:bodyPr>
+          <a:lstStyle/>
+          <a:p>
+            <a:r>
+              <a:rPr sz="1300">
+                <a:solidFill>
+                  <a:srgbClr val="007A33"/>
+                </a:solidFill>
+                <a:latin typeface="Arial"/>
+              </a:rPr>
+              <a:t>What each feature is → slide 9</a:t>
+            </a:r>
+          </a:p>
+        </p:txBody>
+      </p:sp>
+      <p:sp>
+        <p:nvSpPr>
+          <p:cNvPr id="60" name="Rounded Rectangle 59"/>
+          <p:cNvSpPr/>
+          <p:nvPr/>
+        </p:nvSpPr>
+        <p:spPr>
+          <a:xfrm>
+            <a:off x="5029200" y="2011680"/>
+            <a:ext cx="4114800" cy="822960"/>
           </a:xfrm>
           <a:prstGeom prst="roundRect">
             <a:avLst/>
           </a:prstGeom>
           <a:solidFill>
-            <a:srgbClr val="063D22"/>
+            <a:srgbClr val="FFFFFF"/>
           </a:solidFill>
-          <a:ln>
-            <a:noFill/>
+          <a:ln w="19050">
+            <a:solidFill>
+              <a:srgbClr val="2E8B62"/>
+            </a:solidFill>
           </a:ln>
           <a:effectLst/>
         </p:spPr>
@@ -12924,44 +13125,214 @@
           </a:fontRef>
         </p:style>
         <p:txBody>
-          <a:bodyPr wrap="square" rtlCol="0" anchor="ctr"/>
+          <a:bodyPr rtlCol="0" anchor="ctr" wrap="square" tIns="36576" bIns="36576"/>
           <a:lstStyle/>
           <a:p>
             <a:pPr algn="ctr"/>
             <a:r>
-              <a:rPr sz="1600" b="1">
-                <a:solidFill>
-                  <a:srgbClr val="FFFFFF"/>
+              <a:rPr sz="1500" b="1" i="0">
+                <a:solidFill>
+                  <a:srgbClr val="063D22"/>
                 </a:solidFill>
                 <a:latin typeface="Arial"/>
               </a:rPr>
-              <a:t>smooth cutoff</a:t>
+              <a:t>9 × LightGBM</a:t>
             </a:r>
           </a:p>
           <a:p>
             <a:pPr algn="ctr"/>
             <a:r>
-              <a:rPr sz="1300" b="0">
-                <a:solidFill>
-                  <a:srgbClr val="BCDDCE"/>
+              <a:rPr sz="1150" b="0" i="0">
+                <a:solidFill>
+                  <a:srgbClr val="2E8B62"/>
                 </a:solidFill>
                 <a:latin typeface="Arial"/>
               </a:rPr>
-              <a:t>≈ 0.527</a:t>
+              <a:t>Fast · native missing-value handling</a:t>
+            </a:r>
+          </a:p>
+          <a:p>
+            <a:pPr algn="ctr"/>
+            <a:r>
+              <a:rPr sz="1000" b="0" i="0">
+                <a:solidFill>
+                  <a:srgbClr val="5C7268"/>
+                </a:solidFill>
+                <a:latin typeface="Arial"/>
+              </a:rPr>
+              <a:t>3 configs × 3 seeds</a:t>
+            </a:r>
+          </a:p>
+        </p:txBody>
+      </p:sp>
+      <p:sp>
+        <p:nvSpPr>
+          <p:cNvPr id="61" name="Rounded Rectangle 60"/>
+          <p:cNvSpPr/>
+          <p:nvPr/>
+        </p:nvSpPr>
+        <p:spPr>
+          <a:xfrm>
+            <a:off x="5029200" y="2926080"/>
+            <a:ext cx="4114800" cy="822960"/>
+          </a:xfrm>
+          <a:prstGeom prst="roundRect">
+            <a:avLst/>
+          </a:prstGeom>
+          <a:solidFill>
+            <a:srgbClr val="FFFFFF"/>
+          </a:solidFill>
+          <a:ln w="19050">
+            <a:solidFill>
+              <a:srgbClr val="2E8B62"/>
+            </a:solidFill>
+          </a:ln>
+          <a:effectLst/>
+        </p:spPr>
+        <p:style>
+          <a:lnRef idx="1">
+            <a:schemeClr val="accent1"/>
+          </a:lnRef>
+          <a:fillRef idx="3">
+            <a:schemeClr val="accent1"/>
+          </a:fillRef>
+          <a:effectRef idx="2">
+            <a:schemeClr val="accent1"/>
+          </a:effectRef>
+          <a:fontRef idx="minor">
+            <a:schemeClr val="lt1"/>
+          </a:fontRef>
+        </p:style>
+        <p:txBody>
+          <a:bodyPr rtlCol="0" anchor="ctr" wrap="square" tIns="36576" bIns="36576"/>
+          <a:lstStyle/>
+          <a:p>
+            <a:pPr algn="ctr"/>
+            <a:r>
+              <a:rPr sz="1500" b="1" i="0">
+                <a:solidFill>
+                  <a:srgbClr val="063D22"/>
+                </a:solidFill>
+                <a:latin typeface="Arial"/>
+              </a:rPr>
+              <a:t>3 × XGBoost</a:t>
+            </a:r>
+          </a:p>
+          <a:p>
+            <a:pPr algn="ctr"/>
+            <a:r>
+              <a:rPr sz="1150" b="0" i="0">
+                <a:solidFill>
+                  <a:srgbClr val="2E8B62"/>
+                </a:solidFill>
+                <a:latin typeface="Arial"/>
+              </a:rPr>
+              <a:t>Different algorithm → adds diversity</a:t>
+            </a:r>
+          </a:p>
+          <a:p>
+            <a:pPr algn="ctr"/>
+            <a:r>
+              <a:rPr sz="1000" b="0" i="0">
+                <a:solidFill>
+                  <a:srgbClr val="5C7268"/>
+                </a:solidFill>
+                <a:latin typeface="Arial"/>
+              </a:rPr>
+              <a:t>3 seeds</a:t>
+            </a:r>
+          </a:p>
+        </p:txBody>
+      </p:sp>
+      <p:sp>
+        <p:nvSpPr>
+          <p:cNvPr id="62" name="Rounded Rectangle 61"/>
+          <p:cNvSpPr/>
+          <p:nvPr/>
+        </p:nvSpPr>
+        <p:spPr>
+          <a:xfrm>
+            <a:off x="5029200" y="3840480"/>
+            <a:ext cx="4114800" cy="822960"/>
+          </a:xfrm>
+          <a:prstGeom prst="roundRect">
+            <a:avLst/>
+          </a:prstGeom>
+          <a:solidFill>
+            <a:srgbClr val="FFFFFF"/>
+          </a:solidFill>
+          <a:ln w="19050">
+            <a:solidFill>
+              <a:srgbClr val="2E8B62"/>
+            </a:solidFill>
+          </a:ln>
+          <a:effectLst/>
+        </p:spPr>
+        <p:style>
+          <a:lnRef idx="1">
+            <a:schemeClr val="accent1"/>
+          </a:lnRef>
+          <a:fillRef idx="3">
+            <a:schemeClr val="accent1"/>
+          </a:fillRef>
+          <a:effectRef idx="2">
+            <a:schemeClr val="accent1"/>
+          </a:effectRef>
+          <a:fontRef idx="minor">
+            <a:schemeClr val="lt1"/>
+          </a:fontRef>
+        </p:style>
+        <p:txBody>
+          <a:bodyPr rtlCol="0" anchor="ctr" wrap="square" tIns="36576" bIns="36576"/>
+          <a:lstStyle/>
+          <a:p>
+            <a:pPr algn="ctr"/>
+            <a:r>
+              <a:rPr sz="1500" b="1" i="0">
+                <a:solidFill>
+                  <a:srgbClr val="063D22"/>
+                </a:solidFill>
+                <a:latin typeface="Arial"/>
+              </a:rPr>
+              <a:t>4 × CatBoost</a:t>
+            </a:r>
+          </a:p>
+          <a:p>
+            <a:pPr algn="ctr"/>
+            <a:r>
+              <a:rPr sz="1150" b="0" i="0">
+                <a:solidFill>
+                  <a:srgbClr val="2E8B62"/>
+                </a:solidFill>
+                <a:latin typeface="Arial"/>
+              </a:rPr>
+              <a:t>Best on categoricals (the analyst note)</a:t>
+            </a:r>
+          </a:p>
+          <a:p>
+            <a:pPr algn="ctr"/>
+            <a:r>
+              <a:rPr sz="1000" b="0" i="0">
+                <a:solidFill>
+                  <a:srgbClr val="5C7268"/>
+                </a:solidFill>
+                <a:latin typeface="Arial"/>
+              </a:rPr>
+              <a:t>2 configs × 2 seeds</a:t>
             </a:r>
           </a:p>
         </p:txBody>
       </p:sp>
       <p:cxnSp>
         <p:nvCxnSpPr>
-          <p:cNvPr id="47" name="Connector 46"/>
+          <p:cNvPr id="63" name="Connector 62"/>
           <p:cNvCxnSpPr/>
           <p:nvPr/>
         </p:nvCxnSpPr>
         <p:spPr>
           <a:xfrm flipV="1">
-            <a:off x="3694176" y="2523744"/>
-            <a:ext cx="1335024" cy="813816"/>
+            <a:off x="3694176" y="2423160"/>
+            <a:ext cx="1335024" cy="914400"/>
           </a:xfrm>
           <a:prstGeom prst="line">
             <a:avLst/>
@@ -12990,7 +13361,7 @@
       </p:cxnSp>
       <p:cxnSp>
         <p:nvCxnSpPr>
-          <p:cNvPr id="48" name="Connector 47"/>
+          <p:cNvPr id="64" name="Connector 63"/>
           <p:cNvCxnSpPr/>
           <p:nvPr/>
         </p:nvCxnSpPr>
@@ -13026,14 +13397,14 @@
       </p:cxnSp>
       <p:cxnSp>
         <p:nvCxnSpPr>
-          <p:cNvPr id="49" name="Connector 48"/>
+          <p:cNvPr id="65" name="Connector 64"/>
           <p:cNvCxnSpPr/>
           <p:nvPr/>
         </p:nvCxnSpPr>
         <p:spPr>
           <a:xfrm>
             <a:off x="3694176" y="3337560"/>
-            <a:ext cx="1335024" cy="813816"/>
+            <a:ext cx="1335024" cy="914400"/>
           </a:xfrm>
           <a:prstGeom prst="line">
             <a:avLst/>
@@ -13062,14 +13433,14 @@
       </p:cxnSp>
       <p:cxnSp>
         <p:nvCxnSpPr>
-          <p:cNvPr id="50" name="Connector 49"/>
+          <p:cNvPr id="66" name="Connector 65"/>
           <p:cNvCxnSpPr/>
           <p:nvPr/>
         </p:nvCxnSpPr>
         <p:spPr>
           <a:xfrm>
-            <a:off x="9144000" y="2523744"/>
-            <a:ext cx="1280160" cy="813816"/>
+            <a:off x="9144000" y="2423160"/>
+            <a:ext cx="1280160" cy="914400"/>
           </a:xfrm>
           <a:prstGeom prst="line">
             <a:avLst/>
@@ -13098,7 +13469,7 @@
       </p:cxnSp>
       <p:cxnSp>
         <p:nvCxnSpPr>
-          <p:cNvPr id="51" name="Connector 50"/>
+          <p:cNvPr id="67" name="Connector 66"/>
           <p:cNvCxnSpPr/>
           <p:nvPr/>
         </p:nvCxnSpPr>
@@ -13134,14 +13505,14 @@
       </p:cxnSp>
       <p:cxnSp>
         <p:nvCxnSpPr>
-          <p:cNvPr id="52" name="Connector 51"/>
+          <p:cNvPr id="68" name="Connector 67"/>
           <p:cNvCxnSpPr/>
           <p:nvPr/>
         </p:nvCxnSpPr>
         <p:spPr>
           <a:xfrm flipV="1">
             <a:off x="9144000" y="3337560"/>
-            <a:ext cx="1280160" cy="813816"/>
+            <a:ext cx="1280160" cy="914400"/>
           </a:xfrm>
           <a:prstGeom prst="line">
             <a:avLst/>
@@ -13168,425 +13539,6 @@
           </a:fontRef>
         </p:style>
       </p:cxnSp>
-      <p:cxnSp>
-        <p:nvCxnSpPr>
-          <p:cNvPr id="53" name="Connector 52"/>
-          <p:cNvCxnSpPr/>
-          <p:nvPr/>
-        </p:nvCxnSpPr>
-        <p:spPr>
-          <a:xfrm>
-            <a:off x="13533120" y="3337560"/>
-            <a:ext cx="1097280" cy="0"/>
-          </a:xfrm>
-          <a:prstGeom prst="line">
-            <a:avLst/>
-          </a:prstGeom>
-          <a:ln w="28575">
-            <a:solidFill>
-              <a:srgbClr val="063D22"/>
-            </a:solidFill>
-            <a:tailEnd type="triangle" w="med" len="med"/>
-          </a:ln>
-        </p:spPr>
-        <p:style>
-          <a:lnRef idx="2">
-            <a:schemeClr val="accent1"/>
-          </a:lnRef>
-          <a:fillRef idx="0">
-            <a:schemeClr val="accent1"/>
-          </a:fillRef>
-          <a:effectRef idx="1">
-            <a:schemeClr val="accent1"/>
-          </a:effectRef>
-          <a:fontRef idx="minor">
-            <a:schemeClr val="tx1"/>
-          </a:fontRef>
-        </p:style>
-      </p:cxnSp>
-      <p:sp>
-        <p:nvSpPr>
-          <p:cNvPr id="54" name="Rounded Rectangle 53"/>
-          <p:cNvSpPr/>
-          <p:nvPr/>
-        </p:nvSpPr>
-        <p:spPr>
-          <a:xfrm>
-            <a:off x="950976" y="4983480"/>
-            <a:ext cx="16367759" cy="868680"/>
-          </a:xfrm>
-          <a:prstGeom prst="roundRect">
-            <a:avLst/>
-          </a:prstGeom>
-          <a:solidFill>
-            <a:srgbClr val="F4F8F6"/>
-          </a:solidFill>
-          <a:ln w="19050">
-            <a:solidFill>
-              <a:srgbClr val="C8D4CF"/>
-            </a:solidFill>
-          </a:ln>
-          <a:effectLst/>
-        </p:spPr>
-        <p:style>
-          <a:lnRef idx="1">
-            <a:schemeClr val="accent1"/>
-          </a:lnRef>
-          <a:fillRef idx="3">
-            <a:schemeClr val="accent1"/>
-          </a:fillRef>
-          <a:effectRef idx="2">
-            <a:schemeClr val="accent1"/>
-          </a:effectRef>
-          <a:fontRef idx="minor">
-            <a:schemeClr val="lt1"/>
-          </a:fontRef>
-        </p:style>
-        <p:txBody>
-          <a:bodyPr wrap="square" rtlCol="0" anchor="ctr"/>
-          <a:lstStyle/>
-          <a:p>
-            <a:pPr algn="ctr"/>
-            <a:r>
-              <a:rPr sz="1500" b="1">
-                <a:solidFill>
-                  <a:srgbClr val="063D22"/>
-                </a:solidFill>
-                <a:latin typeface="Arial"/>
-              </a:rPr>
-              <a:t>Pseudo-labeling pass (v8 / v10)</a:t>
-            </a:r>
-          </a:p>
-          <a:p>
-            <a:pPr algn="ctr"/>
-            <a:r>
-              <a:rPr sz="1300" b="0">
-                <a:solidFill>
-                  <a:srgbClr val="5C7268"/>
-                </a:solidFill>
-                <a:latin typeface="Arial"/>
-              </a:rPr>
-              <a:t>confident test rows (≥ 0.97) added at weight 0.5  —  +0.14 pt on rolling validation</a:t>
-            </a:r>
-          </a:p>
-        </p:txBody>
-      </p:sp>
-      <p:sp>
-        <p:nvSpPr>
-          <p:cNvPr id="55" name="TextBox 54"/>
-          <p:cNvSpPr txBox="1"/>
-          <p:nvPr/>
-        </p:nvSpPr>
-        <p:spPr>
-          <a:xfrm>
-            <a:off x="950976" y="5943600"/>
-            <a:ext cx="16367759" cy="365760"/>
-          </a:xfrm>
-          <a:prstGeom prst="rect">
-            <a:avLst/>
-          </a:prstGeom>
-          <a:noFill/>
-        </p:spPr>
-        <p:txBody>
-          <a:bodyPr wrap="none">
-            <a:spAutoFit/>
-          </a:bodyPr>
-          <a:lstStyle/>
-          <a:p>
-            <a:pPr algn="ctr"/>
-            <a:r>
-              <a:rPr sz="1400" i="1">
-                <a:solidFill>
-                  <a:srgbClr val="5C7268"/>
-                </a:solidFill>
-                <a:latin typeface="Arial"/>
-              </a:rPr>
-              <a:t>From clean features to a single approve / reject decision per applicant.</a:t>
-            </a:r>
-          </a:p>
-        </p:txBody>
-      </p:sp>
-      <p:sp>
-        <p:nvSpPr>
-          <p:cNvPr id="56" name="TextBox 55"/>
-          <p:cNvSpPr txBox="1"/>
-          <p:nvPr/>
-        </p:nvSpPr>
-        <p:spPr>
-          <a:xfrm>
-            <a:off x="950976" y="6446520"/>
-            <a:ext cx="10972800" cy="365760"/>
-          </a:xfrm>
-          <a:prstGeom prst="rect">
-            <a:avLst/>
-          </a:prstGeom>
-          <a:noFill/>
-        </p:spPr>
-        <p:txBody>
-          <a:bodyPr wrap="none">
-            <a:spAutoFit/>
-          </a:bodyPr>
-          <a:lstStyle/>
-          <a:p>
-            <a:r>
-              <a:rPr sz="2000" b="1">
-                <a:solidFill>
-                  <a:srgbClr val="063D22"/>
-                </a:solidFill>
-                <a:latin typeface="Arial"/>
-              </a:rPr>
-              <a:t>What drives the model — top features by gain</a:t>
-            </a:r>
-          </a:p>
-        </p:txBody>
-      </p:sp>
-      <p:pic>
-        <p:nvPicPr>
-          <p:cNvPr id="57" name="Picture 56" descr="deck_importance_wide.png"/>
-          <p:cNvPicPr>
-            <a:picLocks noChangeAspect="1"/>
-          </p:cNvPicPr>
-          <p:nvPr/>
-        </p:nvPicPr>
-        <p:blipFill>
-          <a:blip r:embed="rId3"/>
-          <a:stretch>
-            <a:fillRect/>
-          </a:stretch>
-        </p:blipFill>
-        <p:spPr>
-          <a:xfrm>
-            <a:off x="950976" y="6858000"/>
-            <a:ext cx="10058400" cy="2286000"/>
-          </a:xfrm>
-          <a:prstGeom prst="rect">
-            <a:avLst/>
-          </a:prstGeom>
-        </p:spPr>
-      </p:pic>
-      <p:pic>
-        <p:nvPicPr>
-          <p:cNvPr id="5" name="Picture 4">
-            <a:extLst>
-              <a:ext uri="{FF2B5EF4-FFF2-40B4-BE49-F238E27FC236}">
-                <a16:creationId xmlns:a16="http://schemas.microsoft.com/office/drawing/2014/main" id="{B4E6C54B-8C83-317D-1AF4-3605A7D7896A}"/>
-              </a:ext>
-            </a:extLst>
-          </p:cNvPr>
-          <p:cNvPicPr>
-            <a:picLocks noChangeAspect="1"/>
-          </p:cNvPicPr>
-          <p:nvPr/>
-        </p:nvPicPr>
-        <p:blipFill>
-          <a:blip r:embed="rId4"/>
-          <a:stretch>
-            <a:fillRect/>
-          </a:stretch>
-        </p:blipFill>
-        <p:spPr>
-          <a:xfrm>
-            <a:off x="5112256" y="2635767"/>
-            <a:ext cx="2503936" cy="196590"/>
-          </a:xfrm>
-          <a:prstGeom prst="rect">
-            <a:avLst/>
-          </a:prstGeom>
-        </p:spPr>
-      </p:pic>
-      <p:pic>
-        <p:nvPicPr>
-          <p:cNvPr id="6" name="Picture 5">
-            <a:extLst>
-              <a:ext uri="{FF2B5EF4-FFF2-40B4-BE49-F238E27FC236}">
-                <a16:creationId xmlns:a16="http://schemas.microsoft.com/office/drawing/2014/main" id="{A27ABDAD-6D53-63BC-51E5-B5ADDE84859C}"/>
-              </a:ext>
-            </a:extLst>
-          </p:cNvPr>
-          <p:cNvPicPr>
-            <a:picLocks noChangeAspect="1"/>
-          </p:cNvPicPr>
-          <p:nvPr/>
-        </p:nvPicPr>
-        <p:blipFill>
-          <a:blip r:embed="rId5"/>
-          <a:stretch>
-            <a:fillRect/>
-          </a:stretch>
-        </p:blipFill>
-        <p:spPr>
-          <a:xfrm>
-            <a:off x="6472367" y="3463731"/>
-            <a:ext cx="1228465" cy="206382"/>
-          </a:xfrm>
-          <a:prstGeom prst="rect">
-            <a:avLst/>
-          </a:prstGeom>
-        </p:spPr>
-      </p:pic>
-      <p:pic>
-        <p:nvPicPr>
-          <p:cNvPr id="7" name="Picture 6">
-            <a:extLst>
-              <a:ext uri="{FF2B5EF4-FFF2-40B4-BE49-F238E27FC236}">
-                <a16:creationId xmlns:a16="http://schemas.microsoft.com/office/drawing/2014/main" id="{7951B2C4-E38E-FCB5-A933-51BC39E6D62E}"/>
-              </a:ext>
-            </a:extLst>
-          </p:cNvPr>
-          <p:cNvPicPr>
-            <a:picLocks noChangeAspect="1"/>
-          </p:cNvPicPr>
-          <p:nvPr/>
-        </p:nvPicPr>
-        <p:blipFill>
-          <a:blip r:embed="rId6"/>
-          <a:stretch>
-            <a:fillRect/>
-          </a:stretch>
-        </p:blipFill>
-        <p:spPr>
-          <a:xfrm>
-            <a:off x="6219251" y="4276858"/>
-            <a:ext cx="1734695" cy="173470"/>
-          </a:xfrm>
-          <a:prstGeom prst="rect">
-            <a:avLst/>
-          </a:prstGeom>
-        </p:spPr>
-      </p:pic>
-      <p:pic>
-        <p:nvPicPr>
-          <p:cNvPr id="8" name="Picture 7">
-            <a:extLst>
-              <a:ext uri="{FF2B5EF4-FFF2-40B4-BE49-F238E27FC236}">
-                <a16:creationId xmlns:a16="http://schemas.microsoft.com/office/drawing/2014/main" id="{096898CC-70E5-622C-2E42-FC0208C0771A}"/>
-              </a:ext>
-            </a:extLst>
-          </p:cNvPr>
-          <p:cNvPicPr>
-            <a:picLocks noChangeAspect="1"/>
-          </p:cNvPicPr>
-          <p:nvPr/>
-        </p:nvPicPr>
-        <p:blipFill>
-          <a:blip r:embed="rId5"/>
-          <a:stretch>
-            <a:fillRect/>
-          </a:stretch>
-        </p:blipFill>
-        <p:spPr>
-          <a:xfrm>
-            <a:off x="7765863" y="2643940"/>
-            <a:ext cx="1228465" cy="206382"/>
-          </a:xfrm>
-          <a:prstGeom prst="rect">
-            <a:avLst/>
-          </a:prstGeom>
-        </p:spPr>
-      </p:pic>
-      <p:sp>
-        <p:nvSpPr>
-          <p:cNvPr id="58" name="Rounded Rectangle 57"/>
-          <p:cNvSpPr/>
-          <p:nvPr/>
-        </p:nvSpPr>
-        <p:spPr>
-          <a:xfrm>
-            <a:off x="11475720" y="6766560"/>
-            <a:ext cx="5852160" cy="2057400"/>
-          </a:xfrm>
-          <a:prstGeom prst="roundRect">
-            <a:avLst/>
-          </a:prstGeom>
-          <a:solidFill>
-            <a:srgbClr val="EAF3EF"/>
-          </a:solidFill>
-          <a:ln>
-            <a:noFill/>
-          </a:ln>
-          <a:effectLst/>
-        </p:spPr>
-        <p:style>
-          <a:lnRef idx="1">
-            <a:schemeClr val="accent1"/>
-          </a:lnRef>
-          <a:fillRef idx="3">
-            <a:schemeClr val="accent1"/>
-          </a:fillRef>
-          <a:effectRef idx="2">
-            <a:schemeClr val="accent1"/>
-          </a:effectRef>
-          <a:fontRef idx="minor">
-            <a:schemeClr val="lt1"/>
-          </a:fontRef>
-        </p:style>
-        <p:txBody>
-          <a:bodyPr rtlCol="0" anchor="t" wrap="square" lIns="256032" rIns="219456" tIns="182880" bIns="128016"/>
-          <a:lstStyle/>
-          <a:p>
-            <a:pPr algn="l"/>
-            <a:r>
-              <a:rPr sz="1700" b="1">
-                <a:solidFill>
-                  <a:srgbClr val="063D22"/>
-                </a:solidFill>
-                <a:latin typeface="Arial"/>
-              </a:rPr>
-              <a:t>Why blend 16 models?</a:t>
-            </a:r>
-          </a:p>
-          <a:p>
-            <a:pPr algn="l">
-              <a:spcBef>
-                <a:spcPts val="600"/>
-              </a:spcBef>
-            </a:pPr>
-            <a:r>
-              <a:rPr sz="1400">
-                <a:solidFill>
-                  <a:srgbClr val="5C7268"/>
-                </a:solidFill>
-                <a:latin typeface="Arial"/>
-              </a:rPr>
-              <a:t>Different model families make different mistakes. Averaging their predictions cancels the random part of each model's error and leaves the genuine signal — so the ensemble beats any single model.</a:t>
-            </a:r>
-          </a:p>
-        </p:txBody>
-      </p:sp>
-      <p:sp>
-        <p:nvSpPr>
-          <p:cNvPr id="59" name="TextBox 58"/>
-          <p:cNvSpPr txBox="1"/>
-          <p:nvPr/>
-        </p:nvSpPr>
-        <p:spPr>
-          <a:xfrm>
-            <a:off x="11475720" y="8869680"/>
-            <a:ext cx="5852160" cy="320040"/>
-          </a:xfrm>
-          <a:prstGeom prst="rect">
-            <a:avLst/>
-          </a:prstGeom>
-          <a:noFill/>
-        </p:spPr>
-        <p:txBody>
-          <a:bodyPr wrap="none">
-            <a:spAutoFit/>
-          </a:bodyPr>
-          <a:lstStyle/>
-          <a:p>
-            <a:r>
-              <a:rPr sz="1300">
-                <a:solidFill>
-                  <a:srgbClr val="007A33"/>
-                </a:solidFill>
-                <a:latin typeface="Arial"/>
-              </a:rPr>
-              <a:t>What each feature is → slide 9</a:t>
-            </a:r>
-          </a:p>
-        </p:txBody>
-      </p:sp>
     </p:spTree>
   </p:cSld>
   <p:clrMapOvr>

</xml_diff>

<commit_message>
Riwad's manual edits (checkpoint before pseudo-labeling explanation)
</commit_message>
<xml_diff>
--- a/presentation/Consulting_Finance_ML_Slides.pptx
+++ b/presentation/Consulting_Finance_ML_Slides.pptx
@@ -13020,7 +13020,7 @@
           </a:fontRef>
         </p:style>
         <p:txBody>
-          <a:bodyPr rtlCol="0" anchor="t" wrap="square" lIns="256032" rIns="219456" tIns="182880" bIns="128016"/>
+          <a:bodyPr wrap="square" lIns="256032" tIns="182880" rIns="219456" bIns="128016" rtlCol="0" anchor="t"/>
           <a:lstStyle/>
           <a:p>
             <a:pPr algn="l"/>
@@ -13125,7 +13125,7 @@
           </a:fontRef>
         </p:style>
         <p:txBody>
-          <a:bodyPr rtlCol="0" anchor="ctr" wrap="square" tIns="36576" bIns="36576"/>
+          <a:bodyPr wrap="square" tIns="36576" bIns="36576" rtlCol="0" anchor="ctr"/>
           <a:lstStyle/>
           <a:p>
             <a:pPr algn="ctr"/>
@@ -13204,7 +13204,7 @@
           </a:fontRef>
         </p:style>
         <p:txBody>
-          <a:bodyPr rtlCol="0" anchor="ctr" wrap="square" tIns="36576" bIns="36576"/>
+          <a:bodyPr wrap="square" tIns="36576" bIns="36576" rtlCol="0" anchor="ctr"/>
           <a:lstStyle/>
           <a:p>
             <a:pPr algn="ctr"/>
@@ -13283,7 +13283,7 @@
           </a:fontRef>
         </p:style>
         <p:txBody>
-          <a:bodyPr rtlCol="0" anchor="ctr" wrap="square" tIns="36576" bIns="36576"/>
+          <a:bodyPr wrap="square" tIns="36576" bIns="36576" rtlCol="0" anchor="ctr"/>
           <a:lstStyle/>
           <a:p>
             <a:pPr algn="ctr"/>

</xml_diff>

<commit_message>
Slide 8: explain pseudo-labeling in plain English + clarify cutoff
Pseudo-labeling box rewritten (what/why/safety/measured gain); smooth-cutoff box
now reads 'approve if p > 0.527'. Dropped the redundant caption to make room.
</commit_message>
<xml_diff>
--- a/presentation/Consulting_Finance_ML_Slides.pptx
+++ b/presentation/Consulting_Finance_ML_Slides.pptx
@@ -12782,7 +12782,7 @@
                 </a:solidFill>
                 <a:latin typeface="Arial"/>
               </a:rPr>
-              <a:t>≈ 0.527</a:t>
+              <a:t>approve if p &gt; 0.527</a:t>
             </a:r>
           </a:p>
         </p:txBody>
@@ -12823,108 +12823,6 @@
           </a:fontRef>
         </p:style>
       </p:cxnSp>
-      <p:sp>
-        <p:nvSpPr>
-          <p:cNvPr id="54" name="Rounded Rectangle 53"/>
-          <p:cNvSpPr/>
-          <p:nvPr/>
-        </p:nvSpPr>
-        <p:spPr>
-          <a:xfrm>
-            <a:off x="950976" y="4983480"/>
-            <a:ext cx="16367759" cy="868680"/>
-          </a:xfrm>
-          <a:prstGeom prst="roundRect">
-            <a:avLst/>
-          </a:prstGeom>
-          <a:solidFill>
-            <a:srgbClr val="F4F8F6"/>
-          </a:solidFill>
-          <a:ln w="19050">
-            <a:solidFill>
-              <a:srgbClr val="C8D4CF"/>
-            </a:solidFill>
-          </a:ln>
-          <a:effectLst/>
-        </p:spPr>
-        <p:style>
-          <a:lnRef idx="1">
-            <a:schemeClr val="accent1"/>
-          </a:lnRef>
-          <a:fillRef idx="3">
-            <a:schemeClr val="accent1"/>
-          </a:fillRef>
-          <a:effectRef idx="2">
-            <a:schemeClr val="accent1"/>
-          </a:effectRef>
-          <a:fontRef idx="minor">
-            <a:schemeClr val="lt1"/>
-          </a:fontRef>
-        </p:style>
-        <p:txBody>
-          <a:bodyPr wrap="square" rtlCol="0" anchor="ctr"/>
-          <a:lstStyle/>
-          <a:p>
-            <a:pPr algn="ctr"/>
-            <a:r>
-              <a:rPr sz="1500" b="1">
-                <a:solidFill>
-                  <a:srgbClr val="063D22"/>
-                </a:solidFill>
-                <a:latin typeface="Arial"/>
-              </a:rPr>
-              <a:t>Pseudo-labeling pass (v8 / v10)</a:t>
-            </a:r>
-          </a:p>
-          <a:p>
-            <a:pPr algn="ctr"/>
-            <a:r>
-              <a:rPr sz="1300" b="0">
-                <a:solidFill>
-                  <a:srgbClr val="5C7268"/>
-                </a:solidFill>
-                <a:latin typeface="Arial"/>
-              </a:rPr>
-              <a:t>confident test rows (≥ 0.97) added at weight 0.5  —  +0.14 pt on rolling validation</a:t>
-            </a:r>
-          </a:p>
-        </p:txBody>
-      </p:sp>
-      <p:sp>
-        <p:nvSpPr>
-          <p:cNvPr id="55" name="TextBox 54"/>
-          <p:cNvSpPr txBox="1"/>
-          <p:nvPr/>
-        </p:nvSpPr>
-        <p:spPr>
-          <a:xfrm>
-            <a:off x="950976" y="5943600"/>
-            <a:ext cx="16367759" cy="365760"/>
-          </a:xfrm>
-          <a:prstGeom prst="rect">
-            <a:avLst/>
-          </a:prstGeom>
-          <a:noFill/>
-        </p:spPr>
-        <p:txBody>
-          <a:bodyPr wrap="none">
-            <a:spAutoFit/>
-          </a:bodyPr>
-          <a:lstStyle/>
-          <a:p>
-            <a:pPr algn="ctr"/>
-            <a:r>
-              <a:rPr sz="1400" i="1">
-                <a:solidFill>
-                  <a:srgbClr val="5C7268"/>
-                </a:solidFill>
-                <a:latin typeface="Arial"/>
-              </a:rPr>
-              <a:t>From clean features to a single approve / reject decision per applicant.</a:t>
-            </a:r>
-          </a:p>
-        </p:txBody>
-      </p:sp>
       <p:sp>
         <p:nvSpPr>
           <p:cNvPr id="56" name="TextBox 55"/>
@@ -13539,6 +13437,97 @@
           </a:fontRef>
         </p:style>
       </p:cxnSp>
+      <p:sp>
+        <p:nvSpPr>
+          <p:cNvPr id="69" name="Rounded Rectangle 68"/>
+          <p:cNvSpPr/>
+          <p:nvPr/>
+        </p:nvSpPr>
+        <p:spPr>
+          <a:xfrm>
+            <a:off x="950976" y="4846320"/>
+            <a:ext cx="16367759" cy="1417320"/>
+          </a:xfrm>
+          <a:prstGeom prst="roundRect">
+            <a:avLst/>
+          </a:prstGeom>
+          <a:solidFill>
+            <a:srgbClr val="F4F8F6"/>
+          </a:solidFill>
+          <a:ln w="12700">
+            <a:solidFill>
+              <a:srgbClr val="C8D4CF"/>
+            </a:solidFill>
+          </a:ln>
+          <a:effectLst/>
+        </p:spPr>
+        <p:style>
+          <a:lnRef idx="1">
+            <a:schemeClr val="accent1"/>
+          </a:lnRef>
+          <a:fillRef idx="3">
+            <a:schemeClr val="accent1"/>
+          </a:fillRef>
+          <a:effectRef idx="2">
+            <a:schemeClr val="accent1"/>
+          </a:effectRef>
+          <a:fontRef idx="minor">
+            <a:schemeClr val="lt1"/>
+          </a:fontRef>
+        </p:style>
+        <p:txBody>
+          <a:bodyPr rtlCol="0" anchor="ctr" wrap="square" lIns="365760" rIns="365760" tIns="109728" bIns="109728"/>
+          <a:lstStyle/>
+          <a:p>
+            <a:pPr algn="ctr">
+              <a:spcAft>
+                <a:spcPts val="300"/>
+              </a:spcAft>
+            </a:pPr>
+            <a:r>
+              <a:rPr sz="1600" b="1" i="0">
+                <a:solidFill>
+                  <a:srgbClr val="063D22"/>
+                </a:solidFill>
+                <a:latin typeface="Arial"/>
+              </a:rPr>
+              <a:t>Pseudo-labeling  —  learning from the new month</a:t>
+            </a:r>
+          </a:p>
+          <a:p>
+            <a:pPr algn="ctr">
+              <a:spcAft>
+                <a:spcPts val="300"/>
+              </a:spcAft>
+            </a:pPr>
+            <a:r>
+              <a:rPr sz="1400" b="0" i="0">
+                <a:solidFill>
+                  <a:srgbClr val="5C7268"/>
+                </a:solidFill>
+                <a:latin typeface="Arial"/>
+              </a:rPr>
+              <a:t>The ensemble's most confident test predictions (≥ 0.97) are added back into training as extra examples, at half weight, so the model adapts to the May-2026 patterns it has to predict.</a:t>
+            </a:r>
+          </a:p>
+          <a:p>
+            <a:pPr algn="ctr">
+              <a:spcAft>
+                <a:spcPts val="300"/>
+              </a:spcAft>
+            </a:pPr>
+            <a:r>
+              <a:rPr sz="1300" b="0" i="1">
+                <a:solidFill>
+                  <a:srgbClr val="5C7268"/>
+                </a:solidFill>
+                <a:latin typeface="Arial"/>
+              </a:rPr>
+              <a:t>Kept safe — only very confident rows, down-weighted — and the gain is measured, not assumed:  +0.14 pt on rolling validation.</a:t>
+            </a:r>
+          </a:p>
+        </p:txBody>
+      </p:sp>
     </p:spTree>
   </p:cSld>
   <p:clrMapOvr>

</xml_diff>

<commit_message>
Riwad's manual edits (checkpoint before slide 9 explanations)
</commit_message>
<xml_diff>
--- a/presentation/Consulting_Finance_ML_Slides.pptx
+++ b/presentation/Consulting_Finance_ML_Slides.pptx
@@ -12699,19 +12699,55 @@
           <a:p>
             <a:pPr algn="ctr"/>
             <a:r>
-              <a:rPr sz="1800" b="1">
+              <a:rPr lang="de-DE" sz="1800" b="1" dirty="0" err="1">
                 <a:solidFill>
                   <a:srgbClr val="FFFFFF"/>
                 </a:solidFill>
                 <a:latin typeface="Arial"/>
               </a:rPr>
-              <a:t>mean blend</a:t>
+              <a:t>Weighted</a:t>
+            </a:r>
+            <a:r>
+              <a:rPr lang="de-DE" sz="1800" b="1" dirty="0">
+                <a:solidFill>
+                  <a:srgbClr val="FFFFFF"/>
+                </a:solidFill>
+                <a:latin typeface="Arial"/>
+              </a:rPr>
+              <a:t> </a:t>
+            </a:r>
+            <a:r>
+              <a:rPr lang="de-DE" sz="1800" b="1" dirty="0" err="1">
+                <a:solidFill>
+                  <a:srgbClr val="FFFFFF"/>
+                </a:solidFill>
+                <a:latin typeface="Arial"/>
+              </a:rPr>
+              <a:t>tuned</a:t>
+            </a:r>
+            <a:r>
+              <a:rPr lang="de-DE" sz="1800" b="1" dirty="0">
+                <a:solidFill>
+                  <a:srgbClr val="FFFFFF"/>
+                </a:solidFill>
+                <a:latin typeface="Arial"/>
+              </a:rPr>
+              <a:t> </a:t>
+            </a:r>
+            <a:r>
+              <a:rPr sz="1800" b="1" dirty="0">
+                <a:solidFill>
+                  <a:srgbClr val="FFFFFF"/>
+                </a:solidFill>
+                <a:latin typeface="Arial"/>
+              </a:rPr>
+              <a:t>blend</a:t>
             </a:r>
           </a:p>
           <a:p>
             <a:pPr algn="ctr"/>
             <a:r>
-              <a:rPr sz="1300" b="0">
+              <a:rPr sz="1300" b="0" dirty="0">
                 <a:solidFill>
                   <a:srgbClr val="EAF3EF"/>
                 </a:solidFill>
@@ -12973,7 +13009,7 @@
           <a:lstStyle/>
           <a:p>
             <a:r>
-              <a:rPr sz="1300">
+              <a:rPr sz="1300" dirty="0">
                 <a:solidFill>
                   <a:srgbClr val="007A33"/>
                 </a:solidFill>
@@ -13028,19 +13064,34 @@
           <a:p>
             <a:pPr algn="ctr"/>
             <a:r>
-              <a:rPr sz="1500" b="1" i="0">
+              <a:rPr sz="1500" b="1" i="0" dirty="0">
                 <a:solidFill>
                   <a:srgbClr val="063D22"/>
                 </a:solidFill>
                 <a:latin typeface="Arial"/>
               </a:rPr>
-              <a:t>9 × LightGBM</a:t>
-            </a:r>
+              <a:t>9 × </a:t>
+            </a:r>
+            <a:r>
+              <a:rPr sz="1500" b="1" i="0" dirty="0" err="1">
+                <a:solidFill>
+                  <a:srgbClr val="063D22"/>
+                </a:solidFill>
+                <a:latin typeface="Arial"/>
+              </a:rPr>
+              <a:t>LightGBM</a:t>
+            </a:r>
+            <a:endParaRPr sz="1500" b="1" i="0" dirty="0">
+              <a:solidFill>
+                <a:srgbClr val="063D22"/>
+              </a:solidFill>
+              <a:latin typeface="Arial"/>
+            </a:endParaRPr>
           </a:p>
           <a:p>
             <a:pPr algn="ctr"/>
             <a:r>
-              <a:rPr sz="1150" b="0" i="0">
+              <a:rPr sz="1150" b="0" i="0" dirty="0">
                 <a:solidFill>
                   <a:srgbClr val="2E8B62"/>
                 </a:solidFill>
@@ -13048,11 +13099,26 @@
               </a:rPr>
               <a:t>Fast · native missing-value handling</a:t>
             </a:r>
+            <a:r>
+              <a:rPr lang="de-DE" sz="1150" b="0" i="0" dirty="0">
+                <a:solidFill>
+                  <a:srgbClr val="2E8B62"/>
+                </a:solidFill>
+                <a:latin typeface="Arial"/>
+              </a:rPr>
+              <a:t> </a:t>
+            </a:r>
+            <a:endParaRPr sz="1150" b="0" i="0" dirty="0">
+              <a:solidFill>
+                <a:srgbClr val="2E8B62"/>
+              </a:solidFill>
+              <a:latin typeface="Arial"/>
+            </a:endParaRPr>
           </a:p>
           <a:p>
             <a:pPr algn="ctr"/>
             <a:r>
-              <a:rPr sz="1000" b="0" i="0">
+              <a:rPr sz="1000" b="0" i="0" dirty="0">
                 <a:solidFill>
                   <a:srgbClr val="5C7268"/>
                 </a:solidFill>
@@ -13107,19 +13173,34 @@
           <a:p>
             <a:pPr algn="ctr"/>
             <a:r>
-              <a:rPr sz="1500" b="1" i="0">
+              <a:rPr sz="1500" b="1" i="0" dirty="0">
                 <a:solidFill>
                   <a:srgbClr val="063D22"/>
                 </a:solidFill>
                 <a:latin typeface="Arial"/>
               </a:rPr>
-              <a:t>3 × XGBoost</a:t>
-            </a:r>
+              <a:t>3 × </a:t>
+            </a:r>
+            <a:r>
+              <a:rPr sz="1500" b="1" i="0" dirty="0" err="1">
+                <a:solidFill>
+                  <a:srgbClr val="063D22"/>
+                </a:solidFill>
+                <a:latin typeface="Arial"/>
+              </a:rPr>
+              <a:t>XGBoost</a:t>
+            </a:r>
+            <a:endParaRPr sz="1500" b="1" i="0" dirty="0">
+              <a:solidFill>
+                <a:srgbClr val="063D22"/>
+              </a:solidFill>
+              <a:latin typeface="Arial"/>
+            </a:endParaRPr>
           </a:p>
           <a:p>
             <a:pPr algn="ctr"/>
             <a:r>
-              <a:rPr sz="1150" b="0" i="0">
+              <a:rPr sz="1150" b="0" i="0" dirty="0">
                 <a:solidFill>
                   <a:srgbClr val="2E8B62"/>
                 </a:solidFill>
@@ -13131,7 +13212,7 @@
           <a:p>
             <a:pPr algn="ctr"/>
             <a:r>
-              <a:rPr sz="1000" b="0" i="0">
+              <a:rPr sz="1000" b="0" i="0" dirty="0">
                 <a:solidFill>
                   <a:srgbClr val="5C7268"/>
                 </a:solidFill>
@@ -13476,7 +13557,7 @@
           </a:fontRef>
         </p:style>
         <p:txBody>
-          <a:bodyPr rtlCol="0" anchor="ctr" wrap="square" lIns="365760" rIns="365760" tIns="109728" bIns="109728"/>
+          <a:bodyPr wrap="square" lIns="365760" tIns="109728" rIns="365760" bIns="109728" rtlCol="0" anchor="ctr"/>
           <a:lstStyle/>
           <a:p>
             <a:pPr algn="ctr">
@@ -13525,6 +13606,125 @@
               </a:rPr>
               <a:t>Kept safe — only very confident rows, down-weighted — and the gain is measured, not assumed:  +0.14 pt on rolling validation.</a:t>
             </a:r>
+          </a:p>
+        </p:txBody>
+      </p:sp>
+      <p:sp>
+        <p:nvSpPr>
+          <p:cNvPr id="6" name="TextBox 5">
+            <a:extLst>
+              <a:ext uri="{FF2B5EF4-FFF2-40B4-BE49-F238E27FC236}">
+                <a16:creationId xmlns:a16="http://schemas.microsoft.com/office/drawing/2014/main" id="{F0C4F650-6F9E-2C83-CF82-59BC68D8AEB7}"/>
+              </a:ext>
+            </a:extLst>
+          </p:cNvPr>
+          <p:cNvSpPr txBox="1"/>
+          <p:nvPr/>
+        </p:nvSpPr>
+        <p:spPr>
+          <a:xfrm>
+            <a:off x="3590986" y="1952625"/>
+            <a:ext cx="1438214" cy="292388"/>
+          </a:xfrm>
+          <a:prstGeom prst="rect">
+            <a:avLst/>
+          </a:prstGeom>
+          <a:noFill/>
+        </p:spPr>
+        <p:txBody>
+          <a:bodyPr wrap="none">
+            <a:spAutoFit/>
+          </a:bodyPr>
+          <a:lstStyle/>
+          <a:p>
+            <a:r>
+              <a:rPr lang="de-DE" sz="1300" b="1" dirty="0">
+                <a:solidFill>
+                  <a:srgbClr val="007A33"/>
+                </a:solidFill>
+                <a:latin typeface="Arial"/>
+              </a:rPr>
+              <a:t>Random </a:t>
+            </a:r>
+            <a:r>
+              <a:rPr lang="de-DE" sz="1300" b="1" dirty="0" err="1">
+                <a:solidFill>
+                  <a:srgbClr val="007A33"/>
+                </a:solidFill>
+                <a:latin typeface="Arial"/>
+              </a:rPr>
+              <a:t>search</a:t>
+            </a:r>
+            <a:endParaRPr sz="1300" b="1" dirty="0">
+              <a:solidFill>
+                <a:srgbClr val="007A33"/>
+              </a:solidFill>
+              <a:latin typeface="Arial"/>
+            </a:endParaRPr>
+          </a:p>
+        </p:txBody>
+      </p:sp>
+      <p:sp>
+        <p:nvSpPr>
+          <p:cNvPr id="7" name="TextBox 6">
+            <a:extLst>
+              <a:ext uri="{FF2B5EF4-FFF2-40B4-BE49-F238E27FC236}">
+                <a16:creationId xmlns:a16="http://schemas.microsoft.com/office/drawing/2014/main" id="{27C5012B-4219-D21C-1146-55198B6A3D05}"/>
+              </a:ext>
+            </a:extLst>
+          </p:cNvPr>
+          <p:cNvSpPr txBox="1"/>
+          <p:nvPr/>
+        </p:nvSpPr>
+        <p:spPr>
+          <a:xfrm>
+            <a:off x="9144000" y="1924786"/>
+            <a:ext cx="1326004" cy="338554"/>
+          </a:xfrm>
+          <a:prstGeom prst="rect">
+            <a:avLst/>
+          </a:prstGeom>
+          <a:noFill/>
+        </p:spPr>
+        <p:txBody>
+          <a:bodyPr wrap="none">
+            <a:spAutoFit/>
+          </a:bodyPr>
+          <a:lstStyle/>
+          <a:p>
+            <a:r>
+              <a:rPr lang="de-DE" sz="1600" b="1" dirty="0" err="1">
+                <a:solidFill>
+                  <a:srgbClr val="007A33"/>
+                </a:solidFill>
+                <a:latin typeface="Arial"/>
+              </a:rPr>
+              <a:t>Grid</a:t>
+            </a:r>
+            <a:r>
+              <a:rPr lang="de-DE" sz="1600" b="1" dirty="0">
+                <a:solidFill>
+                  <a:srgbClr val="007A33"/>
+                </a:solidFill>
+                <a:latin typeface="Arial"/>
+              </a:rPr>
+              <a:t> </a:t>
+            </a:r>
+            <a:r>
+              <a:rPr lang="de-DE" sz="1600" b="1" dirty="0" err="1">
+                <a:solidFill>
+                  <a:srgbClr val="007A33"/>
+                </a:solidFill>
+                <a:latin typeface="Arial"/>
+              </a:rPr>
+              <a:t>search</a:t>
+            </a:r>
+            <a:endParaRPr sz="1600" b="1" dirty="0">
+              <a:solidFill>
+                <a:srgbClr val="007A33"/>
+              </a:solidFill>
+              <a:latin typeface="Arial"/>
+            </a:endParaRPr>
           </a:p>
         </p:txBody>
       </p:sp>

</xml_diff>

<commit_message>
Slide 9: rewrite feature table in plain English (what it is / why we made it)
Replaced terse formula cells with clear descriptions — e.g. risk_max = the higher
(worse) of the two risk scores — and a why-we-made-it column.
</commit_message>
<xml_diff>
--- a/presentation/Consulting_Finance_ML_Slides.pptx
+++ b/presentation/Consulting_Finance_ML_Slides.pptx
@@ -13977,12 +13977,12 @@
               <a:tr h="754380">
                 <a:tc>
                   <a:txBody>
-                    <a:bodyPr/>
+                    <a:bodyPr wrap="square"/>
                     <a:lstStyle/>
                     <a:p>
                       <a:pPr algn="l"/>
                       <a:r>
-                        <a:rPr sz="1700" b="1">
+                        <a:rPr sz="1600" b="1">
                           <a:solidFill>
                             <a:srgbClr val="FFFFFF"/>
                           </a:solidFill>
@@ -14000,18 +14000,18 @@
                 </a:tc>
                 <a:tc>
                   <a:txBody>
-                    <a:bodyPr/>
+                    <a:bodyPr wrap="square"/>
                     <a:lstStyle/>
                     <a:p>
                       <a:pPr algn="l"/>
                       <a:r>
-                        <a:rPr sz="1700" b="1">
+                        <a:rPr sz="1600" b="1">
                           <a:solidFill>
                             <a:srgbClr val="FFFFFF"/>
                           </a:solidFill>
                           <a:latin typeface="Arial"/>
                         </a:rPr>
-                        <a:t>How we built it</a:t>
+                        <a:t>What it is</a:t>
                       </a:r>
                     </a:p>
                   </a:txBody>
@@ -14023,18 +14023,18 @@
                 </a:tc>
                 <a:tc>
                   <a:txBody>
-                    <a:bodyPr/>
+                    <a:bodyPr wrap="square"/>
                     <a:lstStyle/>
                     <a:p>
                       <a:pPr algn="l"/>
                       <a:r>
-                        <a:rPr sz="1700" b="1">
+                        <a:rPr sz="1600" b="1">
                           <a:solidFill>
                             <a:srgbClr val="FFFFFF"/>
                           </a:solidFill>
                           <a:latin typeface="Arial"/>
                         </a:rPr>
-                        <a:t>Why it helps</a:t>
+                        <a:t>Why we made it</a:t>
                       </a:r>
                     </a:p>
                   </a:txBody>
@@ -14053,12 +14053,12 @@
               <a:tr h="754380">
                 <a:tc>
                   <a:txBody>
-                    <a:bodyPr/>
+                    <a:bodyPr wrap="square"/>
                     <a:lstStyle/>
                     <a:p>
                       <a:pPr algn="l"/>
                       <a:r>
-                        <a:rPr sz="1500">
+                        <a:rPr sz="1400">
                           <a:solidFill>
                             <a:srgbClr val="14533B"/>
                           </a:solidFill>
@@ -14076,18 +14076,18 @@
                 </a:tc>
                 <a:tc>
                   <a:txBody>
-                    <a:bodyPr/>
+                    <a:bodyPr wrap="square"/>
                     <a:lstStyle/>
                     <a:p>
                       <a:pPr algn="l"/>
                       <a:r>
-                        <a:rPr sz="1500">
+                        <a:rPr sz="1400">
                           <a:solidFill>
-                            <a:srgbClr val="14533B"/>
+                            <a:srgbClr val="143A2B"/>
                           </a:solidFill>
-                          <a:latin typeface="Courier New"/>
+                          <a:latin typeface="Arial"/>
                         </a:rPr>
-                        <a:t>mean &amp; max of the two risk indicators</a:t>
+                        <a:t>Average, and the higher (worse), of the two risk scores</a:t>
                       </a:r>
                     </a:p>
                   </a:txBody>
@@ -14099,18 +14099,18 @@
                 </a:tc>
                 <a:tc>
                   <a:txBody>
-                    <a:bodyPr/>
+                    <a:bodyPr wrap="square"/>
                     <a:lstStyle/>
                     <a:p>
                       <a:pPr algn="l"/>
                       <a:r>
-                        <a:rPr sz="1500">
+                        <a:rPr sz="1400">
                           <a:solidFill>
                             <a:srgbClr val="5C7268"/>
                           </a:solidFill>
                           <a:latin typeface="Arial"/>
                         </a:rPr>
-                        <a:t>Combine both risk sources</a:t>
+                        <a:t>One combined risk level — plus a flag when either source is high</a:t>
                       </a:r>
                     </a:p>
                   </a:txBody>
@@ -14129,12 +14129,12 @@
               <a:tr h="754380">
                 <a:tc>
                   <a:txBody>
-                    <a:bodyPr/>
+                    <a:bodyPr wrap="square"/>
                     <a:lstStyle/>
                     <a:p>
                       <a:pPr algn="l"/>
                       <a:r>
-                        <a:rPr sz="1500">
+                        <a:rPr sz="1400">
                           <a:solidFill>
                             <a:srgbClr val="14533B"/>
                           </a:solidFill>
@@ -14152,18 +14152,18 @@
                 </a:tc>
                 <a:tc>
                   <a:txBody>
-                    <a:bodyPr/>
+                    <a:bodyPr wrap="square"/>
                     <a:lstStyle/>
                     <a:p>
                       <a:pPr algn="l"/>
                       <a:r>
-                        <a:rPr sz="1500">
+                        <a:rPr sz="1400">
                           <a:solidFill>
-                            <a:srgbClr val="14533B"/>
+                            <a:srgbClr val="143A2B"/>
                           </a:solidFill>
-                          <a:latin typeface="Courier New"/>
+                          <a:latin typeface="Arial"/>
                         </a:rPr>
-                        <a:t>distance from the middle:  |risk - 55|</a:t>
+                        <a:t>How far the risk score sits from the safe middle  (|risk − 55|)</a:t>
                       </a:r>
                     </a:p>
                   </a:txBody>
@@ -14175,18 +14175,18 @@
                 </a:tc>
                 <a:tc>
                   <a:txBody>
-                    <a:bodyPr/>
+                    <a:bodyPr wrap="square"/>
                     <a:lstStyle/>
                     <a:p>
                       <a:pPr algn="l"/>
                       <a:r>
-                        <a:rPr sz="1500">
+                        <a:rPr sz="1400">
                           <a:solidFill>
                             <a:srgbClr val="5C7268"/>
                           </a:solidFill>
                           <a:latin typeface="Arial"/>
                         </a:rPr>
-                        <a:t>Turns the risk hump into usable signal</a:t>
+                        <a:t>Approval peaks mid-scale and drops at both ends — this captures that hump</a:t>
                       </a:r>
                     </a:p>
                   </a:txBody>
@@ -14205,12 +14205,12 @@
               <a:tr h="754380">
                 <a:tc>
                   <a:txBody>
-                    <a:bodyPr/>
+                    <a:bodyPr wrap="square"/>
                     <a:lstStyle/>
                     <a:p>
                       <a:pPr algn="l"/>
                       <a:r>
-                        <a:rPr sz="1500">
+                        <a:rPr sz="1400">
                           <a:solidFill>
                             <a:srgbClr val="14533B"/>
                           </a:solidFill>
@@ -14228,18 +14228,18 @@
                 </a:tc>
                 <a:tc>
                   <a:txBody>
-                    <a:bodyPr/>
+                    <a:bodyPr wrap="square"/>
                     <a:lstStyle/>
                     <a:p>
                       <a:pPr algn="l"/>
                       <a:r>
-                        <a:rPr sz="1500">
+                        <a:rPr sz="1400">
                           <a:solidFill>
-                            <a:srgbClr val="14533B"/>
+                            <a:srgbClr val="143A2B"/>
                           </a:solidFill>
-                          <a:latin typeface="Courier New"/>
+                          <a:latin typeface="Arial"/>
                         </a:rPr>
-                        <a:t>amount / (total_income + 1)</a:t>
+                        <a:t>Loan amount ÷ total income</a:t>
                       </a:r>
                     </a:p>
                   </a:txBody>
@@ -14251,18 +14251,18 @@
                 </a:tc>
                 <a:tc>
                   <a:txBody>
-                    <a:bodyPr/>
+                    <a:bodyPr wrap="square"/>
                     <a:lstStyle/>
                     <a:p>
                       <a:pPr algn="l"/>
                       <a:r>
-                        <a:rPr sz="1500">
+                        <a:rPr sz="1400">
                           <a:solidFill>
                             <a:srgbClr val="5C7268"/>
                           </a:solidFill>
                           <a:latin typeface="Arial"/>
                         </a:rPr>
-                        <a:t>Affordability ratio — a credit standard</a:t>
+                        <a:t>Affordability — loan size vs. what they earn (a credit standard)</a:t>
                       </a:r>
                     </a:p>
                   </a:txBody>
@@ -14281,12 +14281,12 @@
               <a:tr h="754380">
                 <a:tc>
                   <a:txBody>
-                    <a:bodyPr/>
+                    <a:bodyPr wrap="square"/>
                     <a:lstStyle/>
                     <a:p>
                       <a:pPr algn="l"/>
                       <a:r>
-                        <a:rPr sz="1500">
+                        <a:rPr sz="1400">
                           <a:solidFill>
                             <a:srgbClr val="14533B"/>
                           </a:solidFill>
@@ -14304,18 +14304,18 @@
                 </a:tc>
                 <a:tc>
                   <a:txBody>
-                    <a:bodyPr/>
+                    <a:bodyPr wrap="square"/>
                     <a:lstStyle/>
                     <a:p>
                       <a:pPr algn="l"/>
                       <a:r>
-                        <a:rPr sz="1500">
+                        <a:rPr sz="1400">
                           <a:solidFill>
-                            <a:srgbClr val="14533B"/>
+                            <a:srgbClr val="143A2B"/>
                           </a:solidFill>
-                          <a:latin typeface="Courier New"/>
+                          <a:latin typeface="Arial"/>
                         </a:rPr>
-                        <a:t>ann_income + other_income (log-scaled)</a:t>
+                        <a:t>Annual + other income combined (and its log)</a:t>
                       </a:r>
                     </a:p>
                   </a:txBody>
@@ -14327,18 +14327,18 @@
                 </a:tc>
                 <a:tc>
                   <a:txBody>
-                    <a:bodyPr/>
+                    <a:bodyPr wrap="square"/>
                     <a:lstStyle/>
                     <a:p>
                       <a:pPr algn="l"/>
                       <a:r>
-                        <a:rPr sz="1500">
+                        <a:rPr sz="1400">
                           <a:solidFill>
                             <a:srgbClr val="5C7268"/>
                           </a:solidFill>
                           <a:latin typeface="Arial"/>
                         </a:rPr>
-                        <a:t>Real disposable income</a:t>
+                        <a:t>Real disposable income; the log tames very large values</a:t>
                       </a:r>
                     </a:p>
                   </a:txBody>
@@ -14357,12 +14357,12 @@
               <a:tr h="754380">
                 <a:tc>
                   <a:txBody>
-                    <a:bodyPr/>
+                    <a:bodyPr wrap="square"/>
                     <a:lstStyle/>
                     <a:p>
                       <a:pPr algn="l"/>
                       <a:r>
-                        <a:rPr sz="1500">
+                        <a:rPr sz="1400">
                           <a:solidFill>
                             <a:srgbClr val="14533B"/>
                           </a:solidFill>
@@ -14380,18 +14380,18 @@
                 </a:tc>
                 <a:tc>
                   <a:txBody>
-                    <a:bodyPr/>
+                    <a:bodyPr wrap="square"/>
                     <a:lstStyle/>
                     <a:p>
                       <a:pPr algn="l"/>
                       <a:r>
-                        <a:rPr sz="1500">
+                        <a:rPr sz="1400">
                           <a:solidFill>
-                            <a:srgbClr val="14533B"/>
+                            <a:srgbClr val="143A2B"/>
                           </a:solidFill>
-                          <a:latin typeface="Courier New"/>
+                          <a:latin typeface="Arial"/>
                         </a:rPr>
-                        <a:t>3 bureau scores z-scored &amp; merged</a:t>
+                        <a:t>The 3 bureau scores put on one scale and merged</a:t>
                       </a:r>
                     </a:p>
                   </a:txBody>
@@ -14403,18 +14403,18 @@
                 </a:tc>
                 <a:tc>
                   <a:txBody>
-                    <a:bodyPr/>
+                    <a:bodyPr wrap="square"/>
                     <a:lstStyle/>
                     <a:p>
                       <a:pPr algn="l"/>
                       <a:r>
-                        <a:rPr sz="1500">
+                        <a:rPr sz="1400">
                           <a:solidFill>
                             <a:srgbClr val="5C7268"/>
                           </a:solidFill>
                           <a:latin typeface="Arial"/>
                         </a:rPr>
-                        <a:t>One comparable score from 3 scales</a:t>
+                        <a:t>Each person has one score on a different scale — makes them comparable</a:t>
                       </a:r>
                     </a:p>
                   </a:txBody>
@@ -14433,12 +14433,12 @@
               <a:tr h="754380">
                 <a:tc>
                   <a:txBody>
-                    <a:bodyPr/>
+                    <a:bodyPr wrap="square"/>
                     <a:lstStyle/>
                     <a:p>
                       <a:pPr algn="l"/>
                       <a:r>
-                        <a:rPr sz="1500">
+                        <a:rPr sz="1400">
                           <a:solidFill>
                             <a:srgbClr val="14533B"/>
                           </a:solidFill>
@@ -14456,18 +14456,18 @@
                 </a:tc>
                 <a:tc>
                   <a:txBody>
-                    <a:bodyPr/>
+                    <a:bodyPr wrap="square"/>
                     <a:lstStyle/>
                     <a:p>
                       <a:pPr algn="l"/>
                       <a:r>
-                        <a:rPr sz="1500">
+                        <a:rPr sz="1400">
                           <a:solidFill>
-                            <a:srgbClr val="14533B"/>
+                            <a:srgbClr val="143A2B"/>
                           </a:solidFill>
-                          <a:latin typeface="Courier New"/>
+                          <a:latin typeface="Arial"/>
                         </a:rPr>
-                        <a:t>binary 0/1 flags</a:t>
+                        <a:t>Flags for whether a value is present</a:t>
                       </a:r>
                     </a:p>
                   </a:txBody>
@@ -14479,18 +14479,18 @@
                 </a:tc>
                 <a:tc>
                   <a:txBody>
-                    <a:bodyPr/>
+                    <a:bodyPr wrap="square"/>
                     <a:lstStyle/>
                     <a:p>
                       <a:pPr algn="l"/>
                       <a:r>
-                        <a:rPr sz="1500">
+                        <a:rPr sz="1400">
                           <a:solidFill>
                             <a:srgbClr val="5C7268"/>
                           </a:solidFill>
                           <a:latin typeface="Arial"/>
                         </a:rPr>
-                        <a:t>“Value absent” is itself a signal</a:t>
+                        <a:t>Whether a field is missing is itself a useful signal</a:t>
                       </a:r>
                     </a:p>
                   </a:txBody>
@@ -14509,12 +14509,12 @@
               <a:tr h="754380">
                 <a:tc>
                   <a:txBody>
-                    <a:bodyPr/>
+                    <a:bodyPr wrap="square"/>
                     <a:lstStyle/>
                     <a:p>
                       <a:pPr algn="l"/>
                       <a:r>
-                        <a:rPr sz="1500">
+                        <a:rPr sz="1400">
                           <a:solidFill>
                             <a:srgbClr val="14533B"/>
                           </a:solidFill>
@@ -14532,18 +14532,18 @@
                 </a:tc>
                 <a:tc>
                   <a:txBody>
-                    <a:bodyPr/>
+                    <a:bodyPr wrap="square"/>
                     <a:lstStyle/>
                     <a:p>
                       <a:pPr algn="l"/>
                       <a:r>
-                        <a:rPr sz="1500">
+                        <a:rPr sz="1400">
                           <a:solidFill>
-                            <a:srgbClr val="14533B"/>
+                            <a:srgbClr val="143A2B"/>
                           </a:solidFill>
-                          <a:latin typeface="Courier New"/>
+                          <a:latin typeface="Arial"/>
                         </a:rPr>
-                        <a:t>parsed from the date</a:t>
+                        <a:t>Taken from the application date</a:t>
                       </a:r>
                     </a:p>
                   </a:txBody>
@@ -14555,18 +14555,18 @@
                 </a:tc>
                 <a:tc>
                   <a:txBody>
-                    <a:bodyPr/>
+                    <a:bodyPr wrap="square"/>
                     <a:lstStyle/>
                     <a:p>
                       <a:pPr algn="l"/>
                       <a:r>
-                        <a:rPr sz="1500">
+                        <a:rPr sz="1400">
                           <a:solidFill>
                             <a:srgbClr val="5C7268"/>
                           </a:solidFill>
                           <a:latin typeface="Arial"/>
                         </a:rPr>
-                        <a:t>Captures the downward 2026 approval trend</a:t>
+                        <a:t>Captures the approval-rate trend over time (down toward 2026)</a:t>
                       </a:r>
                     </a:p>
                   </a:txBody>

</xml_diff>

<commit_message>
Riwad's manual edits (checkpoint before deleting slide 11 + reworking slide 12)
</commit_message>
<xml_diff>
--- a/presentation/Consulting_Finance_ML_Slides.pptx
+++ b/presentation/Consulting_Finance_ML_Slides.pptx
@@ -13977,7 +13977,7 @@
               <a:tr h="754380">
                 <a:tc>
                   <a:txBody>
-                    <a:bodyPr wrap="square"/>
+                    <a:bodyPr/>
                     <a:lstStyle/>
                     <a:p>
                       <a:pPr algn="l"/>
@@ -14000,7 +14000,7 @@
                 </a:tc>
                 <a:tc>
                   <a:txBody>
-                    <a:bodyPr wrap="square"/>
+                    <a:bodyPr/>
                     <a:lstStyle/>
                     <a:p>
                       <a:pPr algn="l"/>
@@ -14023,7 +14023,7 @@
                 </a:tc>
                 <a:tc>
                   <a:txBody>
-                    <a:bodyPr wrap="square"/>
+                    <a:bodyPr/>
                     <a:lstStyle/>
                     <a:p>
                       <a:pPr algn="l"/>
@@ -14053,7 +14053,7 @@
               <a:tr h="754380">
                 <a:tc>
                   <a:txBody>
-                    <a:bodyPr wrap="square"/>
+                    <a:bodyPr/>
                     <a:lstStyle/>
                     <a:p>
                       <a:pPr algn="l"/>
@@ -14076,7 +14076,7 @@
                 </a:tc>
                 <a:tc>
                   <a:txBody>
-                    <a:bodyPr wrap="square"/>
+                    <a:bodyPr/>
                     <a:lstStyle/>
                     <a:p>
                       <a:pPr algn="l"/>
@@ -14099,7 +14099,7 @@
                 </a:tc>
                 <a:tc>
                   <a:txBody>
-                    <a:bodyPr wrap="square"/>
+                    <a:bodyPr/>
                     <a:lstStyle/>
                     <a:p>
                       <a:pPr algn="l"/>
@@ -14129,7 +14129,7 @@
               <a:tr h="754380">
                 <a:tc>
                   <a:txBody>
-                    <a:bodyPr wrap="square"/>
+                    <a:bodyPr/>
                     <a:lstStyle/>
                     <a:p>
                       <a:pPr algn="l"/>
@@ -14152,7 +14152,7 @@
                 </a:tc>
                 <a:tc>
                   <a:txBody>
-                    <a:bodyPr wrap="square"/>
+                    <a:bodyPr/>
                     <a:lstStyle/>
                     <a:p>
                       <a:pPr algn="l"/>
@@ -14175,7 +14175,7 @@
                 </a:tc>
                 <a:tc>
                   <a:txBody>
-                    <a:bodyPr wrap="square"/>
+                    <a:bodyPr/>
                     <a:lstStyle/>
                     <a:p>
                       <a:pPr algn="l"/>
@@ -14205,7 +14205,7 @@
               <a:tr h="754380">
                 <a:tc>
                   <a:txBody>
-                    <a:bodyPr wrap="square"/>
+                    <a:bodyPr/>
                     <a:lstStyle/>
                     <a:p>
                       <a:pPr algn="l"/>
@@ -14228,7 +14228,7 @@
                 </a:tc>
                 <a:tc>
                   <a:txBody>
-                    <a:bodyPr wrap="square"/>
+                    <a:bodyPr/>
                     <a:lstStyle/>
                     <a:p>
                       <a:pPr algn="l"/>
@@ -14251,7 +14251,7 @@
                 </a:tc>
                 <a:tc>
                   <a:txBody>
-                    <a:bodyPr wrap="square"/>
+                    <a:bodyPr/>
                     <a:lstStyle/>
                     <a:p>
                       <a:pPr algn="l"/>
@@ -14281,7 +14281,7 @@
               <a:tr h="754380">
                 <a:tc>
                   <a:txBody>
-                    <a:bodyPr wrap="square"/>
+                    <a:bodyPr/>
                     <a:lstStyle/>
                     <a:p>
                       <a:pPr algn="l"/>
@@ -14304,7 +14304,7 @@
                 </a:tc>
                 <a:tc>
                   <a:txBody>
-                    <a:bodyPr wrap="square"/>
+                    <a:bodyPr/>
                     <a:lstStyle/>
                     <a:p>
                       <a:pPr algn="l"/>
@@ -14327,7 +14327,7 @@
                 </a:tc>
                 <a:tc>
                   <a:txBody>
-                    <a:bodyPr wrap="square"/>
+                    <a:bodyPr/>
                     <a:lstStyle/>
                     <a:p>
                       <a:pPr algn="l"/>
@@ -14357,7 +14357,7 @@
               <a:tr h="754380">
                 <a:tc>
                   <a:txBody>
-                    <a:bodyPr wrap="square"/>
+                    <a:bodyPr/>
                     <a:lstStyle/>
                     <a:p>
                       <a:pPr algn="l"/>
@@ -14380,7 +14380,7 @@
                 </a:tc>
                 <a:tc>
                   <a:txBody>
-                    <a:bodyPr wrap="square"/>
+                    <a:bodyPr/>
                     <a:lstStyle/>
                     <a:p>
                       <a:pPr algn="l"/>
@@ -14403,7 +14403,7 @@
                 </a:tc>
                 <a:tc>
                   <a:txBody>
-                    <a:bodyPr wrap="square"/>
+                    <a:bodyPr/>
                     <a:lstStyle/>
                     <a:p>
                       <a:pPr algn="l"/>
@@ -14433,7 +14433,7 @@
               <a:tr h="754380">
                 <a:tc>
                   <a:txBody>
-                    <a:bodyPr wrap="square"/>
+                    <a:bodyPr/>
                     <a:lstStyle/>
                     <a:p>
                       <a:pPr algn="l"/>
@@ -14456,7 +14456,7 @@
                 </a:tc>
                 <a:tc>
                   <a:txBody>
-                    <a:bodyPr wrap="square"/>
+                    <a:bodyPr/>
                     <a:lstStyle/>
                     <a:p>
                       <a:pPr algn="l"/>
@@ -14479,7 +14479,7 @@
                 </a:tc>
                 <a:tc>
                   <a:txBody>
-                    <a:bodyPr wrap="square"/>
+                    <a:bodyPr/>
                     <a:lstStyle/>
                     <a:p>
                       <a:pPr algn="l"/>
@@ -14509,7 +14509,7 @@
               <a:tr h="754380">
                 <a:tc>
                   <a:txBody>
-                    <a:bodyPr wrap="square"/>
+                    <a:bodyPr/>
                     <a:lstStyle/>
                     <a:p>
                       <a:pPr algn="l"/>
@@ -14532,7 +14532,7 @@
                 </a:tc>
                 <a:tc>
                   <a:txBody>
-                    <a:bodyPr wrap="square"/>
+                    <a:bodyPr/>
                     <a:lstStyle/>
                     <a:p>
                       <a:pPr algn="l"/>
@@ -14555,7 +14555,7 @@
                 </a:tc>
                 <a:tc>
                   <a:txBody>
-                    <a:bodyPr wrap="square"/>
+                    <a:bodyPr/>
                     <a:lstStyle/>
                     <a:p>
                       <a:pPr algn="l"/>

</xml_diff>

<commit_message>
Delete 'What we learned' slide; sharpen 'What comes next' steps
- removed slide 11 (lessons) per feedback
- reworked the 4 next-steps with specific, defensible reasons tied to the project;
  fixed step 4 to say approval rates drifted (not 'months look different', which
  contradicted our adversarial-validation finding)
- renumbered remaining slides (now 13 total)
</commit_message>
<xml_diff>
--- a/presentation/Consulting_Finance_ML_Slides.pptx
+++ b/presentation/Consulting_Finance_ML_Slides.pptx
@@ -18,7 +18,6 @@
     <p:sldId id="263" r:id="rId9"/>
     <p:sldId id="269" r:id="rId10"/>
     <p:sldId id="264" r:id="rId11"/>
-    <p:sldId id="265" r:id="rId12"/>
     <p:sldId id="266" r:id="rId13"/>
     <p:sldId id="268" r:id="rId14"/>
     <p:sldId id="267" r:id="rId15"/>
@@ -5149,7 +5148,7 @@
                 <a:ea typeface="Courier New" pitchFamily="34" charset="-122"/>
                 <a:cs typeface="Courier New" pitchFamily="34" charset="-120"/>
               </a:rPr>
-              <a:t>12 · WHAT COMES NEXT</a:t>
+              <a:t>11 · WHAT COMES NEXT</a:t>
             </a:r>
             <a:endParaRPr lang="en-US" sz="1800" dirty="0"/>
           </a:p>
@@ -5304,7 +5303,7 @@
                 <a:ea typeface="Arial" pitchFamily="34" charset="-122"/>
                 <a:cs typeface="Arial" pitchFamily="34" charset="-120"/>
               </a:rPr>
-              <a:t>Decide by cost, not accuracy</a:t>
+              <a:t>Optimize for cost, not accuracy</a:t>
             </a:r>
             <a:endParaRPr lang="en-US" sz="2400" dirty="0"/>
           </a:p>
@@ -5348,7 +5347,7 @@
                 <a:ea typeface="Arial" pitchFamily="34" charset="-122"/>
                 <a:cs typeface="Arial" pitchFamily="34" charset="-120"/>
               </a:rPr>
-              <a:t>A default costs far more than a lost customer — weigh the two mistakes differently.</a:t>
+              <a:t>A default loses the whole loan; a wrong rejection loses only some interest — so tune the cutoff to minimise expected € loss, not the error count.</a:t>
             </a:r>
             <a:endParaRPr lang="en-US" sz="1950" dirty="0"/>
           </a:p>
@@ -5503,7 +5502,7 @@
                 <a:ea typeface="Arial" pitchFamily="34" charset="-122"/>
                 <a:cs typeface="Arial" pitchFamily="34" charset="-120"/>
               </a:rPr>
-              <a:t>Real lenders need trustworthy risk percentages for pricing and capital, not just a yes/no.</a:t>
+              <a:t>Our cutoff gives a yes/no, but the score isn't a true probability. Calibrate it so a lender can price loans and hold capital on a real default rate.</a:t>
             </a:r>
             <a:endParaRPr lang="en-US" sz="1950" dirty="0"/>
           </a:p>
@@ -5614,7 +5613,7 @@
                 <a:ea typeface="Arial" pitchFamily="34" charset="-122"/>
                 <a:cs typeface="Arial" pitchFamily="34" charset="-120"/>
               </a:rPr>
-              <a:t>Explain every decision</a:t>
+              <a:t>Give every decision a reason</a:t>
             </a:r>
             <a:endParaRPr lang="en-US" sz="2400" dirty="0"/>
           </a:p>
@@ -5658,7 +5657,7 @@
                 <a:ea typeface="Arial" pitchFamily="34" charset="-122"/>
                 <a:cs typeface="Arial" pitchFamily="34" charset="-120"/>
               </a:rPr>
-              <a:t>Show why each application was approved or rejected, so the credit team can defend it.</a:t>
+              <a:t>ECOA law requires telling a rejected applicant why. Add a per-decision explanation (SHAP) so every call is transparent and contestable.</a:t>
             </a:r>
             <a:endParaRPr lang="en-US" sz="1950" dirty="0"/>
           </a:p>
@@ -5769,7 +5768,7 @@
                 <a:ea typeface="Arial" pitchFamily="34" charset="-122"/>
                 <a:cs typeface="Arial" pitchFamily="34" charset="-120"/>
               </a:rPr>
-              <a:t>Monitor fairness &amp; drift</a:t>
+              <a:t>Monitor drift and bias</a:t>
             </a:r>
             <a:endParaRPr lang="en-US" sz="2400" dirty="0"/>
           </a:p>
@@ -5813,7 +5812,7 @@
                 <a:ea typeface="Arial" pitchFamily="34" charset="-122"/>
                 <a:cs typeface="Arial" pitchFamily="34" charset="-120"/>
               </a:rPr>
-              <a:t>Keep checking for bias and for months that look different from training, then retrain.</a:t>
+              <a:t>Approval rates drifted down over the years — track live performance and retrain on schedule, and keep auditing for proxy bias since we dropped race &amp; religion.</a:t>
             </a:r>
             <a:endParaRPr lang="en-US" sz="1950" dirty="0"/>
           </a:p>
@@ -5975,7 +5974,7 @@
                 <a:ea typeface="Courier New" pitchFamily="34" charset="-122"/>
                 <a:cs typeface="Courier New" pitchFamily="34" charset="-120"/>
               </a:rPr>
-              <a:t>13 · KEY CODE</a:t>
+              <a:t>12 · KEY CODE</a:t>
             </a:r>
             <a:endParaRPr lang="en-US" sz="1800" dirty="0"/>
           </a:p>
@@ -6680,7 +6679,7 @@
                 <a:ea typeface="Courier New" pitchFamily="34" charset="-122"/>
                 <a:cs typeface="Courier New" pitchFamily="34" charset="-120"/>
               </a:rPr>
-              <a:t>14 · QUESTIONS</a:t>
+              <a:t>13 · QUESTIONS</a:t>
             </a:r>
             <a:endParaRPr lang="en-US" sz="1800" dirty="0"/>
           </a:p>

</xml_diff>

<commit_message>
Riwad's manual edits (checkpoint before slide 10 cleanup + slide 11 delete)
</commit_message>
<xml_diff>
--- a/presentation/Consulting_Finance_ML_Slides.pptx
+++ b/presentation/Consulting_Finance_ML_Slides.pptx
@@ -5,7 +5,7 @@
     <p:sldMasterId id="2147483648" r:id="rId1"/>
   </p:sldMasterIdLst>
   <p:notesMasterIdLst>
-    <p:notesMasterId r:id="rId16"/>
+    <p:notesMasterId r:id="rId15"/>
   </p:notesMasterIdLst>
   <p:sldIdLst>
     <p:sldId id="256" r:id="rId2"/>
@@ -18,9 +18,9 @@
     <p:sldId id="263" r:id="rId9"/>
     <p:sldId id="269" r:id="rId10"/>
     <p:sldId id="264" r:id="rId11"/>
-    <p:sldId id="266" r:id="rId13"/>
-    <p:sldId id="268" r:id="rId14"/>
-    <p:sldId id="267" r:id="rId15"/>
+    <p:sldId id="266" r:id="rId12"/>
+    <p:sldId id="268" r:id="rId13"/>
+    <p:sldId id="267" r:id="rId14"/>
   </p:sldIdLst>
   <p:sldSz cx="18288000" cy="10287000"/>
   <p:notesSz cx="10287000" cy="18288000"/>
@@ -382,7 +382,7 @@
           <a:p>
             <a:r>
               <a:rPr lang="en-US" dirty="0"/>
-              <a:t>This slide shows we understood the problem, not just ran a library. The hardest part was the forensics, the validation against the real task, and quantifying the ethics rather than hand-waving them.</a:t>
+              <a:t>Separate what we did from what we'd do next. For a finance audience the strongest next step is deciding by cost rather than accuracy, plus calibrated probabilities: that reframes this from a Kaggle score to real lending economics.</a:t>
             </a:r>
           </a:p>
         </p:txBody>
@@ -469,7 +469,7 @@
           <a:p>
             <a:r>
               <a:rPr lang="en-US" dirty="0"/>
-              <a:t>Separate what we did from what we'd do next. For a finance audience the strongest next step is deciding by cost rather than accuracy, plus calibrated probabilities: that reframes this from a Kaggle score to real lending economics.</a:t>
+              <a:t>The two questions most likely to come up: why we dropped race and religion (lead with the +0.7pt number), and how we knew the column was a leak (it tracked real signal in training but was random in test). Both make us look rigorous.</a:t>
             </a:r>
           </a:p>
         </p:txBody>
@@ -491,94 +491,7 @@
           <a:p>
             <a:fld id="{F7021451-1387-4CA6-816F-3879F97B5CBC}" type="slidenum">
               <a:rPr lang="en-US"/>
-              <a:t>12</a:t>
-            </a:fld>
-            <a:endParaRPr lang="en-US"/>
-          </a:p>
-        </p:txBody>
-      </p:sp>
-    </p:spTree>
-    <p:extLst>
-      <p:ext uri="{BB962C8B-B14F-4D97-AF65-F5344CB8AC3E}">
-        <p14:creationId xmlns:p14="http://schemas.microsoft.com/office/powerpoint/2010/main" val="1024086991"/>
-      </p:ext>
-    </p:extLst>
-  </p:cSld>
-  <p:clrMapOvr>
-    <a:masterClrMapping/>
-  </p:clrMapOvr>
-</p:notes>
-</file>
-
-<file path=ppt/notesSlides/notesSlide12.xml><?xml version="1.0" encoding="utf-8"?>
-<p:notes xmlns:a="http://schemas.openxmlformats.org/drawingml/2006/main" xmlns:r="http://schemas.openxmlformats.org/officeDocument/2006/relationships" xmlns:p="http://schemas.openxmlformats.org/presentationml/2006/main">
-  <p:cSld>
-    <p:spTree>
-      <p:nvGrpSpPr>
-        <p:cNvPr id="1" name=""/>
-        <p:cNvGrpSpPr/>
-        <p:nvPr/>
-      </p:nvGrpSpPr>
-      <p:grpSpPr>
-        <a:xfrm>
-          <a:off x="0" y="0"/>
-          <a:ext cx="0" cy="0"/>
-          <a:chOff x="0" y="0"/>
-          <a:chExt cx="0" cy="0"/>
-        </a:xfrm>
-      </p:grpSpPr>
-      <p:sp>
-        <p:nvSpPr>
-          <p:cNvPr id="2" name="Slide Image Placeholder 1"/>
-          <p:cNvSpPr>
-            <a:spLocks noGrp="1" noRot="1" noChangeAspect="1"/>
-          </p:cNvSpPr>
-          <p:nvPr>
-            <p:ph type="sldImg"/>
-          </p:nvPr>
-        </p:nvSpPr>
-        <p:spPr/>
-      </p:sp>
-      <p:sp>
-        <p:nvSpPr>
-          <p:cNvPr id="3" name="Notes Placeholder 2"/>
-          <p:cNvSpPr>
-            <a:spLocks noGrp="1"/>
-          </p:cNvSpPr>
-          <p:nvPr>
-            <p:ph type="body" idx="1"/>
-          </p:nvPr>
-        </p:nvSpPr>
-        <p:spPr/>
-        <p:txBody>
-          <a:bodyPr/>
-          <a:lstStyle/>
-          <a:p>
-            <a:r>
-              <a:rPr lang="en-US" dirty="0"/>
-              <a:t>The two questions most likely to come up: why we dropped race and religion (lead with the +0.7pt number), and how we knew the column was a leak (it tracked real signal in training but was random in test). Both make us look rigorous.</a:t>
-            </a:r>
-          </a:p>
-        </p:txBody>
-      </p:sp>
-      <p:sp>
-        <p:nvSpPr>
-          <p:cNvPr id="4" name="Slide Number Placeholder 3"/>
-          <p:cNvSpPr>
-            <a:spLocks noGrp="1"/>
-          </p:cNvSpPr>
-          <p:nvPr>
-            <p:ph type="sldNum" sz="quarter" idx="10"/>
-          </p:nvPr>
-        </p:nvSpPr>
-        <p:spPr/>
-        <p:txBody>
-          <a:bodyPr/>
-          <a:lstStyle/>
-          <a:p>
-            <a:fld id="{F7021451-1387-4CA6-816F-3879F97B5CBC}" type="slidenum">
-              <a:rPr lang="en-US"/>
-              <a:t>14</a:t>
+              <a:t>13</a:t>
             </a:fld>
             <a:endParaRPr lang="en-US"/>
           </a:p>
@@ -4253,816 +4166,6 @@
 
 <file path=ppt/slides/slide11.xml><?xml version="1.0" encoding="utf-8"?>
 <p:sld xmlns:a="http://schemas.openxmlformats.org/drawingml/2006/main" xmlns:r="http://schemas.openxmlformats.org/officeDocument/2006/relationships" xmlns:p="http://schemas.openxmlformats.org/presentationml/2006/main">
-  <p:cSld name="Slide 10">
-    <p:bg>
-      <p:bgPr>
-        <a:solidFill>
-          <a:srgbClr val="FFFFFF"/>
-        </a:solidFill>
-        <a:effectLst/>
-      </p:bgPr>
-    </p:bg>
-    <p:spTree>
-      <p:nvGrpSpPr>
-        <p:cNvPr id="1" name=""/>
-        <p:cNvGrpSpPr/>
-        <p:nvPr/>
-      </p:nvGrpSpPr>
-      <p:grpSpPr>
-        <a:xfrm>
-          <a:off x="0" y="0"/>
-          <a:ext cx="0" cy="0"/>
-          <a:chOff x="0" y="0"/>
-          <a:chExt cx="0" cy="0"/>
-        </a:xfrm>
-      </p:grpSpPr>
-      <p:sp>
-        <p:nvSpPr>
-          <p:cNvPr id="2" name="Shape 0"/>
-          <p:cNvSpPr/>
-          <p:nvPr/>
-        </p:nvSpPr>
-        <p:spPr>
-          <a:xfrm>
-            <a:off x="952500" y="1912218"/>
-            <a:ext cx="16383000" cy="19050"/>
-          </a:xfrm>
-          <a:prstGeom prst="rect">
-            <a:avLst/>
-          </a:prstGeom>
-          <a:solidFill>
-            <a:srgbClr val="1A7A57"/>
-          </a:solidFill>
-          <a:ln/>
-        </p:spPr>
-        <p:txBody>
-          <a:bodyPr/>
-          <a:lstStyle/>
-          <a:p>
-            <a:endParaRPr lang="en-GB"/>
-          </a:p>
-        </p:txBody>
-      </p:sp>
-      <p:sp>
-        <p:nvSpPr>
-          <p:cNvPr id="3" name="Text 1"/>
-          <p:cNvSpPr/>
-          <p:nvPr/>
-        </p:nvSpPr>
-        <p:spPr>
-          <a:xfrm>
-            <a:off x="952500" y="742950"/>
-            <a:ext cx="18021300" cy="295275"/>
-          </a:xfrm>
-          <a:prstGeom prst="rect">
-            <a:avLst/>
-          </a:prstGeom>
-          <a:noFill/>
-          <a:ln/>
-        </p:spPr>
-        <p:txBody>
-          <a:bodyPr wrap="square" lIns="25400" tIns="25400" rIns="25400" bIns="25400" rtlCol="0" anchor="t">
-            <a:normAutofit fontScale="92500" lnSpcReduction="10000"/>
-          </a:bodyPr>
-          <a:lstStyle/>
-          <a:p>
-            <a:pPr marL="0" indent="0" algn="l">
-              <a:buNone/>
-            </a:pPr>
-            <a:r>
-              <a:rPr lang="en-US" sz="1800" kern="0" spc="225" dirty="0">
-                <a:solidFill>
-                  <a:srgbClr val="007A33"/>
-                </a:solidFill>
-                <a:latin typeface="Courier New" pitchFamily="34" charset="0"/>
-                <a:ea typeface="Courier New" pitchFamily="34" charset="-122"/>
-                <a:cs typeface="Courier New" pitchFamily="34" charset="-120"/>
-              </a:rPr>
-              <a:t>11 · WHAT WE LEARNED</a:t>
-            </a:r>
-            <a:endParaRPr lang="en-US" sz="1800" dirty="0"/>
-          </a:p>
-        </p:txBody>
-      </p:sp>
-      <p:sp>
-        <p:nvSpPr>
-          <p:cNvPr id="4" name="Text 2"/>
-          <p:cNvSpPr/>
-          <p:nvPr/>
-        </p:nvSpPr>
-        <p:spPr>
-          <a:xfrm>
-            <a:off x="952500" y="1152525"/>
-            <a:ext cx="18021300" cy="550143"/>
-          </a:xfrm>
-          <a:prstGeom prst="rect">
-            <a:avLst/>
-          </a:prstGeom>
-          <a:noFill/>
-          <a:ln/>
-        </p:spPr>
-        <p:txBody>
-          <a:bodyPr wrap="square" lIns="25400" tIns="25400" rIns="25400" bIns="25400" rtlCol="0" anchor="t">
-            <a:normAutofit fontScale="92500" lnSpcReduction="10000"/>
-          </a:bodyPr>
-          <a:lstStyle/>
-          <a:p>
-            <a:pPr marL="0" indent="0" algn="l">
-              <a:lnSpc>
-                <a:spcPct val="112000"/>
-              </a:lnSpc>
-              <a:buNone/>
-            </a:pPr>
-            <a:r>
-              <a:rPr lang="en-US" sz="3600" b="1" kern="0" spc="-37" dirty="0">
-                <a:solidFill>
-                  <a:srgbClr val="063D22"/>
-                </a:solidFill>
-                <a:latin typeface="Arial" pitchFamily="34" charset="0"/>
-                <a:ea typeface="Arial" pitchFamily="34" charset="-122"/>
-                <a:cs typeface="Arial" pitchFamily="34" charset="-120"/>
-              </a:rPr>
-              <a:t>Finding the traps was harder than building the model</a:t>
-            </a:r>
-            <a:endParaRPr lang="en-US" sz="3600" dirty="0"/>
-          </a:p>
-        </p:txBody>
-      </p:sp>
-      <p:sp>
-        <p:nvSpPr>
-          <p:cNvPr id="5" name="Text 3"/>
-          <p:cNvSpPr/>
-          <p:nvPr/>
-        </p:nvSpPr>
-        <p:spPr>
-          <a:xfrm>
-            <a:off x="952500" y="2426568"/>
-            <a:ext cx="3868817" cy="647700"/>
-          </a:xfrm>
-          <a:prstGeom prst="rect">
-            <a:avLst/>
-          </a:prstGeom>
-          <a:noFill/>
-          <a:ln/>
-        </p:spPr>
-        <p:txBody>
-          <a:bodyPr wrap="square" lIns="25400" tIns="25400" rIns="25400" bIns="25400" rtlCol="0" anchor="t">
-            <a:normAutofit fontScale="92500" lnSpcReduction="20000"/>
-          </a:bodyPr>
-          <a:lstStyle/>
-          <a:p>
-            <a:pPr marL="0" indent="0" algn="l">
-              <a:lnSpc>
-                <a:spcPct val="100000"/>
-              </a:lnSpc>
-              <a:buNone/>
-            </a:pPr>
-            <a:r>
-              <a:rPr lang="en-US" sz="4800" b="1" dirty="0">
-                <a:solidFill>
-                  <a:srgbClr val="66B3A1"/>
-                </a:solidFill>
-                <a:latin typeface="Georgia" pitchFamily="34" charset="0"/>
-                <a:ea typeface="Georgia" pitchFamily="34" charset="-122"/>
-                <a:cs typeface="Georgia" pitchFamily="34" charset="-120"/>
-              </a:rPr>
-              <a:t>01</a:t>
-            </a:r>
-            <a:endParaRPr lang="en-US" sz="4800" dirty="0"/>
-          </a:p>
-        </p:txBody>
-      </p:sp>
-      <p:sp>
-        <p:nvSpPr>
-          <p:cNvPr id="6" name="Text 4"/>
-          <p:cNvSpPr/>
-          <p:nvPr/>
-        </p:nvSpPr>
-        <p:spPr>
-          <a:xfrm>
-            <a:off x="952500" y="3207618"/>
-            <a:ext cx="3622619" cy="733425"/>
-          </a:xfrm>
-          <a:prstGeom prst="rect">
-            <a:avLst/>
-          </a:prstGeom>
-          <a:noFill/>
-          <a:ln/>
-        </p:spPr>
-        <p:txBody>
-          <a:bodyPr wrap="square" lIns="25400" tIns="25400" rIns="25400" bIns="25400" rtlCol="0" anchor="t">
-            <a:normAutofit lnSpcReduction="10000"/>
-          </a:bodyPr>
-          <a:lstStyle/>
-          <a:p>
-            <a:pPr marL="0" indent="0" algn="l">
-              <a:buNone/>
-            </a:pPr>
-            <a:r>
-              <a:rPr lang="en-US" sz="2250" b="1" dirty="0">
-                <a:solidFill>
-                  <a:srgbClr val="063D22"/>
-                </a:solidFill>
-                <a:latin typeface="Arial" pitchFamily="34" charset="0"/>
-                <a:ea typeface="Arial" pitchFamily="34" charset="-122"/>
-                <a:cs typeface="Arial" pitchFamily="34" charset="-120"/>
-              </a:rPr>
-              <a:t>The traps, not the algorithm</a:t>
-            </a:r>
-            <a:endParaRPr lang="en-US" sz="2250" dirty="0"/>
-          </a:p>
-        </p:txBody>
-      </p:sp>
-      <p:sp>
-        <p:nvSpPr>
-          <p:cNvPr id="7" name="Text 5"/>
-          <p:cNvSpPr/>
-          <p:nvPr/>
-        </p:nvSpPr>
-        <p:spPr>
-          <a:xfrm>
-            <a:off x="952500" y="4017243"/>
-            <a:ext cx="3622619" cy="1115244"/>
-          </a:xfrm>
-          <a:prstGeom prst="rect">
-            <a:avLst/>
-          </a:prstGeom>
-          <a:noFill/>
-          <a:ln/>
-        </p:spPr>
-        <p:txBody>
-          <a:bodyPr wrap="square" lIns="25400" tIns="25400" rIns="25400" bIns="25400" rtlCol="0" anchor="t">
-            <a:normAutofit fontScale="92500" lnSpcReduction="20000"/>
-          </a:bodyPr>
-          <a:lstStyle/>
-          <a:p>
-            <a:pPr marL="0" indent="0" algn="l">
-              <a:lnSpc>
-                <a:spcPct val="145000"/>
-              </a:lnSpc>
-              <a:buNone/>
-            </a:pPr>
-            <a:r>
-              <a:rPr lang="en-US" sz="1950" dirty="0">
-                <a:solidFill>
-                  <a:srgbClr val="5C7268"/>
-                </a:solidFill>
-                <a:latin typeface="Arial" pitchFamily="34" charset="0"/>
-                <a:ea typeface="Arial" pitchFamily="34" charset="-122"/>
-                <a:cs typeface="Arial" pitchFamily="34" charset="-120"/>
-              </a:rPr>
-              <a:t>Most of the value came from catching sabotaged columns before any modeling.</a:t>
-            </a:r>
-            <a:endParaRPr lang="en-US" sz="1950" dirty="0"/>
-          </a:p>
-        </p:txBody>
-      </p:sp>
-      <p:sp>
-        <p:nvSpPr>
-          <p:cNvPr id="8" name="Shape 6"/>
-          <p:cNvSpPr/>
-          <p:nvPr/>
-        </p:nvSpPr>
-        <p:spPr>
-          <a:xfrm>
-            <a:off x="4850606" y="2426568"/>
-            <a:ext cx="9525" cy="6812682"/>
-          </a:xfrm>
-          <a:prstGeom prst="rect">
-            <a:avLst/>
-          </a:prstGeom>
-          <a:solidFill>
-            <a:srgbClr val="D2E6DD"/>
-          </a:solidFill>
-          <a:ln/>
-        </p:spPr>
-        <p:txBody>
-          <a:bodyPr/>
-          <a:lstStyle/>
-          <a:p>
-            <a:endParaRPr lang="en-GB"/>
-          </a:p>
-        </p:txBody>
-      </p:sp>
-      <p:sp>
-        <p:nvSpPr>
-          <p:cNvPr id="9" name="Text 7"/>
-          <p:cNvSpPr/>
-          <p:nvPr/>
-        </p:nvSpPr>
-        <p:spPr>
-          <a:xfrm>
-            <a:off x="5241131" y="2426568"/>
-            <a:ext cx="3868817" cy="647700"/>
-          </a:xfrm>
-          <a:prstGeom prst="rect">
-            <a:avLst/>
-          </a:prstGeom>
-          <a:noFill/>
-          <a:ln/>
-        </p:spPr>
-        <p:txBody>
-          <a:bodyPr wrap="square" lIns="25400" tIns="25400" rIns="25400" bIns="25400" rtlCol="0" anchor="t">
-            <a:normAutofit fontScale="92500" lnSpcReduction="20000"/>
-          </a:bodyPr>
-          <a:lstStyle/>
-          <a:p>
-            <a:pPr marL="0" indent="0" algn="l">
-              <a:lnSpc>
-                <a:spcPct val="100000"/>
-              </a:lnSpc>
-              <a:buNone/>
-            </a:pPr>
-            <a:r>
-              <a:rPr lang="en-US" sz="4800" b="1" dirty="0">
-                <a:solidFill>
-                  <a:srgbClr val="66B3A1"/>
-                </a:solidFill>
-                <a:latin typeface="Georgia" pitchFamily="34" charset="0"/>
-                <a:ea typeface="Georgia" pitchFamily="34" charset="-122"/>
-                <a:cs typeface="Georgia" pitchFamily="34" charset="-120"/>
-              </a:rPr>
-              <a:t>02</a:t>
-            </a:r>
-            <a:endParaRPr lang="en-US" sz="4800" dirty="0"/>
-          </a:p>
-        </p:txBody>
-      </p:sp>
-      <p:sp>
-        <p:nvSpPr>
-          <p:cNvPr id="10" name="Text 8"/>
-          <p:cNvSpPr/>
-          <p:nvPr/>
-        </p:nvSpPr>
-        <p:spPr>
-          <a:xfrm>
-            <a:off x="5241131" y="3207618"/>
-            <a:ext cx="3868817" cy="385763"/>
-          </a:xfrm>
-          <a:prstGeom prst="rect">
-            <a:avLst/>
-          </a:prstGeom>
-          <a:noFill/>
-          <a:ln/>
-        </p:spPr>
-        <p:txBody>
-          <a:bodyPr wrap="square" lIns="25400" tIns="25400" rIns="25400" bIns="25400" rtlCol="0" anchor="t">
-            <a:normAutofit lnSpcReduction="10000"/>
-          </a:bodyPr>
-          <a:lstStyle/>
-          <a:p>
-            <a:pPr marL="0" indent="0" algn="l">
-              <a:buNone/>
-            </a:pPr>
-            <a:r>
-              <a:rPr lang="en-US" sz="2250" b="1" dirty="0">
-                <a:solidFill>
-                  <a:srgbClr val="063D22"/>
-                </a:solidFill>
-                <a:latin typeface="Arial" pitchFamily="34" charset="0"/>
-                <a:ea typeface="Arial" pitchFamily="34" charset="-122"/>
-                <a:cs typeface="Arial" pitchFamily="34" charset="-120"/>
-              </a:rPr>
-              <a:t>Test like the real task</a:t>
-            </a:r>
-            <a:endParaRPr lang="en-US" sz="2250" dirty="0"/>
-          </a:p>
-        </p:txBody>
-      </p:sp>
-      <p:sp>
-        <p:nvSpPr>
-          <p:cNvPr id="11" name="Text 9"/>
-          <p:cNvSpPr/>
-          <p:nvPr/>
-        </p:nvSpPr>
-        <p:spPr>
-          <a:xfrm>
-            <a:off x="5241131" y="3669581"/>
-            <a:ext cx="3622619" cy="1115244"/>
-          </a:xfrm>
-          <a:prstGeom prst="rect">
-            <a:avLst/>
-          </a:prstGeom>
-          <a:noFill/>
-          <a:ln/>
-        </p:spPr>
-        <p:txBody>
-          <a:bodyPr wrap="square" lIns="25400" tIns="25400" rIns="25400" bIns="25400" rtlCol="0" anchor="t">
-            <a:normAutofit fontScale="92500" lnSpcReduction="20000"/>
-          </a:bodyPr>
-          <a:lstStyle/>
-          <a:p>
-            <a:pPr marL="0" indent="0" algn="l">
-              <a:lnSpc>
-                <a:spcPct val="145000"/>
-              </a:lnSpc>
-              <a:buNone/>
-            </a:pPr>
-            <a:r>
-              <a:rPr lang="en-US" sz="1950" dirty="0">
-                <a:solidFill>
-                  <a:srgbClr val="5C7268"/>
-                </a:solidFill>
-                <a:latin typeface="Arial" pitchFamily="34" charset="0"/>
-                <a:ea typeface="Arial" pitchFamily="34" charset="-122"/>
-                <a:cs typeface="Arial" pitchFamily="34" charset="-120"/>
-              </a:rPr>
-              <a:t>Predicting held-back months exposed mistakes a random split would have hidden.</a:t>
-            </a:r>
-            <a:endParaRPr lang="en-US" sz="1950" dirty="0"/>
-          </a:p>
-        </p:txBody>
-      </p:sp>
-      <p:sp>
-        <p:nvSpPr>
-          <p:cNvPr id="12" name="Shape 10"/>
-          <p:cNvSpPr/>
-          <p:nvPr/>
-        </p:nvSpPr>
-        <p:spPr>
-          <a:xfrm>
-            <a:off x="9139238" y="2426568"/>
-            <a:ext cx="9525" cy="6812682"/>
-          </a:xfrm>
-          <a:prstGeom prst="rect">
-            <a:avLst/>
-          </a:prstGeom>
-          <a:solidFill>
-            <a:srgbClr val="D2E6DD"/>
-          </a:solidFill>
-          <a:ln/>
-        </p:spPr>
-        <p:txBody>
-          <a:bodyPr/>
-          <a:lstStyle/>
-          <a:p>
-            <a:endParaRPr lang="en-GB"/>
-          </a:p>
-        </p:txBody>
-      </p:sp>
-      <p:sp>
-        <p:nvSpPr>
-          <p:cNvPr id="13" name="Text 11"/>
-          <p:cNvSpPr/>
-          <p:nvPr/>
-        </p:nvSpPr>
-        <p:spPr>
-          <a:xfrm>
-            <a:off x="9529763" y="2426568"/>
-            <a:ext cx="3868817" cy="647700"/>
-          </a:xfrm>
-          <a:prstGeom prst="rect">
-            <a:avLst/>
-          </a:prstGeom>
-          <a:noFill/>
-          <a:ln/>
-        </p:spPr>
-        <p:txBody>
-          <a:bodyPr wrap="square" lIns="25400" tIns="25400" rIns="25400" bIns="25400" rtlCol="0" anchor="t">
-            <a:normAutofit fontScale="92500" lnSpcReduction="20000"/>
-          </a:bodyPr>
-          <a:lstStyle/>
-          <a:p>
-            <a:pPr marL="0" indent="0" algn="l">
-              <a:lnSpc>
-                <a:spcPct val="100000"/>
-              </a:lnSpc>
-              <a:buNone/>
-            </a:pPr>
-            <a:r>
-              <a:rPr lang="en-US" sz="4800" b="1" dirty="0">
-                <a:solidFill>
-                  <a:srgbClr val="66B3A1"/>
-                </a:solidFill>
-                <a:latin typeface="Georgia" pitchFamily="34" charset="0"/>
-                <a:ea typeface="Georgia" pitchFamily="34" charset="-122"/>
-                <a:cs typeface="Georgia" pitchFamily="34" charset="-120"/>
-              </a:rPr>
-              <a:t>03</a:t>
-            </a:r>
-            <a:endParaRPr lang="en-US" sz="4800" dirty="0"/>
-          </a:p>
-        </p:txBody>
-      </p:sp>
-      <p:sp>
-        <p:nvSpPr>
-          <p:cNvPr id="14" name="Text 12"/>
-          <p:cNvSpPr/>
-          <p:nvPr/>
-        </p:nvSpPr>
-        <p:spPr>
-          <a:xfrm>
-            <a:off x="9529763" y="3207618"/>
-            <a:ext cx="3868817" cy="385763"/>
-          </a:xfrm>
-          <a:prstGeom prst="rect">
-            <a:avLst/>
-          </a:prstGeom>
-          <a:noFill/>
-          <a:ln/>
-        </p:spPr>
-        <p:txBody>
-          <a:bodyPr wrap="square" lIns="25400" tIns="25400" rIns="25400" bIns="25400" rtlCol="0" anchor="t">
-            <a:normAutofit lnSpcReduction="10000"/>
-          </a:bodyPr>
-          <a:lstStyle/>
-          <a:p>
-            <a:pPr marL="0" indent="0" algn="l">
-              <a:buNone/>
-            </a:pPr>
-            <a:r>
-              <a:rPr lang="en-US" sz="2250" b="1" dirty="0">
-                <a:solidFill>
-                  <a:srgbClr val="063D22"/>
-                </a:solidFill>
-                <a:latin typeface="Arial" pitchFamily="34" charset="0"/>
-                <a:ea typeface="Arial" pitchFamily="34" charset="-122"/>
-                <a:cs typeface="Arial" pitchFamily="34" charset="-120"/>
-              </a:rPr>
-              <a:t>Measure the ethics</a:t>
-            </a:r>
-            <a:endParaRPr lang="en-US" sz="2250" dirty="0"/>
-          </a:p>
-        </p:txBody>
-      </p:sp>
-      <p:sp>
-        <p:nvSpPr>
-          <p:cNvPr id="15" name="Text 13"/>
-          <p:cNvSpPr/>
-          <p:nvPr/>
-        </p:nvSpPr>
-        <p:spPr>
-          <a:xfrm>
-            <a:off x="9529763" y="3669581"/>
-            <a:ext cx="3622619" cy="1115244"/>
-          </a:xfrm>
-          <a:prstGeom prst="rect">
-            <a:avLst/>
-          </a:prstGeom>
-          <a:noFill/>
-          <a:ln/>
-        </p:spPr>
-        <p:txBody>
-          <a:bodyPr wrap="square" lIns="25400" tIns="25400" rIns="25400" bIns="25400" rtlCol="0" anchor="t">
-            <a:normAutofit fontScale="92500" lnSpcReduction="20000"/>
-          </a:bodyPr>
-          <a:lstStyle/>
-          <a:p>
-            <a:pPr marL="0" indent="0" algn="l">
-              <a:lnSpc>
-                <a:spcPct val="145000"/>
-              </a:lnSpc>
-              <a:buNone/>
-            </a:pPr>
-            <a:r>
-              <a:rPr lang="en-US" sz="1950" dirty="0">
-                <a:solidFill>
-                  <a:srgbClr val="5C7268"/>
-                </a:solidFill>
-                <a:latin typeface="Arial" pitchFamily="34" charset="0"/>
-                <a:ea typeface="Arial" pitchFamily="34" charset="-122"/>
-                <a:cs typeface="Arial" pitchFamily="34" charset="-120"/>
-              </a:rPr>
-              <a:t>“We dropped race” is weak. “It costs exactly +0.7pt of bias” is strong.</a:t>
-            </a:r>
-            <a:endParaRPr lang="en-US" sz="1950" dirty="0"/>
-          </a:p>
-        </p:txBody>
-      </p:sp>
-      <p:sp>
-        <p:nvSpPr>
-          <p:cNvPr id="16" name="Shape 14"/>
-          <p:cNvSpPr/>
-          <p:nvPr/>
-        </p:nvSpPr>
-        <p:spPr>
-          <a:xfrm>
-            <a:off x="13427869" y="2426568"/>
-            <a:ext cx="9525" cy="6812682"/>
-          </a:xfrm>
-          <a:prstGeom prst="rect">
-            <a:avLst/>
-          </a:prstGeom>
-          <a:solidFill>
-            <a:srgbClr val="D2E6DD"/>
-          </a:solidFill>
-          <a:ln/>
-        </p:spPr>
-        <p:txBody>
-          <a:bodyPr/>
-          <a:lstStyle/>
-          <a:p>
-            <a:endParaRPr lang="en-GB"/>
-          </a:p>
-        </p:txBody>
-      </p:sp>
-      <p:sp>
-        <p:nvSpPr>
-          <p:cNvPr id="17" name="Text 15"/>
-          <p:cNvSpPr/>
-          <p:nvPr/>
-        </p:nvSpPr>
-        <p:spPr>
-          <a:xfrm>
-            <a:off x="13818394" y="2426568"/>
-            <a:ext cx="3868817" cy="647700"/>
-          </a:xfrm>
-          <a:prstGeom prst="rect">
-            <a:avLst/>
-          </a:prstGeom>
-          <a:noFill/>
-          <a:ln/>
-        </p:spPr>
-        <p:txBody>
-          <a:bodyPr wrap="square" lIns="25400" tIns="25400" rIns="25400" bIns="25400" rtlCol="0" anchor="t">
-            <a:normAutofit fontScale="92500" lnSpcReduction="20000"/>
-          </a:bodyPr>
-          <a:lstStyle/>
-          <a:p>
-            <a:pPr marL="0" indent="0" algn="l">
-              <a:lnSpc>
-                <a:spcPct val="100000"/>
-              </a:lnSpc>
-              <a:buNone/>
-            </a:pPr>
-            <a:r>
-              <a:rPr lang="en-US" sz="4800" b="1" dirty="0">
-                <a:solidFill>
-                  <a:srgbClr val="66B3A1"/>
-                </a:solidFill>
-                <a:latin typeface="Georgia" pitchFamily="34" charset="0"/>
-                <a:ea typeface="Georgia" pitchFamily="34" charset="-122"/>
-                <a:cs typeface="Georgia" pitchFamily="34" charset="-120"/>
-              </a:rPr>
-              <a:t>04</a:t>
-            </a:r>
-            <a:endParaRPr lang="en-US" sz="4800" dirty="0"/>
-          </a:p>
-        </p:txBody>
-      </p:sp>
-      <p:sp>
-        <p:nvSpPr>
-          <p:cNvPr id="18" name="Text 16"/>
-          <p:cNvSpPr/>
-          <p:nvPr/>
-        </p:nvSpPr>
-        <p:spPr>
-          <a:xfrm>
-            <a:off x="13818394" y="3207618"/>
-            <a:ext cx="3868817" cy="385763"/>
-          </a:xfrm>
-          <a:prstGeom prst="rect">
-            <a:avLst/>
-          </a:prstGeom>
-          <a:noFill/>
-          <a:ln/>
-        </p:spPr>
-        <p:txBody>
-          <a:bodyPr wrap="square" lIns="25400" tIns="25400" rIns="25400" bIns="25400" rtlCol="0" anchor="t">
-            <a:normAutofit lnSpcReduction="10000"/>
-          </a:bodyPr>
-          <a:lstStyle/>
-          <a:p>
-            <a:pPr marL="0" indent="0" algn="l">
-              <a:buNone/>
-            </a:pPr>
-            <a:r>
-              <a:rPr lang="en-US" sz="2250" b="1" dirty="0">
-                <a:solidFill>
-                  <a:srgbClr val="063D22"/>
-                </a:solidFill>
-                <a:latin typeface="Arial" pitchFamily="34" charset="0"/>
-                <a:ea typeface="Arial" pitchFamily="34" charset="-122"/>
-                <a:cs typeface="Arial" pitchFamily="34" charset="-120"/>
-              </a:rPr>
-              <a:t>Deleting can be the fix</a:t>
-            </a:r>
-            <a:endParaRPr lang="en-US" sz="2250" dirty="0"/>
-          </a:p>
-        </p:txBody>
-      </p:sp>
-      <p:sp>
-        <p:nvSpPr>
-          <p:cNvPr id="19" name="Text 17"/>
-          <p:cNvSpPr/>
-          <p:nvPr/>
-        </p:nvSpPr>
-        <p:spPr>
-          <a:xfrm>
-            <a:off x="13818394" y="3669581"/>
-            <a:ext cx="3622619" cy="1474291"/>
-          </a:xfrm>
-          <a:prstGeom prst="rect">
-            <a:avLst/>
-          </a:prstGeom>
-          <a:noFill/>
-          <a:ln/>
-        </p:spPr>
-        <p:txBody>
-          <a:bodyPr wrap="square" lIns="25400" tIns="25400" rIns="25400" bIns="25400" rtlCol="0" anchor="t">
-            <a:normAutofit/>
-          </a:bodyPr>
-          <a:lstStyle/>
-          <a:p>
-            <a:pPr marL="0" indent="0" algn="l">
-              <a:lnSpc>
-                <a:spcPct val="145000"/>
-              </a:lnSpc>
-              <a:buNone/>
-            </a:pPr>
-            <a:r>
-              <a:rPr lang="en-US" sz="1950" dirty="0">
-                <a:solidFill>
-                  <a:srgbClr val="5C7268"/>
-                </a:solidFill>
-                <a:latin typeface="Arial" pitchFamily="34" charset="0"/>
-                <a:ea typeface="Arial" pitchFamily="34" charset="-122"/>
-                <a:cs typeface="Arial" pitchFamily="34" charset="-120"/>
-              </a:rPr>
-              <a:t>We removed the four most “predictive” columns on purpose — their power was fake.</a:t>
-            </a:r>
-            <a:endParaRPr lang="en-US" sz="1950" dirty="0"/>
-          </a:p>
-        </p:txBody>
-      </p:sp>
-      <p:sp>
-        <p:nvSpPr>
-          <p:cNvPr id="20" name="Shape 18"/>
-          <p:cNvSpPr/>
-          <p:nvPr/>
-        </p:nvSpPr>
-        <p:spPr>
-          <a:xfrm>
-            <a:off x="952500" y="9239250"/>
-            <a:ext cx="16383000" cy="9525"/>
-          </a:xfrm>
-          <a:prstGeom prst="rect">
-            <a:avLst/>
-          </a:prstGeom>
-          <a:solidFill>
-            <a:srgbClr val="D2E6DD"/>
-          </a:solidFill>
-          <a:ln/>
-        </p:spPr>
-        <p:txBody>
-          <a:bodyPr/>
-          <a:lstStyle/>
-          <a:p>
-            <a:endParaRPr lang="en-GB"/>
-          </a:p>
-        </p:txBody>
-      </p:sp>
-      <p:sp>
-        <p:nvSpPr>
-          <p:cNvPr id="21" name="Text 19"/>
-          <p:cNvSpPr/>
-          <p:nvPr/>
-        </p:nvSpPr>
-        <p:spPr>
-          <a:xfrm>
-            <a:off x="952500" y="9458325"/>
-            <a:ext cx="16874490" cy="295275"/>
-          </a:xfrm>
-          <a:prstGeom prst="rect">
-            <a:avLst/>
-          </a:prstGeom>
-          <a:noFill/>
-          <a:ln/>
-        </p:spPr>
-        <p:txBody>
-          <a:bodyPr wrap="square" lIns="25400" tIns="25400" rIns="25400" bIns="25400" rtlCol="0" anchor="t">
-            <a:normAutofit fontScale="92500" lnSpcReduction="10000"/>
-          </a:bodyPr>
-          <a:lstStyle/>
-          <a:p>
-            <a:pPr marL="0" indent="0" algn="l">
-              <a:buNone/>
-            </a:pPr>
-            <a:r>
-              <a:rPr lang="en-US" sz="1800" dirty="0">
-                <a:solidFill>
-                  <a:srgbClr val="5C7268"/>
-                </a:solidFill>
-                <a:latin typeface="Courier New" pitchFamily="34" charset="0"/>
-                <a:ea typeface="Courier New" pitchFamily="34" charset="-122"/>
-                <a:cs typeface="Courier New" pitchFamily="34" charset="-120"/>
-              </a:rPr>
-              <a:t>Source: team retrospective</a:t>
-            </a:r>
-            <a:endParaRPr lang="en-US" sz="1800" dirty="0"/>
-          </a:p>
-        </p:txBody>
-      </p:sp>
-    </p:spTree>
-  </p:cSld>
-  <p:clrMapOvr>
-    <a:masterClrMapping/>
-  </p:clrMapOvr>
-</p:sld>
-</file>
-
-<file path=ppt/slides/slide12.xml><?xml version="1.0" encoding="utf-8"?>
-<p:sld xmlns:a="http://schemas.openxmlformats.org/drawingml/2006/main" xmlns:r="http://schemas.openxmlformats.org/officeDocument/2006/relationships" xmlns:p="http://schemas.openxmlformats.org/presentationml/2006/main">
   <p:cSld name="Slide 11">
     <p:bg>
       <p:bgPr>
@@ -5894,7 +4997,7 @@
 </p:sld>
 </file>
 
-<file path=ppt/slides/slide13.xml><?xml version="1.0" encoding="utf-8"?>
+<file path=ppt/slides/slide12.xml><?xml version="1.0" encoding="utf-8"?>
 <p:sld xmlns:a="http://schemas.openxmlformats.org/drawingml/2006/main" xmlns:r="http://schemas.openxmlformats.org/officeDocument/2006/relationships" xmlns:p="http://schemas.openxmlformats.org/presentationml/2006/main">
   <p:cSld>
     <p:spTree>
@@ -6619,7 +5722,7 @@
 </p:sld>
 </file>
 
-<file path=ppt/slides/slide14.xml><?xml version="1.0" encoding="utf-8"?>
+<file path=ppt/slides/slide13.xml><?xml version="1.0" encoding="utf-8"?>
 <p:sld xmlns:a="http://schemas.openxmlformats.org/drawingml/2006/main" xmlns:r="http://schemas.openxmlformats.org/officeDocument/2006/relationships" xmlns:p="http://schemas.openxmlformats.org/presentationml/2006/main">
   <p:cSld name="Slide 12">
     <p:bg>

</xml_diff>

<commit_message>
Clean up slide 10 (results) + delete 'What comes next'
- slide 10: removed the redundant model-family ladder, the verbose v10 footnote,
  and the extra adversarial note — kept the graph, table, and 0.8565 headline
- deleted 'What comes next' slide; renumbered (now 12 slides)
</commit_message>
<xml_diff>
--- a/presentation/Consulting_Finance_ML_Slides.pptx
+++ b/presentation/Consulting_Finance_ML_Slides.pptx
@@ -18,7 +18,6 @@
     <p:sldId id="263" r:id="rId9"/>
     <p:sldId id="269" r:id="rId10"/>
     <p:sldId id="264" r:id="rId11"/>
-    <p:sldId id="266" r:id="rId12"/>
     <p:sldId id="268" r:id="rId13"/>
     <p:sldId id="267" r:id="rId14"/>
   </p:sldIdLst>
@@ -3291,564 +3290,6 @@
       </p:sp>
       <p:sp>
         <p:nvSpPr>
-          <p:cNvPr id="43" name="Text 41"/>
-          <p:cNvSpPr/>
-          <p:nvPr/>
-        </p:nvSpPr>
-        <p:spPr>
-          <a:xfrm>
-            <a:off x="952500" y="6374904"/>
-            <a:ext cx="11050079" cy="295275"/>
-          </a:xfrm>
-          <a:prstGeom prst="rect">
-            <a:avLst/>
-          </a:prstGeom>
-          <a:noFill/>
-          <a:ln/>
-        </p:spPr>
-        <p:txBody>
-          <a:bodyPr wrap="square" lIns="25400" tIns="25400" rIns="25400" bIns="25400" rtlCol="0" anchor="t">
-            <a:normAutofit fontScale="92500" lnSpcReduction="10000"/>
-          </a:bodyPr>
-          <a:lstStyle/>
-          <a:p>
-            <a:pPr marL="0" indent="0" algn="l">
-              <a:buNone/>
-            </a:pPr>
-            <a:r>
-              <a:rPr lang="en-US" sz="1800" dirty="0">
-                <a:solidFill>
-                  <a:srgbClr val="5C7268"/>
-                </a:solidFill>
-                <a:latin typeface="Courier New" pitchFamily="34" charset="0"/>
-                <a:ea typeface="Courier New" pitchFamily="34" charset="-122"/>
-                <a:cs typeface="Courier New" pitchFamily="34" charset="-120"/>
-              </a:rPr>
-              <a:t>Model family ladder · 5-fold accuracy</a:t>
-            </a:r>
-            <a:endParaRPr lang="en-US" sz="1800" dirty="0"/>
-          </a:p>
-        </p:txBody>
-      </p:sp>
-      <p:sp>
-        <p:nvSpPr>
-          <p:cNvPr id="44" name="Text 42"/>
-          <p:cNvSpPr/>
-          <p:nvPr/>
-        </p:nvSpPr>
-        <p:spPr>
-          <a:xfrm>
-            <a:off x="952500" y="6746379"/>
-            <a:ext cx="1173659" cy="295275"/>
-          </a:xfrm>
-          <a:prstGeom prst="rect">
-            <a:avLst/>
-          </a:prstGeom>
-          <a:noFill/>
-          <a:ln/>
-        </p:spPr>
-        <p:txBody>
-          <a:bodyPr wrap="square" lIns="25400" tIns="25400" rIns="25400" bIns="25400" rtlCol="0" anchor="t">
-            <a:normAutofit fontScale="92500" lnSpcReduction="10000"/>
-          </a:bodyPr>
-          <a:lstStyle/>
-          <a:p>
-            <a:pPr marL="0" indent="0" algn="l">
-              <a:buNone/>
-            </a:pPr>
-            <a:r>
-              <a:rPr lang="en-US" sz="1800" dirty="0">
-                <a:solidFill>
-                  <a:srgbClr val="5C7268"/>
-                </a:solidFill>
-                <a:latin typeface="Courier New" pitchFamily="34" charset="0"/>
-                <a:ea typeface="Courier New" pitchFamily="34" charset="-122"/>
-                <a:cs typeface="Courier New" pitchFamily="34" charset="-120"/>
-              </a:rPr>
-              <a:t>NB 0.760</a:t>
-            </a:r>
-            <a:endParaRPr lang="en-US" sz="1800" dirty="0"/>
-          </a:p>
-        </p:txBody>
-      </p:sp>
-      <p:sp>
-        <p:nvSpPr>
-          <p:cNvPr id="45" name="Text 43"/>
-          <p:cNvSpPr/>
-          <p:nvPr/>
-        </p:nvSpPr>
-        <p:spPr>
-          <a:xfrm>
-            <a:off x="2145209" y="6746379"/>
-            <a:ext cx="213420" cy="295275"/>
-          </a:xfrm>
-          <a:prstGeom prst="rect">
-            <a:avLst/>
-          </a:prstGeom>
-          <a:noFill/>
-          <a:ln/>
-        </p:spPr>
-        <p:txBody>
-          <a:bodyPr wrap="square" lIns="25400" tIns="25400" rIns="25400" bIns="25400" rtlCol="0" anchor="t">
-            <a:normAutofit fontScale="92500" lnSpcReduction="10000"/>
-          </a:bodyPr>
-          <a:lstStyle/>
-          <a:p>
-            <a:pPr marL="0" indent="0" algn="l">
-              <a:buNone/>
-            </a:pPr>
-            <a:r>
-              <a:rPr lang="en-US" sz="1800" dirty="0">
-                <a:solidFill>
-                  <a:srgbClr val="66B3A1"/>
-                </a:solidFill>
-                <a:latin typeface="Courier New" pitchFamily="34" charset="0"/>
-                <a:ea typeface="Courier New" pitchFamily="34" charset="-122"/>
-                <a:cs typeface="Courier New" pitchFamily="34" charset="-120"/>
-              </a:rPr>
-              <a:t>→</a:t>
-            </a:r>
-            <a:endParaRPr lang="en-US" sz="1800" dirty="0"/>
-          </a:p>
-        </p:txBody>
-      </p:sp>
-      <p:sp>
-        <p:nvSpPr>
-          <p:cNvPr id="46" name="Text 44"/>
-          <p:cNvSpPr/>
-          <p:nvPr/>
-        </p:nvSpPr>
-        <p:spPr>
-          <a:xfrm>
-            <a:off x="2377678" y="6746379"/>
-            <a:ext cx="1358146" cy="295275"/>
-          </a:xfrm>
-          <a:prstGeom prst="rect">
-            <a:avLst/>
-          </a:prstGeom>
-          <a:noFill/>
-          <a:ln/>
-        </p:spPr>
-        <p:txBody>
-          <a:bodyPr wrap="square" lIns="25400" tIns="25400" rIns="25400" bIns="25400" rtlCol="0" anchor="t">
-            <a:normAutofit fontScale="92500" lnSpcReduction="10000"/>
-          </a:bodyPr>
-          <a:lstStyle/>
-          <a:p>
-            <a:pPr marL="0" indent="0" algn="l">
-              <a:buNone/>
-            </a:pPr>
-            <a:r>
-              <a:rPr lang="en-US" sz="1800" dirty="0">
-                <a:solidFill>
-                  <a:srgbClr val="5C7268"/>
-                </a:solidFill>
-                <a:latin typeface="Courier New" pitchFamily="34" charset="0"/>
-                <a:ea typeface="Courier New" pitchFamily="34" charset="-122"/>
-                <a:cs typeface="Courier New" pitchFamily="34" charset="-120"/>
-              </a:rPr>
-              <a:t>LDA 0.777</a:t>
-            </a:r>
-            <a:endParaRPr lang="en-US" sz="1800" dirty="0"/>
-          </a:p>
-        </p:txBody>
-      </p:sp>
-      <p:sp>
-        <p:nvSpPr>
-          <p:cNvPr id="47" name="Text 45"/>
-          <p:cNvSpPr/>
-          <p:nvPr/>
-        </p:nvSpPr>
-        <p:spPr>
-          <a:xfrm>
-            <a:off x="3707606" y="6746379"/>
-            <a:ext cx="213420" cy="295275"/>
-          </a:xfrm>
-          <a:prstGeom prst="rect">
-            <a:avLst/>
-          </a:prstGeom>
-          <a:noFill/>
-          <a:ln/>
-        </p:spPr>
-        <p:txBody>
-          <a:bodyPr wrap="square" lIns="25400" tIns="25400" rIns="25400" bIns="25400" rtlCol="0" anchor="t">
-            <a:normAutofit fontScale="92500" lnSpcReduction="10000"/>
-          </a:bodyPr>
-          <a:lstStyle/>
-          <a:p>
-            <a:pPr marL="0" indent="0" algn="l">
-              <a:buNone/>
-            </a:pPr>
-            <a:r>
-              <a:rPr lang="en-US" sz="1800" dirty="0">
-                <a:solidFill>
-                  <a:srgbClr val="66B3A1"/>
-                </a:solidFill>
-                <a:latin typeface="Courier New" pitchFamily="34" charset="0"/>
-                <a:ea typeface="Courier New" pitchFamily="34" charset="-122"/>
-                <a:cs typeface="Courier New" pitchFamily="34" charset="-120"/>
-              </a:rPr>
-              <a:t>→</a:t>
-            </a:r>
-            <a:endParaRPr lang="en-US" sz="1800" dirty="0"/>
-          </a:p>
-        </p:txBody>
-      </p:sp>
-      <p:sp>
-        <p:nvSpPr>
-          <p:cNvPr id="48" name="Text 46"/>
-          <p:cNvSpPr/>
-          <p:nvPr/>
-        </p:nvSpPr>
-        <p:spPr>
-          <a:xfrm>
-            <a:off x="3940076" y="6746379"/>
-            <a:ext cx="1173659" cy="295275"/>
-          </a:xfrm>
-          <a:prstGeom prst="rect">
-            <a:avLst/>
-          </a:prstGeom>
-          <a:noFill/>
-          <a:ln/>
-        </p:spPr>
-        <p:txBody>
-          <a:bodyPr wrap="square" lIns="25400" tIns="25400" rIns="25400" bIns="25400" rtlCol="0" anchor="t">
-            <a:normAutofit fontScale="92500" lnSpcReduction="10000"/>
-          </a:bodyPr>
-          <a:lstStyle/>
-          <a:p>
-            <a:pPr marL="0" indent="0" algn="l">
-              <a:buNone/>
-            </a:pPr>
-            <a:r>
-              <a:rPr lang="en-US" sz="1800" dirty="0">
-                <a:solidFill>
-                  <a:srgbClr val="5C7268"/>
-                </a:solidFill>
-                <a:latin typeface="Courier New" pitchFamily="34" charset="0"/>
-                <a:ea typeface="Courier New" pitchFamily="34" charset="-122"/>
-                <a:cs typeface="Courier New" pitchFamily="34" charset="-120"/>
-              </a:rPr>
-              <a:t>LR 0.784</a:t>
-            </a:r>
-            <a:endParaRPr lang="en-US" sz="1800" dirty="0"/>
-          </a:p>
-        </p:txBody>
-      </p:sp>
-      <p:sp>
-        <p:nvSpPr>
-          <p:cNvPr id="49" name="Text 47"/>
-          <p:cNvSpPr/>
-          <p:nvPr/>
-        </p:nvSpPr>
-        <p:spPr>
-          <a:xfrm>
-            <a:off x="5132784" y="6746379"/>
-            <a:ext cx="213420" cy="295275"/>
-          </a:xfrm>
-          <a:prstGeom prst="rect">
-            <a:avLst/>
-          </a:prstGeom>
-          <a:noFill/>
-          <a:ln/>
-        </p:spPr>
-        <p:txBody>
-          <a:bodyPr wrap="square" lIns="25400" tIns="25400" rIns="25400" bIns="25400" rtlCol="0" anchor="t">
-            <a:normAutofit fontScale="92500" lnSpcReduction="10000"/>
-          </a:bodyPr>
-          <a:lstStyle/>
-          <a:p>
-            <a:pPr marL="0" indent="0" algn="l">
-              <a:buNone/>
-            </a:pPr>
-            <a:r>
-              <a:rPr lang="en-US" sz="1800" dirty="0">
-                <a:solidFill>
-                  <a:srgbClr val="66B3A1"/>
-                </a:solidFill>
-                <a:latin typeface="Courier New" pitchFamily="34" charset="0"/>
-                <a:ea typeface="Courier New" pitchFamily="34" charset="-122"/>
-                <a:cs typeface="Courier New" pitchFamily="34" charset="-120"/>
-              </a:rPr>
-              <a:t>→</a:t>
-            </a:r>
-            <a:endParaRPr lang="en-US" sz="1800" dirty="0"/>
-          </a:p>
-        </p:txBody>
-      </p:sp>
-      <p:sp>
-        <p:nvSpPr>
-          <p:cNvPr id="50" name="Text 48"/>
-          <p:cNvSpPr/>
-          <p:nvPr/>
-        </p:nvSpPr>
-        <p:spPr>
-          <a:xfrm>
-            <a:off x="5365254" y="6746379"/>
-            <a:ext cx="1173659" cy="295275"/>
-          </a:xfrm>
-          <a:prstGeom prst="rect">
-            <a:avLst/>
-          </a:prstGeom>
-          <a:noFill/>
-          <a:ln/>
-        </p:spPr>
-        <p:txBody>
-          <a:bodyPr wrap="square" lIns="25400" tIns="25400" rIns="25400" bIns="25400" rtlCol="0" anchor="t">
-            <a:normAutofit fontScale="92500" lnSpcReduction="10000"/>
-          </a:bodyPr>
-          <a:lstStyle/>
-          <a:p>
-            <a:pPr marL="0" indent="0" algn="l">
-              <a:buNone/>
-            </a:pPr>
-            <a:r>
-              <a:rPr lang="en-US" sz="1800" dirty="0">
-                <a:solidFill>
-                  <a:srgbClr val="244236"/>
-                </a:solidFill>
-                <a:latin typeface="Courier New" pitchFamily="34" charset="0"/>
-                <a:ea typeface="Courier New" pitchFamily="34" charset="-122"/>
-                <a:cs typeface="Courier New" pitchFamily="34" charset="-120"/>
-              </a:rPr>
-              <a:t>RF 0.833</a:t>
-            </a:r>
-            <a:endParaRPr lang="en-US" sz="1800" dirty="0"/>
-          </a:p>
-        </p:txBody>
-      </p:sp>
-      <p:sp>
-        <p:nvSpPr>
-          <p:cNvPr id="51" name="Text 49"/>
-          <p:cNvSpPr/>
-          <p:nvPr/>
-        </p:nvSpPr>
-        <p:spPr>
-          <a:xfrm>
-            <a:off x="6557963" y="6746379"/>
-            <a:ext cx="213420" cy="295275"/>
-          </a:xfrm>
-          <a:prstGeom prst="rect">
-            <a:avLst/>
-          </a:prstGeom>
-          <a:noFill/>
-          <a:ln/>
-        </p:spPr>
-        <p:txBody>
-          <a:bodyPr wrap="square" lIns="25400" tIns="25400" rIns="25400" bIns="25400" rtlCol="0" anchor="t">
-            <a:normAutofit fontScale="92500" lnSpcReduction="10000"/>
-          </a:bodyPr>
-          <a:lstStyle/>
-          <a:p>
-            <a:pPr marL="0" indent="0" algn="l">
-              <a:buNone/>
-            </a:pPr>
-            <a:r>
-              <a:rPr lang="en-US" sz="1800" dirty="0">
-                <a:solidFill>
-                  <a:srgbClr val="66B3A1"/>
-                </a:solidFill>
-                <a:latin typeface="Courier New" pitchFamily="34" charset="0"/>
-                <a:ea typeface="Courier New" pitchFamily="34" charset="-122"/>
-                <a:cs typeface="Courier New" pitchFamily="34" charset="-120"/>
-              </a:rPr>
-              <a:t>→</a:t>
-            </a:r>
-            <a:endParaRPr lang="en-US" sz="1800" dirty="0"/>
-          </a:p>
-        </p:txBody>
-      </p:sp>
-      <p:sp>
-        <p:nvSpPr>
-          <p:cNvPr id="52" name="Text 50"/>
-          <p:cNvSpPr/>
-          <p:nvPr/>
-        </p:nvSpPr>
-        <p:spPr>
-          <a:xfrm>
-            <a:off x="6790432" y="6727329"/>
-            <a:ext cx="2112280" cy="333375"/>
-          </a:xfrm>
-          <a:prstGeom prst="rect">
-            <a:avLst/>
-          </a:prstGeom>
-          <a:noFill/>
-          <a:ln/>
-        </p:spPr>
-        <p:txBody>
-          <a:bodyPr wrap="square" lIns="25400" tIns="25400" rIns="25400" bIns="25400" rtlCol="0" anchor="t">
-            <a:normAutofit/>
-          </a:bodyPr>
-          <a:lstStyle/>
-          <a:p>
-            <a:pPr marL="0" indent="0" algn="l">
-              <a:buNone/>
-            </a:pPr>
-            <a:r>
-              <a:rPr lang="en-US" sz="1800" b="1" dirty="0">
-                <a:solidFill>
-                  <a:srgbClr val="063D22"/>
-                </a:solidFill>
-                <a:latin typeface="Courier New" pitchFamily="34" charset="0"/>
-                <a:ea typeface="Courier New" pitchFamily="34" charset="-122"/>
-                <a:cs typeface="Courier New" pitchFamily="34" charset="-120"/>
-              </a:rPr>
-              <a:t>LightGBM 0.836</a:t>
-            </a:r>
-            <a:endParaRPr lang="en-US" sz="1800" dirty="0"/>
-          </a:p>
-        </p:txBody>
-      </p:sp>
-      <p:sp>
-        <p:nvSpPr>
-          <p:cNvPr id="53" name="Text 51"/>
-          <p:cNvSpPr/>
-          <p:nvPr/>
-        </p:nvSpPr>
-        <p:spPr>
-          <a:xfrm>
-            <a:off x="8805937" y="6746379"/>
-            <a:ext cx="213420" cy="295275"/>
-          </a:xfrm>
-          <a:prstGeom prst="rect">
-            <a:avLst/>
-          </a:prstGeom>
-          <a:noFill/>
-          <a:ln/>
-        </p:spPr>
-        <p:txBody>
-          <a:bodyPr wrap="square" lIns="25400" tIns="25400" rIns="25400" bIns="25400" rtlCol="0" anchor="t">
-            <a:normAutofit fontScale="92500" lnSpcReduction="10000"/>
-          </a:bodyPr>
-          <a:lstStyle/>
-          <a:p>
-            <a:pPr marL="0" indent="0" algn="l">
-              <a:buNone/>
-            </a:pPr>
-            <a:r>
-              <a:rPr lang="en-US" sz="1800" dirty="0">
-                <a:solidFill>
-                  <a:srgbClr val="66B3A1"/>
-                </a:solidFill>
-                <a:latin typeface="Courier New" pitchFamily="34" charset="0"/>
-                <a:ea typeface="Courier New" pitchFamily="34" charset="-122"/>
-                <a:cs typeface="Courier New" pitchFamily="34" charset="-120"/>
-              </a:rPr>
-              <a:t>→</a:t>
-            </a:r>
-            <a:endParaRPr lang="en-US" sz="1800" dirty="0"/>
-          </a:p>
-        </p:txBody>
-      </p:sp>
-      <p:sp>
-        <p:nvSpPr>
-          <p:cNvPr id="54" name="Text 52"/>
-          <p:cNvSpPr/>
-          <p:nvPr/>
-        </p:nvSpPr>
-        <p:spPr>
-          <a:xfrm>
-            <a:off x="9038406" y="6727329"/>
-            <a:ext cx="2112280" cy="333375"/>
-          </a:xfrm>
-          <a:prstGeom prst="rect">
-            <a:avLst/>
-          </a:prstGeom>
-          <a:noFill/>
-          <a:ln/>
-        </p:spPr>
-        <p:txBody>
-          <a:bodyPr wrap="square" lIns="25400" tIns="25400" rIns="25400" bIns="25400" rtlCol="0" anchor="t">
-            <a:normAutofit/>
-          </a:bodyPr>
-          <a:lstStyle/>
-          <a:p>
-            <a:pPr marL="0" indent="0" algn="l">
-              <a:buNone/>
-            </a:pPr>
-            <a:r>
-              <a:rPr lang="en-US" sz="1800" b="1" dirty="0">
-                <a:solidFill>
-                  <a:srgbClr val="1A7A57"/>
-                </a:solidFill>
-                <a:latin typeface="Courier New" pitchFamily="34" charset="0"/>
-                <a:ea typeface="Courier New" pitchFamily="34" charset="-122"/>
-                <a:cs typeface="Courier New" pitchFamily="34" charset="-120"/>
-              </a:rPr>
-              <a:t>ensemble 0.859</a:t>
-            </a:r>
-            <a:endParaRPr lang="en-US" sz="1800" dirty="0"/>
-          </a:p>
-        </p:txBody>
-      </p:sp>
-      <p:sp>
-        <p:nvSpPr>
-          <p:cNvPr id="55" name="Text 53"/>
-          <p:cNvSpPr/>
-          <p:nvPr/>
-        </p:nvSpPr>
-        <p:spPr>
-          <a:xfrm>
-            <a:off x="952500" y="7232154"/>
-            <a:ext cx="10346892" cy="678061"/>
-          </a:xfrm>
-          <a:prstGeom prst="rect">
-            <a:avLst/>
-          </a:prstGeom>
-          <a:noFill/>
-          <a:ln/>
-        </p:spPr>
-        <p:txBody>
-          <a:bodyPr wrap="square" lIns="25400" tIns="25400" rIns="25400" bIns="25400" rtlCol="0" anchor="t">
-            <a:normAutofit fontScale="92500" lnSpcReduction="20000"/>
-          </a:bodyPr>
-          <a:lstStyle/>
-          <a:p>
-            <a:pPr marL="0" indent="0" algn="l">
-              <a:lnSpc>
-                <a:spcPct val="140000"/>
-              </a:lnSpc>
-              <a:buNone/>
-            </a:pPr>
-            <a:r>
-              <a:rPr lang="en-US" sz="1800" dirty="0">
-                <a:solidFill>
-                  <a:srgbClr val="5C7268"/>
-                </a:solidFill>
-                <a:latin typeface="Arial" pitchFamily="34" charset="0"/>
-                <a:ea typeface="Arial" pitchFamily="34" charset="-122"/>
-                <a:cs typeface="Arial" pitchFamily="34" charset="-120"/>
-              </a:rPr>
-              <a:t>v10 adds leak-free z-scoring and a conservative smooth threshold (ROC AUC 0.9377). Its OOF dips slightly below v6/v7 </a:t>
-            </a:r>
-            <a:r>
-              <a:rPr lang="en-US" sz="1800" b="1" dirty="0">
-                <a:solidFill>
-                  <a:srgbClr val="244236"/>
-                </a:solidFill>
-                <a:latin typeface="Arial" pitchFamily="34" charset="0"/>
-                <a:ea typeface="Arial" pitchFamily="34" charset="-122"/>
-                <a:cs typeface="Arial" pitchFamily="34" charset="-120"/>
-              </a:rPr>
-              <a:t>by design </a:t>
-            </a:r>
-            <a:r>
-              <a:rPr lang="en-US" sz="1800" dirty="0">
-                <a:solidFill>
-                  <a:srgbClr val="5C7268"/>
-                </a:solidFill>
-                <a:latin typeface="Arial" pitchFamily="34" charset="0"/>
-                <a:ea typeface="Arial" pitchFamily="34" charset="-122"/>
-                <a:cs typeface="Arial" pitchFamily="34" charset="-120"/>
-              </a:rPr>
-              <a:t>— not because the model is worse.</a:t>
-            </a:r>
-            <a:endParaRPr lang="en-US" sz="1800" dirty="0"/>
-          </a:p>
-        </p:txBody>
-      </p:sp>
-      <p:sp>
-        <p:nvSpPr>
           <p:cNvPr id="56" name="Text 54"/>
           <p:cNvSpPr/>
           <p:nvPr/>
@@ -3993,72 +3434,6 @@
                 <a:cs typeface="Arial" pitchFamily="34" charset="-120"/>
               </a:rPr>
               <a:t>.</a:t>
-            </a:r>
-            <a:endParaRPr lang="en-US" sz="2025" dirty="0"/>
-          </a:p>
-        </p:txBody>
-      </p:sp>
-      <p:sp>
-        <p:nvSpPr>
-          <p:cNvPr id="59" name="Text 57"/>
-          <p:cNvSpPr/>
-          <p:nvPr/>
-        </p:nvSpPr>
-        <p:spPr>
-          <a:xfrm>
-            <a:off x="11531426" y="7020669"/>
-            <a:ext cx="5978196" cy="814388"/>
-          </a:xfrm>
-          <a:prstGeom prst="rect">
-            <a:avLst/>
-          </a:prstGeom>
-          <a:noFill/>
-          <a:ln/>
-        </p:spPr>
-        <p:txBody>
-          <a:bodyPr wrap="square" lIns="25400" tIns="25400" rIns="25400" bIns="25400" rtlCol="0" anchor="t">
-            <a:normAutofit fontScale="92500" lnSpcReduction="20000"/>
-          </a:bodyPr>
-          <a:lstStyle/>
-          <a:p>
-            <a:pPr marL="0" indent="0" algn="l">
-              <a:lnSpc>
-                <a:spcPct val="150000"/>
-              </a:lnSpc>
-              <a:buNone/>
-            </a:pPr>
-            <a:r>
-              <a:rPr lang="en-US" sz="2025" dirty="0">
-                <a:solidFill>
-                  <a:srgbClr val="5C7268"/>
-                </a:solidFill>
-                <a:latin typeface="Arial" pitchFamily="34" charset="0"/>
-                <a:ea typeface="Arial" pitchFamily="34" charset="-122"/>
-                <a:cs typeface="Arial" pitchFamily="34" charset="-120"/>
-              </a:rPr>
-              <a:t>Adversarial validation confirms the CV→LB gap is </a:t>
-            </a:r>
-            <a:r>
-              <a:rPr lang="en-US" sz="2025" b="1" dirty="0">
-                <a:solidFill>
-                  <a:srgbClr val="244236"/>
-                </a:solidFill>
-                <a:latin typeface="Arial" pitchFamily="34" charset="0"/>
-                <a:ea typeface="Arial" pitchFamily="34" charset="-122"/>
-                <a:cs typeface="Arial" pitchFamily="34" charset="-120"/>
-              </a:rPr>
-              <a:t>distribution shift over time</a:t>
-            </a:r>
-            <a:r>
-              <a:rPr lang="en-US" sz="2025" dirty="0">
-                <a:solidFill>
-                  <a:srgbClr val="5C7268"/>
-                </a:solidFill>
-                <a:latin typeface="Arial" pitchFamily="34" charset="0"/>
-                <a:ea typeface="Arial" pitchFamily="34" charset="-122"/>
-                <a:cs typeface="Arial" pitchFamily="34" charset="-120"/>
-              </a:rPr>
-              <a:t>, not overfitting.</a:t>
             </a:r>
             <a:endParaRPr lang="en-US" sz="2025" dirty="0"/>
           </a:p>
@@ -5077,7 +4452,7 @@
                 <a:ea typeface="Courier New" pitchFamily="34" charset="-122"/>
                 <a:cs typeface="Courier New" pitchFamily="34" charset="-120"/>
               </a:rPr>
-              <a:t>12 · KEY CODE</a:t>
+              <a:t>11 · KEY CODE</a:t>
             </a:r>
             <a:endParaRPr lang="en-US" sz="1800" dirty="0"/>
           </a:p>
@@ -5782,7 +5157,7 @@
                 <a:ea typeface="Courier New" pitchFamily="34" charset="-122"/>
                 <a:cs typeface="Courier New" pitchFamily="34" charset="-120"/>
               </a:rPr>
-              <a:t>13 · QUESTIONS</a:t>
+              <a:t>12 · QUESTIONS</a:t>
             </a:r>
             <a:endParaRPr lang="en-US" sz="1800" dirty="0"/>
           </a:p>

</xml_diff>

<commit_message>
Riwad's manual edits (checkpoint before removing em dashes)
</commit_message>
<xml_diff>
--- a/presentation/Consulting_Finance_ML_Slides.pptx
+++ b/presentation/Consulting_Finance_ML_Slides.pptx
@@ -5,7 +5,7 @@
     <p:sldMasterId id="2147483648" r:id="rId1"/>
   </p:sldMasterIdLst>
   <p:notesMasterIdLst>
-    <p:notesMasterId r:id="rId15"/>
+    <p:notesMasterId r:id="rId14"/>
   </p:notesMasterIdLst>
   <p:sldIdLst>
     <p:sldId id="256" r:id="rId2"/>
@@ -18,8 +18,8 @@
     <p:sldId id="263" r:id="rId9"/>
     <p:sldId id="269" r:id="rId10"/>
     <p:sldId id="264" r:id="rId11"/>
-    <p:sldId id="268" r:id="rId13"/>
-    <p:sldId id="267" r:id="rId14"/>
+    <p:sldId id="268" r:id="rId12"/>
+    <p:sldId id="267" r:id="rId13"/>
   </p:sldIdLst>
   <p:sldSz cx="18288000" cy="10287000"/>
   <p:notesSz cx="10287000" cy="18288000"/>
@@ -381,7 +381,7 @@
           <a:p>
             <a:r>
               <a:rPr lang="en-US" dirty="0"/>
-              <a:t>Separate what we did from what we'd do next. For a finance audience the strongest next step is deciding by cost rather than accuracy, plus calibrated probabilities: that reframes this from a Kaggle score to real lending economics.</a:t>
+              <a:t>The two questions most likely to come up: why we dropped race and religion (lead with the +0.7pt number), and how we knew the column was a leak (it tracked real signal in training but was random in test). Both make us look rigorous.</a:t>
             </a:r>
           </a:p>
         </p:txBody>
@@ -403,94 +403,7 @@
           <a:p>
             <a:fld id="{F7021451-1387-4CA6-816F-3879F97B5CBC}" type="slidenum">
               <a:rPr lang="en-US"/>
-              <a:t>11</a:t>
-            </a:fld>
-            <a:endParaRPr lang="en-US"/>
-          </a:p>
-        </p:txBody>
-      </p:sp>
-    </p:spTree>
-    <p:extLst>
-      <p:ext uri="{BB962C8B-B14F-4D97-AF65-F5344CB8AC3E}">
-        <p14:creationId xmlns:p14="http://schemas.microsoft.com/office/powerpoint/2010/main" val="1024086991"/>
-      </p:ext>
-    </p:extLst>
-  </p:cSld>
-  <p:clrMapOvr>
-    <a:masterClrMapping/>
-  </p:clrMapOvr>
-</p:notes>
-</file>
-
-<file path=ppt/notesSlides/notesSlide11.xml><?xml version="1.0" encoding="utf-8"?>
-<p:notes xmlns:a="http://schemas.openxmlformats.org/drawingml/2006/main" xmlns:r="http://schemas.openxmlformats.org/officeDocument/2006/relationships" xmlns:p="http://schemas.openxmlformats.org/presentationml/2006/main">
-  <p:cSld>
-    <p:spTree>
-      <p:nvGrpSpPr>
-        <p:cNvPr id="1" name=""/>
-        <p:cNvGrpSpPr/>
-        <p:nvPr/>
-      </p:nvGrpSpPr>
-      <p:grpSpPr>
-        <a:xfrm>
-          <a:off x="0" y="0"/>
-          <a:ext cx="0" cy="0"/>
-          <a:chOff x="0" y="0"/>
-          <a:chExt cx="0" cy="0"/>
-        </a:xfrm>
-      </p:grpSpPr>
-      <p:sp>
-        <p:nvSpPr>
-          <p:cNvPr id="2" name="Slide Image Placeholder 1"/>
-          <p:cNvSpPr>
-            <a:spLocks noGrp="1" noRot="1" noChangeAspect="1"/>
-          </p:cNvSpPr>
-          <p:nvPr>
-            <p:ph type="sldImg"/>
-          </p:nvPr>
-        </p:nvSpPr>
-        <p:spPr/>
-      </p:sp>
-      <p:sp>
-        <p:nvSpPr>
-          <p:cNvPr id="3" name="Notes Placeholder 2"/>
-          <p:cNvSpPr>
-            <a:spLocks noGrp="1"/>
-          </p:cNvSpPr>
-          <p:nvPr>
-            <p:ph type="body" idx="1"/>
-          </p:nvPr>
-        </p:nvSpPr>
-        <p:spPr/>
-        <p:txBody>
-          <a:bodyPr/>
-          <a:lstStyle/>
-          <a:p>
-            <a:r>
-              <a:rPr lang="en-US" dirty="0"/>
-              <a:t>The two questions most likely to come up: why we dropped race and religion (lead with the +0.7pt number), and how we knew the column was a leak (it tracked real signal in training but was random in test). Both make us look rigorous.</a:t>
-            </a:r>
-          </a:p>
-        </p:txBody>
-      </p:sp>
-      <p:sp>
-        <p:nvSpPr>
-          <p:cNvPr id="4" name="Slide Number Placeholder 3"/>
-          <p:cNvSpPr>
-            <a:spLocks noGrp="1"/>
-          </p:cNvSpPr>
-          <p:nvPr>
-            <p:ph type="sldNum" sz="quarter" idx="10"/>
-          </p:nvPr>
-        </p:nvSpPr>
-        <p:spPr/>
-        <p:txBody>
-          <a:bodyPr/>
-          <a:lstStyle/>
-          <a:p>
-            <a:fld id="{F7021451-1387-4CA6-816F-3879F97B5CBC}" type="slidenum">
-              <a:rPr lang="en-US"/>
-              <a:t>13</a:t>
+              <a:t>12</a:t>
             </a:fld>
             <a:endParaRPr lang="en-US"/>
           </a:p>
@@ -1976,7 +1889,7 @@
         </p:nvSpPr>
         <p:spPr>
           <a:xfrm>
-            <a:off x="952500" y="3717429"/>
+            <a:off x="822343" y="5067858"/>
             <a:ext cx="11050079" cy="295275"/>
           </a:xfrm>
           <a:prstGeom prst="rect">
@@ -2017,7 +1930,7 @@
         </p:nvSpPr>
         <p:spPr>
           <a:xfrm>
-            <a:off x="952500" y="4593729"/>
+            <a:off x="822343" y="6383290"/>
             <a:ext cx="704627" cy="19050"/>
           </a:xfrm>
           <a:prstGeom prst="rect">
@@ -2044,7 +1957,7 @@
         </p:nvSpPr>
         <p:spPr>
           <a:xfrm>
-            <a:off x="1066800" y="4222254"/>
+            <a:off x="936643" y="6011815"/>
             <a:ext cx="552227" cy="314325"/>
           </a:xfrm>
           <a:prstGeom prst="rect">
@@ -2085,7 +1998,7 @@
         </p:nvSpPr>
         <p:spPr>
           <a:xfrm>
-            <a:off x="1657127" y="4593729"/>
+            <a:off x="1526970" y="6383290"/>
             <a:ext cx="5770736" cy="19050"/>
           </a:xfrm>
           <a:prstGeom prst="rect">
@@ -2112,7 +2025,7 @@
         </p:nvSpPr>
         <p:spPr>
           <a:xfrm>
-            <a:off x="1771427" y="4222254"/>
+            <a:off x="1641270" y="6011815"/>
             <a:ext cx="5715258" cy="314325"/>
           </a:xfrm>
           <a:prstGeom prst="rect">
@@ -2153,7 +2066,7 @@
         </p:nvSpPr>
         <p:spPr>
           <a:xfrm>
-            <a:off x="7427863" y="4593729"/>
+            <a:off x="7297706" y="6383290"/>
             <a:ext cx="1164357" cy="19050"/>
           </a:xfrm>
           <a:prstGeom prst="rect">
@@ -2180,7 +2093,7 @@
         </p:nvSpPr>
         <p:spPr>
           <a:xfrm>
-            <a:off x="7465963" y="4222254"/>
+            <a:off x="7335806" y="6011815"/>
             <a:ext cx="1011957" cy="314325"/>
           </a:xfrm>
           <a:prstGeom prst="rect">
@@ -2221,7 +2134,7 @@
         </p:nvSpPr>
         <p:spPr>
           <a:xfrm>
-            <a:off x="8592220" y="4593729"/>
+            <a:off x="8462063" y="6383290"/>
             <a:ext cx="1394520" cy="19050"/>
           </a:xfrm>
           <a:prstGeom prst="rect">
@@ -2248,7 +2161,7 @@
         </p:nvSpPr>
         <p:spPr>
           <a:xfrm>
-            <a:off x="8630320" y="4222254"/>
+            <a:off x="8500163" y="6011815"/>
             <a:ext cx="1242120" cy="314325"/>
           </a:xfrm>
           <a:prstGeom prst="rect">
@@ -2289,7 +2202,7 @@
         </p:nvSpPr>
         <p:spPr>
           <a:xfrm>
-            <a:off x="9986739" y="4593729"/>
+            <a:off x="9856582" y="6383290"/>
             <a:ext cx="1011287" cy="19050"/>
           </a:xfrm>
           <a:prstGeom prst="rect">
@@ -2316,7 +2229,7 @@
         </p:nvSpPr>
         <p:spPr>
           <a:xfrm>
-            <a:off x="10024839" y="4222254"/>
+            <a:off x="9894682" y="6011815"/>
             <a:ext cx="858887" cy="314325"/>
           </a:xfrm>
           <a:prstGeom prst="rect">
@@ -2357,7 +2270,7 @@
         </p:nvSpPr>
         <p:spPr>
           <a:xfrm>
-            <a:off x="952500" y="5103316"/>
+            <a:off x="822343" y="6892877"/>
             <a:ext cx="704627" cy="9525"/>
           </a:xfrm>
           <a:prstGeom prst="rect">
@@ -2384,7 +2297,7 @@
         </p:nvSpPr>
         <p:spPr>
           <a:xfrm>
-            <a:off x="1066800" y="4717554"/>
+            <a:off x="936643" y="6507115"/>
             <a:ext cx="552227" cy="319088"/>
           </a:xfrm>
           <a:prstGeom prst="rect">
@@ -2425,7 +2338,7 @@
         </p:nvSpPr>
         <p:spPr>
           <a:xfrm>
-            <a:off x="1657127" y="5103316"/>
+            <a:off x="1526970" y="6892877"/>
             <a:ext cx="5770736" cy="9525"/>
           </a:xfrm>
           <a:prstGeom prst="rect">
@@ -2452,7 +2365,7 @@
         </p:nvSpPr>
         <p:spPr>
           <a:xfrm>
-            <a:off x="1771427" y="4717554"/>
+            <a:off x="1641270" y="6507115"/>
             <a:ext cx="5715258" cy="319088"/>
           </a:xfrm>
           <a:prstGeom prst="rect">
@@ -2493,7 +2406,7 @@
         </p:nvSpPr>
         <p:spPr>
           <a:xfrm>
-            <a:off x="7427863" y="5103316"/>
+            <a:off x="7297706" y="6892877"/>
             <a:ext cx="1164357" cy="9525"/>
           </a:xfrm>
           <a:prstGeom prst="rect">
@@ -2520,7 +2433,7 @@
         </p:nvSpPr>
         <p:spPr>
           <a:xfrm>
-            <a:off x="7465963" y="4717554"/>
+            <a:off x="7335806" y="6507115"/>
             <a:ext cx="1011957" cy="319088"/>
           </a:xfrm>
           <a:prstGeom prst="rect">
@@ -2561,7 +2474,7 @@
         </p:nvSpPr>
         <p:spPr>
           <a:xfrm>
-            <a:off x="8592220" y="5103316"/>
+            <a:off x="8462063" y="6892877"/>
             <a:ext cx="1394520" cy="9525"/>
           </a:xfrm>
           <a:prstGeom prst="rect">
@@ -2588,7 +2501,7 @@
         </p:nvSpPr>
         <p:spPr>
           <a:xfrm>
-            <a:off x="8630320" y="4717554"/>
+            <a:off x="8500163" y="6507115"/>
             <a:ext cx="1242120" cy="319088"/>
           </a:xfrm>
           <a:prstGeom prst="rect">
@@ -2629,7 +2542,7 @@
         </p:nvSpPr>
         <p:spPr>
           <a:xfrm>
-            <a:off x="9986739" y="5103316"/>
+            <a:off x="9856582" y="6892877"/>
             <a:ext cx="1011287" cy="9525"/>
           </a:xfrm>
           <a:prstGeom prst="rect">
@@ -2656,7 +2569,7 @@
         </p:nvSpPr>
         <p:spPr>
           <a:xfrm>
-            <a:off x="10024839" y="4717554"/>
+            <a:off x="9894682" y="6507115"/>
             <a:ext cx="858887" cy="319088"/>
           </a:xfrm>
           <a:prstGeom prst="rect">
@@ -2697,7 +2610,7 @@
         </p:nvSpPr>
         <p:spPr>
           <a:xfrm>
-            <a:off x="952500" y="5112841"/>
+            <a:off x="822343" y="6902402"/>
             <a:ext cx="10045526" cy="528638"/>
           </a:xfrm>
           <a:prstGeom prst="rect">
@@ -2724,7 +2637,7 @@
         </p:nvSpPr>
         <p:spPr>
           <a:xfrm>
-            <a:off x="952500" y="5631954"/>
+            <a:off x="822343" y="7421515"/>
             <a:ext cx="704627" cy="9525"/>
           </a:xfrm>
           <a:prstGeom prst="rect">
@@ -2751,7 +2664,7 @@
         </p:nvSpPr>
         <p:spPr>
           <a:xfrm>
-            <a:off x="1066800" y="5217616"/>
+            <a:off x="936643" y="7007177"/>
             <a:ext cx="552227" cy="347663"/>
           </a:xfrm>
           <a:prstGeom prst="rect">
@@ -2792,7 +2705,7 @@
         </p:nvSpPr>
         <p:spPr>
           <a:xfrm>
-            <a:off x="1657127" y="5631954"/>
+            <a:off x="1526970" y="7421515"/>
             <a:ext cx="5770736" cy="9525"/>
           </a:xfrm>
           <a:prstGeom prst="rect">
@@ -2819,7 +2732,7 @@
         </p:nvSpPr>
         <p:spPr>
           <a:xfrm>
-            <a:off x="1771427" y="5217616"/>
+            <a:off x="1641270" y="7007177"/>
             <a:ext cx="5715258" cy="347663"/>
           </a:xfrm>
           <a:prstGeom prst="rect">
@@ -2860,7 +2773,7 @@
         </p:nvSpPr>
         <p:spPr>
           <a:xfrm>
-            <a:off x="7427863" y="5631954"/>
+            <a:off x="7297706" y="7421515"/>
             <a:ext cx="1164357" cy="9525"/>
           </a:xfrm>
           <a:prstGeom prst="rect">
@@ -2887,7 +2800,7 @@
         </p:nvSpPr>
         <p:spPr>
           <a:xfrm>
-            <a:off x="7465963" y="5217616"/>
+            <a:off x="7335806" y="7007177"/>
             <a:ext cx="1011957" cy="347663"/>
           </a:xfrm>
           <a:prstGeom prst="rect">
@@ -2928,7 +2841,7 @@
         </p:nvSpPr>
         <p:spPr>
           <a:xfrm>
-            <a:off x="8592220" y="5631954"/>
+            <a:off x="8462063" y="7421515"/>
             <a:ext cx="1394520" cy="9525"/>
           </a:xfrm>
           <a:prstGeom prst="rect">
@@ -2955,7 +2868,7 @@
         </p:nvSpPr>
         <p:spPr>
           <a:xfrm>
-            <a:off x="8630320" y="5217616"/>
+            <a:off x="8500163" y="7007177"/>
             <a:ext cx="1242120" cy="347663"/>
           </a:xfrm>
           <a:prstGeom prst="rect">
@@ -2996,7 +2909,7 @@
         </p:nvSpPr>
         <p:spPr>
           <a:xfrm>
-            <a:off x="9986739" y="5631954"/>
+            <a:off x="9856582" y="7421515"/>
             <a:ext cx="1011287" cy="9525"/>
           </a:xfrm>
           <a:prstGeom prst="rect">
@@ -3023,7 +2936,7 @@
         </p:nvSpPr>
         <p:spPr>
           <a:xfrm>
-            <a:off x="10024839" y="5217616"/>
+            <a:off x="9894682" y="7007177"/>
             <a:ext cx="858887" cy="347663"/>
           </a:xfrm>
           <a:prstGeom prst="rect">
@@ -3064,7 +2977,7 @@
         </p:nvSpPr>
         <p:spPr>
           <a:xfrm>
-            <a:off x="952500" y="5641479"/>
+            <a:off x="822343" y="7431040"/>
             <a:ext cx="10045526" cy="523875"/>
           </a:xfrm>
           <a:prstGeom prst="rect">
@@ -3091,7 +3004,7 @@
         </p:nvSpPr>
         <p:spPr>
           <a:xfrm>
-            <a:off x="1066800" y="5746254"/>
+            <a:off x="936643" y="7535815"/>
             <a:ext cx="552227" cy="352425"/>
           </a:xfrm>
           <a:prstGeom prst="rect">
@@ -3132,7 +3045,7 @@
         </p:nvSpPr>
         <p:spPr>
           <a:xfrm>
-            <a:off x="1771427" y="5746254"/>
+            <a:off x="1641270" y="7535815"/>
             <a:ext cx="5715258" cy="352425"/>
           </a:xfrm>
           <a:prstGeom prst="rect">
@@ -3173,7 +3086,7 @@
         </p:nvSpPr>
         <p:spPr>
           <a:xfrm>
-            <a:off x="7465963" y="5746254"/>
+            <a:off x="7335806" y="7535815"/>
             <a:ext cx="1011957" cy="352425"/>
           </a:xfrm>
           <a:prstGeom prst="rect">
@@ -3214,7 +3127,7 @@
         </p:nvSpPr>
         <p:spPr>
           <a:xfrm>
-            <a:off x="8630320" y="5746254"/>
+            <a:off x="8500163" y="7535815"/>
             <a:ext cx="1242120" cy="352425"/>
           </a:xfrm>
           <a:prstGeom prst="rect">
@@ -3255,7 +3168,7 @@
         </p:nvSpPr>
         <p:spPr>
           <a:xfrm>
-            <a:off x="10024839" y="5746254"/>
+            <a:off x="9894682" y="7535815"/>
             <a:ext cx="858887" cy="352425"/>
           </a:xfrm>
           <a:prstGeom prst="rect">
@@ -3296,7 +3209,7 @@
         </p:nvSpPr>
         <p:spPr>
           <a:xfrm>
-            <a:off x="11531426" y="3792662"/>
+            <a:off x="11442509" y="5016365"/>
             <a:ext cx="6384481" cy="870570"/>
           </a:xfrm>
           <a:prstGeom prst="rect">
@@ -3340,7 +3253,7 @@
         </p:nvSpPr>
         <p:spPr>
           <a:xfrm>
-            <a:off x="11531426" y="4720382"/>
+            <a:off x="11442509" y="6227666"/>
             <a:ext cx="5978196" cy="733425"/>
           </a:xfrm>
           <a:prstGeom prst="rect">
@@ -3381,7 +3294,7 @@
         </p:nvSpPr>
         <p:spPr>
           <a:xfrm>
-            <a:off x="11531426" y="5682407"/>
+            <a:off x="11442509" y="7189691"/>
             <a:ext cx="5978196" cy="1204913"/>
           </a:xfrm>
           <a:prstGeom prst="rect">
@@ -3523,7 +3436,7 @@
         </p:blipFill>
         <p:spPr>
           <a:xfrm>
-            <a:off x="1188720" y="2103120"/>
+            <a:off x="822343" y="2694776"/>
             <a:ext cx="15361920" cy="1632204"/>
           </a:xfrm>
           <a:prstGeom prst="rect">
@@ -3540,839 +3453,6 @@
 </file>
 
 <file path=ppt/slides/slide11.xml><?xml version="1.0" encoding="utf-8"?>
-<p:sld xmlns:a="http://schemas.openxmlformats.org/drawingml/2006/main" xmlns:r="http://schemas.openxmlformats.org/officeDocument/2006/relationships" xmlns:p="http://schemas.openxmlformats.org/presentationml/2006/main">
-  <p:cSld name="Slide 11">
-    <p:bg>
-      <p:bgPr>
-        <a:solidFill>
-          <a:srgbClr val="FFFFFF"/>
-        </a:solidFill>
-        <a:effectLst/>
-      </p:bgPr>
-    </p:bg>
-    <p:spTree>
-      <p:nvGrpSpPr>
-        <p:cNvPr id="1" name=""/>
-        <p:cNvGrpSpPr/>
-        <p:nvPr/>
-      </p:nvGrpSpPr>
-      <p:grpSpPr>
-        <a:xfrm>
-          <a:off x="0" y="0"/>
-          <a:ext cx="0" cy="0"/>
-          <a:chOff x="0" y="0"/>
-          <a:chExt cx="0" cy="0"/>
-        </a:xfrm>
-      </p:grpSpPr>
-      <p:sp>
-        <p:nvSpPr>
-          <p:cNvPr id="2" name="Shape 0"/>
-          <p:cNvSpPr/>
-          <p:nvPr/>
-        </p:nvSpPr>
-        <p:spPr>
-          <a:xfrm>
-            <a:off x="952500" y="1912218"/>
-            <a:ext cx="16383000" cy="19050"/>
-          </a:xfrm>
-          <a:prstGeom prst="rect">
-            <a:avLst/>
-          </a:prstGeom>
-          <a:solidFill>
-            <a:srgbClr val="1A7A57"/>
-          </a:solidFill>
-          <a:ln/>
-        </p:spPr>
-        <p:txBody>
-          <a:bodyPr/>
-          <a:lstStyle/>
-          <a:p>
-            <a:endParaRPr lang="en-GB"/>
-          </a:p>
-        </p:txBody>
-      </p:sp>
-      <p:sp>
-        <p:nvSpPr>
-          <p:cNvPr id="3" name="Text 1"/>
-          <p:cNvSpPr/>
-          <p:nvPr/>
-        </p:nvSpPr>
-        <p:spPr>
-          <a:xfrm>
-            <a:off x="952500" y="742950"/>
-            <a:ext cx="18021300" cy="295275"/>
-          </a:xfrm>
-          <a:prstGeom prst="rect">
-            <a:avLst/>
-          </a:prstGeom>
-          <a:noFill/>
-          <a:ln/>
-        </p:spPr>
-        <p:txBody>
-          <a:bodyPr wrap="square" lIns="25400" tIns="25400" rIns="25400" bIns="25400" rtlCol="0" anchor="t">
-            <a:normAutofit fontScale="92500" lnSpcReduction="10000"/>
-          </a:bodyPr>
-          <a:lstStyle/>
-          <a:p>
-            <a:pPr marL="0" indent="0" algn="l">
-              <a:buNone/>
-            </a:pPr>
-            <a:r>
-              <a:rPr lang="en-US" sz="1800" kern="0" spc="225" dirty="0">
-                <a:solidFill>
-                  <a:srgbClr val="007A33"/>
-                </a:solidFill>
-                <a:latin typeface="Courier New" pitchFamily="34" charset="0"/>
-                <a:ea typeface="Courier New" pitchFamily="34" charset="-122"/>
-                <a:cs typeface="Courier New" pitchFamily="34" charset="-120"/>
-              </a:rPr>
-              <a:t>11 · WHAT COMES NEXT</a:t>
-            </a:r>
-            <a:endParaRPr lang="en-US" sz="1800" dirty="0"/>
-          </a:p>
-        </p:txBody>
-      </p:sp>
-      <p:sp>
-        <p:nvSpPr>
-          <p:cNvPr id="4" name="Text 2"/>
-          <p:cNvSpPr/>
-          <p:nvPr/>
-        </p:nvSpPr>
-        <p:spPr>
-          <a:xfrm>
-            <a:off x="952500" y="1152525"/>
-            <a:ext cx="18021300" cy="550143"/>
-          </a:xfrm>
-          <a:prstGeom prst="rect">
-            <a:avLst/>
-          </a:prstGeom>
-          <a:noFill/>
-          <a:ln/>
-        </p:spPr>
-        <p:txBody>
-          <a:bodyPr wrap="square" lIns="25400" tIns="25400" rIns="25400" bIns="25400" rtlCol="0" anchor="t">
-            <a:normAutofit fontScale="92500" lnSpcReduction="10000"/>
-          </a:bodyPr>
-          <a:lstStyle/>
-          <a:p>
-            <a:pPr marL="0" indent="0" algn="l">
-              <a:lnSpc>
-                <a:spcPct val="112000"/>
-              </a:lnSpc>
-              <a:buNone/>
-            </a:pPr>
-            <a:r>
-              <a:rPr lang="en-US" sz="3600" b="1" kern="0" spc="-37" dirty="0">
-                <a:solidFill>
-                  <a:srgbClr val="063D22"/>
-                </a:solidFill>
-                <a:latin typeface="Arial" pitchFamily="34" charset="0"/>
-                <a:ea typeface="Arial" pitchFamily="34" charset="-122"/>
-                <a:cs typeface="Arial" pitchFamily="34" charset="-120"/>
-              </a:rPr>
-              <a:t>Four steps would make this ready for a real bank</a:t>
-            </a:r>
-            <a:endParaRPr lang="en-US" sz="3600" dirty="0"/>
-          </a:p>
-        </p:txBody>
-      </p:sp>
-      <p:sp>
-        <p:nvSpPr>
-          <p:cNvPr id="5" name="Shape 3"/>
-          <p:cNvSpPr/>
-          <p:nvPr/>
-        </p:nvSpPr>
-        <p:spPr>
-          <a:xfrm>
-            <a:off x="952500" y="2388468"/>
-            <a:ext cx="8058150" cy="3292004"/>
-          </a:xfrm>
-          <a:prstGeom prst="roundRect">
-            <a:avLst>
-              <a:gd name="adj" fmla="val 3472"/>
-            </a:avLst>
-          </a:prstGeom>
-          <a:solidFill>
-            <a:srgbClr val="E6F5EF"/>
-          </a:solidFill>
-          <a:ln/>
-        </p:spPr>
-        <p:txBody>
-          <a:bodyPr/>
-          <a:lstStyle/>
-          <a:p>
-            <a:endParaRPr lang="en-GB"/>
-          </a:p>
-        </p:txBody>
-      </p:sp>
-      <p:sp>
-        <p:nvSpPr>
-          <p:cNvPr id="6" name="Text 4"/>
-          <p:cNvSpPr/>
-          <p:nvPr/>
-        </p:nvSpPr>
-        <p:spPr>
-          <a:xfrm>
-            <a:off x="1314450" y="2712318"/>
-            <a:ext cx="8067675" cy="295275"/>
-          </a:xfrm>
-          <a:prstGeom prst="rect">
-            <a:avLst/>
-          </a:prstGeom>
-          <a:noFill/>
-          <a:ln/>
-        </p:spPr>
-        <p:txBody>
-          <a:bodyPr wrap="square" lIns="25400" tIns="25400" rIns="25400" bIns="25400" rtlCol="0" anchor="t">
-            <a:normAutofit fontScale="92500" lnSpcReduction="10000"/>
-          </a:bodyPr>
-          <a:lstStyle/>
-          <a:p>
-            <a:pPr marL="0" indent="0" algn="l">
-              <a:buNone/>
-            </a:pPr>
-            <a:r>
-              <a:rPr lang="en-US" sz="1800" dirty="0">
-                <a:solidFill>
-                  <a:srgbClr val="007A33"/>
-                </a:solidFill>
-                <a:latin typeface="Courier New" pitchFamily="34" charset="0"/>
-                <a:ea typeface="Courier New" pitchFamily="34" charset="-122"/>
-                <a:cs typeface="Courier New" pitchFamily="34" charset="-120"/>
-              </a:rPr>
-              <a:t>01</a:t>
-            </a:r>
-            <a:endParaRPr lang="en-US" sz="1800" dirty="0"/>
-          </a:p>
-        </p:txBody>
-      </p:sp>
-      <p:sp>
-        <p:nvSpPr>
-          <p:cNvPr id="7" name="Text 5"/>
-          <p:cNvSpPr/>
-          <p:nvPr/>
-        </p:nvSpPr>
-        <p:spPr>
-          <a:xfrm>
-            <a:off x="1314450" y="3102843"/>
-            <a:ext cx="8067675" cy="409575"/>
-          </a:xfrm>
-          <a:prstGeom prst="rect">
-            <a:avLst/>
-          </a:prstGeom>
-          <a:noFill/>
-          <a:ln/>
-        </p:spPr>
-        <p:txBody>
-          <a:bodyPr wrap="square" lIns="25400" tIns="25400" rIns="25400" bIns="25400" rtlCol="0" anchor="t">
-            <a:normAutofit lnSpcReduction="10000"/>
-          </a:bodyPr>
-          <a:lstStyle/>
-          <a:p>
-            <a:pPr marL="0" indent="0" algn="l">
-              <a:buNone/>
-            </a:pPr>
-            <a:r>
-              <a:rPr lang="en-US" sz="2400" b="1" dirty="0">
-                <a:solidFill>
-                  <a:srgbClr val="063D22"/>
-                </a:solidFill>
-                <a:latin typeface="Arial" pitchFamily="34" charset="0"/>
-                <a:ea typeface="Arial" pitchFamily="34" charset="-122"/>
-                <a:cs typeface="Arial" pitchFamily="34" charset="-120"/>
-              </a:rPr>
-              <a:t>Optimize for cost, not accuracy</a:t>
-            </a:r>
-            <a:endParaRPr lang="en-US" sz="2400" dirty="0"/>
-          </a:p>
-        </p:txBody>
-      </p:sp>
-      <p:sp>
-        <p:nvSpPr>
-          <p:cNvPr id="8" name="Text 6"/>
-          <p:cNvSpPr/>
-          <p:nvPr/>
-        </p:nvSpPr>
-        <p:spPr>
-          <a:xfrm>
-            <a:off x="1314450" y="3569568"/>
-            <a:ext cx="7554278" cy="756196"/>
-          </a:xfrm>
-          <a:prstGeom prst="rect">
-            <a:avLst/>
-          </a:prstGeom>
-          <a:noFill/>
-          <a:ln/>
-        </p:spPr>
-        <p:txBody>
-          <a:bodyPr wrap="square" lIns="25400" tIns="25400" rIns="25400" bIns="25400" rtlCol="0" anchor="t">
-            <a:normAutofit fontScale="92500" lnSpcReduction="20000"/>
-          </a:bodyPr>
-          <a:lstStyle/>
-          <a:p>
-            <a:pPr marL="0" indent="0" algn="l">
-              <a:lnSpc>
-                <a:spcPct val="145000"/>
-              </a:lnSpc>
-              <a:buNone/>
-            </a:pPr>
-            <a:r>
-              <a:rPr lang="en-US" sz="1950" dirty="0">
-                <a:solidFill>
-                  <a:srgbClr val="5C7268"/>
-                </a:solidFill>
-                <a:latin typeface="Arial" pitchFamily="34" charset="0"/>
-                <a:ea typeface="Arial" pitchFamily="34" charset="-122"/>
-                <a:cs typeface="Arial" pitchFamily="34" charset="-120"/>
-              </a:rPr>
-              <a:t>A default loses the whole loan; a wrong rejection loses only some interest — so tune the cutoff to minimise expected € loss, not the error count.</a:t>
-            </a:r>
-            <a:endParaRPr lang="en-US" sz="1950" dirty="0"/>
-          </a:p>
-        </p:txBody>
-      </p:sp>
-      <p:sp>
-        <p:nvSpPr>
-          <p:cNvPr id="9" name="Shape 7"/>
-          <p:cNvSpPr/>
-          <p:nvPr/>
-        </p:nvSpPr>
-        <p:spPr>
-          <a:xfrm>
-            <a:off x="9277350" y="2388468"/>
-            <a:ext cx="8058150" cy="3292004"/>
-          </a:xfrm>
-          <a:prstGeom prst="roundRect">
-            <a:avLst>
-              <a:gd name="adj" fmla="val 3472"/>
-            </a:avLst>
-          </a:prstGeom>
-          <a:solidFill>
-            <a:srgbClr val="E6F5EF"/>
-          </a:solidFill>
-          <a:ln/>
-        </p:spPr>
-        <p:txBody>
-          <a:bodyPr/>
-          <a:lstStyle/>
-          <a:p>
-            <a:endParaRPr lang="en-GB"/>
-          </a:p>
-        </p:txBody>
-      </p:sp>
-      <p:sp>
-        <p:nvSpPr>
-          <p:cNvPr id="10" name="Text 8"/>
-          <p:cNvSpPr/>
-          <p:nvPr/>
-        </p:nvSpPr>
-        <p:spPr>
-          <a:xfrm>
-            <a:off x="9639300" y="2712318"/>
-            <a:ext cx="8067675" cy="295275"/>
-          </a:xfrm>
-          <a:prstGeom prst="rect">
-            <a:avLst/>
-          </a:prstGeom>
-          <a:noFill/>
-          <a:ln/>
-        </p:spPr>
-        <p:txBody>
-          <a:bodyPr wrap="square" lIns="25400" tIns="25400" rIns="25400" bIns="25400" rtlCol="0" anchor="t">
-            <a:normAutofit fontScale="92500" lnSpcReduction="10000"/>
-          </a:bodyPr>
-          <a:lstStyle/>
-          <a:p>
-            <a:pPr marL="0" indent="0" algn="l">
-              <a:buNone/>
-            </a:pPr>
-            <a:r>
-              <a:rPr lang="en-US" sz="1800" dirty="0">
-                <a:solidFill>
-                  <a:srgbClr val="007A33"/>
-                </a:solidFill>
-                <a:latin typeface="Courier New" pitchFamily="34" charset="0"/>
-                <a:ea typeface="Courier New" pitchFamily="34" charset="-122"/>
-                <a:cs typeface="Courier New" pitchFamily="34" charset="-120"/>
-              </a:rPr>
-              <a:t>02</a:t>
-            </a:r>
-            <a:endParaRPr lang="en-US" sz="1800" dirty="0"/>
-          </a:p>
-        </p:txBody>
-      </p:sp>
-      <p:sp>
-        <p:nvSpPr>
-          <p:cNvPr id="11" name="Text 9"/>
-          <p:cNvSpPr/>
-          <p:nvPr/>
-        </p:nvSpPr>
-        <p:spPr>
-          <a:xfrm>
-            <a:off x="9639300" y="3102843"/>
-            <a:ext cx="8067675" cy="409575"/>
-          </a:xfrm>
-          <a:prstGeom prst="rect">
-            <a:avLst/>
-          </a:prstGeom>
-          <a:noFill/>
-          <a:ln/>
-        </p:spPr>
-        <p:txBody>
-          <a:bodyPr wrap="square" lIns="25400" tIns="25400" rIns="25400" bIns="25400" rtlCol="0" anchor="t">
-            <a:normAutofit lnSpcReduction="10000"/>
-          </a:bodyPr>
-          <a:lstStyle/>
-          <a:p>
-            <a:pPr marL="0" indent="0" algn="l">
-              <a:buNone/>
-            </a:pPr>
-            <a:r>
-              <a:rPr lang="en-US" sz="2400" b="1" dirty="0">
-                <a:solidFill>
-                  <a:srgbClr val="063D22"/>
-                </a:solidFill>
-                <a:latin typeface="Arial" pitchFamily="34" charset="0"/>
-                <a:ea typeface="Arial" pitchFamily="34" charset="-122"/>
-                <a:cs typeface="Arial" pitchFamily="34" charset="-120"/>
-              </a:rPr>
-              <a:t>Calibrate the probabilities</a:t>
-            </a:r>
-            <a:endParaRPr lang="en-US" sz="2400" dirty="0"/>
-          </a:p>
-        </p:txBody>
-      </p:sp>
-      <p:sp>
-        <p:nvSpPr>
-          <p:cNvPr id="12" name="Text 10"/>
-          <p:cNvSpPr/>
-          <p:nvPr/>
-        </p:nvSpPr>
-        <p:spPr>
-          <a:xfrm>
-            <a:off x="9639300" y="3569568"/>
-            <a:ext cx="7554278" cy="756196"/>
-          </a:xfrm>
-          <a:prstGeom prst="rect">
-            <a:avLst/>
-          </a:prstGeom>
-          <a:noFill/>
-          <a:ln/>
-        </p:spPr>
-        <p:txBody>
-          <a:bodyPr wrap="square" lIns="25400" tIns="25400" rIns="25400" bIns="25400" rtlCol="0" anchor="t">
-            <a:normAutofit fontScale="92500" lnSpcReduction="20000"/>
-          </a:bodyPr>
-          <a:lstStyle/>
-          <a:p>
-            <a:pPr marL="0" indent="0" algn="l">
-              <a:lnSpc>
-                <a:spcPct val="145000"/>
-              </a:lnSpc>
-              <a:buNone/>
-            </a:pPr>
-            <a:r>
-              <a:rPr lang="en-US" sz="1950" dirty="0">
-                <a:solidFill>
-                  <a:srgbClr val="5C7268"/>
-                </a:solidFill>
-                <a:latin typeface="Arial" pitchFamily="34" charset="0"/>
-                <a:ea typeface="Arial" pitchFamily="34" charset="-122"/>
-                <a:cs typeface="Arial" pitchFamily="34" charset="-120"/>
-              </a:rPr>
-              <a:t>Our cutoff gives a yes/no, but the score isn't a true probability. Calibrate it so a lender can price loans and hold capital on a real default rate.</a:t>
-            </a:r>
-            <a:endParaRPr lang="en-US" sz="1950" dirty="0"/>
-          </a:p>
-        </p:txBody>
-      </p:sp>
-      <p:sp>
-        <p:nvSpPr>
-          <p:cNvPr id="13" name="Shape 11"/>
-          <p:cNvSpPr/>
-          <p:nvPr/>
-        </p:nvSpPr>
-        <p:spPr>
-          <a:xfrm>
-            <a:off x="952500" y="5947172"/>
-            <a:ext cx="8058150" cy="3292078"/>
-          </a:xfrm>
-          <a:prstGeom prst="roundRect">
-            <a:avLst>
-              <a:gd name="adj" fmla="val 3472"/>
-            </a:avLst>
-          </a:prstGeom>
-          <a:solidFill>
-            <a:srgbClr val="E6F5EF"/>
-          </a:solidFill>
-          <a:ln/>
-        </p:spPr>
-        <p:txBody>
-          <a:bodyPr/>
-          <a:lstStyle/>
-          <a:p>
-            <a:endParaRPr lang="en-GB"/>
-          </a:p>
-        </p:txBody>
-      </p:sp>
-      <p:sp>
-        <p:nvSpPr>
-          <p:cNvPr id="14" name="Text 12"/>
-          <p:cNvSpPr/>
-          <p:nvPr/>
-        </p:nvSpPr>
-        <p:spPr>
-          <a:xfrm>
-            <a:off x="1314450" y="6271022"/>
-            <a:ext cx="8067675" cy="295275"/>
-          </a:xfrm>
-          <a:prstGeom prst="rect">
-            <a:avLst/>
-          </a:prstGeom>
-          <a:noFill/>
-          <a:ln/>
-        </p:spPr>
-        <p:txBody>
-          <a:bodyPr wrap="square" lIns="25400" tIns="25400" rIns="25400" bIns="25400" rtlCol="0" anchor="t">
-            <a:normAutofit fontScale="92500" lnSpcReduction="10000"/>
-          </a:bodyPr>
-          <a:lstStyle/>
-          <a:p>
-            <a:pPr marL="0" indent="0" algn="l">
-              <a:buNone/>
-            </a:pPr>
-            <a:r>
-              <a:rPr lang="en-US" sz="1800" dirty="0">
-                <a:solidFill>
-                  <a:srgbClr val="007A33"/>
-                </a:solidFill>
-                <a:latin typeface="Courier New" pitchFamily="34" charset="0"/>
-                <a:ea typeface="Courier New" pitchFamily="34" charset="-122"/>
-                <a:cs typeface="Courier New" pitchFamily="34" charset="-120"/>
-              </a:rPr>
-              <a:t>03</a:t>
-            </a:r>
-            <a:endParaRPr lang="en-US" sz="1800" dirty="0"/>
-          </a:p>
-        </p:txBody>
-      </p:sp>
-      <p:sp>
-        <p:nvSpPr>
-          <p:cNvPr id="15" name="Text 13"/>
-          <p:cNvSpPr/>
-          <p:nvPr/>
-        </p:nvSpPr>
-        <p:spPr>
-          <a:xfrm>
-            <a:off x="1314450" y="6661547"/>
-            <a:ext cx="8067675" cy="409575"/>
-          </a:xfrm>
-          <a:prstGeom prst="rect">
-            <a:avLst/>
-          </a:prstGeom>
-          <a:noFill/>
-          <a:ln/>
-        </p:spPr>
-        <p:txBody>
-          <a:bodyPr wrap="square" lIns="25400" tIns="25400" rIns="25400" bIns="25400" rtlCol="0" anchor="t">
-            <a:normAutofit lnSpcReduction="10000"/>
-          </a:bodyPr>
-          <a:lstStyle/>
-          <a:p>
-            <a:pPr marL="0" indent="0" algn="l">
-              <a:buNone/>
-            </a:pPr>
-            <a:r>
-              <a:rPr lang="en-US" sz="2400" b="1" dirty="0">
-                <a:solidFill>
-                  <a:srgbClr val="063D22"/>
-                </a:solidFill>
-                <a:latin typeface="Arial" pitchFamily="34" charset="0"/>
-                <a:ea typeface="Arial" pitchFamily="34" charset="-122"/>
-                <a:cs typeface="Arial" pitchFamily="34" charset="-120"/>
-              </a:rPr>
-              <a:t>Give every decision a reason</a:t>
-            </a:r>
-            <a:endParaRPr lang="en-US" sz="2400" dirty="0"/>
-          </a:p>
-        </p:txBody>
-      </p:sp>
-      <p:sp>
-        <p:nvSpPr>
-          <p:cNvPr id="16" name="Text 14"/>
-          <p:cNvSpPr/>
-          <p:nvPr/>
-        </p:nvSpPr>
-        <p:spPr>
-          <a:xfrm>
-            <a:off x="1314450" y="7128272"/>
-            <a:ext cx="7554278" cy="756196"/>
-          </a:xfrm>
-          <a:prstGeom prst="rect">
-            <a:avLst/>
-          </a:prstGeom>
-          <a:noFill/>
-          <a:ln/>
-        </p:spPr>
-        <p:txBody>
-          <a:bodyPr wrap="square" lIns="25400" tIns="25400" rIns="25400" bIns="25400" rtlCol="0" anchor="t">
-            <a:normAutofit fontScale="92500" lnSpcReduction="20000"/>
-          </a:bodyPr>
-          <a:lstStyle/>
-          <a:p>
-            <a:pPr marL="0" indent="0" algn="l">
-              <a:lnSpc>
-                <a:spcPct val="145000"/>
-              </a:lnSpc>
-              <a:buNone/>
-            </a:pPr>
-            <a:r>
-              <a:rPr lang="en-US" sz="1950" dirty="0">
-                <a:solidFill>
-                  <a:srgbClr val="5C7268"/>
-                </a:solidFill>
-                <a:latin typeface="Arial" pitchFamily="34" charset="0"/>
-                <a:ea typeface="Arial" pitchFamily="34" charset="-122"/>
-                <a:cs typeface="Arial" pitchFamily="34" charset="-120"/>
-              </a:rPr>
-              <a:t>ECOA law requires telling a rejected applicant why. Add a per-decision explanation (SHAP) so every call is transparent and contestable.</a:t>
-            </a:r>
-            <a:endParaRPr lang="en-US" sz="1950" dirty="0"/>
-          </a:p>
-        </p:txBody>
-      </p:sp>
-      <p:sp>
-        <p:nvSpPr>
-          <p:cNvPr id="17" name="Shape 15"/>
-          <p:cNvSpPr/>
-          <p:nvPr/>
-        </p:nvSpPr>
-        <p:spPr>
-          <a:xfrm>
-            <a:off x="9277350" y="5947172"/>
-            <a:ext cx="8058150" cy="3292078"/>
-          </a:xfrm>
-          <a:prstGeom prst="roundRect">
-            <a:avLst>
-              <a:gd name="adj" fmla="val 3472"/>
-            </a:avLst>
-          </a:prstGeom>
-          <a:solidFill>
-            <a:srgbClr val="E6F5EF"/>
-          </a:solidFill>
-          <a:ln/>
-        </p:spPr>
-        <p:txBody>
-          <a:bodyPr/>
-          <a:lstStyle/>
-          <a:p>
-            <a:endParaRPr lang="en-GB"/>
-          </a:p>
-        </p:txBody>
-      </p:sp>
-      <p:sp>
-        <p:nvSpPr>
-          <p:cNvPr id="18" name="Text 16"/>
-          <p:cNvSpPr/>
-          <p:nvPr/>
-        </p:nvSpPr>
-        <p:spPr>
-          <a:xfrm>
-            <a:off x="9639300" y="6271022"/>
-            <a:ext cx="8067675" cy="295275"/>
-          </a:xfrm>
-          <a:prstGeom prst="rect">
-            <a:avLst/>
-          </a:prstGeom>
-          <a:noFill/>
-          <a:ln/>
-        </p:spPr>
-        <p:txBody>
-          <a:bodyPr wrap="square" lIns="25400" tIns="25400" rIns="25400" bIns="25400" rtlCol="0" anchor="t">
-            <a:normAutofit fontScale="92500" lnSpcReduction="10000"/>
-          </a:bodyPr>
-          <a:lstStyle/>
-          <a:p>
-            <a:pPr marL="0" indent="0" algn="l">
-              <a:buNone/>
-            </a:pPr>
-            <a:r>
-              <a:rPr lang="en-US" sz="1800" dirty="0">
-                <a:solidFill>
-                  <a:srgbClr val="007A33"/>
-                </a:solidFill>
-                <a:latin typeface="Courier New" pitchFamily="34" charset="0"/>
-                <a:ea typeface="Courier New" pitchFamily="34" charset="-122"/>
-                <a:cs typeface="Courier New" pitchFamily="34" charset="-120"/>
-              </a:rPr>
-              <a:t>04</a:t>
-            </a:r>
-            <a:endParaRPr lang="en-US" sz="1800" dirty="0"/>
-          </a:p>
-        </p:txBody>
-      </p:sp>
-      <p:sp>
-        <p:nvSpPr>
-          <p:cNvPr id="19" name="Text 17"/>
-          <p:cNvSpPr/>
-          <p:nvPr/>
-        </p:nvSpPr>
-        <p:spPr>
-          <a:xfrm>
-            <a:off x="9639300" y="6661547"/>
-            <a:ext cx="8067675" cy="409575"/>
-          </a:xfrm>
-          <a:prstGeom prst="rect">
-            <a:avLst/>
-          </a:prstGeom>
-          <a:noFill/>
-          <a:ln/>
-        </p:spPr>
-        <p:txBody>
-          <a:bodyPr wrap="square" lIns="25400" tIns="25400" rIns="25400" bIns="25400" rtlCol="0" anchor="t">
-            <a:normAutofit lnSpcReduction="10000"/>
-          </a:bodyPr>
-          <a:lstStyle/>
-          <a:p>
-            <a:pPr marL="0" indent="0" algn="l">
-              <a:buNone/>
-            </a:pPr>
-            <a:r>
-              <a:rPr lang="en-US" sz="2400" b="1" dirty="0">
-                <a:solidFill>
-                  <a:srgbClr val="063D22"/>
-                </a:solidFill>
-                <a:latin typeface="Arial" pitchFamily="34" charset="0"/>
-                <a:ea typeface="Arial" pitchFamily="34" charset="-122"/>
-                <a:cs typeface="Arial" pitchFamily="34" charset="-120"/>
-              </a:rPr>
-              <a:t>Monitor drift and bias</a:t>
-            </a:r>
-            <a:endParaRPr lang="en-US" sz="2400" dirty="0"/>
-          </a:p>
-        </p:txBody>
-      </p:sp>
-      <p:sp>
-        <p:nvSpPr>
-          <p:cNvPr id="20" name="Text 18"/>
-          <p:cNvSpPr/>
-          <p:nvPr/>
-        </p:nvSpPr>
-        <p:spPr>
-          <a:xfrm>
-            <a:off x="9639300" y="7128272"/>
-            <a:ext cx="7554278" cy="756196"/>
-          </a:xfrm>
-          <a:prstGeom prst="rect">
-            <a:avLst/>
-          </a:prstGeom>
-          <a:noFill/>
-          <a:ln/>
-        </p:spPr>
-        <p:txBody>
-          <a:bodyPr wrap="square" lIns="25400" tIns="25400" rIns="25400" bIns="25400" rtlCol="0" anchor="t">
-            <a:normAutofit fontScale="92500" lnSpcReduction="20000"/>
-          </a:bodyPr>
-          <a:lstStyle/>
-          <a:p>
-            <a:pPr marL="0" indent="0" algn="l">
-              <a:lnSpc>
-                <a:spcPct val="145000"/>
-              </a:lnSpc>
-              <a:buNone/>
-            </a:pPr>
-            <a:r>
-              <a:rPr lang="en-US" sz="1950" dirty="0">
-                <a:solidFill>
-                  <a:srgbClr val="5C7268"/>
-                </a:solidFill>
-                <a:latin typeface="Arial" pitchFamily="34" charset="0"/>
-                <a:ea typeface="Arial" pitchFamily="34" charset="-122"/>
-                <a:cs typeface="Arial" pitchFamily="34" charset="-120"/>
-              </a:rPr>
-              <a:t>Approval rates drifted down over the years — track live performance and retrain on schedule, and keep auditing for proxy bias since we dropped race &amp; religion.</a:t>
-            </a:r>
-            <a:endParaRPr lang="en-US" sz="1950" dirty="0"/>
-          </a:p>
-        </p:txBody>
-      </p:sp>
-      <p:sp>
-        <p:nvSpPr>
-          <p:cNvPr id="21" name="Shape 19"/>
-          <p:cNvSpPr/>
-          <p:nvPr/>
-        </p:nvSpPr>
-        <p:spPr>
-          <a:xfrm>
-            <a:off x="952500" y="9239250"/>
-            <a:ext cx="16383000" cy="9525"/>
-          </a:xfrm>
-          <a:prstGeom prst="rect">
-            <a:avLst/>
-          </a:prstGeom>
-          <a:solidFill>
-            <a:srgbClr val="D2E6DD"/>
-          </a:solidFill>
-          <a:ln/>
-        </p:spPr>
-        <p:txBody>
-          <a:bodyPr/>
-          <a:lstStyle/>
-          <a:p>
-            <a:endParaRPr lang="en-GB"/>
-          </a:p>
-        </p:txBody>
-      </p:sp>
-      <p:sp>
-        <p:nvSpPr>
-          <p:cNvPr id="22" name="Text 20"/>
-          <p:cNvSpPr/>
-          <p:nvPr/>
-        </p:nvSpPr>
-        <p:spPr>
-          <a:xfrm>
-            <a:off x="952500" y="9458325"/>
-            <a:ext cx="16874490" cy="295275"/>
-          </a:xfrm>
-          <a:prstGeom prst="rect">
-            <a:avLst/>
-          </a:prstGeom>
-          <a:noFill/>
-          <a:ln/>
-        </p:spPr>
-        <p:txBody>
-          <a:bodyPr wrap="square" lIns="25400" tIns="25400" rIns="25400" bIns="25400" rtlCol="0" anchor="t">
-            <a:normAutofit fontScale="92500" lnSpcReduction="10000"/>
-          </a:bodyPr>
-          <a:lstStyle/>
-          <a:p>
-            <a:pPr marL="0" indent="0" algn="l">
-              <a:buNone/>
-            </a:pPr>
-            <a:r>
-              <a:rPr lang="en-US" sz="1800" dirty="0">
-                <a:solidFill>
-                  <a:srgbClr val="5C7268"/>
-                </a:solidFill>
-                <a:latin typeface="Courier New" pitchFamily="34" charset="0"/>
-                <a:ea typeface="Courier New" pitchFamily="34" charset="-122"/>
-                <a:cs typeface="Courier New" pitchFamily="34" charset="-120"/>
-              </a:rPr>
-              <a:t>Source: team roadmap</a:t>
-            </a:r>
-            <a:endParaRPr lang="en-US" sz="1800" dirty="0"/>
-          </a:p>
-        </p:txBody>
-      </p:sp>
-    </p:spTree>
-  </p:cSld>
-  <p:clrMapOvr>
-    <a:masterClrMapping/>
-  </p:clrMapOvr>
-</p:sld>
-</file>
-
-<file path=ppt/slides/slide12.xml><?xml version="1.0" encoding="utf-8"?>
 <p:sld xmlns:a="http://schemas.openxmlformats.org/drawingml/2006/main" xmlns:r="http://schemas.openxmlformats.org/officeDocument/2006/relationships" xmlns:p="http://schemas.openxmlformats.org/presentationml/2006/main">
   <p:cSld>
     <p:spTree>
@@ -5097,7 +4177,7 @@
 </p:sld>
 </file>
 
-<file path=ppt/slides/slide13.xml><?xml version="1.0" encoding="utf-8"?>
+<file path=ppt/slides/slide12.xml><?xml version="1.0" encoding="utf-8"?>
 <p:sld xmlns:a="http://schemas.openxmlformats.org/drawingml/2006/main" xmlns:r="http://schemas.openxmlformats.org/officeDocument/2006/relationships" xmlns:p="http://schemas.openxmlformats.org/presentationml/2006/main">
   <p:cSld name="Slide 12">
     <p:bg>

</xml_diff>

<commit_message>
Remove all em dashes from the deck (replaced 30 with hyphens)
</commit_message>
<xml_diff>
--- a/presentation/Consulting_Finance_ML_Slides.pptx
+++ b/presentation/Consulting_Finance_ML_Slides.pptx
@@ -1490,7 +1490,7 @@
                 <a:ea typeface="Courier New" pitchFamily="34" charset="-122"/>
                 <a:cs typeface="Courier New" pitchFamily="34" charset="-120"/>
               </a:rPr>
-              <a:t>ESADE — DATA SCIENCE FOR FINANCE · 2026</a:t>
+              <a:t>ESADE - DATA SCIENCE FOR FINANCE · 2026</a:t>
             </a:r>
             <a:endParaRPr lang="en-US" sz="1800" dirty="0"/>
           </a:p>
@@ -1575,7 +1575,7 @@
                 <a:ea typeface="Arial" pitchFamily="34" charset="-122"/>
                 <a:cs typeface="Arial" pitchFamily="34" charset="-120"/>
               </a:rPr>
-              <a:t>Teaching a model to make the same call a bank’s credit analyst would — using data that was deliberately messy.</a:t>
+              <a:t>Teaching a model to make the same call a bank’s credit analyst would - using data that was deliberately messy.</a:t>
             </a:r>
             <a:endParaRPr lang="en-US" sz="2550" dirty="0"/>
           </a:p>
@@ -1619,7 +1619,7 @@
                 <a:ea typeface="Arial" pitchFamily="34" charset="-122"/>
                 <a:cs typeface="Arial" pitchFamily="34" charset="-120"/>
               </a:rPr>
-              <a:t>Built clean — we caught the planted data trap and used no race or religion data.</a:t>
+              <a:t>Built clean - we caught the planted data trap and used no race or religion data.</a:t>
             </a:r>
             <a:endParaRPr lang="en-US" sz="2100" dirty="0"/>
           </a:p>
@@ -1916,7 +1916,7 @@
                 <a:ea typeface="Courier New" pitchFamily="34" charset="-122"/>
                 <a:cs typeface="Courier New" pitchFamily="34" charset="-120"/>
               </a:rPr>
-              <a:t>FINAL SUBMISSIONS SELECTED — v6 + v10</a:t>
+              <a:t>FINAL SUBMISSIONS SELECTED - v6 + v10</a:t>
             </a:r>
             <a:endParaRPr lang="en-US" sz="1800" dirty="0"/>
           </a:p>
@@ -3280,7 +3280,7 @@
                 <a:ea typeface="Arial" pitchFamily="34" charset="-122"/>
                 <a:cs typeface="Arial" pitchFamily="34" charset="-120"/>
               </a:rPr>
-              <a:t>0.8565 public accuracy — no leak, no protected attributes.</a:t>
+              <a:t>0.8565 public accuracy - no leak, no protected attributes.</a:t>
             </a:r>
             <a:endParaRPr lang="en-US" sz="2250" dirty="0"/>
           </a:p>
@@ -3324,7 +3324,7 @@
                 <a:ea typeface="Arial" pitchFamily="34" charset="-122"/>
                 <a:cs typeface="Arial" pitchFamily="34" charset="-120"/>
               </a:rPr>
-              <a:t>Our held-back validation tracked just above the live score the whole way — it </a:t>
+              <a:t>Our held-back validation tracked just above the live score the whole way - it </a:t>
             </a:r>
             <a:r>
               <a:rPr lang="en-US" sz="2025" b="1" dirty="0">
@@ -3821,7 +3821,7 @@
                 </a:solidFill>
                 <a:latin typeface="Arial"/>
               </a:rPr>
-              <a:t>The column that predicts in training is random noise in test — proof it was scrambled on purpose.</a:t>
+              <a:t>The column that predicts in training is random noise in test - proof it was scrambled on purpose.</a:t>
             </a:r>
           </a:p>
         </p:txBody>
@@ -5652,7 +5652,7 @@
                 <a:ea typeface="Arial" pitchFamily="34" charset="-122"/>
                 <a:cs typeface="Arial" pitchFamily="34" charset="-120"/>
               </a:rPr>
-              <a:t>It learns the bank’s existing policy — so it must also avoid copying the analysts’ bias (see slide 7).</a:t>
+              <a:t>It learns the bank’s existing policy - so it must also avoid copying the analysts’ bias (see slide 7).</a:t>
             </a:r>
             <a:endParaRPr lang="en-US" sz="1950" dirty="0"/>
           </a:p>
@@ -6671,7 +6671,7 @@
                 <a:ea typeface="Arial" pitchFamily="34" charset="-122"/>
                 <a:cs typeface="Arial" pitchFamily="34" charset="-120"/>
               </a:rPr>
-              <a:t>The data was deliberately rigged — so we hunted for traps before modeling</a:t>
+              <a:t>The data was deliberately rigged - so we hunted for traps before modeling</a:t>
             </a:r>
             <a:endParaRPr lang="en-US" sz="3600" dirty="0"/>
           </a:p>
@@ -6734,7 +6734,7 @@
                 <a:ea typeface="Courier New" pitchFamily="34" charset="-122"/>
                 <a:cs typeface="Courier New" pitchFamily="34" charset="-120"/>
               </a:rPr>
-              <a:t>— promise vs reality</a:t>
+              <a:t>- promise vs reality</a:t>
             </a:r>
             <a:endParaRPr lang="en-US" sz="1800" dirty="0"/>
           </a:p>
@@ -6822,7 +6822,7 @@
                 <a:ea typeface="Arial" pitchFamily="34" charset="-122"/>
                 <a:cs typeface="Arial" pitchFamily="34" charset="-120"/>
               </a:rPr>
-              <a:t>— it was scrambled on purpose. </a:t>
+              <a:t>- it was scrambled on purpose. </a:t>
             </a:r>
             <a:r>
               <a:rPr lang="en-US" sz="2175" b="1" dirty="0">
@@ -6985,7 +6985,7 @@
                 <a:ea typeface="Arial" pitchFamily="34" charset="-122"/>
                 <a:cs typeface="Arial" pitchFamily="34" charset="-120"/>
               </a:rPr>
-              <a:t>Hidden leak — the “perfect” column above</a:t>
+              <a:t>Hidden leak - the “perfect” column above</a:t>
             </a:r>
             <a:endParaRPr lang="en-US" sz="1950" dirty="0"/>
           </a:p>
@@ -7318,7 +7318,7 @@
                 <a:ea typeface="Arial" pitchFamily="34" charset="-122"/>
                 <a:cs typeface="Arial" pitchFamily="34" charset="-120"/>
               </a:rPr>
-              <a:t>Race &amp; religion — off-limits (slide 7)</a:t>
+              <a:t>Race &amp; religion - off-limits (slide 7)</a:t>
             </a:r>
             <a:endParaRPr lang="en-US" sz="1950" dirty="0"/>
           </a:p>
@@ -8377,7 +8377,7 @@
                 <a:ea typeface="Arial" pitchFamily="34" charset="-122"/>
                 <a:cs typeface="Arial" pitchFamily="34" charset="-120"/>
               </a:rPr>
-              <a:t>— </a:t>
+              <a:t>- </a:t>
             </a:r>
             <a:r>
               <a:rPr lang="en-US" sz="1800" dirty="0">
@@ -8443,7 +8443,7 @@
                 <a:ea typeface="Arial" pitchFamily="34" charset="-122"/>
                 <a:cs typeface="Arial" pitchFamily="34" charset="-120"/>
               </a:rPr>
-              <a:t>— so “value absent” becomes usable signal.</a:t>
+              <a:t>- so “value absent” becomes usable signal.</a:t>
             </a:r>
             <a:endParaRPr lang="en-US" sz="2025" dirty="0"/>
           </a:p>
@@ -8509,7 +8509,7 @@
                 <a:ea typeface="Arial" pitchFamily="34" charset="-122"/>
                 <a:cs typeface="Arial" pitchFamily="34" charset="-120"/>
               </a:rPr>
-              <a:t>(no test leakage) — the correct, leak-free choice; for tree models the accuracy effect is ~0.</a:t>
+              <a:t>(no test leakage) - the correct, leak-free choice; for tree models the accuracy effect is ~0.</a:t>
             </a:r>
             <a:endParaRPr lang="en-US" sz="1800" dirty="0"/>
           </a:p>
@@ -8922,7 +8922,7 @@
                 <a:ea typeface="Arial" pitchFamily="34" charset="-122"/>
                 <a:cs typeface="Arial" pitchFamily="34" charset="-120"/>
               </a:rPr>
-              <a:t>The free text is really 60 fixed comments in three tiers — no fancy text analysis needed.</a:t>
+              <a:t>The free text is really 60 fixed comments in three tiers - no fancy text analysis needed.</a:t>
             </a:r>
             <a:endParaRPr lang="en-US" sz="1875" dirty="0"/>
           </a:p>
@@ -9369,7 +9369,7 @@
                 <a:ea typeface="Arial" pitchFamily="34" charset="-122"/>
                 <a:cs typeface="Arial" pitchFamily="34" charset="-120"/>
               </a:rPr>
-              <a:t>Using race or religion would lift accuracy — we said no</a:t>
+              <a:t>Using race or religion would lift accuracy - we said no</a:t>
             </a:r>
             <a:endParaRPr lang="en-US" sz="3600" dirty="0"/>
           </a:p>
@@ -9726,7 +9726,7 @@
                 <a:ea typeface="Arial" pitchFamily="34" charset="-122"/>
                 <a:cs typeface="Arial" pitchFamily="34" charset="-120"/>
               </a:rPr>
-              <a:t>of accuracy — almost certainly enough for first place.</a:t>
+              <a:t>of accuracy - almost certainly enough for first place.</a:t>
             </a:r>
             <a:endParaRPr lang="en-US" sz="2250" dirty="0"/>
           </a:p>
@@ -9792,7 +9792,7 @@
                 <a:ea typeface="Arial" pitchFamily="34" charset="-122"/>
                 <a:cs typeface="Arial" pitchFamily="34" charset="-120"/>
               </a:rPr>
-              <a:t>, yet they change who gets approved — e.g. </a:t>
+              <a:t>, yet they change who gets approved - e.g. </a:t>
             </a:r>
             <a:r>
               <a:rPr lang="en-US" sz="2100" b="1" dirty="0">
@@ -9858,7 +9858,7 @@
                 <a:ea typeface="Arial" pitchFamily="34" charset="-122"/>
                 <a:cs typeface="Arial" pitchFamily="34" charset="-120"/>
               </a:rPr>
-              <a:t>So the gain isn’t better prediction. It’s discrimination — and it’s illegal. We left the points on the table.</a:t>
+              <a:t>So the gain isn’t better prediction. It’s discrimination - and it’s illegal. We left the points on the table.</a:t>
             </a:r>
             <a:endParaRPr lang="en-US" sz="2100" dirty="0"/>
           </a:p>
@@ -10445,7 +10445,7 @@
                 </a:solidFill>
                 <a:latin typeface="Arial"/>
               </a:rPr>
-              <a:t>What drives the model — top features by gain</a:t>
+              <a:t>What drives the model - top features by gain</a:t>
             </a:r>
           </a:p>
         </p:txBody>
@@ -10538,7 +10538,7 @@
                 </a:solidFill>
                 <a:latin typeface="Arial"/>
               </a:rPr>
-              <a:t>Different model families make different mistakes. Averaging their predictions cancels the random part of each model's error and leaves the genuine signal — so the ensemble beats any single model.</a:t>
+              <a:t>Different model families make different mistakes. Averaging their predictions cancels the random part of each model's error and leaves the genuine signal - so the ensemble beats any single model.</a:t>
             </a:r>
           </a:p>
         </p:txBody>
@@ -11129,7 +11129,7 @@
                 </a:solidFill>
                 <a:latin typeface="Arial"/>
               </a:rPr>
-              <a:t>Pseudo-labeling  —  learning from the new month</a:t>
+              <a:t>Pseudo-labeling  -  learning from the new month</a:t>
             </a:r>
           </a:p>
           <a:p>
@@ -11161,7 +11161,7 @@
                 </a:solidFill>
                 <a:latin typeface="Arial"/>
               </a:rPr>
-              <a:t>Kept safe — only very confident rows, down-weighted — and the gain is measured, not assumed:  +0.14 pt on rolling validation.</a:t>
+              <a:t>Kept safe - only very confident rows, down-weighted - and the gain is measured, not assumed:  +0.14 pt on rolling validation.</a:t>
             </a:r>
           </a:p>
         </p:txBody>
@@ -11667,7 +11667,7 @@
                           </a:solidFill>
                           <a:latin typeface="Arial"/>
                         </a:rPr>
-                        <a:t>One combined risk level — plus a flag when either source is high</a:t>
+                        <a:t>One combined risk level - plus a flag when either source is high</a:t>
                       </a:r>
                     </a:p>
                   </a:txBody>
@@ -11743,7 +11743,7 @@
                           </a:solidFill>
                           <a:latin typeface="Arial"/>
                         </a:rPr>
-                        <a:t>Approval peaks mid-scale and drops at both ends — this captures that hump</a:t>
+                        <a:t>Approval peaks mid-scale and drops at both ends - this captures that hump</a:t>
                       </a:r>
                     </a:p>
                   </a:txBody>
@@ -11819,7 +11819,7 @@
                           </a:solidFill>
                           <a:latin typeface="Arial"/>
                         </a:rPr>
-                        <a:t>Affordability — loan size vs. what they earn (a credit standard)</a:t>
+                        <a:t>Affordability - loan size vs. what they earn (a credit standard)</a:t>
                       </a:r>
                     </a:p>
                   </a:txBody>
@@ -11971,7 +11971,7 @@
                           </a:solidFill>
                           <a:latin typeface="Arial"/>
                         </a:rPr>
-                        <a:t>Each person has one score on a different scale — makes them comparable</a:t>
+                        <a:t>Each person has one score on a different scale - makes them comparable</a:t>
                       </a:r>
                     </a:p>
                   </a:txBody>

</xml_diff>

<commit_message>
Slide 10: add out-of-fold confusion matrix (deck palette)
Placed under the 0.8565 headline; trimmed the two right-column text notes to make room
(their points are carried by the title, graph, and slide 7). Shows balanced errors
(FP 1705 / FN 1920) at accuracy 0.855.
</commit_message>
<xml_diff>
--- a/presentation/Consulting_Finance_ML_Slides.pptx
+++ b/presentation/Consulting_Finance_ML_Slides.pptx
@@ -3203,113 +3203,6 @@
       </p:sp>
       <p:sp>
         <p:nvSpPr>
-          <p:cNvPr id="57" name="Text 55"/>
-          <p:cNvSpPr/>
-          <p:nvPr/>
-        </p:nvSpPr>
-        <p:spPr>
-          <a:xfrm>
-            <a:off x="11442509" y="6227666"/>
-            <a:ext cx="5978196" cy="733425"/>
-          </a:xfrm>
-          <a:prstGeom prst="rect">
-            <a:avLst/>
-          </a:prstGeom>
-          <a:noFill/>
-          <a:ln/>
-        </p:spPr>
-        <p:txBody>
-          <a:bodyPr wrap="square" lIns="25400" tIns="25400" rIns="25400" bIns="25400" rtlCol="0" anchor="t">
-            <a:normAutofit lnSpcReduction="10000"/>
-          </a:bodyPr>
-          <a:lstStyle/>
-          <a:p>
-            <a:pPr marL="0" indent="0" algn="l">
-              <a:buNone/>
-            </a:pPr>
-            <a:r>
-              <a:rPr lang="en-US" sz="2250" b="1" dirty="0">
-                <a:solidFill>
-                  <a:srgbClr val="063D22"/>
-                </a:solidFill>
-                <a:latin typeface="Arial" pitchFamily="34" charset="0"/>
-                <a:ea typeface="Arial" pitchFamily="34" charset="-122"/>
-                <a:cs typeface="Arial" pitchFamily="34" charset="-120"/>
-              </a:rPr>
-              <a:t>0.8565 public accuracy - no leak, no protected attributes.</a:t>
-            </a:r>
-            <a:endParaRPr lang="en-US" sz="2250" dirty="0"/>
-          </a:p>
-        </p:txBody>
-      </p:sp>
-      <p:sp>
-        <p:nvSpPr>
-          <p:cNvPr id="58" name="Text 56"/>
-          <p:cNvSpPr/>
-          <p:nvPr/>
-        </p:nvSpPr>
-        <p:spPr>
-          <a:xfrm>
-            <a:off x="11442509" y="7189691"/>
-            <a:ext cx="5978196" cy="1204913"/>
-          </a:xfrm>
-          <a:prstGeom prst="rect">
-            <a:avLst/>
-          </a:prstGeom>
-          <a:noFill/>
-          <a:ln/>
-        </p:spPr>
-        <p:txBody>
-          <a:bodyPr wrap="square" lIns="25400" tIns="25400" rIns="25400" bIns="25400" rtlCol="0" anchor="t">
-            <a:normAutofit fontScale="92500"/>
-          </a:bodyPr>
-          <a:lstStyle/>
-          <a:p>
-            <a:pPr marL="0" indent="0" algn="l">
-              <a:lnSpc>
-                <a:spcPct val="150000"/>
-              </a:lnSpc>
-              <a:buNone/>
-            </a:pPr>
-            <a:r>
-              <a:rPr lang="en-US" sz="2025" dirty="0">
-                <a:solidFill>
-                  <a:srgbClr val="244236"/>
-                </a:solidFill>
-                <a:latin typeface="Arial" pitchFamily="34" charset="0"/>
-                <a:ea typeface="Arial" pitchFamily="34" charset="-122"/>
-                <a:cs typeface="Arial" pitchFamily="34" charset="-120"/>
-              </a:rPr>
-              <a:t>Our held-back validation tracked just above the live score the whole way - it </a:t>
-            </a:r>
-            <a:r>
-              <a:rPr lang="en-US" sz="2025" b="1" dirty="0">
-                <a:solidFill>
-                  <a:srgbClr val="063D22"/>
-                </a:solidFill>
-                <a:latin typeface="Arial" pitchFamily="34" charset="0"/>
-                <a:ea typeface="Arial" pitchFamily="34" charset="-122"/>
-                <a:cs typeface="Arial" pitchFamily="34" charset="-120"/>
-              </a:rPr>
-              <a:t>called the result in advance </a:t>
-            </a:r>
-            <a:r>
-              <a:rPr lang="en-US" sz="2025" dirty="0">
-                <a:solidFill>
-                  <a:srgbClr val="244236"/>
-                </a:solidFill>
-                <a:latin typeface="Arial" pitchFamily="34" charset="0"/>
-                <a:ea typeface="Arial" pitchFamily="34" charset="-122"/>
-                <a:cs typeface="Arial" pitchFamily="34" charset="-120"/>
-              </a:rPr>
-              <a:t>.</a:t>
-            </a:r>
-            <a:endParaRPr lang="en-US" sz="2025" dirty="0"/>
-          </a:p>
-        </p:txBody>
-      </p:sp>
-      <p:sp>
-        <p:nvSpPr>
           <p:cNvPr id="60" name="Shape 58"/>
           <p:cNvSpPr/>
           <p:nvPr/>
@@ -3400,6 +3293,64 @@
           </a:prstGeom>
         </p:spPr>
       </p:pic>
+      <p:pic>
+        <p:nvPicPr>
+          <p:cNvPr id="63" name="Picture 62" descr="deck_confusion.png"/>
+          <p:cNvPicPr>
+            <a:picLocks noChangeAspect="1"/>
+          </p:cNvPicPr>
+          <p:nvPr/>
+        </p:nvPicPr>
+        <p:blipFill>
+          <a:blip r:embed="rId4"/>
+          <a:stretch>
+            <a:fillRect/>
+          </a:stretch>
+        </p:blipFill>
+        <p:spPr>
+          <a:xfrm>
+            <a:off x="11475720" y="6035040"/>
+            <a:ext cx="3611880" cy="3065578"/>
+          </a:xfrm>
+          <a:prstGeom prst="rect">
+            <a:avLst/>
+          </a:prstGeom>
+        </p:spPr>
+      </p:pic>
+      <p:sp>
+        <p:nvSpPr>
+          <p:cNvPr id="64" name="TextBox 63"/>
+          <p:cNvSpPr txBox="1"/>
+          <p:nvPr/>
+        </p:nvSpPr>
+        <p:spPr>
+          <a:xfrm>
+            <a:off x="11475720" y="9098280"/>
+            <a:ext cx="5852160" cy="365760"/>
+          </a:xfrm>
+          <a:prstGeom prst="rect">
+            <a:avLst/>
+          </a:prstGeom>
+          <a:noFill/>
+        </p:spPr>
+        <p:txBody>
+          <a:bodyPr wrap="none">
+            <a:spAutoFit/>
+          </a:bodyPr>
+          <a:lstStyle/>
+          <a:p>
+            <a:r>
+              <a:rPr sz="1300">
+                <a:solidFill>
+                  <a:srgbClr val="5C7268"/>
+                </a:solidFill>
+                <a:latin typeface="Arial"/>
+              </a:rPr>
+              <a:t>Errors are balanced - the model favours neither approve nor reject.</a:t>
+            </a:r>
+          </a:p>
+        </p:txBody>
+      </p:sp>
     </p:spTree>
   </p:cSld>
   <p:clrMapOvr>

</xml_diff>

<commit_message>
Slide 5: turn the run-on CLEAN & STANDARDISE text into a clean 5-bullet list
</commit_message>
<xml_diff>
--- a/presentation/Consulting_Finance_ML_Slides.pptx
+++ b/presentation/Consulting_Finance_ML_Slides.pptx
@@ -7869,20 +7869,85 @@
               <a:lnSpc>
                 <a:spcPct val="155000"/>
               </a:lnSpc>
-              <a:buNone/>
-            </a:pPr>
-            <a:r>
-              <a:rPr lang="en-US" sz="1875" dirty="0">
+              <a:spcAft>
+                <a:spcPts val="600"/>
+              </a:spcAft>
+              <a:buNone/>
+            </a:pPr>
+            <a:r>
+              <a:rPr sz="1600">
                 <a:solidFill>
                   <a:srgbClr val="244236"/>
                 </a:solidFill>
-                <a:latin typeface="Arial" pitchFamily="34" charset="0"/>
-                <a:ea typeface="Arial" pitchFamily="34" charset="-122"/>
-                <a:cs typeface="Arial" pitchFamily="34" charset="-120"/>
-              </a:rPr>
-              <a:t>Fix mixed units · parse two date formats Unify yes/no codes · z-score credit scores (train-only stats) Add missingness flags</a:t>
+                <a:latin typeface="Arial"/>
+              </a:rPr>
+              <a:t>•  Fix mixed-unit incomes</a:t>
             </a:r>
             <a:endParaRPr lang="en-US" sz="1875" dirty="0"/>
+          </a:p>
+          <a:p>
+            <a:pPr algn="l">
+              <a:spcAft>
+                <a:spcPts val="600"/>
+              </a:spcAft>
+            </a:pPr>
+            <a:r>
+              <a:rPr sz="1600">
+                <a:solidFill>
+                  <a:srgbClr val="244236"/>
+                </a:solidFill>
+                <a:latin typeface="Arial"/>
+              </a:rPr>
+              <a:t>•  Parse two date formats</a:t>
+            </a:r>
+          </a:p>
+          <a:p>
+            <a:pPr algn="l">
+              <a:spcAft>
+                <a:spcPts val="600"/>
+              </a:spcAft>
+            </a:pPr>
+            <a:r>
+              <a:rPr sz="1600">
+                <a:solidFill>
+                  <a:srgbClr val="244236"/>
+                </a:solidFill>
+                <a:latin typeface="Arial"/>
+              </a:rPr>
+              <a:t>•  Unify yes/no codes</a:t>
+            </a:r>
+          </a:p>
+          <a:p>
+            <a:pPr algn="l">
+              <a:spcAft>
+                <a:spcPts val="600"/>
+              </a:spcAft>
+            </a:pPr>
+            <a:r>
+              <a:rPr sz="1600">
+                <a:solidFill>
+                  <a:srgbClr val="244236"/>
+                </a:solidFill>
+                <a:latin typeface="Arial"/>
+              </a:rPr>
+              <a:t>•  Z-score credit scores</a:t>
+            </a:r>
+          </a:p>
+          <a:p>
+            <a:pPr algn="l">
+              <a:spcAft>
+                <a:spcPts val="600"/>
+              </a:spcAft>
+            </a:pPr>
+            <a:r>
+              <a:rPr sz="1600">
+                <a:solidFill>
+                  <a:srgbClr val="244236"/>
+                </a:solidFill>
+                <a:latin typeface="Arial"/>
+              </a:rPr>
+              <a:t>•  Add missingness flags</a:t>
+            </a:r>
           </a:p>
         </p:txBody>
       </p:sp>

</xml_diff>